<commit_message>
Live scoring: fedcast score and the Ledger view's Score button; log and Brier per track, model and baseline into ledger/scores.jsonl once the decision is in the evidence. Short brief deck (front page plus two slides).
Co-Authored-By: Claude Fable 5.1 <noreply@anthropic.com>
</commit_message>
<xml_diff>
--- a/docs/FedCast_Fullerton.pptx
+++ b/docs/FedCast_Fullerton.pptx
@@ -129,13 +129,13 @@
   <p:extLst>
     <p:ext uri="{521415D9-36F7-43E2-AB2F-B90AF26B5E84}">
       <p14:sectionLst xmlns:p14="http://schemas.microsoft.com/office/powerpoint/2010/main">
-        <p14:section name="Opening" id="{e243ee2c-17ed-fc69-5a53-04c731e61d58}">
+        <p14:section name="Opening" id="{4c3782d7-9cd0-5c26-222a-cfa8f3e5a3f5}">
           <p14:sldIdLst>
             <p14:sldId id="256"/>
             <p14:sldId id="257"/>
           </p14:sldIdLst>
         </p14:section>
-        <p14:section name="Objective" id="{3dbdd1ef-cedc-d113-da20-9d27ba08a80f}">
+        <p14:section name="Objective" id="{8b520ad7-c864-106f-c1c2-3859526d89bb}">
           <p14:sldIdLst>
             <p14:sldId id="258"/>
             <p14:sldId id="259"/>
@@ -144,21 +144,21 @@
             <p14:sldId id="262"/>
           </p14:sldIdLst>
         </p14:section>
-        <p14:section name="How it works" id="{56e1f8ee-2f96-872a-1c0b-2346d4a719d9}">
+        <p14:section name="How it works" id="{4b9b7ebb-c2ab-b2f1-b12e-6999eea1de8b}">
           <p14:sldIdLst>
             <p14:sldId id="263"/>
             <p14:sldId id="264"/>
             <p14:sldId id="265"/>
           </p14:sldIdLst>
         </p14:section>
-        <p14:section name="The harness" id="{b9997f85-3feb-bb03-be17-b11ec07c2bd2}">
+        <p14:section name="The harness" id="{bcd77549-0e03-5fbe-1965-70fefddf844f}">
           <p14:sldIdLst>
             <p14:sldId id="266"/>
             <p14:sldId id="267"/>
             <p14:sldId id="268"/>
           </p14:sldIdLst>
         </p14:section>
-        <p14:section name="Evidence" id="{57022b4f-3eec-402b-13a6-5abb11d4c311}">
+        <p14:section name="Evidence" id="{936f6400-439c-1588-3c06-a05f9a9fc8ec}">
           <p14:sldIdLst>
             <p14:sldId id="269"/>
             <p14:sldId id="270"/>
@@ -169,7 +169,7 @@
             <p14:sldId id="275"/>
           </p14:sldIdLst>
         </p14:section>
-        <p14:section name="Limits and next" id="{ed528062-ad37-55eb-cb4c-5604f2eb5dd3}">
+        <p14:section name="Limits and next" id="{b3fb1f83-ee01-423e-ce5c-bcc9c5d12b04}">
           <p14:sldIdLst>
             <p14:sldId id="276"/>
             <p14:sldId id="277"/>
@@ -1812,7 +1812,7 @@
           <a:p>
             <a:r>
               <a:rPr lang="en-US" dirty="0"/>
-              <a:t>Three follow-ups worth discussing with the room. Live scoring starts this week. Longer windows are where reading evidence should matter more: for the December meeting the market already prices a hike at three in four, and the year-end rate is open. And an events agent for regime shifts: the cuts of 1987, 1998, 2008 and 2020 were driven by financial stress, not by the data the models read; the base-rates pre-read already lists the intermeeting moves, and a watch-out agent could flag when conditions look like those episodes.</a:t>
+              <a:t>Three follow-ups worth discussing with the room. Live scoring is built and the first record lands the morning after the decision. Longer windows are where reading evidence should matter more: for the December meeting the market already prices a hike at three in four, and the year-end rate is open. And an events agent for regime shifts: the cuts of 1987, 1998, 2008 and 2020 were driven by financial stress, not by the data the models read; the base-rates pre-read already lists the intermeeting moves, and a watch-out agent could flag when conditions look like those episodes.</a:t>
             </a:r>
             <a:endParaRPr lang="en-US" dirty="0"/>
           </a:p>
@@ -16228,7 +16228,7 @@
                   <a:schemeClr val="tx2"/>
                 </a:solidFill>
               </a:rPr>
-              <a:t>Score live decisions</a:t>
+              <a:t>Score live decisions: built this week</a:t>
             </a:r>
             <a:endParaRPr lang="en-US" sz="1500" dirty="0"/>
           </a:p>
@@ -16264,7 +16264,7 @@
                   <a:schemeClr val="tx1"/>
                 </a:solidFill>
               </a:rPr>
-              <a:t>From 28 October, a log score per model and per track is written to the ledger by code. Every weight decision waits on this record.</a:t>
+              <a:t>Once the overnight-rate row is dated after the meeting, one click scores every forecast of that meeting, each track, each model and two naive baselines, with log score and Brier, into an append-only file. The first record lands the morning after 28 October. Every weight decision waits on this record.</a:t>
             </a:r>
             <a:endParaRPr lang="en-US" sz="1150" dirty="0"/>
           </a:p>

</xml_diff>

<commit_message>
Retire the arm letters: the ladder is analysts 1, 2, 3 and 4 to 8, each step adding one thing
Each rung held exactly one analyst, so A to D were a second name for the same thing and only confused.
Measurement rows now carry a scope ("1 naive", "2 evidence", "3 generalist", "4-8 specialists"); records carry
analyst_no; `fedcast analyse --analyst 1..8|name|specialists|all` replaces --arm. UI, brief, deck, plan and notes
present the ladder as an evolution: question only; + evidence; + answer shape and verifier; + one slice each.
Ladder slide and brief carry the 28 October column.

Co-Authored-By: Claude Fable 5.1 <noreply@anthropic.com>
</commit_message>
<xml_diff>
--- a/docs/FedCast_Fullerton.pptx
+++ b/docs/FedCast_Fullerton.pptx
@@ -129,13 +129,13 @@
   <p:extLst>
     <p:ext uri="{521415D9-36F7-43E2-AB2F-B90AF26B5E84}">
       <p14:sectionLst xmlns:p14="http://schemas.microsoft.com/office/powerpoint/2010/main">
-        <p14:section name="Opening" id="{4c3782d7-9cd0-5c26-222a-cfa8f3e5a3f5}">
+        <p14:section name="Opening" id="{be377cea-06bf-2115-d346-690e18a1862b}">
           <p14:sldIdLst>
             <p14:sldId id="256"/>
             <p14:sldId id="257"/>
           </p14:sldIdLst>
         </p14:section>
-        <p14:section name="Objective" id="{8b520ad7-c864-106f-c1c2-3859526d89bb}">
+        <p14:section name="Objective" id="{585f81b1-93ce-a0fd-6bec-2218d9f62864}">
           <p14:sldIdLst>
             <p14:sldId id="258"/>
             <p14:sldId id="259"/>
@@ -144,21 +144,21 @@
             <p14:sldId id="262"/>
           </p14:sldIdLst>
         </p14:section>
-        <p14:section name="How it works" id="{4b9b7ebb-c2ab-b2f1-b12e-6999eea1de8b}">
+        <p14:section name="How it works" id="{4ac93ffd-9b66-a051-4bd8-ac980cc7d41d}">
           <p14:sldIdLst>
             <p14:sldId id="263"/>
             <p14:sldId id="264"/>
             <p14:sldId id="265"/>
           </p14:sldIdLst>
         </p14:section>
-        <p14:section name="The harness" id="{bcd77549-0e03-5fbe-1965-70fefddf844f}">
+        <p14:section name="The harness" id="{67738a85-be33-6475-8835-333390c4713e}">
           <p14:sldIdLst>
             <p14:sldId id="266"/>
             <p14:sldId id="267"/>
             <p14:sldId id="268"/>
           </p14:sldIdLst>
         </p14:section>
-        <p14:section name="Evidence" id="{936f6400-439c-1588-3c06-a05f9a9fc8ec}">
+        <p14:section name="Evidence" id="{8b2e86d5-f801-993e-06c8-69e4590dbb99}">
           <p14:sldIdLst>
             <p14:sldId id="269"/>
             <p14:sldId id="270"/>
@@ -169,7 +169,7 @@
             <p14:sldId id="275"/>
           </p14:sldIdLst>
         </p14:section>
-        <p14:section name="Limits and next" id="{b3fb1f83-ee01-423e-ce5c-bcc9c5d12b04}">
+        <p14:section name="Limits and next" id="{9a3f574a-217f-3a1b-ec7c-3131ce7ebfd1}">
           <p14:sldIdLst>
             <p14:sldId id="276"/>
             <p14:sldId id="277"/>
@@ -756,7 +756,7 @@
           <a:p>
             <a:r>
               <a:rPr lang="en-US" dirty="0"/>
-              <a:t>This is the slide that explains what harnessing means. The same model is run eight ways on the same snapshot. Analyst 1 gets nothing but the question: that is what the model does on its own, the control. Each later arm adds exactly one technique, so the score difference between neighbouring arms is the value of that technique. Arms A and B are meant to fail; the tool is judged on C and D.</a:t>
+              <a:t>This is the slide that explains what harnessing means. The same model is run eight ways on the same snapshot. Analyst 1 gets nothing but the question: that is what the model does on its own, the control. Each step up adds exactly one thing, so the score difference between neighbouring steps is the value of that thing. Analysts 1 and 2 are meant to fail; the tool is judged on 3 and 4 to 8.</a:t>
             </a:r>
             <a:endParaRPr lang="en-US" dirty="0"/>
           </a:p>
@@ -1020,7 +1020,7 @@
           <a:p>
             <a:r>
               <a:rPr lang="en-US" dirty="0"/>
-              <a:t>Read left to right. The naive model wobbles by three to five points between identical runs, cites nothing, and leaks three dozen numbers from memory; it still thinks the Fed is cutting. Showing it the evidence removes the leaks but not the wobble, and nothing can be checked. Structure plus verification makes the output stable and fully verifiable. Specialists keep that and add attribution. Same model, same day; the difference is the harness.</a:t>
+              <a:t>Read left to right as an evolution. Analyst 1 wobbles by three to five points between identical runs, cites nothing, and leaks three dozen numbers from memory; it still thinks the Fed is cutting. Adding the evidence (analyst 2) removes the leaks but not the wobble, and nothing can be checked. Adding the answer shape and the verifier (analyst 3) is the step that makes the output stable and fully verifiable. Specialists (4 to 8) keep that and add attribution. Same model, same day; the difference at each step is the one thing added.</a:t>
             </a:r>
             <a:endParaRPr lang="en-US" dirty="0"/>
           </a:p>
@@ -4011,7 +4011,7 @@
                   <a:schemeClr val="tx2"/>
                 </a:solidFill>
               </a:rPr>
-              <a:t>Eight analysts, one model, four arms</a:t>
+              <a:t>Eight analysts, one model, one ladder</a:t>
             </a:r>
             <a:endParaRPr lang="en-US" sz="3200" dirty="0"/>
           </a:p>
@@ -4077,7 +4077,7 @@
                 <a:ea typeface="Cambria" pitchFamily="34" charset="-122"/>
                 <a:cs typeface="Cambria" pitchFamily="34" charset="-120"/>
               </a:rPr>
-              <a:t>A</a:t>
+              <a:t>1</a:t>
             </a:r>
             <a:endParaRPr lang="en-US" sz="3000" dirty="0"/>
           </a:p>
@@ -4185,7 +4185,7 @@
                   <a:schemeClr val="tx1"/>
                 </a:solidFill>
               </a:rPr>
-              <a:t>What the model does on its own. The control every other arm is measured against.</a:t>
+              <a:t>What the model does on its own. The control every later step is measured against.</a:t>
             </a:r>
             <a:endParaRPr lang="en-US" sz="1250" dirty="0"/>
           </a:p>
@@ -4251,7 +4251,7 @@
                 <a:ea typeface="Cambria" pitchFamily="34" charset="-122"/>
                 <a:cs typeface="Cambria" pitchFamily="34" charset="-120"/>
               </a:rPr>
-              <a:t>B</a:t>
+              <a:t>2</a:t>
             </a:r>
             <a:endParaRPr lang="en-US" sz="3000" dirty="0"/>
           </a:p>
@@ -4425,7 +4425,7 @@
                 <a:ea typeface="Cambria" pitchFamily="34" charset="-122"/>
                 <a:cs typeface="Cambria" pitchFamily="34" charset="-120"/>
               </a:rPr>
-              <a:t>C</a:t>
+              <a:t>3</a:t>
             </a:r>
             <a:endParaRPr lang="en-US" sz="3000" dirty="0"/>
           </a:p>
@@ -4591,7 +4591,7 @@
               <a:buNone/>
             </a:pPr>
             <a:r>
-              <a:rPr lang="en-US" sz="3000" b="1" dirty="0">
+              <a:rPr lang="en-US" sz="2200" b="1" dirty="0">
                 <a:solidFill>
                   <a:schemeClr val="bg1"/>
                 </a:solidFill>
@@ -4599,9 +4599,9 @@
                 <a:ea typeface="Cambria" pitchFamily="34" charset="-122"/>
                 <a:cs typeface="Cambria" pitchFamily="34" charset="-120"/>
               </a:rPr>
-              <a:t>D</a:t>
-            </a:r>
-            <a:endParaRPr lang="en-US" sz="3000" dirty="0"/>
+              <a:t>4-8</a:t>
+            </a:r>
+            <a:endParaRPr lang="en-US" sz="2200" dirty="0"/>
           </a:p>
         </p:txBody>
       </p:sp>
@@ -4743,7 +4743,7 @@
                   <a:schemeClr val="accent4"/>
                 </a:solidFill>
               </a:rPr>
-              <a:t>Each arm adds one technique. The value of the technique is the difference between neighbouring arms.</a:t>
+              <a:t>Each step adds one thing. The value of that thing is the difference in score between neighbouring steps.</a:t>
             </a:r>
             <a:endParaRPr lang="en-US" sz="1200" dirty="0"/>
           </a:p>
@@ -6149,7 +6149,7 @@
                   <a:schemeClr val="tx2"/>
                 </a:solidFill>
               </a:rPr>
-              <a:t>The ladder, three snapshots, five runs each</a:t>
+              <a:t>The ladder, four snapshots, five runs each</a:t>
             </a:r>
             <a:endParaRPr lang="en-US" sz="3200" dirty="0"/>
           </a:p>
@@ -6260,7 +6260,7 @@
                             <a:srgbClr val="FFFFFF"/>
                           </a:solidFill>
                         </a:rPr>
-                        <a:t>Arm A: naive</a:t>
+                        <a:t>Analyst 1: the question only</a:t>
                       </a:r>
                       <a:endParaRPr lang="en-US" sz="1150" dirty="0"/>
                     </a:p>
@@ -6321,7 +6321,7 @@
                             <a:srgbClr val="FFFFFF"/>
                           </a:solidFill>
                         </a:rPr>
-                        <a:t>Arm B: evidence shown</a:t>
+                        <a:t>Analyst 2: + the evidence</a:t>
                       </a:r>
                       <a:endParaRPr lang="en-US" sz="1150" dirty="0"/>
                     </a:p>
@@ -6382,7 +6382,7 @@
                             <a:srgbClr val="FFFFFF"/>
                           </a:solidFill>
                         </a:rPr>
-                        <a:t>Arm C: generalist + verifier</a:t>
+                        <a:t>Analyst 3: + answer shape + verifier</a:t>
                       </a:r>
                       <a:endParaRPr lang="en-US" sz="1150" dirty="0"/>
                     </a:p>
@@ -6443,7 +6443,7 @@
                             <a:srgbClr val="FFFFFF"/>
                           </a:solidFill>
                         </a:rPr>
-                        <a:t>Arm D: specialists</a:t>
+                        <a:t>Analysts 4-8: + one slice each</a:t>
                       </a:r>
                       <a:endParaRPr lang="en-US" sz="1150" dirty="0"/>
                     </a:p>
@@ -6578,7 +6578,7 @@
                             <a:srgbClr val="C8553D"/>
                           </a:solidFill>
                         </a:rPr>
-                        <a:t>3.4 / 4.5 / 4.9 pp, fail</a:t>
+                        <a:t>3.4 / 4.5 / 4.9 / 4.1 pp, fail</a:t>
                       </a:r>
                       <a:endParaRPr lang="en-US" sz="1150" dirty="0"/>
                     </a:p>
@@ -6636,7 +6636,7 @@
                             <a:srgbClr val="C8553D"/>
                           </a:solidFill>
                         </a:rPr>
-                        <a:t>3.3 / 2.3 / 4.8 pp, fail</a:t>
+                        <a:t>3.3 / 2.3 / 4.8 / 3.4 pp, fail</a:t>
                       </a:r>
                       <a:endParaRPr lang="en-US" sz="1150" dirty="0"/>
                     </a:p>
@@ -6694,7 +6694,7 @@
                             <a:srgbClr val="2C6E49"/>
                           </a:solidFill>
                         </a:rPr>
-                        <a:t>0.6 / 0.5 / 0.5 bp of tilt, pass</a:t>
+                        <a:t>0.6 / 0.5 / 0.5 / 0.8 bp of tilt, pass</a:t>
                       </a:r>
                       <a:endParaRPr lang="en-US" sz="1150" dirty="0"/>
                     </a:p>
@@ -6752,7 +6752,7 @@
                             <a:srgbClr val="2C6E49"/>
                           </a:solidFill>
                         </a:rPr>
-                        <a:t>0.5 / 0.8 / 1.2 bp of tilt, pass</a:t>
+                        <a:t>0.5 / 0.8 / 1.2 / 0.8 bp of tilt, pass</a:t>
                       </a:r>
                       <a:endParaRPr lang="en-US" sz="1150" dirty="0"/>
                     </a:p>
@@ -7000,7 +7000,7 @@
                             <a:srgbClr val="2C6E49"/>
                           </a:solidFill>
                         </a:rPr>
-                        <a:t>100% on all three, pass</a:t>
+                        <a:t>100 / 100 / 100 / 99%, pass</a:t>
                       </a:r>
                       <a:endParaRPr lang="en-US" sz="1150" dirty="0"/>
                     </a:p>
@@ -7058,7 +7058,7 @@
                             <a:srgbClr val="2C6E49"/>
                           </a:solidFill>
                         </a:rPr>
-                        <a:t>100 / 97 / 100%, pass</a:t>
+                        <a:t>100 / 97 / 100 / 100%, pass</a:t>
                       </a:r>
                       <a:endParaRPr lang="en-US" sz="1150" dirty="0"/>
                     </a:p>
@@ -7190,7 +7190,7 @@
                             <a:srgbClr val="C8553D"/>
                           </a:solidFill>
                         </a:rPr>
-                        <a:t>36 / 36 / 39, fail</a:t>
+                        <a:t>36 / 36 / 39 / 38, fail</a:t>
                       </a:r>
                       <a:endParaRPr lang="en-US" sz="1150" dirty="0"/>
                     </a:p>
@@ -7482,7 +7482,7 @@
                             <a:srgbClr val="6B7280"/>
                           </a:solidFill>
                         </a:rPr>
-                        <a:t>Cut 25 bps at 57%: its memory of the Fed is stale</a:t>
+                        <a:t>Cut 25 bps at 57 to 67%: its memory of the Fed is stale</a:t>
                       </a:r>
                       <a:endParaRPr lang="en-US" sz="1150" dirty="0"/>
                     </a:p>
@@ -7540,7 +7540,7 @@
                             <a:srgbClr val="6B7280"/>
                           </a:solidFill>
                         </a:rPr>
-                        <a:t>+25 bps at 55 to 57%: reads the evidence, overshoots the market</a:t>
+                        <a:t>+25 bps at 50 to 57%: reads the evidence, overshoots the market</a:t>
                       </a:r>
                       <a:endParaRPr lang="en-US" sz="1150" dirty="0"/>
                     </a:p>
@@ -7598,7 +7598,7 @@
                             <a:srgbClr val="6B7280"/>
                           </a:solidFill>
                         </a:rPr>
-                        <a:t>+7.0 / +6.6 / +6.4 bp hawkish</a:t>
+                        <a:t>+7.0 / +6.6 / +6.4 / +5.8 bp hawkish</a:t>
                       </a:r>
                       <a:endParaRPr lang="en-US" sz="1150" dirty="0"/>
                     </a:p>
@@ -7656,7 +7656,7 @@
                             <a:srgbClr val="6B7280"/>
                           </a:solidFill>
                         </a:rPr>
-                        <a:t>+4.4 / +4.1 / +4.4 bp hawkish; labour the lone non-hawk</a:t>
+                        <a:t>+4.4 / +4.1 / +4.4 / +4.0 bp hawkish; labour the lone non-hawk</a:t>
                       </a:r>
                       <a:endParaRPr lang="en-US" sz="1150" dirty="0"/>
                     </a:p>
@@ -7735,7 +7735,7 @@
                   <a:schemeClr val="accent4"/>
                 </a:solidFill>
               </a:rPr>
-              <a:t>Snapshots of 15, 24 and 26 October 2026. Arms C and D report S1 in basis points of tilt because they output a lean, not a distribution.</a:t>
+              <a:t>Snapshots of 15, 24, 26 and 28 October 2026. Analysts 3 to 8 report S1 in basis points of tilt because they output a lean, not a distribution.</a:t>
             </a:r>
             <a:endParaRPr lang="en-US" sz="1050" dirty="0"/>
           </a:p>
@@ -16893,7 +16893,7 @@
                   <a:schemeClr val="tx2"/>
                 </a:solidFill>
               </a:rPr>
-              <a:t>Arm F and a second model family</a:t>
+              <a:t>One more step and a second model family</a:t>
             </a:r>
             <a:endParaRPr lang="en-US" sz="1500" dirty="0"/>
           </a:p>
@@ -18737,7 +18737,7 @@
                   <a:schemeClr val="tx1"/>
                 </a:solidFill>
               </a:rPr>
-              <a:t>The decision is the first target, not the only one. The same chain can forecast the December meeting, the year-end rate, or another central bank, and the control arms measure whether the language model is still earning its place.</a:t>
+              <a:t>The decision is the first target, not the only one. The same chain can forecast the December meeting, the year-end rate, or another central bank, and the control analysts measure whether the language model is still earning its place.</a:t>
             </a:r>
             <a:endParaRPr lang="en-US" sz="1400" dirty="0"/>
           </a:p>
@@ -20250,7 +20250,7 @@
                             <a:srgbClr val="1B1F2A"/>
                           </a:solidFill>
                         </a:rPr>
-                        <a:t>16 meetings; no frozen evidence, no quote verification, no replay, no control arm</a:t>
+                        <a:t>16 meetings; no frozen evidence, no quote verification, no replay, no control</a:t>
                       </a:r>
                       <a:endParaRPr lang="en-US" sz="1150" dirty="0"/>
                     </a:p>

</xml_diff>

<commit_message>
Deck: next-steps card text clear of the number circle
Co-Authored-By: Claude Fable 5.1 <noreply@anthropic.com>
</commit_message>
<xml_diff>
--- a/docs/FedCast_Fullerton.pptx
+++ b/docs/FedCast_Fullerton.pptx
@@ -1900,7 +1900,7 @@
     </p:spTree>
     <p:extLst>
       <p:ext uri="{BB962C8B-B14F-4D97-AF65-F5344CB8AC3E}">
-        <p14:creationId xmlns:p14="http://schemas.microsoft.com/office/powerpoint/2010/main" val="956866070"/>
+        <p14:creationId xmlns:p14="http://schemas.microsoft.com/office/powerpoint/2010/main" val="1508859901"/>
       </p:ext>
     </p:extLst>
   </p:cSld>
@@ -3047,7 +3047,7 @@
           </a:prstGeom>
           <a:extLst>
             <a:ext uri="{C572A759-6A51-4108-AA02-DFA0A04FC94B}">
-              <ma14:wrappingTextBoxFlag xmlns="" xmlns:ma14="http://schemas.microsoft.com/office/mac/drawingml/2011/main" val="0"/>
+              <ma14:wrappingTextBoxFlag xmlns:ma14="http://schemas.microsoft.com/office/mac/drawingml/2011/main" xmlns="" val="0"/>
             </a:ext>
           </a:extLst>
         </p:spPr>
@@ -3232,7 +3232,7 @@
           </a:prstGeom>
           <a:extLst>
             <a:ext uri="{C572A759-6A51-4108-AA02-DFA0A04FC94B}">
-              <ma14:wrappingTextBoxFlag xmlns="" xmlns:ma14="http://schemas.microsoft.com/office/mac/drawingml/2011/main" val="0"/>
+              <ma14:wrappingTextBoxFlag xmlns:ma14="http://schemas.microsoft.com/office/mac/drawingml/2011/main" xmlns="" val="0"/>
             </a:ext>
           </a:extLst>
         </p:spPr>
@@ -5124,7 +5124,7 @@
           </a:prstGeom>
           <a:extLst>
             <a:ext uri="{C572A759-6A51-4108-AA02-DFA0A04FC94B}">
-              <ma14:wrappingTextBoxFlag xmlns="" xmlns:ma14="http://schemas.microsoft.com/office/mac/drawingml/2011/main" val="0"/>
+              <ma14:wrappingTextBoxFlag xmlns:ma14="http://schemas.microsoft.com/office/mac/drawingml/2011/main" xmlns="" val="0"/>
             </a:ext>
           </a:extLst>
         </p:spPr>
@@ -7510,7 +7510,7 @@
           </a:prstGeom>
           <a:extLst>
             <a:ext uri="{C572A759-6A51-4108-AA02-DFA0A04FC94B}">
-              <ma14:wrappingTextBoxFlag xmlns="" xmlns:ma14="http://schemas.microsoft.com/office/mac/drawingml/2011/main" val="0"/>
+              <ma14:wrappingTextBoxFlag xmlns:ma14="http://schemas.microsoft.com/office/mac/drawingml/2011/main" xmlns="" val="0"/>
             </a:ext>
           </a:extLst>
         </p:spPr>
@@ -8447,7 +8447,7 @@
           </a:prstGeom>
           <a:extLst>
             <a:ext uri="{C572A759-6A51-4108-AA02-DFA0A04FC94B}">
-              <ma14:wrappingTextBoxFlag xmlns="" xmlns:ma14="http://schemas.microsoft.com/office/mac/drawingml/2011/main" val="0"/>
+              <ma14:wrappingTextBoxFlag xmlns:ma14="http://schemas.microsoft.com/office/mac/drawingml/2011/main" xmlns="" val="0"/>
             </a:ext>
           </a:extLst>
         </p:spPr>
@@ -10028,7 +10028,7 @@
           </a:prstGeom>
           <a:extLst>
             <a:ext uri="{C572A759-6A51-4108-AA02-DFA0A04FC94B}">
-              <ma14:wrappingTextBoxFlag xmlns="" xmlns:ma14="http://schemas.microsoft.com/office/mac/drawingml/2011/main" val="0"/>
+              <ma14:wrappingTextBoxFlag xmlns:ma14="http://schemas.microsoft.com/office/mac/drawingml/2011/main" xmlns="" val="0"/>
             </a:ext>
           </a:extLst>
         </p:spPr>
@@ -11879,8 +11879,8 @@
         </p:nvSpPr>
         <p:spPr>
           <a:xfrm>
-            <a:off x="731520" y="2286000"/>
-            <a:ext cx="5074920" cy="804672"/>
+            <a:off x="731520" y="2368296"/>
+            <a:ext cx="5074920" cy="731520"/>
           </a:xfrm>
           <a:prstGeom prst="rect">
             <a:avLst/>
@@ -12046,8 +12046,8 @@
         </p:nvSpPr>
         <p:spPr>
           <a:xfrm>
-            <a:off x="6400800" y="2286000"/>
-            <a:ext cx="5074920" cy="804672"/>
+            <a:off x="6400800" y="2368296"/>
+            <a:ext cx="5074920" cy="731520"/>
           </a:xfrm>
           <a:prstGeom prst="rect">
             <a:avLst/>
@@ -12213,8 +12213,8 @@
         </p:nvSpPr>
         <p:spPr>
           <a:xfrm>
-            <a:off x="731520" y="3749040"/>
-            <a:ext cx="5074920" cy="804672"/>
+            <a:off x="731520" y="3831336"/>
+            <a:ext cx="5074920" cy="731520"/>
           </a:xfrm>
           <a:prstGeom prst="rect">
             <a:avLst/>
@@ -12380,8 +12380,8 @@
         </p:nvSpPr>
         <p:spPr>
           <a:xfrm>
-            <a:off x="6400800" y="3749040"/>
-            <a:ext cx="5074920" cy="804672"/>
+            <a:off x="6400800" y="3831336"/>
+            <a:ext cx="5074920" cy="731520"/>
           </a:xfrm>
           <a:prstGeom prst="rect">
             <a:avLst/>
@@ -12547,8 +12547,8 @@
         </p:nvSpPr>
         <p:spPr>
           <a:xfrm>
-            <a:off x="731520" y="5212080"/>
-            <a:ext cx="5074920" cy="804672"/>
+            <a:off x="731520" y="5294376"/>
+            <a:ext cx="5074920" cy="731520"/>
           </a:xfrm>
           <a:prstGeom prst="rect">
             <a:avLst/>
@@ -12714,8 +12714,8 @@
         </p:nvSpPr>
         <p:spPr>
           <a:xfrm>
-            <a:off x="6400800" y="5212080"/>
-            <a:ext cx="5074920" cy="804672"/>
+            <a:off x="6400800" y="5294376"/>
+            <a:ext cx="5074920" cy="731520"/>
           </a:xfrm>
           <a:prstGeom prst="rect">
             <a:avLst/>
@@ -12790,7 +12790,7 @@
     </p:spTree>
     <p:extLst>
       <p:ext uri="{BB962C8B-B14F-4D97-AF65-F5344CB8AC3E}">
-        <p14:creationId xmlns:p14="http://schemas.microsoft.com/office/powerpoint/2010/main" val="651567409"/>
+        <p14:creationId xmlns:p14="http://schemas.microsoft.com/office/powerpoint/2010/main" val="752257888"/>
       </p:ext>
     </p:extLst>
   </p:cSld>
@@ -13800,7 +13800,7 @@
           </a:prstGeom>
           <a:extLst>
             <a:ext uri="{C572A759-6A51-4108-AA02-DFA0A04FC94B}">
-              <ma14:wrappingTextBoxFlag xmlns="" xmlns:ma14="http://schemas.microsoft.com/office/mac/drawingml/2011/main" val="0"/>
+              <ma14:wrappingTextBoxFlag xmlns:ma14="http://schemas.microsoft.com/office/mac/drawingml/2011/main" xmlns="" val="0"/>
             </a:ext>
           </a:extLst>
         </p:spPr>
@@ -15590,7 +15590,7 @@
           </a:prstGeom>
           <a:extLst>
             <a:ext uri="{C572A759-6A51-4108-AA02-DFA0A04FC94B}">
-              <ma14:wrappingTextBoxFlag xmlns="" xmlns:ma14="http://schemas.microsoft.com/office/mac/drawingml/2011/main" val="0"/>
+              <ma14:wrappingTextBoxFlag xmlns:ma14="http://schemas.microsoft.com/office/mac/drawingml/2011/main" xmlns="" val="0"/>
             </a:ext>
           </a:extLst>
         </p:spPr>
@@ -16328,7 +16328,7 @@
           </a:prstGeom>
           <a:extLst>
             <a:ext uri="{C572A759-6A51-4108-AA02-DFA0A04FC94B}">
-              <ma14:wrappingTextBoxFlag xmlns="" xmlns:ma14="http://schemas.microsoft.com/office/mac/drawingml/2011/main" val="0"/>
+              <ma14:wrappingTextBoxFlag xmlns:ma14="http://schemas.microsoft.com/office/mac/drawingml/2011/main" xmlns="" val="0"/>
             </a:ext>
           </a:extLst>
         </p:spPr>
@@ -18379,7 +18379,7 @@
           </a:prstGeom>
           <a:extLst>
             <a:ext uri="{C572A759-6A51-4108-AA02-DFA0A04FC94B}">
-              <ma14:wrappingTextBoxFlag xmlns="" xmlns:ma14="http://schemas.microsoft.com/office/mac/drawingml/2011/main" val="0"/>
+              <ma14:wrappingTextBoxFlag xmlns:ma14="http://schemas.microsoft.com/office/mac/drawingml/2011/main" xmlns="" val="0"/>
             </a:ext>
           </a:extLst>
         </p:spPr>
@@ -19110,7 +19110,7 @@
           </a:prstGeom>
           <a:extLst>
             <a:ext uri="{C572A759-6A51-4108-AA02-DFA0A04FC94B}">
-              <ma14:wrappingTextBoxFlag xmlns="" xmlns:ma14="http://schemas.microsoft.com/office/mac/drawingml/2011/main" val="0"/>
+              <ma14:wrappingTextBoxFlag xmlns:ma14="http://schemas.microsoft.com/office/mac/drawingml/2011/main" xmlns="" val="0"/>
             </a:ext>
           </a:extLst>
         </p:spPr>
@@ -20580,7 +20580,7 @@
           </a:prstGeom>
           <a:extLst>
             <a:ext uri="{C572A759-6A51-4108-AA02-DFA0A04FC94B}">
-              <ma14:wrappingTextBoxFlag xmlns="" xmlns:ma14="http://schemas.microsoft.com/office/mac/drawingml/2011/main" val="0"/>
+              <ma14:wrappingTextBoxFlag xmlns:ma14="http://schemas.microsoft.com/office/mac/drawingml/2011/main" xmlns="" val="0"/>
             </a:ext>
           </a:extLst>
         </p:spPr>
@@ -24624,7 +24624,7 @@
           </a:prstGeom>
           <a:extLst>
             <a:ext uri="{C572A759-6A51-4108-AA02-DFA0A04FC94B}">
-              <ma14:wrappingTextBoxFlag xmlns="" xmlns:ma14="http://schemas.microsoft.com/office/mac/drawingml/2011/main" val="0"/>
+              <ma14:wrappingTextBoxFlag xmlns:ma14="http://schemas.microsoft.com/office/mac/drawingml/2011/main" xmlns="" val="0"/>
             </a:ext>
           </a:extLst>
         </p:spPr>

</xml_diff>

<commit_message>
Appendix slide: the 'why it stops at 10' bullet and the cruder-alternative sentence removed; multiplier note names the position and the rescaling total
Co-Authored-By: Claude Fable 5.1 <noreply@anthropic.com>
</commit_message>
<xml_diff>
--- a/docs/FedCast_Fullerton.pptx
+++ b/docs/FedCast_Fullerton.pptx
@@ -2229,7 +2229,7 @@
           <a:p>
             <a:r>
               <a:rPr lang="en-US" dirty="0"/>
-              <a:t>Three parts. The score and why it stops at 10: it is already in points of probability, and 10 is the most any single input may move the number, the same cap as a human view; a wider range would let the analysts write the number, which the design forbids. The average: one vote each. The spread: the points leave every bucket on the hold-or-cut side and land on both hike buckets, in proportion to size and distance from the middle, so the shape of the distribution is kept and nothing goes to zero.</a:t>
+              <a:t>Three parts. The score: already in points of probability, capped at 10 like a human view. The average: one vote each. The spread: the points leave every bucket on the hold-or-cut side and land on both hike buckets, in proportion to size and distance from the middle, so the shape of the distribution is kept and nothing goes to zero.</a:t>
             </a:r>
           </a:p>
         </p:txBody>
@@ -2260,7 +2260,7 @@
     </p:spTree>
     <p:extLst>
       <p:ext uri="{BB962C8B-B14F-4D97-AF65-F5344CB8AC3E}">
-        <p14:creationId xmlns:p14="http://schemas.microsoft.com/office/powerpoint/2010/main" val="500207554"/>
+        <p14:creationId xmlns:p14="http://schemas.microsoft.com/office/powerpoint/2010/main" val="471727733"/>
       </p:ext>
     </p:extLst>
   </p:cSld>
@@ -3249,7 +3249,7 @@
           </a:prstGeom>
           <a:extLst>
             <a:ext uri="{C572A759-6A51-4108-AA02-DFA0A04FC94B}">
-              <ma14:wrappingTextBoxFlag xmlns:ma14="http://schemas.microsoft.com/office/mac/drawingml/2011/main" xmlns="" val="0"/>
+              <ma14:wrappingTextBoxFlag xmlns="" xmlns:ma14="http://schemas.microsoft.com/office/mac/drawingml/2011/main" val="0"/>
             </a:ext>
           </a:extLst>
         </p:spPr>
@@ -3434,7 +3434,7 @@
           </a:prstGeom>
           <a:extLst>
             <a:ext uri="{C572A759-6A51-4108-AA02-DFA0A04FC94B}">
-              <ma14:wrappingTextBoxFlag xmlns:ma14="http://schemas.microsoft.com/office/mac/drawingml/2011/main" xmlns="" val="0"/>
+              <ma14:wrappingTextBoxFlag xmlns="" xmlns:ma14="http://schemas.microsoft.com/office/mac/drawingml/2011/main" val="0"/>
             </a:ext>
           </a:extLst>
         </p:spPr>
@@ -5426,7 +5426,7 @@
           </a:prstGeom>
           <a:extLst>
             <a:ext uri="{C572A759-6A51-4108-AA02-DFA0A04FC94B}">
-              <ma14:wrappingTextBoxFlag xmlns:ma14="http://schemas.microsoft.com/office/mac/drawingml/2011/main" xmlns="" val="0"/>
+              <ma14:wrappingTextBoxFlag xmlns="" xmlns:ma14="http://schemas.microsoft.com/office/mac/drawingml/2011/main" val="0"/>
             </a:ext>
           </a:extLst>
         </p:spPr>
@@ -7828,7 +7828,7 @@
           </a:prstGeom>
           <a:extLst>
             <a:ext uri="{C572A759-6A51-4108-AA02-DFA0A04FC94B}">
-              <ma14:wrappingTextBoxFlag xmlns:ma14="http://schemas.microsoft.com/office/mac/drawingml/2011/main" xmlns="" val="0"/>
+              <ma14:wrappingTextBoxFlag xmlns="" xmlns:ma14="http://schemas.microsoft.com/office/mac/drawingml/2011/main" val="0"/>
             </a:ext>
           </a:extLst>
         </p:spPr>
@@ -8817,7 +8817,7 @@
           </a:prstGeom>
           <a:extLst>
             <a:ext uri="{C572A759-6A51-4108-AA02-DFA0A04FC94B}">
-              <ma14:wrappingTextBoxFlag xmlns:ma14="http://schemas.microsoft.com/office/mac/drawingml/2011/main" xmlns="" val="0"/>
+              <ma14:wrappingTextBoxFlag xmlns="" xmlns:ma14="http://schemas.microsoft.com/office/mac/drawingml/2011/main" val="0"/>
             </a:ext>
           </a:extLst>
         </p:spPr>
@@ -10481,7 +10481,7 @@
           </a:prstGeom>
           <a:extLst>
             <a:ext uri="{C572A759-6A51-4108-AA02-DFA0A04FC94B}">
-              <ma14:wrappingTextBoxFlag xmlns:ma14="http://schemas.microsoft.com/office/mac/drawingml/2011/main" xmlns="" val="0"/>
+              <ma14:wrappingTextBoxFlag xmlns="" xmlns:ma14="http://schemas.microsoft.com/office/mac/drawingml/2011/main" val="0"/>
             </a:ext>
           </a:extLst>
         </p:spPr>
@@ -13399,7 +13399,7 @@
           </a:prstGeom>
           <a:extLst>
             <a:ext uri="{C572A759-6A51-4108-AA02-DFA0A04FC94B}">
-              <ma14:wrappingTextBoxFlag xmlns:ma14="http://schemas.microsoft.com/office/mac/drawingml/2011/main" xmlns="" val="0"/>
+              <ma14:wrappingTextBoxFlag xmlns="" xmlns:ma14="http://schemas.microsoft.com/office/mac/drawingml/2011/main" val="0"/>
             </a:ext>
           </a:extLst>
         </p:spPr>
@@ -14465,7 +14465,7 @@
           </a:prstGeom>
           <a:extLst>
             <a:ext uri="{C572A759-6A51-4108-AA02-DFA0A04FC94B}">
-              <ma14:wrappingTextBoxFlag xmlns:ma14="http://schemas.microsoft.com/office/mac/drawingml/2011/main" xmlns="" val="0"/>
+              <ma14:wrappingTextBoxFlag xmlns="" xmlns:ma14="http://schemas.microsoft.com/office/mac/drawingml/2011/main" val="0"/>
             </a:ext>
           </a:extLst>
         </p:spPr>
@@ -16303,7 +16303,7 @@
           </a:prstGeom>
           <a:extLst>
             <a:ext uri="{C572A759-6A51-4108-AA02-DFA0A04FC94B}">
-              <ma14:wrappingTextBoxFlag xmlns:ma14="http://schemas.microsoft.com/office/mac/drawingml/2011/main" xmlns="" val="0"/>
+              <ma14:wrappingTextBoxFlag xmlns="" xmlns:ma14="http://schemas.microsoft.com/office/mac/drawingml/2011/main" val="0"/>
             </a:ext>
           </a:extLst>
         </p:spPr>
@@ -16426,13 +16426,6 @@
             </a:outerShdw>
           </a:effectLst>
         </p:spPr>
-        <p:txBody>
-          <a:bodyPr/>
-          <a:lstStyle/>
-          <a:p>
-            <a:endParaRPr lang="en-US"/>
-          </a:p>
-        </p:txBody>
       </p:sp>
       <p:sp>
         <p:nvSpPr>
@@ -16522,7 +16515,7 @@
                   <a:schemeClr val="tx1"/>
                 </a:solidFill>
               </a:rPr>
-              <a:t>Why it stops at 10: ten points is the most any single input may move the number, the same cap a human view has. A range of −100 to +100 would let the analysts write the number; the design lets them shift it, never write it.</a:t>
+              <a:t>Ten is the cap any single input has on the number, the same as a human view.</a:t>
             </a:r>
             <a:endParaRPr lang="en-US" sz="1050" dirty="0"/>
           </a:p>
@@ -19198,7 +19191,7 @@
                   <a:schemeClr val="accent4"/>
                 </a:solidFill>
               </a:rPr>
-              <a:t>Multiplier = e^(0.153 × bucket number) ÷ 1.0486, the rescaling total. Exactly 4.00 points crossed; the after column is the machine forecast recorded as entry #18. The cruder alternative, taking all 4 points from no change and giving them to +25, is easier to say and would be amendment #9 if preferred.</a:t>
+              <a:t>Multiplier = e^(0.153 × position) ÷ 1.0486, where position is −2, −1, 0, +1, +2 and 1.0486 is what the five re-weighted buckets add up to before rescaling. Exactly 4.00 points crossed; the after column is the machine forecast recorded as entry #18.</a:t>
             </a:r>
             <a:endParaRPr lang="en-US" sz="1000" dirty="0"/>
           </a:p>
@@ -19224,7 +19217,7 @@
           </a:prstGeom>
           <a:extLst>
             <a:ext uri="{C572A759-6A51-4108-AA02-DFA0A04FC94B}">
-              <ma14:wrappingTextBoxFlag xmlns="" xmlns:ma14="http://schemas.microsoft.com/office/mac/drawingml/2011/main" val="0"/>
+              <ma14:wrappingTextBoxFlag xmlns:ma14="http://schemas.microsoft.com/office/mac/drawingml/2011/main" xmlns="" val="0"/>
             </a:ext>
           </a:extLst>
         </p:spPr>
@@ -19252,7 +19245,7 @@
     </p:spTree>
     <p:extLst>
       <p:ext uri="{BB962C8B-B14F-4D97-AF65-F5344CB8AC3E}">
-        <p14:creationId xmlns:p14="http://schemas.microsoft.com/office/powerpoint/2010/main" val="2272862402"/>
+        <p14:creationId xmlns:p14="http://schemas.microsoft.com/office/powerpoint/2010/main" val="3859886456"/>
       </p:ext>
     </p:extLst>
   </p:cSld>
@@ -21217,7 +21210,7 @@
           </a:prstGeom>
           <a:extLst>
             <a:ext uri="{C572A759-6A51-4108-AA02-DFA0A04FC94B}">
-              <ma14:wrappingTextBoxFlag xmlns="" xmlns:ma14="http://schemas.microsoft.com/office/mac/drawingml/2011/main" val="0"/>
+              <ma14:wrappingTextBoxFlag xmlns:ma14="http://schemas.microsoft.com/office/mac/drawingml/2011/main" xmlns="" val="0"/>
             </a:ext>
           </a:extLst>
         </p:spPr>
@@ -21990,7 +21983,7 @@
           </a:prstGeom>
           <a:extLst>
             <a:ext uri="{C572A759-6A51-4108-AA02-DFA0A04FC94B}">
-              <ma14:wrappingTextBoxFlag xmlns:ma14="http://schemas.microsoft.com/office/mac/drawingml/2011/main" xmlns="" val="0"/>
+              <ma14:wrappingTextBoxFlag xmlns="" xmlns:ma14="http://schemas.microsoft.com/office/mac/drawingml/2011/main" val="0"/>
             </a:ext>
           </a:extLst>
         </p:spPr>
@@ -24174,7 +24167,7 @@
           </a:prstGeom>
           <a:extLst>
             <a:ext uri="{C572A759-6A51-4108-AA02-DFA0A04FC94B}">
-              <ma14:wrappingTextBoxFlag xmlns:ma14="http://schemas.microsoft.com/office/mac/drawingml/2011/main" xmlns="" val="0"/>
+              <ma14:wrappingTextBoxFlag xmlns="" xmlns:ma14="http://schemas.microsoft.com/office/mac/drawingml/2011/main" val="0"/>
             </a:ext>
           </a:extLst>
         </p:spPr>
@@ -24947,7 +24940,7 @@
           </a:prstGeom>
           <a:extLst>
             <a:ext uri="{C572A759-6A51-4108-AA02-DFA0A04FC94B}">
-              <ma14:wrappingTextBoxFlag xmlns:ma14="http://schemas.microsoft.com/office/mac/drawingml/2011/main" xmlns="" val="0"/>
+              <ma14:wrappingTextBoxFlag xmlns="" xmlns:ma14="http://schemas.microsoft.com/office/mac/drawingml/2011/main" val="0"/>
             </a:ext>
           </a:extLst>
         </p:spPr>
@@ -26536,7 +26529,7 @@
           </a:prstGeom>
           <a:extLst>
             <a:ext uri="{C572A759-6A51-4108-AA02-DFA0A04FC94B}">
-              <ma14:wrappingTextBoxFlag xmlns:ma14="http://schemas.microsoft.com/office/mac/drawingml/2011/main" xmlns="" val="0"/>
+              <ma14:wrappingTextBoxFlag xmlns="" xmlns:ma14="http://schemas.microsoft.com/office/mac/drawingml/2011/main" val="0"/>
             </a:ext>
           </a:extLst>
         </p:spPr>
@@ -30603,7 +30596,7 @@
           </a:prstGeom>
           <a:extLst>
             <a:ext uri="{C572A759-6A51-4108-AA02-DFA0A04FC94B}">
-              <ma14:wrappingTextBoxFlag xmlns:ma14="http://schemas.microsoft.com/office/mac/drawingml/2011/main" xmlns="" val="0"/>
+              <ma14:wrappingTextBoxFlag xmlns="" xmlns:ma14="http://schemas.microsoft.com/office/mac/drawingml/2011/main" val="0"/>
             </a:ext>
           </a:extLst>
         </p:spPr>

</xml_diff>

<commit_message>
Next-steps slide: the probit card says plainly that it scored poorly because of class imbalance and what replaces it
Co-Authored-By: Claude Fable 5.1 <noreply@anthropic.com>
</commit_message>
<xml_diff>
--- a/docs/FedCast_Fullerton.pptx
+++ b/docs/FedCast_Fullerton.pptx
@@ -3910,7 +3910,11 @@
                   <a:srgbClr val="CADCFC"/>
                 </a:solidFill>
               </a:rPr>
-              <a:t>A forecaster for the next Federal Reserve rate decision, built to be judged by its process rather than its luck</a:t>
+              <a:t>A forecaster for the next Federal Reserve rate decision, built to be judged by its process</a:t>
+            </a:r>
+            <a:r>
+              <a:rPr lang="en-US" dirty="0"/>
+              <a:t>.</a:t>
             </a:r>
             <a:endParaRPr lang="en-US" sz="2000" dirty="0"/>
           </a:p>
@@ -4660,6 +4664,13 @@
             <a:prstDash val="solid"/>
           </a:ln>
         </p:spPr>
+        <p:txBody>
+          <a:bodyPr/>
+          <a:lstStyle/>
+          <a:p>
+            <a:endParaRPr lang="en-US"/>
+          </a:p>
+        </p:txBody>
       </p:sp>
       <p:sp>
         <p:nvSpPr>
@@ -4685,6 +4696,13 @@
             <a:prstDash val="solid"/>
           </a:ln>
         </p:spPr>
+        <p:txBody>
+          <a:bodyPr/>
+          <a:lstStyle/>
+          <a:p>
+            <a:endParaRPr lang="en-US"/>
+          </a:p>
+        </p:txBody>
       </p:sp>
       <p:sp>
         <p:nvSpPr>
@@ -4818,6 +4836,13 @@
             <a:prstDash val="solid"/>
           </a:ln>
         </p:spPr>
+        <p:txBody>
+          <a:bodyPr/>
+          <a:lstStyle/>
+          <a:p>
+            <a:endParaRPr lang="en-US"/>
+          </a:p>
+        </p:txBody>
       </p:sp>
       <p:sp>
         <p:nvSpPr>
@@ -4972,6 +4997,13 @@
             <a:prstDash val="solid"/>
           </a:ln>
         </p:spPr>
+        <p:txBody>
+          <a:bodyPr/>
+          <a:lstStyle/>
+          <a:p>
+            <a:endParaRPr lang="en-US"/>
+          </a:p>
+        </p:txBody>
       </p:sp>
       <p:sp>
         <p:nvSpPr>
@@ -4997,6 +5029,13 @@
             <a:prstDash val="solid"/>
           </a:ln>
         </p:spPr>
+        <p:txBody>
+          <a:bodyPr/>
+          <a:lstStyle/>
+          <a:p>
+            <a:endParaRPr lang="en-US"/>
+          </a:p>
+        </p:txBody>
       </p:sp>
       <p:sp>
         <p:nvSpPr>
@@ -5130,6 +5169,13 @@
             <a:prstDash val="solid"/>
           </a:ln>
         </p:spPr>
+        <p:txBody>
+          <a:bodyPr/>
+          <a:lstStyle/>
+          <a:p>
+            <a:endParaRPr lang="en-US"/>
+          </a:p>
+        </p:txBody>
       </p:sp>
       <p:sp>
         <p:nvSpPr>
@@ -5284,6 +5330,13 @@
             <a:prstDash val="solid"/>
           </a:ln>
         </p:spPr>
+        <p:txBody>
+          <a:bodyPr/>
+          <a:lstStyle/>
+          <a:p>
+            <a:endParaRPr lang="en-US"/>
+          </a:p>
+        </p:txBody>
       </p:sp>
       <p:sp>
         <p:nvSpPr>
@@ -5309,6 +5362,13 @@
             <a:prstDash val="solid"/>
           </a:ln>
         </p:spPr>
+        <p:txBody>
+          <a:bodyPr/>
+          <a:lstStyle/>
+          <a:p>
+            <a:endParaRPr lang="en-US"/>
+          </a:p>
+        </p:txBody>
       </p:sp>
       <p:sp>
         <p:nvSpPr>
@@ -5442,6 +5502,13 @@
             <a:prstDash val="solid"/>
           </a:ln>
         </p:spPr>
+        <p:txBody>
+          <a:bodyPr/>
+          <a:lstStyle/>
+          <a:p>
+            <a:endParaRPr lang="en-US"/>
+          </a:p>
+        </p:txBody>
       </p:sp>
       <p:sp>
         <p:nvSpPr>
@@ -12874,15 +12941,7 @@
                   <a:schemeClr val="tx1"/>
                 </a:solidFill>
               </a:rPr>
-              <a:t>A grading form in the app: a user marks an analyst's answer from 1 to 5 on four questions (did it start from the base rate, argue both sides, say what it was unsure of, say what would prove it wrong). Twenty hand grades become the reference; a model grader is trusted only once it agrees with them. The grade becomes the tenth measured dimension and a </a:t>
-            </a:r>
-            <a:r>
-              <a:rPr lang="en-US" sz="1000">
-                <a:solidFill>
-                  <a:schemeClr val="tx1"/>
-                </a:solidFill>
-              </a:rPr>
-              <a:t>gate on the opinion.</a:t>
+              <a:t>A grading form in the app: a user marks an analyst's answer from 1 to 5 on four questions (did it start from the base rate, argue both sides, say what it was unsure of, say what would prove it wrong). Twenty hand grades become the reference; a model grader is trusted only once it agrees with them. The grade becomes the tenth measured dimension and a gate on the opinion.</a:t>
             </a:r>
             <a:endParaRPr lang="en-US" sz="1000" dirty="0"/>
           </a:p>
@@ -13063,9 +13122,28 @@
                   <a:schemeClr val="tx1"/>
                 </a:solidFill>
               </a:rPr>
-              <a:t>1987, 1998, 2008, 2020: the Fed cut on financial stress, not the data the models read. A watch-out agent that scans for bank failures, funding stress and market dislocations and raises a typed watch-out every analyst must answer.</a:t>
-            </a:r>
+              <a:t>1987, 1998, 2008, 2020: the Fed cut on financial stress, differing from what the models read. </a:t>
+            </a:r>
+          </a:p>
+          <a:p>
+            <a:pPr marL="0" indent="0">
+              <a:buNone/>
+            </a:pPr>
             <a:endParaRPr lang="en-US" sz="1000" dirty="0"/>
+          </a:p>
+          <a:p>
+            <a:pPr marL="0" indent="0">
+              <a:buNone/>
+            </a:pPr>
+            <a:r>
+              <a:rPr lang="en-US" sz="1000" b="1" dirty="0">
+                <a:solidFill>
+                  <a:schemeClr val="tx1"/>
+                </a:solidFill>
+              </a:rPr>
+              <a:t>A watch-out agent that scans for bank failures, funding stress and market dislocations and raises a typed watch-out every analyst must answer.</a:t>
+            </a:r>
+            <a:endParaRPr lang="en-US" sz="1000" b="1" dirty="0"/>
           </a:p>
         </p:txBody>
       </p:sp>
@@ -13208,7 +13286,7 @@
                   <a:schemeClr val="tx2"/>
                 </a:solidFill>
               </a:rPr>
-              <a:t>A second model family</a:t>
+              <a:t>Further validation from second model family. (cheaper?)</a:t>
             </a:r>
             <a:endParaRPr lang="en-US" sz="1300" dirty="0"/>
           </a:p>
@@ -13244,7 +13322,20 @@
                   <a:schemeClr val="tx1"/>
                 </a:solidFill>
               </a:rPr>
-              <a:t>The same harness, the same snapshots, a different language model. If the ladder reads the same, the harness is doing the work, not the model.</a:t>
+              <a:t>The same harness, the same snapshots, a different language model. </a:t>
+            </a:r>
+          </a:p>
+          <a:p>
+            <a:pPr marL="0" indent="0">
+              <a:buNone/>
+            </a:pPr>
+            <a:r>
+              <a:rPr lang="en-US" sz="1000" dirty="0">
+                <a:solidFill>
+                  <a:schemeClr val="tx1"/>
+                </a:solidFill>
+              </a:rPr>
+              <a:t>If the ladder reads the same, the harness is doing the work, not the model.</a:t>
             </a:r>
             <a:endParaRPr lang="en-US" sz="1000" dirty="0"/>
           </a:p>
@@ -13389,7 +13480,7 @@
                   <a:schemeClr val="tx2"/>
                 </a:solidFill>
               </a:rPr>
-              <a:t>Other central banks and geographies</a:t>
+              <a:t>Scale: Other central banks and geographies</a:t>
             </a:r>
             <a:endParaRPr lang="en-US" sz="1300" dirty="0"/>
           </a:p>
@@ -13570,7 +13661,7 @@
                   <a:schemeClr val="tx2"/>
                 </a:solidFill>
               </a:rPr>
-              <a:t>Better classical models</a:t>
+              <a:t>Improvement: Better classical models</a:t>
             </a:r>
             <a:endParaRPr lang="en-US" sz="1300" dirty="0"/>
           </a:p>
@@ -13601,12 +13692,12 @@
               <a:buNone/>
             </a:pPr>
             <a:r>
-              <a:rPr lang="en-US" sz="1000" dirty="0">
+              <a:rPr lang="en-US" sz="1000">
                 <a:solidFill>
                   <a:schemeClr val="tx1"/>
                 </a:solidFill>
               </a:rPr>
-              <a:t>The probit's successor: features written down before fitting, a regularised ordinal model, a reliability check beside the log score, and the expanding window as the only judge. A regularised boosted model as one pre-registered candidate. About 130 usable decisions, 68% holds: small models, honestly tested, not big ones.</a:t>
+              <a:t>Our probit scored poorly. The cause is the data: 68% of decisions are holds and the cuts bunch into a few episodes, so the model learns hold and misses the rest. Replace it with a model built for that imbalance (class weights, or an ordinal model that shrinks toward the base rate), tested only on decisions it has not seen. About 130 usable decisions, so small models.</a:t>
             </a:r>
             <a:endParaRPr lang="en-US" sz="1000" dirty="0"/>
           </a:p>
@@ -16979,7 +17070,7 @@
         </p:nvGraphicFramePr>
         <p:xfrm>
           <a:off x="6172200" y="1783080"/>
-          <a:ext cx="5468112" cy="914400"/>
+          <a:ext cx="5742432" cy="3072384"/>
         </p:xfrm>
         <a:graphic>
           <a:graphicData uri="http://schemas.openxmlformats.org/drawingml/2006/table">
@@ -19775,7 +19866,7 @@
         </p:nvGraphicFramePr>
         <p:xfrm>
           <a:off x="6172200" y="1783080"/>
-          <a:ext cx="5468112" cy="914400"/>
+          <a:ext cx="5742432" cy="1920240"/>
         </p:xfrm>
         <a:graphic>
           <a:graphicData uri="http://schemas.openxmlformats.org/drawingml/2006/table">
@@ -21687,7 +21778,7 @@
         </p:nvSpPr>
         <p:spPr>
           <a:xfrm>
-            <a:off x="5120640" y="1435608"/>
+            <a:off x="5120640" y="1307592"/>
             <a:ext cx="6519672" cy="777240"/>
           </a:xfrm>
           <a:prstGeom prst="rect">
@@ -21700,8 +21791,9 @@
           <a:bodyPr wrap="square" lIns="0" tIns="0" rIns="0" bIns="0" rtlCol="0" anchor="ctr"/>
           <a:lstStyle/>
           <a:p>
-            <a:pPr marL="0" indent="0">
-              <a:buNone/>
+            <a:pPr marL="171450" indent="-171450">
+              <a:buFont typeface="Arial" panose="020B0604020202020204" pitchFamily="34" charset="0"/>
+              <a:buChar char="•"/>
             </a:pPr>
             <a:r>
               <a:rPr lang="en-US" sz="1150" dirty="0">
@@ -21709,7 +21801,7 @@
                   <a:schemeClr val="tx1"/>
                 </a:solidFill>
               </a:rPr>
-              <a:t>The 28 October decision, our final number before it, and what the outcome says. The app: the forecast as it stands today.</a:t>
+              <a:t>The 28 October decision, what our outcome says.</a:t>
             </a:r>
             <a:endParaRPr lang="en-US" sz="1150" dirty="0"/>
           </a:p>
@@ -21827,7 +21919,7 @@
         </p:nvSpPr>
         <p:spPr>
           <a:xfrm>
-            <a:off x="5120640" y="2304288"/>
+            <a:off x="5120640" y="2148840"/>
             <a:ext cx="6519672" cy="777240"/>
           </a:xfrm>
           <a:prstGeom prst="rect">
@@ -21840,8 +21932,9 @@
           <a:bodyPr wrap="square" lIns="0" tIns="0" rIns="0" bIns="0" rtlCol="0" anchor="ctr"/>
           <a:lstStyle/>
           <a:p>
-            <a:pPr marL="0" indent="0">
-              <a:buNone/>
+            <a:pPr marL="171450" indent="-171450">
+              <a:buFont typeface="Arial" panose="020B0604020202020204" pitchFamily="34" charset="0"/>
+              <a:buChar char="•"/>
             </a:pPr>
             <a:r>
               <a:rPr lang="en-US" sz="1150" dirty="0">
@@ -21849,7 +21942,21 @@
                   <a:schemeClr val="tx1"/>
                 </a:solidFill>
               </a:rPr>
-              <a:t>Four kinds of signal already exist; where FedCast sits among them, and the three reasons we built it this way.</a:t>
+              <a:t>Four kinds of signal already exist; </a:t>
+            </a:r>
+          </a:p>
+          <a:p>
+            <a:pPr marL="171450" indent="-171450">
+              <a:buFont typeface="Arial" panose="020B0604020202020204" pitchFamily="34" charset="0"/>
+              <a:buChar char="•"/>
+            </a:pPr>
+            <a:r>
+              <a:rPr lang="en-US" sz="1150" dirty="0">
+                <a:solidFill>
+                  <a:schemeClr val="tx1"/>
+                </a:solidFill>
+              </a:rPr>
+              <a:t>Three reasons we built it this way.</a:t>
             </a:r>
             <a:endParaRPr lang="en-US" sz="1150" dirty="0"/>
           </a:p>
@@ -21980,8 +22087,9 @@
           <a:bodyPr wrap="square" lIns="0" tIns="0" rIns="0" bIns="0" rtlCol="0" anchor="ctr"/>
           <a:lstStyle/>
           <a:p>
-            <a:pPr marL="0" indent="0">
-              <a:buNone/>
+            <a:pPr marL="171450" indent="-171450">
+              <a:buFont typeface="Arial" panose="020B0604020202020204" pitchFamily="34" charset="0"/>
+              <a:buChar char="•"/>
             </a:pPr>
             <a:r>
               <a:rPr lang="en-US" sz="1150" dirty="0">
@@ -21989,7 +22097,25 @@
                   <a:schemeClr val="tx1"/>
                 </a:solidFill>
               </a:rPr>
-              <a:t>Four families of input pooled by code at fixed weights, and the arithmetic from five models to one number. The app: the evidence graph and the pool.</a:t>
+              <a:t>Model Architecture</a:t>
+            </a:r>
+          </a:p>
+          <a:p>
+            <a:pPr marL="171450" indent="-171450">
+              <a:buFont typeface="Arial" panose="020B0604020202020204" pitchFamily="34" charset="0"/>
+              <a:buChar char="•"/>
+            </a:pPr>
+            <a:r>
+              <a:rPr lang="en-US" sz="1150" dirty="0"/>
+              <a:t>A</a:t>
+            </a:r>
+            <a:r>
+              <a:rPr lang="en-US" sz="1150" dirty="0">
+                <a:solidFill>
+                  <a:schemeClr val="tx1"/>
+                </a:solidFill>
+              </a:rPr>
+              <a:t>pp showcase</a:t>
             </a:r>
             <a:endParaRPr lang="en-US" sz="1150" dirty="0"/>
           </a:p>
@@ -22120,8 +22246,9 @@
           <a:bodyPr wrap="square" lIns="0" tIns="0" rIns="0" bIns="0" rtlCol="0" anchor="ctr"/>
           <a:lstStyle/>
           <a:p>
-            <a:pPr marL="0" indent="0">
-              <a:buNone/>
+            <a:pPr marL="171450" indent="-171450">
+              <a:buFont typeface="Arial" panose="020B0604020202020204" pitchFamily="34" charset="0"/>
+              <a:buChar char="•"/>
             </a:pPr>
             <a:r>
               <a:rPr lang="en-US" sz="1150" dirty="0">
@@ -22129,7 +22256,21 @@
                   <a:schemeClr val="tx1"/>
                 </a:solidFill>
               </a:rPr>
-              <a:t>What a language model cannot stop doing and how the harness works around it; the eight analysts; what each is asked and what it returned. The app: the prompts and the results.</a:t>
+              <a:t>Limitations of model and how we workaround it. </a:t>
+            </a:r>
+          </a:p>
+          <a:p>
+            <a:pPr marL="171450" indent="-171450">
+              <a:buFont typeface="Arial" panose="020B0604020202020204" pitchFamily="34" charset="0"/>
+              <a:buChar char="•"/>
+            </a:pPr>
+            <a:r>
+              <a:rPr lang="en-US" sz="1150" dirty="0">
+                <a:solidFill>
+                  <a:schemeClr val="tx1"/>
+                </a:solidFill>
+              </a:rPr>
+              <a:t>The app: the prompts and the results.</a:t>
             </a:r>
             <a:endParaRPr lang="en-US" sz="1150" dirty="0"/>
           </a:p>
@@ -22247,7 +22388,7 @@
         </p:nvSpPr>
         <p:spPr>
           <a:xfrm>
-            <a:off x="5120640" y="4910328"/>
+            <a:off x="5120640" y="4818888"/>
             <a:ext cx="6519672" cy="777240"/>
           </a:xfrm>
           <a:prstGeom prst="rect">
@@ -22260,8 +22401,9 @@
           <a:bodyPr wrap="square" lIns="0" tIns="0" rIns="0" bIns="0" rtlCol="0" anchor="ctr"/>
           <a:lstStyle/>
           <a:p>
-            <a:pPr marL="0" indent="0">
-              <a:buNone/>
+            <a:pPr marL="171450" indent="-171450">
+              <a:buFont typeface="Arial" panose="020B0604020202020204" pitchFamily="34" charset="0"/>
+              <a:buChar char="•"/>
             </a:pPr>
             <a:r>
               <a:rPr lang="en-US" sz="1150" dirty="0">
@@ -22269,7 +22411,7 @@
                   <a:schemeClr val="tx1"/>
                 </a:solidFill>
               </a:rPr>
-              <a:t>What each step of the harness bought, measured on four snapshots. The app: the scorecard, the drift table, the ledger and replay.</a:t>
+              <a:t>Effectiveness of the harness</a:t>
             </a:r>
             <a:endParaRPr lang="en-US" sz="1150" dirty="0"/>
           </a:p>
@@ -22387,7 +22529,7 @@
         </p:nvSpPr>
         <p:spPr>
           <a:xfrm>
-            <a:off x="5120640" y="5779008"/>
+            <a:off x="5120640" y="5596128"/>
             <a:ext cx="6519672" cy="777240"/>
           </a:xfrm>
           <a:prstGeom prst="rect">
@@ -22400,8 +22542,9 @@
           <a:bodyPr wrap="square" lIns="0" tIns="0" rIns="0" bIns="0" rtlCol="0" anchor="ctr"/>
           <a:lstStyle/>
           <a:p>
-            <a:pPr marL="0" indent="0">
-              <a:buNone/>
+            <a:pPr marL="171450" indent="-171450">
+              <a:buFont typeface="Arial" panose="020B0604020202020204" pitchFamily="34" charset="0"/>
+              <a:buChar char="•"/>
             </a:pPr>
             <a:r>
               <a:rPr lang="en-US" sz="1150" dirty="0">
@@ -22409,7 +22552,32 @@
                   <a:schemeClr val="tx1"/>
                 </a:solidFill>
               </a:rPr>
-              <a:t>Six follow-ups in order of value. Appendix: how the analysts' opinion moves the number; the probit.</a:t>
+              <a:t>Follow up</a:t>
+            </a:r>
+          </a:p>
+          <a:p>
+            <a:pPr marL="171450" indent="-171450">
+              <a:buFont typeface="Arial" panose="020B0604020202020204" pitchFamily="34" charset="0"/>
+              <a:buChar char="•"/>
+            </a:pPr>
+            <a:r>
+              <a:rPr lang="en-US" sz="1150" dirty="0" err="1"/>
+              <a:t>QnA</a:t>
+            </a:r>
+            <a:endParaRPr lang="en-US" sz="1150" dirty="0"/>
+          </a:p>
+          <a:p>
+            <a:pPr marL="171450" indent="-171450">
+              <a:buFont typeface="Arial" panose="020B0604020202020204" pitchFamily="34" charset="0"/>
+              <a:buChar char="•"/>
+            </a:pPr>
+            <a:r>
+              <a:rPr lang="en-US" sz="1150" dirty="0">
+                <a:solidFill>
+                  <a:schemeClr val="tx1"/>
+                </a:solidFill>
+              </a:rPr>
+              <a:t>Appendix: how the analysts' opinion moves the number; the probit.</a:t>
             </a:r>
             <a:endParaRPr lang="en-US" sz="1150" dirty="0"/>
           </a:p>
@@ -22863,6 +23031,13 @@
             </a:outerShdw>
           </a:effectLst>
         </p:spPr>
+        <p:txBody>
+          <a:bodyPr/>
+          <a:lstStyle/>
+          <a:p>
+            <a:endParaRPr lang="en-US"/>
+          </a:p>
+        </p:txBody>
       </p:sp>
       <p:sp>
         <p:nvSpPr>
@@ -22966,7 +23141,7 @@
                   <a:schemeClr val="tx1"/>
                 </a:solidFill>
               </a:rPr>
-              <a:t>23 items frozen on 28 October: futures, eight FRED series as first published, both statements, minutes, transcript, projections, speeches, 32 years of decisions, the NY Fed natural rate, prediction-market odds.</a:t>
+              <a:t>23 items frozen on 28 October: futures, eight FRED series as first published, Fed statements, minutes, transcript, projections, speeches, 32 years of decisions, the NY Fed natural rate, prediction-market odds.</a:t>
             </a:r>
             <a:endParaRPr lang="en-US" sz="1000" dirty="0"/>
           </a:p>
@@ -23002,7 +23177,7 @@
                   <a:schemeClr val="tx2"/>
                 </a:solidFill>
               </a:rPr>
-              <a:t>Classic models, pooled by code</a:t>
+              <a:t>Classic models, weighted by code</a:t>
             </a:r>
             <a:endParaRPr lang="en-US" sz="1150" dirty="0"/>
           </a:p>
@@ -23038,9 +23213,17 @@
                   <a:schemeClr val="tx1"/>
                 </a:solidFill>
               </a:rPr>
-              <a:t>Futures-implied 0.6, the Fed's Taylor rules 0.2, prediction-market odds 0.1, historical base rates 0.1; a 1.5% floor on every outcome. Pooled: no change 70.9%, hike 26.2%.</a:t>
-            </a:r>
-            <a:endParaRPr lang="en-US" sz="1000" dirty="0"/>
+              <a:t>Futures-implied 0.6, the Fed's Taylor rules 0.2, prediction-market odds 0.1, historical base rates 0.1; a 1.5% floor on every outcome. Pooled: </a:t>
+            </a:r>
+            <a:r>
+              <a:rPr lang="en-US" sz="1000" b="1" dirty="0">
+                <a:solidFill>
+                  <a:schemeClr val="tx1"/>
+                </a:solidFill>
+              </a:rPr>
+              <a:t>no change 70.9%, hike 26.2%.</a:t>
+            </a:r>
+            <a:endParaRPr lang="en-US" sz="1000" b="1" dirty="0"/>
           </a:p>
         </p:txBody>
       </p:sp>
@@ -23110,9 +23293,35 @@
                   <a:schemeClr val="tx1"/>
                 </a:solidFill>
               </a:rPr>
-              <a:t>Five specialists read the Fed's words; every claim quoted and verified by code. Their mean opinion, +4.0, moves 4 points toward a hike: no change 67.6%, +25 bps 22.4%, +50 bps 7.7%.</a:t>
-            </a:r>
-            <a:endParaRPr lang="en-US" sz="1000" dirty="0"/>
+              <a:t>Five specialists read the Fed's words; every claim quoted and verified by code.</a:t>
+            </a:r>
+          </a:p>
+          <a:p>
+            <a:pPr marL="0" indent="0">
+              <a:buNone/>
+            </a:pPr>
+            <a:r>
+              <a:rPr lang="en-US" sz="1000" dirty="0">
+                <a:solidFill>
+                  <a:schemeClr val="tx1"/>
+                </a:solidFill>
+              </a:rPr>
+              <a:t> Their mean opinion moves 4 points toward a hike: </a:t>
+            </a:r>
+          </a:p>
+          <a:p>
+            <a:pPr marL="0" indent="0">
+              <a:buNone/>
+            </a:pPr>
+            <a:r>
+              <a:rPr lang="en-US" sz="1000" b="1" dirty="0">
+                <a:solidFill>
+                  <a:schemeClr val="tx1"/>
+                </a:solidFill>
+              </a:rPr>
+              <a:t>no change 67.6%, +25 bps 22.4%, +50 bps 7.7%.</a:t>
+            </a:r>
+            <a:endParaRPr lang="en-US" sz="1000" b="1" dirty="0"/>
           </a:p>
         </p:txBody>
       </p:sp>
@@ -23149,6 +23358,13 @@
             </a:outerShdw>
           </a:effectLst>
         </p:spPr>
+        <p:txBody>
+          <a:bodyPr/>
+          <a:lstStyle/>
+          <a:p>
+            <a:endParaRPr lang="en-US"/>
+          </a:p>
+        </p:txBody>
       </p:sp>
       <p:sp>
         <p:nvSpPr>
@@ -23274,7 +23490,7 @@
         </p:nvGraphicFramePr>
         <p:xfrm>
           <a:off x="6400800" y="4114800"/>
-          <a:ext cx="5010912" cy="914400"/>
+          <a:ext cx="5056632" cy="1536192"/>
         </p:xfrm>
         <a:graphic>
           <a:graphicData uri="http://schemas.openxmlformats.org/drawingml/2006/table">
@@ -27170,7 +27386,23 @@
                   <a:schemeClr val="tx1"/>
                 </a:solidFill>
               </a:rPr>
-              <a:t>Eight decisions a year: a good year proves nothing</a:t>
+              <a:t>We are at early stages of model building hence </a:t>
+            </a:r>
+            <a:r>
+              <a:rPr lang="en-US" sz="1300" b="1" dirty="0">
+                <a:solidFill>
+                  <a:schemeClr val="tx1"/>
+                </a:solidFill>
+              </a:rPr>
+              <a:t>process takes precedence over results</a:t>
+            </a:r>
+            <a:r>
+              <a:rPr lang="en-US" sz="1300" dirty="0">
+                <a:solidFill>
+                  <a:schemeClr val="tx1"/>
+                </a:solidFill>
+              </a:rPr>
+              <a:t>.</a:t>
             </a:r>
             <a:endParaRPr lang="en-US" sz="1300" dirty="0"/>
           </a:p>
@@ -27188,7 +27420,87 @@
                   <a:schemeClr val="tx1"/>
                 </a:solidFill>
               </a:rPr>
-              <a:t>The yardstick is a ten-point scorecard, fixed before any code: same evidence, same answer? every claim quoted? any number from memory? a shock moves the number the right way?</a:t>
+              <a:t>A good repeatable process ensures repeatability: </a:t>
+            </a:r>
+          </a:p>
+          <a:p>
+            <a:pPr marL="800100" lvl="1" indent="-342900">
+              <a:spcAft>
+                <a:spcPts val="800"/>
+              </a:spcAft>
+              <a:buSzPct val="100000"/>
+              <a:buChar char="•"/>
+            </a:pPr>
+            <a:r>
+              <a:rPr lang="en-US" sz="1300" dirty="0"/>
+              <a:t>S</a:t>
+            </a:r>
+            <a:r>
+              <a:rPr lang="en-US" sz="1300" dirty="0">
+                <a:solidFill>
+                  <a:schemeClr val="tx1"/>
+                </a:solidFill>
+              </a:rPr>
+              <a:t>ame evidence, same answer?</a:t>
+            </a:r>
+          </a:p>
+          <a:p>
+            <a:pPr marL="800100" lvl="1" indent="-342900">
+              <a:spcAft>
+                <a:spcPts val="800"/>
+              </a:spcAft>
+              <a:buSzPct val="100000"/>
+              <a:buChar char="•"/>
+            </a:pPr>
+            <a:r>
+              <a:rPr lang="en-US" sz="1300" dirty="0"/>
+              <a:t>Is </a:t>
+            </a:r>
+            <a:r>
+              <a:rPr lang="en-US" sz="1300" dirty="0">
+                <a:solidFill>
+                  <a:schemeClr val="tx1"/>
+                </a:solidFill>
+              </a:rPr>
+              <a:t>every claim quoted? </a:t>
+            </a:r>
+          </a:p>
+          <a:p>
+            <a:pPr marL="800100" lvl="1" indent="-342900">
+              <a:spcAft>
+                <a:spcPts val="800"/>
+              </a:spcAft>
+              <a:buSzPct val="100000"/>
+              <a:buChar char="•"/>
+            </a:pPr>
+            <a:r>
+              <a:rPr lang="en-US" sz="1300" dirty="0">
+                <a:solidFill>
+                  <a:schemeClr val="tx1"/>
+                </a:solidFill>
+              </a:rPr>
+              <a:t>any number from memory? </a:t>
+            </a:r>
+          </a:p>
+          <a:p>
+            <a:pPr marL="800100" lvl="1" indent="-342900">
+              <a:spcAft>
+                <a:spcPts val="800"/>
+              </a:spcAft>
+              <a:buSzPct val="100000"/>
+              <a:buChar char="•"/>
+            </a:pPr>
+            <a:r>
+              <a:rPr lang="en-US" sz="1300" dirty="0"/>
+              <a:t>Does </a:t>
+            </a:r>
+            <a:r>
+              <a:rPr lang="en-US" sz="1300" dirty="0">
+                <a:solidFill>
+                  <a:schemeClr val="tx1"/>
+                </a:solidFill>
+              </a:rPr>
+              <a:t>a shock moves the number the right way?</a:t>
             </a:r>
             <a:endParaRPr lang="en-US" sz="1300" dirty="0"/>
           </a:p>
@@ -27351,7 +27663,7 @@
                   <a:schemeClr val="tx2"/>
                 </a:solidFill>
               </a:rPr>
-              <a:t>Every step is auditable</a:t>
+              <a:t>We build every step to be auditable</a:t>
             </a:r>
             <a:endParaRPr lang="en-US" sz="1500" dirty="0"/>
           </a:p>
@@ -27409,9 +27721,17 @@
                   <a:schemeClr val="tx1"/>
                 </a:solidFill>
               </a:rPr>
-              <a:t>Every number it uses must exist in the frozen evidence, or it is flagged as from memory</a:t>
-            </a:r>
-            <a:endParaRPr lang="en-US" sz="1300" dirty="0"/>
+              <a:t>Every number it uses must exist in the frozen evidence, or </a:t>
+            </a:r>
+            <a:r>
+              <a:rPr lang="en-US" sz="1300" b="1" dirty="0">
+                <a:solidFill>
+                  <a:schemeClr val="tx1"/>
+                </a:solidFill>
+              </a:rPr>
+              <a:t>it is flagged as from memory</a:t>
+            </a:r>
+            <a:endParaRPr lang="en-US" sz="1300" b="1" dirty="0"/>
           </a:p>
           <a:p>
             <a:pPr marL="342900" indent="-342900">
@@ -27429,7 +27749,27 @@
               </a:rPr>
               <a:t>Every model lists the items it read; every ledger entry recomputes from its snapshot. If it is not quoted, it does not count</a:t>
             </a:r>
-            <a:endParaRPr lang="en-US" sz="1300" dirty="0"/>
+          </a:p>
+          <a:p>
+            <a:pPr marL="342900" indent="-342900">
+              <a:spcAft>
+                <a:spcPts val="800"/>
+              </a:spcAft>
+              <a:buSzPct val="100000"/>
+              <a:buChar char="•"/>
+            </a:pPr>
+            <a:r>
+              <a:rPr lang="en-US" sz="1300" dirty="0"/>
+              <a:t>We believe that this method allows us to </a:t>
+            </a:r>
+            <a:r>
+              <a:rPr lang="en-US" sz="1300" b="1" dirty="0"/>
+              <a:t>use less expensive models </a:t>
+            </a:r>
+            <a:r>
+              <a:rPr lang="en-US" sz="1300" dirty="0"/>
+              <a:t>as well</a:t>
+            </a:r>
           </a:p>
         </p:txBody>
       </p:sp>
@@ -27612,7 +27952,7 @@
                   <a:schemeClr val="tx1"/>
                 </a:solidFill>
               </a:rPr>
-              <a:t>Everything is quotable and the analysts can read only the evidence, so a wrong call is a traceable wrong call: we see which quote led where</a:t>
+              <a:t>Since is quotable and the human analyst can read only the evidence, so a wrong call is a traceable wrong call: we see which quote led were.</a:t>
             </a:r>
             <a:endParaRPr lang="en-US" sz="1300" dirty="0"/>
           </a:p>
@@ -27758,7 +28098,7 @@
                   <a:schemeClr val="tx2"/>
                 </a:solidFill>
               </a:rPr>
-              <a:t>Model architecture</a:t>
+              <a:t>Model architecture: Ensemble model</a:t>
             </a:r>
             <a:endParaRPr lang="en-US" sz="3200" dirty="0"/>
           </a:p>
@@ -28412,9 +28752,31 @@
                   <a:schemeClr val="tx1"/>
                 </a:solidFill>
               </a:rPr>
-              <a:t>Weights 0.6 / 0.2 / 0.1 / 0.1, fixed and published. A 1.5% floor on every outcome. Then the analysts' opinion, capped at 10 points. Code does this; no model writes the number.</a:t>
-            </a:r>
+              <a:t>Weights 0.6 / 0.2 / 0.1 / 0.1, fixed and published. A 1.5% floor on every outcome.</a:t>
+            </a:r>
+          </a:p>
+          <a:p>
+            <a:pPr marL="0" indent="0" algn="ctr">
+              <a:buNone/>
+            </a:pPr>
             <a:endParaRPr lang="en-US" sz="950" dirty="0"/>
+          </a:p>
+          <a:p>
+            <a:pPr marL="0" indent="0" algn="ctr">
+              <a:buNone/>
+            </a:pPr>
+            <a:r>
+              <a:rPr lang="en-US" sz="950" dirty="0">
+                <a:solidFill>
+                  <a:schemeClr val="tx1"/>
+                </a:solidFill>
+              </a:rPr>
+              <a:t> </a:t>
+            </a:r>
+            <a:r>
+              <a:rPr lang="en-US" sz="950" dirty="0"/>
+              <a:t>LLM analyst opinions then skew it.</a:t>
+            </a:r>
           </a:p>
         </p:txBody>
       </p:sp>

</xml_diff>

<commit_message>
Deck final pass: typos and broken sentence fixed (slides 7, 9, 12), headline no longer wraps (15), 'opinion' in the appendix and backup, plain probit text (23); talking-point notes with timings on all 23 slides
Co-Authored-By: Claude Fable 5.1 <noreply@anthropic.com>
</commit_message>
<xml_diff>
--- a/docs/FedCast_Fullerton.pptx
+++ b/docs/FedCast_Fullerton.pptx
@@ -1091,9 +1091,16 @@
           <a:lstStyle/>
           <a:p>
             <a:r>
-              <a:rPr lang="en-US" dirty="0"/>
-              <a:t>Before the session: start the app (fedcast ui), press Pull evidence then Run forecast so the top bar reads 'under an hour ago', open the Forecast view, and have the Evidence graph, Analyst prompts, Analyst results and Scorecard tabs one click away. Open with the one-line thesis: a language model inside an engineered harness gives forecasts that are measurably more repeatable and more faithful to evidence than the same model asked naively, and the way to prove it is to measure the process, not to wait for eight decisions a year to come true.</a:t>
-            </a:r>
+              <a:rPr lang="en-US"/>
+              <a:t>BEFORE: app open at localhost:8765, evidence pulled today, Forecast view showing the December number. Tabs ready: Evidence graph, Analyst prompts, Analyst results, Scorecard, Ledger.</a:t>
+            </a:r>
+          </a:p>
+          <a:p>
+            <a:r>
+              <a:rPr lang="en-US"/>
+              <a:t>OPEN (30 s): one sentence. A forecaster for the next Fed decision, built to be judged by its process, not its luck. Today: how it called 28 October, how it is built, what the language model is allowed to do, and how we prove it behaves.</a:t>
+            </a:r>
+            <a:endParaRPr lang="en-US" dirty="0"/>
           </a:p>
         </p:txBody>
       </p:sp>
@@ -1178,9 +1185,10 @@
           <a:lstStyle/>
           <a:p>
             <a:r>
-              <a:rPr lang="en-US" dirty="0"/>
-              <a:t>This is the longest demo. Start at the raw futures price so the audience sees arithmetic, not a black box. Then the pool box, then one click into an evidence item to show the frozen text.</a:t>
-            </a:r>
+              <a:rPr lang="en-US"/>
+              <a:t>DEMO 2, 3 MIN, the longest. Evidence graph: click Market-implied (futures price, 100 minus price, expected change, the 90/10 split: arithmetic, not a black box). Click Pool (weights, pooled line, the specialists' opinion line, Machine track). Click one evidence item (frozen text, link to the original). Say: blue is in the number, grey is computed but not in it; the language model's opinion is one line between Pooled and Machine track: it can tilt, it cannot write.</a:t>
+            </a:r>
+            <a:endParaRPr lang="en-US" dirty="0"/>
           </a:p>
         </p:txBody>
       </p:sp>
@@ -1265,9 +1273,10 @@
           <a:lstStyle/>
           <a:p>
             <a:r>
-              <a:rPr lang="en-US" dirty="0"/>
-              <a:t>Three things a language model cannot be made to stop doing: it remembers, it varies between runs, and it can invent support. None is removed; each is designed around. The proof is on the harness slide later.</a:t>
-            </a:r>
+              <a:rPr lang="en-US"/>
+              <a:t>2 MIN. Three things a language model cannot be made to stop doing. Memory: instruction, quote per claim, every number checked, sent back once. Variance: fixed schema, five identical runs, the spread measured, pass mark 2 points. Invented support: every quote matched by code character for character, bounds, one repair round. Say: 'none is removed; each is designed around, and measured.' The proof comes two slides later.</a:t>
+            </a:r>
+            <a:endParaRPr lang="en-US" dirty="0"/>
           </a:p>
         </p:txBody>
       </p:sp>
@@ -1352,9 +1361,10 @@
           <a:lstStyle/>
           <a:p>
             <a:r>
-              <a:rPr lang="en-US" dirty="0"/>
-              <a:t>One model, the same frozen evidence, eight configurations. Left: analysts 1 to 3 are controls, drawn grey and dashed; they never enter the number. Right: the five specialists that do. Every analyst runs five times on the same snapshot; for 1 to 3 those runs build the benchmark 4 to 8 are measured against. Analyst 1 sets the baseline (variance, numbers from memory, nothing quoted); 2 tests what immutable evidence fixes; 3 tests the answer shape and code verification. Each rung adds one thing, so the change in the measurements is the value of that thing.</a:t>
-            </a:r>
+              <a:rPr lang="en-US"/>
+              <a:t>2 MIN. Left, the three controls, grey and dashed: they never enter the number. 1 naive: the question only. 2: evidence shown, free text. 3: same evidence, fixed shape, verifier. Right, the five specialists that do enter: one slice each, the same shape and verifier. Each is asked a question about its slice, never a probability; it returns quoted claims and an opinion from -10 to +10. Bottom: every analyst runs five times; 1 to 3 build the benchmark 4 to 8 are measured against.</a:t>
+            </a:r>
+            <a:endParaRPr lang="en-US" dirty="0"/>
           </a:p>
         </p:txBody>
       </p:sp>
@@ -1439,9 +1449,10 @@
           <a:lstStyle/>
           <a:p>
             <a:r>
-              <a:rPr lang="en-US" dirty="0"/>
-              <a:t>Open analyst 1 first so the contrast with analyst 6 lands. Scroll the full prompt slowly past the schema and the pre-read; do not read it out.</a:t>
-            </a:r>
+              <a:rPr lang="en-US"/>
+              <a:t>DEMO 3, 2 MIN. Analyst prompts view. Open analyst 1: 195 characters, no evidence. Open analyst 6: the system prompt, the schema (claims with quote and item id; the opinion bounded -10 to +10), the inflation pre-read, the item ids. Say: 'if it is not on this page, the analyst does not get it; the only difference between analyst 1 and analyst 6 is this page.'</a:t>
+            </a:r>
+            <a:endParaRPr lang="en-US" dirty="0"/>
           </a:p>
         </p:txBody>
       </p:sp>
@@ -1526,17 +1537,16 @@
           <a:lstStyle/>
           <a:p>
             <a:r>
-              <a:rPr lang="en-US" dirty="0"/>
-              <a:t>Three charts, one per dimension, averaged over the four snapshots. Left: how much the answer moves between identical runs. The step that matters is analyst 2 to analyst 3: the answer shape and the verifier take the wobble from three and a half points to under one. Middle: numbers from memory, gone as soon as the evidence is shown. Right: share of claims whose quote code found verbatim; analyst 2 cannot be measured because it quotes nothing. The specialists keep what analyst 3 achieved. For analysts 3 to 8 the wobble is </a:t>
-            </a:r>
-            <a:r>
               <a:rPr lang="en-US"/>
-              <a:t>in their opinion, which is already in points of probability, </a:t>
-            </a:r>
-            <a:r>
-              <a:rPr lang="en-US" dirty="0"/>
-              <a:t>so the four bars are comparable.</a:t>
-            </a:r>
+              <a:t>2 MIN. THIS IS THE PROOF. Left chart: wobble between identical runs, 4.2 for the naive model, 3.5 with evidence, 0.6 with the answer shape and verifier, 0.8 for the specialists. Middle: numbers from memory, 37 to 0 as soon as evidence is shown. Right: quoted claims, 0 to 99.7%.</a:t>
+            </a:r>
+          </a:p>
+          <a:p>
+            <a:r>
+              <a:rPr lang="en-US"/>
+              <a:t>Say: 'the step from analyst 2 to analyst 3 is the harness. Evidence alone does not make the model repeatable; the answer shape plus code verification does. Specialists keep that and add attribution.'</a:t>
+            </a:r>
+            <a:endParaRPr lang="en-US" dirty="0"/>
           </a:p>
         </p:txBody>
       </p:sp>
@@ -1621,17 +1631,10 @@
           <a:lstStyle/>
           <a:p>
             <a:r>
-              <a:rPr lang="en-US" dirty="0"/>
-              <a:t>One line of method, then the outcome. Each specialist runs five times on the same frozen snapshot; the five answers must sit within the variance pass mark, every claim must carry a quote code finds, and no number may come from memory. Only then </a:t>
-            </a:r>
-            <a:r>
               <a:rPr lang="en-US"/>
-              <a:t>does the opinion count. </a:t>
-            </a:r>
-            <a:r>
-              <a:rPr lang="en-US" dirty="0"/>
-              <a:t>The band is the 28 October run; bottom left is what the five said and what it did to the number; bottom right is one claim as recorded, with the quote code found.</a:t>
-            </a:r>
+              <a:t>2 MIN. The 28 October run: 25 runs, 25 prompts, 263 claims, all 263 verified, 0 numbers from memory, five opinions. Four say hike, labour says hold; mean +4.0; 4 points moved toward a hike: +25 from 20.2 to 22.4. Right: one real claim with its quote found by code in the September statement. Say: 'two dissents for a hike is that opinion, in the vote.'</a:t>
+            </a:r>
+            <a:endParaRPr lang="en-US" dirty="0"/>
           </a:p>
         </p:txBody>
       </p:sp>
@@ -1716,9 +1719,10 @@
           <a:lstStyle/>
           <a:p>
             <a:r>
-              <a:rPr lang="en-US" dirty="0"/>
-              <a:t>If asked where a quote comes from, open the statement claim on analyst 4: the quote is the statement's own line, found by code in item fed.statement.2026-09-16.</a:t>
-            </a:r>
+              <a:rPr lang="en-US"/>
+              <a:t>DEMO 4, 2 MIN. Analyst results. Analyst 1 card: a cut, numbers from memory flagged. Analyst 4 card: opinion, grounded, leaked, watch-out badges; one claim with its quote and the verified mark. If asked where a quote comes from, open the statement claim on analyst 4: the statement's own line, found by code.</a:t>
+            </a:r>
+            <a:endParaRPr lang="en-US" dirty="0"/>
           </a:p>
         </p:txBody>
       </p:sp>
@@ -1803,9 +1807,10 @@
           <a:lstStyle/>
           <a:p>
             <a:r>
-              <a:rPr lang="en-US" dirty="0"/>
-              <a:t>If time is short, skip the dropdown and go straight to the over-time table.</a:t>
-            </a:r>
+              <a:rPr lang="en-US"/>
+              <a:t>DEMO 5, 2 MIN. Scorecard view. Pick 24 October, then 28 October in the dropdown; expand 'what was checked' under Shock direction (seven shocks, each with its delta); scroll to the over-time table. Say: 'red in the control columns is expected; red on the right would be a defect. Two red cells have already pointed at defects, both fixed.' If short on time, go straight to the over-time table.</a:t>
+            </a:r>
+            <a:endParaRPr lang="en-US" dirty="0"/>
           </a:p>
         </p:txBody>
       </p:sp>
@@ -1890,9 +1895,10 @@
           <a:lstStyle/>
           <a:p>
             <a:r>
-              <a:rPr lang="en-US" dirty="0"/>
-              <a:t>One minute. Press the button, read the result line, move on.</a:t>
-            </a:r>
+              <a:rPr lang="en-US"/>
+              <a:t>DEMO 6, 1 MIN. Ledger view, press Verify ledger. Read the result line: chain intact, entries under the current spec recompute exactly. Say: 'nothing here can be edited without the chain breaking; any entry recomputes from its snapshot; eight numbered amendments, each with its reason.' Move on.</a:t>
+            </a:r>
+            <a:endParaRPr lang="en-US" dirty="0"/>
           </a:p>
         </p:txBody>
       </p:sp>
@@ -1977,9 +1983,10 @@
           <a:lstStyle/>
           <a:p>
             <a:r>
-              <a:rPr lang="en-US" dirty="0"/>
-              <a:t>Six follow-ups, in order of value. One: pre-registered weight sets scored on every live decision, so the weights stop being judgement. Two: reasoning quality graded by people in the app, which becomes the tenth measured dimension and a gate. Three: an events agent for the regime shifts the models cannot read. Four: a second model family to show the harness, not the model, does the work. Five: other central banks; the chain needs a calendar, a rate series, the statements and a curve, and the scorecard transfers unchanged. Six: better classical models, judged by the expanding window only.</a:t>
-            </a:r>
+              <a:rPr lang="en-US"/>
+              <a:t>2 MIN. December is on file (entry #23, +25 at 73.6%). Six follow-ups in order of value: 1 pre-registered weight sets scored on every live decision; 2 reasoning quality graded by people in the app, the grader trusted only once it agrees with the hand grades; 3 an events agent for regime shifts; 4 a second model family; 5 other central banks, same chain; 6 a classical model built for class imbalance. Ask the room which they would do first.</a:t>
+            </a:r>
+            <a:endParaRPr lang="en-US" dirty="0"/>
           </a:p>
         </p:txBody>
       </p:sp>
@@ -2064,9 +2071,16 @@
           <a:lstStyle/>
           <a:p>
             <a:r>
-              <a:rPr lang="en-US" dirty="0"/>
-              <a:t>One minute. The thread: every system on the right put a model's output in front of people making live decisions, and the hard part was never the model, it was earning trust in what it said. FedCast is that problem made explicit and measurable.</a:t>
-            </a:r>
+              <a:rPr lang="en-US"/>
+              <a:t>1 MIN. Thread: every system here put a model's output in front of people making live decisions; the hard part was never the model, it was earning trust in what it said. FedCast is that problem made measurable.</a:t>
+            </a:r>
+          </a:p>
+          <a:p>
+            <a:r>
+              <a:rPr lang="en-US"/>
+              <a:t>Do not read the cards; pick one (investment analytics, COVID) and move on.</a:t>
+            </a:r>
+            <a:endParaRPr lang="en-US" dirty="0"/>
           </a:p>
         </p:txBody>
       </p:sp>
@@ -2151,9 +2165,10 @@
           <a:lstStyle/>
           <a:p>
             <a:r>
-              <a:rPr lang="en-US" dirty="0"/>
-              <a:t>Close on the ask. The forecast for 28 October is on file; the scoring is automatic from here; what the room can add is scrutiny and the next target.</a:t>
-            </a:r>
+              <a:rPr lang="en-US"/>
+              <a:t>1 MIN. Close on the three lines, then the ask: scrutinise the scorecard, challenge a quote, name the next decision that deserves the same chain. Questions.</a:t>
+            </a:r>
+            <a:endParaRPr lang="en-US" dirty="0"/>
           </a:p>
         </p:txBody>
       </p:sp>
@@ -2238,9 +2253,10 @@
           <a:lstStyle/>
           <a:p>
             <a:r>
-              <a:rPr lang="en-US" dirty="0"/>
-              <a:t>Read left to right as an evolution. Analyst 1 wobbles by three to five points between identical runs, cites nothing, and leaks three dozen numbers from memory; it still thinks the Fed is cutting. Adding the evidence (analyst 2) removes the leaks but not the wobble, and nothing can be checked. Adding the answer shape and the verifier (analyst 3) is the step that makes the output stable and fully verifiable. Specialists (4 to 8) keep that and add attribution. Same model, same day; the difference at each step is the one thing added.</a:t>
-            </a:r>
+              <a:rPr lang="en-US"/>
+              <a:t>BACKUP. The full ladder table, four snapshots. Use if someone asks for the numbers behind the charts on slide 14.</a:t>
+            </a:r>
+            <a:endParaRPr lang="en-US" dirty="0"/>
           </a:p>
         </p:txBody>
       </p:sp>
@@ -2325,9 +2341,10 @@
           <a:lstStyle/>
           <a:p>
             <a:r>
-              <a:rPr lang="en-US" dirty="0"/>
-              <a:t>Three parts. The score: already in points of probability, capped at 10 like a human view. The average: one vote each. The spread: the points leave every bucket on the hold-or-cut side and land on both hike buckets, in proportion to size and distance from the middle, so the shape of the distribution is kept and nothing goes to zero.</a:t>
-            </a:r>
+              <a:rPr lang="en-US"/>
+              <a:t>APPENDIX. Use if asked how +4.0 moves the number. Three parts: the opinion (points of probability, capped at 10 like a human view); the average (one vote each); the spread (each bucket re-weighted by e to the steepness times its position, rescaled; the steepness is searched so exactly 4 points cross). The table is entry #18.</a:t>
+            </a:r>
+            <a:endParaRPr lang="en-US" dirty="0"/>
           </a:p>
         </p:txBody>
       </p:sp>
@@ -2412,9 +2429,10 @@
           <a:lstStyle/>
           <a:p>
             <a:r>
-              <a:rPr lang="en-US" dirty="0"/>
-              <a:t>The quant side's own test. A first ordered probit, spec frozen before fitting, failed its out-of-sample gate and was reported, not tuned. A second version beats the base rate on the expanding window but was specified after seeing the first fail, so it carries a contamination caveat and waits for live decisions. The base rates, which need no fitting, beat the fitted model and are the yardstick. Below: why no gradient-boosted anything.</a:t>
-            </a:r>
+              <a:rPr lang="en-US"/>
+              <a:t>APPENDIX. Use if asked about the probit or classic ML. v1 failed its gate; v2 beats the base rate but was specified after seeing v1 fail, so it is caveated and sits at weight 0. The base rate given the previous decision beat the fitted model and is in the pool. Small, unbalanced sample: no big models.</a:t>
+            </a:r>
+            <a:endParaRPr lang="en-US" dirty="0"/>
           </a:p>
         </p:txBody>
       </p:sp>
@@ -2499,9 +2517,10 @@
           <a:lstStyle/>
           <a:p>
             <a:r>
-              <a:rPr lang="en-US" dirty="0"/>
-              <a:t>One minute. The thread: a decision was made, here is how we called it, why we built the tool this way, how the number is put together, what the language model is allowed to do and how we prove it behaves, and what comes next. Six stops, with the app opened between them.</a:t>
-            </a:r>
+              <a:rPr lang="en-US"/>
+              <a:t>30 S. Six stops in this order; the app opens between them. Say: 'what happened, why we built it this way, how the number is built, what the LLM may do, how we prove it, what is next.'</a:t>
+            </a:r>
+            <a:endParaRPr lang="en-US" dirty="0"/>
           </a:p>
         </p:txBody>
       </p:sp>
@@ -2586,9 +2605,28 @@
           <a:lstStyle/>
           <a:p>
             <a:r>
-              <a:rPr lang="en-US" dirty="0"/>
-              <a:t>Left, three points: where the numbers come from, the pool of classic models, the LLM analysts on top. Right, three points: we hit the target but so did the market and the odds, and we do not claim to beat them at five weeks; the LLM analysts got the direction right, and the table shows each one's opinion against the vote; every reason is a quote found in the evidence, and one decision proves little, so the scoring is formal and the rest of the talk is about process.</a:t>
-            </a:r>
+              <a:rPr lang="en-US"/>
+              <a:t>2 MIN. Top row left to right: the date, our number nine hours before, what the Fed did, the vote.</a:t>
+            </a:r>
+          </a:p>
+          <a:p>
+            <a:r>
+              <a:rPr lang="en-US"/>
+              <a:t>LEFT, three points: 23 frozen items; four classic models pooled by code at fixed weights (70.9% no change); five LLM analysts on top, opinion +4.0, final 67.6%.</a:t>
+            </a:r>
+          </a:p>
+          <a:p>
+            <a:r>
+              <a:rPr lang="en-US"/>
+              <a:t>RIGHT, three points: we hit the target, so did the market and the odds, no claim to beat them at five weeks; the LLM analysts got the direction right, table: four hawks, labour the dove, mean +4.0, and the vote had two dissents for a hike; every reason is a quote, one decision proves little, scored formally when the rate row lands.</a:t>
+            </a:r>
+          </a:p>
+          <a:p>
+            <a:r>
+              <a:rPr lang="en-US"/>
+              <a:t>Then: 'the rest of this talk is how that number was made and why you can trust the process.'</a:t>
+            </a:r>
+            <a:endParaRPr lang="en-US" dirty="0"/>
           </a:p>
         </p:txBody>
       </p:sp>
@@ -2673,9 +2711,10 @@
           <a:lstStyle/>
           <a:p>
             <a:r>
-              <a:rPr lang="en-US" dirty="0"/>
-              <a:t>Keep this to one minute. The point is only that the number exists, is dated, and is traceable. Do not explain the models yet.</a:t>
-            </a:r>
+              <a:rPr lang="en-US"/>
+              <a:t>DEMO 1, 1 MIN. Forecast view. Point at the two tracks, the meta line (entry, snapshot hash, specialists' opinion), the five bars. Say: made at &lt;time&gt; from evidence frozen at &lt;time&gt;; everything next is how it got there. Do not explain models yet.</a:t>
+            </a:r>
+            <a:endParaRPr lang="en-US" dirty="0"/>
           </a:p>
         </p:txBody>
       </p:sp>
@@ -2760,9 +2799,16 @@
           <a:lstStyle/>
           <a:p>
             <a:r>
-              <a:rPr lang="en-US" dirty="0"/>
-              <a:t>Four kinds of signal exist already; each is good at one thing. Market prices are the best single predictor at thirty days and are the anchor of the pool. Surveys carry judgement; FedCast takes the data the committee reads instead, as history and a fitted model. The rules are the Fed's own benchmarks. The LLM papers show a model can read the Fed, on sixteen meetings. FedCast's claim is not a better guess but the combination: one of each kind, pooled by code at fixed weights, every number traceable to frozen evidence.</a:t>
-            </a:r>
+              <a:rPr lang="en-US"/>
+              <a:t>2 MIN. Four kinds of signal exist; each good at one thing. Market prices: best single predictor at 30 days, about 88% right, the anchor of our pool. Rules: transparent, but r* and u* are unobservable. Surveys: slow. LLM papers: 90%+ on sixteen meetings, no verification, no replay.</a:t>
+            </a:r>
+          </a:p>
+          <a:p>
+            <a:r>
+              <a:rPr lang="en-US"/>
+              <a:t>The line: pure data on the left, pure model on the right. FedCast in the middle: one input from each, combined by code at fixed weights. 'Neither a formula nor an oracle.'</a:t>
+            </a:r>
+            <a:endParaRPr lang="en-US" dirty="0"/>
           </a:p>
         </p:txBody>
       </p:sp>
@@ -2847,9 +2893,16 @@
           <a:lstStyle/>
           <a:p>
             <a:r>
-              <a:rPr lang="en-US" dirty="0"/>
-              <a:t>Three reasons, the first is the one to land. Eight decisions a year cannot tell skill from luck, so we judge the process with a scorecard fixed before any code. Second, auditable means concrete: an analyst that says inflation is elevated must quote the line it read and code must find it. Third, because everything is quotable and the analysts can read only the evidence, a wrong call is a traceable wrong call, and because the harness is repeatable it goes wrong the same way every time, so a fix can be tested and stays fixed. Details later in the deck: the ladder, the scorecard, the drift table.</a:t>
-            </a:r>
+              <a:rPr lang="en-US"/>
+              <a:t>2 MIN. The one to land is point 1: eight decisions a year cannot tell skill from luck, so we judge the process, with questions fixed before any code: same evidence same answer, every claim quoted, no number from memory, shocks move the number the right way. Outcomes logged, never used to tune.</a:t>
+            </a:r>
+          </a:p>
+          <a:p>
+            <a:r>
+              <a:rPr lang="en-US"/>
+              <a:t>Point 2, concrete: an analyst that says inflation is elevated must quote the line, and code checks it. Point 3: because everything is quotable and repeatable, a wrong call is traceable and a fix stays fixed: audit, fix, re-measure.</a:t>
+            </a:r>
+            <a:endParaRPr lang="en-US" dirty="0"/>
           </a:p>
         </p:txBody>
       </p:sp>
@@ -2934,9 +2987,16 @@
           <a:lstStyle/>
           <a:p>
             <a:r>
-              <a:rPr lang="en-US" dirty="0"/>
-              <a:t>Left: the diagram from the brief. Four families of input, combined by code with fixed, published weights; no model writes the number. The language-model family enters only as a bounded opinion. Right: the chain in order, each line a view in the app. Walk the diagram first, then the chain.</a:t>
-            </a:r>
+              <a:rPr lang="en-US"/>
+              <a:t>2 MIN. Left, the four families: economic predictors (futures, Taylor rules, odds), empirical history, classic ML (probit, weight 0), LLM-derived (bounded opinion, not a weight). Pooled by code; no model writes the number.</a:t>
+            </a:r>
+          </a:p>
+          <a:p>
+            <a:r>
+              <a:rPr lang="en-US"/>
+              <a:t>Right, the chain in order: evidence, signals, pool, analysts (only 4 to 8 enter; 1 to 3 are controls), you (bounded, typed channels), ledger. Say: 'every line here is a view in the app.'</a:t>
+            </a:r>
+            <a:endParaRPr lang="en-US" dirty="0"/>
           </a:p>
         </p:txBody>
       </p:sp>
@@ -3021,25 +3081,16 @@
           <a:lstStyle/>
           <a:p>
             <a:r>
-              <a:rPr lang="en-US" dirty="0"/>
-              <a:t>Entry 18, the final one before the meeting. The pool is a weighted average, then the floor. The specialists</a:t>
-            </a:r>
-            <a:r>
               <a:rPr lang="en-US"/>
-              <a:t>' mean score of +4.0 is 4.0 points of probability </a:t>
-            </a:r>
-            <a:r>
-              <a:rPr lang="en-US" dirty="0"/>
-              <a:t>moved toward a hike, through the same capped mechanism a human view uses</a:t>
-            </a:r>
+              <a:t>2 MIN. Read the table top to bottom: what each model reads, its distribution, its weight. Pooled line: weighted average then the 1.5% floor (no outcome below 1.5%, so nothing is ever called impossible). The tinted row: the specialists' opinion, +4.0, moves 4 points toward a hike, after the pool, capped at 10. Machine forecast: 67.6 / 22.4 / 7.7.</a:t>
+            </a:r>
+          </a:p>
+          <a:p>
             <a:r>
               <a:rPr lang="en-US"/>
-              <a:t>. The opinion </a:t>
-            </a:r>
-            <a:r>
-              <a:rPr lang="en-US" dirty="0"/>
-              <a:t>row is tinted and labelled 'after pooling': it is a modifier on the pooled number, not a model in the pool. Then the footer: the weights are judgement, logged; ideally they would be backtested, but there is no live record yet, so live scores from 28 October onward decide them by amendment.</a:t>
-            </a:r>
+              <a:t>Red box: weights are judgement, logged, never fitted; the backtest decides who is in the pool, live scores will decide the weights, by amendment.</a:t>
+            </a:r>
+            <a:endParaRPr lang="en-US" dirty="0"/>
           </a:p>
         </p:txBody>
       </p:sp>
@@ -7805,7 +7856,7 @@
                   <a:srgbClr val="CADCFC"/>
                 </a:solidFill>
               </a:rPr>
-              <a:t>Each specialist is asked one question about its own slice (above), never for a probability. It returns claims, each with a verbatim quote and item id, and a score from . Code averages the five scores and moves that many points of probability from the hold side to the hike side (or the reverse), capped at 10.</a:t>
+              <a:t>Each specialist is asked one question about its own slice (above), never for a probability. It returns claims, each with a verbatim quote and item id, and an opinion from -10 to +10: points of probability toward a hike (positive) or a cut (negative). Code averages the five opinions and moves that many points from the hold side to the hike side (or the reverse), capped at 10.</a:t>
             </a:r>
             <a:endParaRPr lang="en-US" sz="1150" dirty="0"/>
           </a:p>
@@ -9722,7 +9773,7 @@
                   <a:schemeClr val="bg1"/>
                 </a:solidFill>
               </a:rPr>
-              <a:t>5 scores, ±10</a:t>
+              <a:t>5 opinions, ±10</a:t>
             </a:r>
             <a:endParaRPr lang="en-US" sz="2000" dirty="0"/>
           </a:p>
@@ -10440,7 +10491,7 @@
               <a:buNone/>
             </a:pPr>
             <a:r>
-              <a:rPr lang="en-US" sz="1400" b="1">
+              <a:rPr lang="en-US" sz="1200" b="1">
                 <a:solidFill>
                   <a:schemeClr val="tx2"/>
                 </a:solidFill>
@@ -10451,7 +10502,7 @@
               <a:t>+25 bps: 20.2% </a:t>
             </a:r>
             <a:r>
-              <a:rPr lang="en-US" sz="1400" b="1" dirty="0">
+              <a:rPr lang="en-US" sz="1200" b="1" dirty="0">
                 <a:solidFill>
                   <a:schemeClr val="tx2"/>
                 </a:solidFill>
@@ -10461,7 +10512,7 @@
               </a:rPr>
               <a:t>→ 22.4%</a:t>
             </a:r>
-            <a:endParaRPr lang="en-US" sz="1400" dirty="0"/>
+            <a:endParaRPr lang="en-US" sz="1200" dirty="0"/>
           </a:p>
         </p:txBody>
       </p:sp>
@@ -16601,7 +16652,7 @@
                   <a:schemeClr val="accent4"/>
                 </a:solidFill>
               </a:rPr>
-              <a:t>repeatability in points of their score because they output a score, not a distribution.</a:t>
+              <a:t>repeatability in points of their opinion because they output an opinion, not a distribution.</a:t>
             </a:r>
             <a:endParaRPr lang="en-US" sz="1050" dirty="0"/>
           </a:p>
@@ -16711,7 +16762,23 @@
                   <a:schemeClr val="tx2"/>
                 </a:solidFill>
               </a:rPr>
-              <a:t>Appendix: how the analysts' score moves the number</a:t>
+              <a:t>Appendix: how </a:t>
+            </a:r>
+            <a:r>
+              <a:rPr lang="en-US" sz="3200" b="1">
+                <a:solidFill>
+                  <a:schemeClr val="tx2"/>
+                </a:solidFill>
+              </a:rPr>
+              <a:t>the analysts' opinion moves </a:t>
+            </a:r>
+            <a:r>
+              <a:rPr lang="en-US" sz="3200" b="1" dirty="0">
+                <a:solidFill>
+                  <a:schemeClr val="tx2"/>
+                </a:solidFill>
+              </a:rPr>
+              <a:t>the number</a:t>
             </a:r>
             <a:endParaRPr lang="en-US" sz="3200" dirty="0"/>
           </a:p>
@@ -16783,12 +16850,12 @@
               <a:buNone/>
             </a:pPr>
             <a:r>
-              <a:rPr lang="en-US" sz="1400" b="1" dirty="0">
+              <a:rPr lang="en-US" sz="1400" b="1">
                 <a:solidFill>
                   <a:schemeClr val="tx2"/>
                 </a:solidFill>
               </a:rPr>
-              <a:t>1. The score</a:t>
+              <a:t>1. The opinion</a:t>
             </a:r>
             <a:endParaRPr lang="en-US" sz="1400" dirty="0"/>
           </a:p>
@@ -16917,12 +16984,20 @@
               <a:buChar char="•"/>
             </a:pPr>
             <a:r>
+              <a:rPr lang="en-US" sz="1050">
+                <a:solidFill>
+                  <a:schemeClr val="tx1"/>
+                </a:solidFill>
+              </a:rPr>
+              <a:t>Five opinions, one vote each, </a:t>
+            </a:r>
+            <a:r>
               <a:rPr lang="en-US" sz="1050" dirty="0">
                 <a:solidFill>
                   <a:schemeClr val="tx1"/>
                 </a:solidFill>
               </a:rPr>
-              <a:t>Five scores, one vote each, plain mean. 28 October: +6.0, +6.2, +5.8, +3.4, −1.4; mean +4.0.</a:t>
+              <a:t>plain mean. 28 October: +6.0, +6.2, +5.8, +3.4, −1.4; mean +4.0.</a:t>
             </a:r>
             <a:endParaRPr lang="en-US" sz="1050" dirty="0"/>
           </a:p>
@@ -17012,7 +17087,23 @@
                   <a:schemeClr val="tx1"/>
                 </a:solidFill>
               </a:rPr>
-              <a:t>Number the five outcomes −2, −1, 0, +1, +2 from most dovish to most hawkish. Multiply each bucket by e raised to (steepness × its number), then rescale so the five sum to one. Code searches for the one steepness at which exactly the mean score's points cross the line; on 28 October it was 0.153. Each bucket moves in proportion to its own size and its distance from the middle, so no bucket is zeroed and the shape is kept.</a:t>
+              <a:t>Number the five outcomes −2, −1, 0, +1, +2 from most dovish to most hawkish. Multiply each bucket by e raised to (steepness × its number), then rescale so the five sum to one. Code searches for the one steepness at which exactly </a:t>
+            </a:r>
+            <a:r>
+              <a:rPr lang="en-US" sz="1000">
+                <a:solidFill>
+                  <a:schemeClr val="tx1"/>
+                </a:solidFill>
+              </a:rPr>
+              <a:t>the mean opinion's </a:t>
+            </a:r>
+            <a:r>
+              <a:rPr lang="en-US" sz="1000" dirty="0">
+                <a:solidFill>
+                  <a:schemeClr val="tx1"/>
+                </a:solidFill>
+              </a:rPr>
+              <a:t>points cross the line; on 28 October it was 0.153. Each bucket moves in proportion to its own size and its distance from the middle, so no bucket is zeroed and the shape is kept.</a:t>
             </a:r>
             <a:endParaRPr lang="en-US" sz="1000" dirty="0"/>
           </a:p>
@@ -17048,7 +17139,23 @@
                   <a:schemeClr val="tx2"/>
                 </a:solidFill>
               </a:rPr>
-              <a:t>28 October, entry #18: mean score +4.0</a:t>
+              <a:t>28 October, entry #18</a:t>
+            </a:r>
+            <a:r>
+              <a:rPr lang="en-US" sz="1400" b="1">
+                <a:solidFill>
+                  <a:schemeClr val="tx2"/>
+                </a:solidFill>
+              </a:rPr>
+              <a:t>: mean opinion </a:t>
+            </a:r>
+            <a:r>
+              <a:rPr lang="en-US" sz="1400" b="1" dirty="0">
+                <a:solidFill>
+                  <a:schemeClr val="tx2"/>
+                </a:solidFill>
+              </a:rPr>
+              <a:t>+4.0</a:t>
             </a:r>
             <a:endParaRPr lang="en-US" sz="1400" dirty="0"/>
           </a:p>
@@ -21510,12 +21617,12 @@
               <a:buNone/>
             </a:pPr>
             <a:r>
-              <a:rPr lang="en-US" sz="1000" dirty="0">
+              <a:rPr lang="en-US" sz="1000">
                 <a:solidFill>
                   <a:schemeClr val="tx1"/>
                 </a:solidFill>
               </a:rPr>
-              <a:t>About 130 scheduled decisions with full features, roughly 250 in all; 68% are holds and the cuts cluster in three short episodes. On a sample that small and that unbalanced a boosted tree or a random forest memorises the episodes and a calibration curve on a few dozen non-hold cases is noise. The route is a better-specified small model: features written down before fitting, heavy regularisation, a reliability check beside the log score, the expanding window as the only judge. A regularised boosted model can be one pre-registered candidate, judged the same way.</a:t>
+              <a:t>About 130 usable decisions; 68% are holds and the cuts bunch into a few episodes. A big model memorises the episodes and looks good on any test near them. The replacement must handle that imbalance (class weights, or an ordinal model shrunk toward the base rate) and be judged only on decisions it has not seen, the expanding window.</a:t>
             </a:r>
             <a:endParaRPr lang="en-US" sz="1000" dirty="0"/>
           </a:p>
@@ -27415,13 +27522,18 @@
               <a:buChar char="•"/>
             </a:pPr>
             <a:r>
-              <a:rPr lang="en-US" sz="1300" dirty="0">
+              <a:rPr lang="en-US" sz="1300">
                 <a:solidFill>
                   <a:schemeClr val="tx1"/>
                 </a:solidFill>
               </a:rPr>
-              <a:t>A good repeatable process ensures repeatability: </a:t>
-            </a:r>
+              <a:t>A good process is a repeatable one: </a:t>
+            </a:r>
+            <a:endParaRPr lang="en-US" sz="1300" dirty="0">
+              <a:solidFill>
+                <a:schemeClr val="tx1"/>
+              </a:solidFill>
+            </a:endParaRPr>
           </a:p>
           <a:p>
             <a:pPr marL="800100" lvl="1" indent="-342900">
@@ -27491,8 +27603,16 @@
               <a:buChar char="•"/>
             </a:pPr>
             <a:r>
-              <a:rPr lang="en-US" sz="1300" dirty="0"/>
-              <a:t>Does </a:t>
+              <a:rPr lang="en-US" sz="1300"/>
+              <a:t>Does a shock move the number</a:t>
+            </a:r>
+            <a:r>
+              <a:rPr lang="en-US" sz="1300">
+                <a:solidFill>
+                  <a:schemeClr val="tx1"/>
+                </a:solidFill>
+              </a:rPr>
+              <a:t> </a:t>
             </a:r>
             <a:r>
               <a:rPr lang="en-US" sz="1300" dirty="0">
@@ -27500,7 +27620,7 @@
                   <a:schemeClr val="tx1"/>
                 </a:solidFill>
               </a:rPr>
-              <a:t>a shock moves the number the right way?</a:t>
+              <a:t>the right way?</a:t>
             </a:r>
             <a:endParaRPr lang="en-US" sz="1300" dirty="0"/>
           </a:p>
@@ -27947,12 +28067,28 @@
               <a:buChar char="•"/>
             </a:pPr>
             <a:r>
+              <a:rPr lang="en-US" sz="1300">
+                <a:solidFill>
+                  <a:schemeClr val="tx1"/>
+                </a:solidFill>
+              </a:rPr>
+              <a:t>Since everything is quotable and the LLM analysts can read only the evidence, </a:t>
+            </a:r>
+            <a:r>
               <a:rPr lang="en-US" sz="1300" dirty="0">
                 <a:solidFill>
                   <a:schemeClr val="tx1"/>
                 </a:solidFill>
               </a:rPr>
-              <a:t>Since is quotable and the human analyst can read only the evidence, so a wrong call is a traceable wrong call: we see which quote led were.</a:t>
+              <a:t>so a wrong call is a traceable wrong call: we </a:t>
+            </a:r>
+            <a:r>
+              <a:rPr lang="en-US" sz="1300">
+                <a:solidFill>
+                  <a:schemeClr val="tx1"/>
+                </a:solidFill>
+              </a:rPr>
+              <a:t>see which quote led where.</a:t>
             </a:r>
             <a:endParaRPr lang="en-US" sz="1300" dirty="0"/>
           </a:p>
@@ -29729,7 +29865,7 @@
           <p:nvPr>
             <p:extLst>
               <p:ext uri="{D42A27DB-BD31-4B8C-83A1-F6EECF244321}">
-                <p14:modId xmlns:p14="http://schemas.microsoft.com/office/powerpoint/2010/main" val="3165394686"/>
+                <p14:modId xmlns:p14="http://schemas.microsoft.com/office/powerpoint/2010/main" val="1563022806"/>
               </p:ext>
             </p:extLst>
           </p:nvPr>
@@ -32773,7 +32909,7 @@
                             <a:srgbClr val="1B1F2A"/>
                           </a:solidFill>
                         </a:rPr>
-                        <a:t>specialists' opinion: </a:t>
+                        <a:t>Specialists' opinion: </a:t>
                       </a:r>
                       <a:r>
                         <a:rPr lang="en-US" sz="1000" b="1" dirty="0">

</xml_diff>

<commit_message>
Deck: empirical data with an example, legible 'what it reads', limits slide merged to two columns with the question-breakdown framing, base-rates appendix, notes for 8, 9, 11, 12 and the appendix
Co-Authored-By: Claude Fable 5.1 <noreply@anthropic.com>
</commit_message>
<xml_diff>
--- a/docs/FedCast_Fullerton.pptx
+++ b/docs/FedCast_Fullerton.pptx
@@ -5,7 +5,7 @@
     <p:sldMasterId id="2147483648" r:id="rId1"/>
   </p:sldMasterIdLst>
   <p:notesMasterIdLst>
-    <p:notesMasterId r:id="rId25"/>
+    <p:notesMasterId r:id="rId26"/>
   </p:notesMasterIdLst>
   <p:sldIdLst>
     <p:sldId id="256" r:id="rId2"/>
@@ -18,7 +18,7 @@
     <p:sldId id="281" r:id="rId9"/>
     <p:sldId id="263" r:id="rId10"/>
     <p:sldId id="264" r:id="rId11"/>
-    <p:sldId id="283" r:id="rId12"/>
+    <p:sldId id="285" r:id="rId12"/>
     <p:sldId id="266" r:id="rId13"/>
     <p:sldId id="268" r:id="rId14"/>
     <p:sldId id="269" r:id="rId15"/>
@@ -31,6 +31,7 @@
     <p:sldId id="277" r:id="rId22"/>
     <p:sldId id="278" r:id="rId23"/>
     <p:sldId id="279" r:id="rId24"/>
+    <p:sldId id="286" r:id="rId25"/>
   </p:sldIdLst>
   <p:sldSz cx="12192000" cy="6858000"/>
   <p:notesSz cx="6858000" cy="12192000"/>
@@ -149,7 +150,7 @@
           <p14:sldIdLst>
             <p14:sldId id="263"/>
             <p14:sldId id="264"/>
-            <p14:sldId id="283"/>
+            <p14:sldId id="285"/>
           </p14:sldIdLst>
         </p14:section>
         <p14:section name="The harness" id="{92928B70-AC41-17EA-8015-68E5296D82D9}">
@@ -178,6 +179,7 @@
             <p14:sldId id="277"/>
             <p14:sldId id="278"/>
             <p14:sldId id="279"/>
+            <p14:sldId id="286"/>
           </p14:sldIdLst>
         </p14:section>
       </p14:sectionLst>
@@ -1274,7 +1276,7 @@
           <a:p>
             <a:r>
               <a:rPr lang="en-US"/>
-              <a:t>2 MIN. Three things a language model cannot be made to stop doing. Memory: instruction, quote per claim, every number checked, sent back once. Variance: fixed schema, five identical runs, the spread measured, pass mark 2 points. Invented support: every quote matched by code character for character, bounds, one repair round. Say: 'none is removed; each is designed around, and measured.' The proof comes two slides later.</a:t>
+              <a:t>2 MIN. Two things a language model cannot stop doing. LEFT: it answers from memory and differently each time. Same fix for both: break the one big question into small fixed ones with a fixed answer shape, like a multiple-choice and short-answer paper, so there is less room to wander; evidence only, every claim quoted; every number checked; five identical runs, spread within 2 points. RIGHT: it can invent support. Fix: verification by code, not by a model; bounds; one repair round. 'Neither is removed; each is designed around, and measured.' Proof three slides on.</a:t>
             </a:r>
             <a:endParaRPr lang="en-US" dirty="0"/>
           </a:p>
@@ -1306,7 +1308,7 @@
     </p:spTree>
     <p:extLst>
       <p:ext uri="{BB962C8B-B14F-4D97-AF65-F5344CB8AC3E}">
-        <p14:creationId xmlns:p14="http://schemas.microsoft.com/office/powerpoint/2010/main" val="51336607"/>
+        <p14:creationId xmlns:p14="http://schemas.microsoft.com/office/powerpoint/2010/main" val="3245161562"/>
       </p:ext>
     </p:extLst>
   </p:cSld>
@@ -1362,7 +1364,7 @@
           <a:p>
             <a:r>
               <a:rPr lang="en-US"/>
-              <a:t>2 MIN. Left, the three controls, grey and dashed: they never enter the number. 1 naive: the question only. 2: evidence shown, free text. 3: same evidence, fixed shape, verifier. Right, the five specialists that do enter: one slice each, the same shape and verifier. Each is asked a question about its slice, never a probability; it returns quoted claims and an opinion from -10 to +10. Bottom: every analyst runs five times; 1 to 3 build the benchmark 4 to 8 are measured against.</a:t>
+              <a:t>2 MIN. THREE POINTS. One: the left three are controls, grey and dashed; they never touch the number. Analyst 1 is the model on its own; 2 adds the evidence; 3 adds the answer shape and the verifier. Two: the five on the right enter the number; each gets one slice of evidence and one question about it, never 'give me a probability'; it returns quoted claims and an opinion from -10 to +10. Three: every analyst runs five times on the same snapshot; for 1 to 3 those runs are the benchmark 4 to 8 are measured against. Walk through: 1 sets the baseline, 2 tests what evidence fixes, 3 tests the shape and the verifier.</a:t>
             </a:r>
             <a:endParaRPr lang="en-US" dirty="0"/>
           </a:p>
@@ -2472,6 +2474,94 @@
 </p:notes>
 </file>
 
+<file path=ppt/notesSlides/notesSlide24.xml><?xml version="1.0" encoding="utf-8"?>
+<p:notes xmlns:a="http://schemas.openxmlformats.org/drawingml/2006/main" xmlns:r="http://schemas.openxmlformats.org/officeDocument/2006/relationships" xmlns:p="http://schemas.openxmlformats.org/presentationml/2006/main">
+  <p:cSld>
+    <p:spTree>
+      <p:nvGrpSpPr>
+        <p:cNvPr id="1" name=""/>
+        <p:cNvGrpSpPr/>
+        <p:nvPr/>
+      </p:nvGrpSpPr>
+      <p:grpSpPr>
+        <a:xfrm>
+          <a:off x="0" y="0"/>
+          <a:ext cx="0" cy="0"/>
+          <a:chOff x="0" y="0"/>
+          <a:chExt cx="0" cy="0"/>
+        </a:xfrm>
+      </p:grpSpPr>
+      <p:sp>
+        <p:nvSpPr>
+          <p:cNvPr id="2" name="Slide Image Placeholder 1"/>
+          <p:cNvSpPr>
+            <a:spLocks noGrp="1" noRot="1" noChangeAspect="1"/>
+          </p:cNvSpPr>
+          <p:nvPr>
+            <p:ph type="sldImg"/>
+          </p:nvPr>
+        </p:nvSpPr>
+        <p:spPr/>
+      </p:sp>
+      <p:sp>
+        <p:nvSpPr>
+          <p:cNvPr id="3" name="Notes Placeholder 2"/>
+          <p:cNvSpPr>
+            <a:spLocks noGrp="1"/>
+          </p:cNvSpPr>
+          <p:nvPr>
+            <p:ph type="body" idx="1"/>
+          </p:nvPr>
+        </p:nvSpPr>
+        <p:spPr/>
+        <p:txBody>
+          <a:bodyPr/>
+          <a:lstStyle/>
+          <a:p>
+            <a:r>
+              <a:rPr lang="en-US"/>
+              <a:t>APPENDIX. Use if asked what historical base rates are. Take the 266 scheduled decisions since 1994, group by the previous decision, count what came next: that is the forecast. After a hike: hiked again 64%, held 36%, never cut. No parameters; it beat the fitted probit on the expanding window, so it is in the pool at 0.1. It is the prior the other models update.</a:t>
+            </a:r>
+            <a:endParaRPr lang="en-US" dirty="0"/>
+          </a:p>
+        </p:txBody>
+      </p:sp>
+      <p:sp>
+        <p:nvSpPr>
+          <p:cNvPr id="4" name="Slide Number Placeholder 3"/>
+          <p:cNvSpPr>
+            <a:spLocks noGrp="1"/>
+          </p:cNvSpPr>
+          <p:nvPr>
+            <p:ph type="sldNum" sz="quarter" idx="10"/>
+          </p:nvPr>
+        </p:nvSpPr>
+        <p:spPr/>
+        <p:txBody>
+          <a:bodyPr/>
+          <a:lstStyle/>
+          <a:p>
+            <a:fld id="{F7021451-1387-4CA6-816F-3879F97B5CBC}" type="slidenum">
+              <a:rPr lang="en-US"/>
+              <a:t>24</a:t>
+            </a:fld>
+            <a:endParaRPr lang="en-US"/>
+          </a:p>
+        </p:txBody>
+      </p:sp>
+    </p:spTree>
+    <p:extLst>
+      <p:ext uri="{BB962C8B-B14F-4D97-AF65-F5344CB8AC3E}">
+        <p14:creationId xmlns:p14="http://schemas.microsoft.com/office/powerpoint/2010/main" val="4133600115"/>
+      </p:ext>
+    </p:extLst>
+  </p:cSld>
+  <p:clrMapOvr>
+    <a:masterClrMapping/>
+  </p:clrMapOvr>
+</p:notes>
+</file>
+
 <file path=ppt/notesSlides/notesSlide3.xml><?xml version="1.0" encoding="utf-8"?>
 <p:notes xmlns:a="http://schemas.openxmlformats.org/drawingml/2006/main" xmlns:r="http://schemas.openxmlformats.org/officeDocument/2006/relationships" xmlns:p="http://schemas.openxmlformats.org/presentationml/2006/main">
   <p:cSld>
@@ -2988,13 +3078,13 @@
           <a:p>
             <a:r>
               <a:rPr lang="en-US"/>
-              <a:t>2 MIN. Left, the four families: economic predictors (futures, Taylor rules, odds), empirical history, classic ML (probit, weight 0), LLM-derived (bounded opinion, not a weight). Pooled by code; no model writes the number.</a:t>
+              <a:t>2 MIN. Left, the four families. Economic predictors: futures (the anchor), the Fed's four rules, odds. Empirical data: what the Fed did next after each kind of decision since 1994; after a hike it hiked again two times in three and never cut, so history alone says 'hike' today. Classic ML: the probit, weight 0. LLM-derived: a bounded opinion, not a weight. Pooled by code; no model writes the number.</a:t>
             </a:r>
           </a:p>
           <a:p>
             <a:r>
               <a:rPr lang="en-US"/>
-              <a:t>Right, the chain in order: evidence, signals, pool, analysts (only 4 to 8 enter; 1 to 3 are controls), you (bounded, typed channels), ledger. Say: 'every line here is a view in the app.'</a:t>
+              <a:t>Right, the chain in order: evidence, signals, pool, analysts (only 4 to 8 enter; 1 to 3 are controls), you, ledger. 'Every line is a view in the app.'</a:t>
             </a:r>
             <a:endParaRPr lang="en-US" dirty="0"/>
           </a:p>
@@ -3082,13 +3172,19 @@
           <a:p>
             <a:r>
               <a:rPr lang="en-US"/>
-              <a:t>2 MIN. Read the table top to bottom: what each model reads, its distribution, its weight. Pooled line: weighted average then the 1.5% floor (no outcome below 1.5%, so nothing is ever called impossible). The tinted row: the specialists' opinion, +4.0, moves 4 points toward a hike, after the pool, capped at 10. Machine forecast: 67.6 / 22.4 / 7.7.</a:t>
+              <a:t>2 MIN. Read down: what each model reads, its distribution, its weight. Market: the futures price. Rules: inflation, unemployment, the natural rate. Odds: Polymarket. Base rates: the 49 meetings since 1994 that followed a hike (appendix if asked). Probit: nine macro features, weight 0.</a:t>
             </a:r>
           </a:p>
           <a:p>
             <a:r>
               <a:rPr lang="en-US"/>
-              <a:t>Red box: weights are judgement, logged, never fitted; the backtest decides who is in the pool, live scores will decide the weights, by amendment.</a:t>
+              <a:t>Pooled: weighted average then the 1.5% floor (nothing is ever called impossible). Tinted row: the specialists' opinion, +4.0, moves 4 points toward a hike, capped at 10. Machine forecast: 67.6 / 22.4 / 7.7.</a:t>
+            </a:r>
+          </a:p>
+          <a:p>
+            <a:r>
+              <a:rPr lang="en-US"/>
+              <a:t>Red box: weights are judgement, logged, never fitted; live scores will decide them.</a:t>
             </a:r>
             <a:endParaRPr lang="en-US" dirty="0"/>
           </a:p>
@@ -3397,7 +3493,7 @@
           </a:prstGeom>
           <a:extLst>
             <a:ext uri="{C572A759-6A51-4108-AA02-DFA0A04FC94B}">
-              <ma14:wrappingTextBoxFlag xmlns="" xmlns:ma14="http://schemas.microsoft.com/office/mac/drawingml/2011/main" val="0"/>
+              <ma14:wrappingTextBoxFlag xmlns:ma14="http://schemas.microsoft.com/office/mac/drawingml/2011/main" xmlns="" val="0"/>
             </a:ext>
           </a:extLst>
         </p:spPr>
@@ -3582,7 +3678,7 @@
           </a:prstGeom>
           <a:extLst>
             <a:ext uri="{C572A759-6A51-4108-AA02-DFA0A04FC94B}">
-              <ma14:wrappingTextBoxFlag xmlns="" xmlns:ma14="http://schemas.microsoft.com/office/mac/drawingml/2011/main" val="0"/>
+              <ma14:wrappingTextBoxFlag xmlns:ma14="http://schemas.microsoft.com/office/mac/drawingml/2011/main" xmlns="" val="0"/>
             </a:ext>
           </a:extLst>
         </p:spPr>
@@ -4683,7 +4779,7 @@
                   <a:schemeClr val="accent4"/>
                 </a:solidFill>
               </a:rPr>
-              <a:t>Three things a language model cannot be made to stop doing. None is removed; each is designed around, and the design is measured on every snapshot.</a:t>
+              <a:t>Two things a language model cannot be made to stop doing. Neither is removed; each is designed around, and the design is measured on every snapshot.</a:t>
             </a:r>
             <a:endParaRPr lang="en-US" sz="1200" dirty="0"/>
           </a:p>
@@ -4698,11 +4794,11 @@
         <p:spPr>
           <a:xfrm>
             <a:off x="548640" y="1645920"/>
-            <a:ext cx="3593592" cy="1051560"/>
+            <a:ext cx="5431536" cy="1097280"/>
           </a:xfrm>
           <a:prstGeom prst="roundRect">
             <a:avLst>
-              <a:gd name="adj" fmla="val 8696"/>
+              <a:gd name="adj" fmla="val 8333"/>
             </a:avLst>
           </a:prstGeom>
           <a:solidFill>
@@ -4715,13 +4811,6 @@
             <a:prstDash val="solid"/>
           </a:ln>
         </p:spPr>
-        <p:txBody>
-          <a:bodyPr/>
-          <a:lstStyle/>
-          <a:p>
-            <a:endParaRPr lang="en-US"/>
-          </a:p>
-        </p:txBody>
       </p:sp>
       <p:sp>
         <p:nvSpPr>
@@ -4731,8 +4820,8 @@
         </p:nvSpPr>
         <p:spPr>
           <a:xfrm>
-            <a:off x="548640" y="2514600"/>
-            <a:ext cx="3593592" cy="182880"/>
+            <a:off x="548640" y="2560320"/>
+            <a:ext cx="5431536" cy="182880"/>
           </a:xfrm>
           <a:prstGeom prst="rect">
             <a:avLst/>
@@ -4747,13 +4836,6 @@
             <a:prstDash val="solid"/>
           </a:ln>
         </p:spPr>
-        <p:txBody>
-          <a:bodyPr/>
-          <a:lstStyle/>
-          <a:p>
-            <a:endParaRPr lang="en-US"/>
-          </a:p>
-        </p:txBody>
       </p:sp>
       <p:sp>
         <p:nvSpPr>
@@ -4763,8 +4845,8 @@
         </p:nvSpPr>
         <p:spPr>
           <a:xfrm>
-            <a:off x="731520" y="1755648"/>
-            <a:ext cx="3227832" cy="182880"/>
+            <a:off x="777240" y="1755648"/>
+            <a:ext cx="4974336" cy="182880"/>
           </a:xfrm>
           <a:prstGeom prst="rect">
             <a:avLst/>
@@ -4799,8 +4881,8 @@
         </p:nvSpPr>
         <p:spPr>
           <a:xfrm>
-            <a:off x="731520" y="1956816"/>
-            <a:ext cx="3227832" cy="329184"/>
+            <a:off x="777240" y="1956816"/>
+            <a:ext cx="4974336" cy="329184"/>
           </a:xfrm>
           <a:prstGeom prst="rect">
             <a:avLst/>
@@ -4816,14 +4898,14 @@
               <a:buNone/>
             </a:pPr>
             <a:r>
-              <a:rPr lang="en-US" sz="1500" b="1" dirty="0">
+              <a:rPr lang="en-US" sz="1600" b="1" dirty="0">
                 <a:solidFill>
                   <a:schemeClr val="bg1"/>
                 </a:solidFill>
               </a:rPr>
-              <a:t>Memory cannot be switched off</a:t>
-            </a:r>
-            <a:endParaRPr lang="en-US" sz="1500" dirty="0"/>
+              <a:t>It answers from memory, and differently each time</a:t>
+            </a:r>
+            <a:endParaRPr lang="en-US" sz="1600" dirty="0"/>
           </a:p>
         </p:txBody>
       </p:sp>
@@ -4835,8 +4917,8 @@
         </p:nvSpPr>
         <p:spPr>
           <a:xfrm>
-            <a:off x="731520" y="2286000"/>
-            <a:ext cx="3227832" cy="384048"/>
+            <a:off x="777240" y="2304288"/>
+            <a:ext cx="4974336" cy="411480"/>
           </a:xfrm>
           <a:prstGeom prst="rect">
             <a:avLst/>
@@ -4857,7 +4939,7 @@
                   <a:srgbClr val="F8D7CE"/>
                 </a:solidFill>
               </a:rPr>
-              <a:t>It knows the Fed from its training and will use that unless stopped.</a:t>
+              <a:t>It knows the Fed from its training and will use that unless stopped; ask the same question twice and the number moves.</a:t>
             </a:r>
             <a:endParaRPr lang="en-US" sz="1100" dirty="0"/>
           </a:p>
@@ -4871,8 +4953,8 @@
         </p:nvSpPr>
         <p:spPr>
           <a:xfrm>
-            <a:off x="548640" y="2697480"/>
-            <a:ext cx="3593592" cy="2743200"/>
+            <a:off x="548640" y="2743200"/>
+            <a:ext cx="5431536" cy="3108960"/>
           </a:xfrm>
           <a:prstGeom prst="rect">
             <a:avLst/>
@@ -4887,13 +4969,6 @@
             <a:prstDash val="solid"/>
           </a:ln>
         </p:spPr>
-        <p:txBody>
-          <a:bodyPr/>
-          <a:lstStyle/>
-          <a:p>
-            <a:endParaRPr lang="en-US"/>
-          </a:p>
-        </p:txBody>
       </p:sp>
       <p:sp>
         <p:nvSpPr>
@@ -4903,8 +4978,8 @@
         </p:nvSpPr>
         <p:spPr>
           <a:xfrm>
-            <a:off x="731520" y="2834640"/>
-            <a:ext cx="3227832" cy="182880"/>
+            <a:off x="777240" y="2880360"/>
+            <a:ext cx="4974336" cy="182880"/>
           </a:xfrm>
           <a:prstGeom prst="rect">
             <a:avLst/>
@@ -4939,8 +5014,8 @@
         </p:nvSpPr>
         <p:spPr>
           <a:xfrm>
-            <a:off x="731520" y="3108960"/>
-            <a:ext cx="3227832" cy="2240280"/>
+            <a:off x="777240" y="3154680"/>
+            <a:ext cx="4974336" cy="2606040"/>
           </a:xfrm>
           <a:prstGeom prst="rect">
             <a:avLst/>
@@ -4962,7 +5037,7 @@
                   <a:srgbClr val="1B1F2A"/>
                 </a:solidFill>
               </a:rPr>
-              <a:t>Instruction: </a:t>
+              <a:t>Break the question down: </a:t>
             </a:r>
             <a:r>
               <a:rPr lang="en-US" sz="1300" dirty="0">
@@ -4970,7 +5045,7 @@
                   <a:schemeClr val="tx1"/>
                 </a:solidFill>
               </a:rPr>
-              <a:t>use only the evidence; nothing remembered about the economy, the Fed or markets.</a:t>
+              <a:t>instead of one big 'what will the Fed do', each analyst gets small fixed questions with a fixed answer shape, like a multiple-choice and short-answer paper. Less room to wander, so less variation between runs.</a:t>
             </a:r>
             <a:endParaRPr lang="en-US" sz="1300" dirty="0"/>
           </a:p>
@@ -4985,7 +5060,7 @@
                   <a:srgbClr val="1B1F2A"/>
                 </a:solidFill>
               </a:rPr>
-              <a:t>Answer shape: </a:t>
+              <a:t>Evidence only: </a:t>
             </a:r>
             <a:r>
               <a:rPr lang="en-US" sz="1300" dirty="0">
@@ -4993,7 +5068,7 @@
                   <a:schemeClr val="tx1"/>
                 </a:solidFill>
               </a:rPr>
-              <a:t>every claim carries a verbatim quote from a named item, so a remembered fact has nowhere to stand.</a:t>
+              <a:t>the instruction says use only the evidence; every claim must carry a verbatim quote from a named item, so a remembered fact has nowhere to stand.</a:t>
             </a:r>
             <a:endParaRPr lang="en-US" sz="1300" dirty="0"/>
           </a:p>
@@ -5008,7 +5083,7 @@
                   <a:srgbClr val="1B1F2A"/>
                 </a:solidFill>
               </a:rPr>
-              <a:t>Check: </a:t>
+              <a:t>Measured: </a:t>
             </a:r>
             <a:r>
               <a:rPr lang="en-US" sz="1300" dirty="0">
@@ -5016,7 +5091,7 @@
                   <a:schemeClr val="tx1"/>
                 </a:solidFill>
               </a:rPr>
-              <a:t>every number is matched to the snapshot by code; one not found is flagged as from memory and sent back once.</a:t>
+              <a:t>every number in the answer is matched to the snapshot by code; five identical runs per analyst, and the spread between them must stay within 2 points.</a:t>
             </a:r>
             <a:endParaRPr lang="en-US" sz="1300" dirty="0"/>
           </a:p>
@@ -5030,12 +5105,12 @@
         </p:nvSpPr>
         <p:spPr>
           <a:xfrm>
-            <a:off x="4297680" y="1645920"/>
-            <a:ext cx="3593592" cy="1051560"/>
+            <a:off x="6208776" y="1645920"/>
+            <a:ext cx="5431536" cy="1097280"/>
           </a:xfrm>
           <a:prstGeom prst="roundRect">
             <a:avLst>
-              <a:gd name="adj" fmla="val 8696"/>
+              <a:gd name="adj" fmla="val 8333"/>
             </a:avLst>
           </a:prstGeom>
           <a:solidFill>
@@ -5048,13 +5123,6 @@
             <a:prstDash val="solid"/>
           </a:ln>
         </p:spPr>
-        <p:txBody>
-          <a:bodyPr/>
-          <a:lstStyle/>
-          <a:p>
-            <a:endParaRPr lang="en-US"/>
-          </a:p>
-        </p:txBody>
       </p:sp>
       <p:sp>
         <p:nvSpPr>
@@ -5064,8 +5132,8 @@
         </p:nvSpPr>
         <p:spPr>
           <a:xfrm>
-            <a:off x="4297680" y="2514600"/>
-            <a:ext cx="3593592" cy="182880"/>
+            <a:off x="6208776" y="2560320"/>
+            <a:ext cx="5431536" cy="182880"/>
           </a:xfrm>
           <a:prstGeom prst="rect">
             <a:avLst/>
@@ -5080,13 +5148,6 @@
             <a:prstDash val="solid"/>
           </a:ln>
         </p:spPr>
-        <p:txBody>
-          <a:bodyPr/>
-          <a:lstStyle/>
-          <a:p>
-            <a:endParaRPr lang="en-US"/>
-          </a:p>
-        </p:txBody>
       </p:sp>
       <p:sp>
         <p:nvSpPr>
@@ -5096,8 +5157,8 @@
         </p:nvSpPr>
         <p:spPr>
           <a:xfrm>
-            <a:off x="4480560" y="1755648"/>
-            <a:ext cx="3227832" cy="182880"/>
+            <a:off x="6437376" y="1755648"/>
+            <a:ext cx="4974336" cy="182880"/>
           </a:xfrm>
           <a:prstGeom prst="rect">
             <a:avLst/>
@@ -5132,8 +5193,8 @@
         </p:nvSpPr>
         <p:spPr>
           <a:xfrm>
-            <a:off x="4480560" y="1956816"/>
-            <a:ext cx="3227832" cy="329184"/>
+            <a:off x="6437376" y="1956816"/>
+            <a:ext cx="4974336" cy="329184"/>
           </a:xfrm>
           <a:prstGeom prst="rect">
             <a:avLst/>
@@ -5149,14 +5210,14 @@
               <a:buNone/>
             </a:pPr>
             <a:r>
-              <a:rPr lang="en-US" sz="1500" b="1" dirty="0">
+              <a:rPr lang="en-US" sz="1600" b="1" dirty="0">
                 <a:solidFill>
                   <a:schemeClr val="bg1"/>
                 </a:solidFill>
               </a:rPr>
-              <a:t>Answers vary between runs</a:t>
-            </a:r>
-            <a:endParaRPr lang="en-US" sz="1500" dirty="0"/>
+              <a:t>It can invent its own support</a:t>
+            </a:r>
+            <a:endParaRPr lang="en-US" sz="1600" dirty="0"/>
           </a:p>
         </p:txBody>
       </p:sp>
@@ -5168,8 +5229,8 @@
         </p:nvSpPr>
         <p:spPr>
           <a:xfrm>
-            <a:off x="4480560" y="2286000"/>
-            <a:ext cx="3227832" cy="384048"/>
+            <a:off x="6437376" y="2304288"/>
+            <a:ext cx="4974336" cy="411480"/>
           </a:xfrm>
           <a:prstGeom prst="rect">
             <a:avLst/>
@@ -5190,7 +5251,7 @@
                   <a:srgbClr val="F8D7CE"/>
                 </a:solidFill>
               </a:rPr>
-              <a:t>Ask twice and the number moves.</a:t>
+              <a:t>A fluent quote or figure that was never in the document.</a:t>
             </a:r>
             <a:endParaRPr lang="en-US" sz="1100" dirty="0"/>
           </a:p>
@@ -5204,8 +5265,8 @@
         </p:nvSpPr>
         <p:spPr>
           <a:xfrm>
-            <a:off x="4297680" y="2697480"/>
-            <a:ext cx="3593592" cy="2743200"/>
+            <a:off x="6208776" y="2743200"/>
+            <a:ext cx="5431536" cy="3108960"/>
           </a:xfrm>
           <a:prstGeom prst="rect">
             <a:avLst/>
@@ -5220,13 +5281,6 @@
             <a:prstDash val="solid"/>
           </a:ln>
         </p:spPr>
-        <p:txBody>
-          <a:bodyPr/>
-          <a:lstStyle/>
-          <a:p>
-            <a:endParaRPr lang="en-US"/>
-          </a:p>
-        </p:txBody>
       </p:sp>
       <p:sp>
         <p:nvSpPr>
@@ -5236,8 +5290,8 @@
         </p:nvSpPr>
         <p:spPr>
           <a:xfrm>
-            <a:off x="4480560" y="2834640"/>
-            <a:ext cx="3227832" cy="182880"/>
+            <a:off x="6437376" y="2880360"/>
+            <a:ext cx="4974336" cy="182880"/>
           </a:xfrm>
           <a:prstGeom prst="rect">
             <a:avLst/>
@@ -5272,8 +5326,8 @@
         </p:nvSpPr>
         <p:spPr>
           <a:xfrm>
-            <a:off x="4480560" y="3108960"/>
-            <a:ext cx="3227832" cy="2240280"/>
+            <a:off x="6437376" y="3154680"/>
+            <a:ext cx="4974336" cy="2606040"/>
           </a:xfrm>
           <a:prstGeom prst="rect">
             <a:avLst/>
@@ -5295,7 +5349,7 @@
                   <a:srgbClr val="1B1F2A"/>
                 </a:solidFill>
               </a:rPr>
-              <a:t>Answer shape: </a:t>
+              <a:t>Check by code, not by a model: </a:t>
             </a:r>
             <a:r>
               <a:rPr lang="en-US" sz="1300" dirty="0">
@@ -5303,7 +5357,7 @@
                   <a:schemeClr val="tx1"/>
                 </a:solidFill>
               </a:rPr>
-              <a:t>a fixed JSON schema; anything else is rejected unread.</a:t>
+              <a:t>every quote is matched to its item character for character; a quote stitched from two places fails.</a:t>
             </a:r>
             <a:endParaRPr lang="en-US" sz="1300" dirty="0"/>
           </a:p>
@@ -5318,7 +5372,7 @@
                   <a:srgbClr val="1B1F2A"/>
                 </a:solidFill>
               </a:rPr>
-              <a:t>Five identical runs </a:t>
+              <a:t>Bounds: </a:t>
             </a:r>
             <a:r>
               <a:rPr lang="en-US" sz="1300" dirty="0">
@@ -5326,7 +5380,7 @@
                   <a:schemeClr val="tx1"/>
                 </a:solidFill>
               </a:rPr>
-              <a:t>per analyst per snapshot, each stored under its prompt hash.</a:t>
+              <a:t>every watch-out answered by id; the opinion clipped to −10 to +10.</a:t>
             </a:r>
             <a:endParaRPr lang="en-US" sz="1300" dirty="0"/>
           </a:p>
@@ -5341,7 +5395,7 @@
                   <a:srgbClr val="1B1F2A"/>
                 </a:solidFill>
               </a:rPr>
-              <a:t>Measured: </a:t>
+              <a:t>One repair round: </a:t>
             </a:r>
             <a:r>
               <a:rPr lang="en-US" sz="1300" dirty="0">
@@ -5349,7 +5403,7 @@
                   <a:schemeClr val="tx1"/>
                 </a:solidFill>
               </a:rPr>
-              <a:t>the spread of the five answers. Pass mark: 2 points.</a:t>
+              <a:t>the verifier's report goes back once; both answers are kept; what still fails stays unverified, never hidden.</a:t>
             </a:r>
             <a:endParaRPr lang="en-US" sz="1300" dirty="0"/>
           </a:p>
@@ -5357,340 +5411,7 @@
       </p:sp>
       <p:sp>
         <p:nvSpPr>
-          <p:cNvPr id="21" name="Shape 18"/>
-          <p:cNvSpPr/>
-          <p:nvPr/>
-        </p:nvSpPr>
-        <p:spPr>
-          <a:xfrm>
-            <a:off x="8046720" y="1645920"/>
-            <a:ext cx="3593592" cy="1051560"/>
-          </a:xfrm>
-          <a:prstGeom prst="roundRect">
-            <a:avLst>
-              <a:gd name="adj" fmla="val 8696"/>
-            </a:avLst>
-          </a:prstGeom>
-          <a:solidFill>
-            <a:srgbClr val="C8553D"/>
-          </a:solidFill>
-          <a:ln w="12700">
-            <a:solidFill>
-              <a:srgbClr val="C8553D"/>
-            </a:solidFill>
-            <a:prstDash val="solid"/>
-          </a:ln>
-        </p:spPr>
-        <p:txBody>
-          <a:bodyPr/>
-          <a:lstStyle/>
-          <a:p>
-            <a:endParaRPr lang="en-US"/>
-          </a:p>
-        </p:txBody>
-      </p:sp>
-      <p:sp>
-        <p:nvSpPr>
-          <p:cNvPr id="22" name="Shape 19"/>
-          <p:cNvSpPr/>
-          <p:nvPr/>
-        </p:nvSpPr>
-        <p:spPr>
-          <a:xfrm>
-            <a:off x="8046720" y="2514600"/>
-            <a:ext cx="3593592" cy="182880"/>
-          </a:xfrm>
-          <a:prstGeom prst="rect">
-            <a:avLst/>
-          </a:prstGeom>
-          <a:solidFill>
-            <a:srgbClr val="C8553D"/>
-          </a:solidFill>
-          <a:ln w="12700">
-            <a:solidFill>
-              <a:srgbClr val="C8553D"/>
-            </a:solidFill>
-            <a:prstDash val="solid"/>
-          </a:ln>
-        </p:spPr>
-        <p:txBody>
-          <a:bodyPr/>
-          <a:lstStyle/>
-          <a:p>
-            <a:endParaRPr lang="en-US"/>
-          </a:p>
-        </p:txBody>
-      </p:sp>
-      <p:sp>
-        <p:nvSpPr>
-          <p:cNvPr id="23" name="Text 20"/>
-          <p:cNvSpPr txBox="1"/>
-          <p:nvPr/>
-        </p:nvSpPr>
-        <p:spPr>
-          <a:xfrm>
-            <a:off x="8229600" y="1755648"/>
-            <a:ext cx="3227832" cy="182880"/>
-          </a:xfrm>
-          <a:prstGeom prst="rect">
-            <a:avLst/>
-          </a:prstGeom>
-          <a:noFill/>
-          <a:ln/>
-        </p:spPr>
-        <p:txBody>
-          <a:bodyPr wrap="square" lIns="0" tIns="0" rIns="0" bIns="0" rtlCol="0" anchor="t"/>
-          <a:lstStyle/>
-          <a:p>
-            <a:pPr marL="0" indent="0">
-              <a:buNone/>
-            </a:pPr>
-            <a:r>
-              <a:rPr lang="en-US" sz="900" b="1" kern="0" spc="100" dirty="0">
-                <a:solidFill>
-                  <a:srgbClr val="F8D7CE"/>
-                </a:solidFill>
-              </a:rPr>
-              <a:t>LIMIT</a:t>
-            </a:r>
-            <a:endParaRPr lang="en-US" sz="900" dirty="0"/>
-          </a:p>
-        </p:txBody>
-      </p:sp>
-      <p:sp>
-        <p:nvSpPr>
-          <p:cNvPr id="24" name="Text 21"/>
-          <p:cNvSpPr txBox="1"/>
-          <p:nvPr/>
-        </p:nvSpPr>
-        <p:spPr>
-          <a:xfrm>
-            <a:off x="8229600" y="1956816"/>
-            <a:ext cx="3227832" cy="329184"/>
-          </a:xfrm>
-          <a:prstGeom prst="rect">
-            <a:avLst/>
-          </a:prstGeom>
-          <a:noFill/>
-          <a:ln/>
-        </p:spPr>
-        <p:txBody>
-          <a:bodyPr wrap="square" lIns="0" tIns="0" rIns="0" bIns="0" rtlCol="0" anchor="t"/>
-          <a:lstStyle/>
-          <a:p>
-            <a:pPr marL="0" indent="0">
-              <a:buNone/>
-            </a:pPr>
-            <a:r>
-              <a:rPr lang="en-US" sz="1500" b="1" dirty="0">
-                <a:solidFill>
-                  <a:schemeClr val="bg1"/>
-                </a:solidFill>
-              </a:rPr>
-              <a:t>It can invent its own support</a:t>
-            </a:r>
-            <a:endParaRPr lang="en-US" sz="1500" dirty="0"/>
-          </a:p>
-        </p:txBody>
-      </p:sp>
-      <p:sp>
-        <p:nvSpPr>
-          <p:cNvPr id="25" name="Text 22"/>
-          <p:cNvSpPr txBox="1"/>
-          <p:nvPr/>
-        </p:nvSpPr>
-        <p:spPr>
-          <a:xfrm>
-            <a:off x="8229600" y="2286000"/>
-            <a:ext cx="3227832" cy="384048"/>
-          </a:xfrm>
-          <a:prstGeom prst="rect">
-            <a:avLst/>
-          </a:prstGeom>
-          <a:noFill/>
-          <a:ln/>
-        </p:spPr>
-        <p:txBody>
-          <a:bodyPr wrap="square" lIns="0" tIns="0" rIns="0" bIns="0" rtlCol="0" anchor="t"/>
-          <a:lstStyle/>
-          <a:p>
-            <a:pPr marL="0" indent="0">
-              <a:buNone/>
-            </a:pPr>
-            <a:r>
-              <a:rPr lang="en-US" sz="1100" dirty="0">
-                <a:solidFill>
-                  <a:srgbClr val="F8D7CE"/>
-                </a:solidFill>
-              </a:rPr>
-              <a:t>A fluent quote or figure that was never in the document.</a:t>
-            </a:r>
-            <a:endParaRPr lang="en-US" sz="1100" dirty="0"/>
-          </a:p>
-        </p:txBody>
-      </p:sp>
-      <p:sp>
-        <p:nvSpPr>
-          <p:cNvPr id="26" name="Shape 23"/>
-          <p:cNvSpPr/>
-          <p:nvPr/>
-        </p:nvSpPr>
-        <p:spPr>
-          <a:xfrm>
-            <a:off x="8046720" y="2697480"/>
-            <a:ext cx="3593592" cy="2743200"/>
-          </a:xfrm>
-          <a:prstGeom prst="rect">
-            <a:avLst/>
-          </a:prstGeom>
-          <a:solidFill>
-            <a:srgbClr val="EEF2F7"/>
-          </a:solidFill>
-          <a:ln w="12700">
-            <a:solidFill>
-              <a:srgbClr val="EEF2F7"/>
-            </a:solidFill>
-            <a:prstDash val="solid"/>
-          </a:ln>
-        </p:spPr>
-        <p:txBody>
-          <a:bodyPr/>
-          <a:lstStyle/>
-          <a:p>
-            <a:endParaRPr lang="en-US"/>
-          </a:p>
-        </p:txBody>
-      </p:sp>
-      <p:sp>
-        <p:nvSpPr>
-          <p:cNvPr id="27" name="Text 24"/>
-          <p:cNvSpPr txBox="1"/>
-          <p:nvPr/>
-        </p:nvSpPr>
-        <p:spPr>
-          <a:xfrm>
-            <a:off x="8229600" y="2834640"/>
-            <a:ext cx="3227832" cy="182880"/>
-          </a:xfrm>
-          <a:prstGeom prst="rect">
-            <a:avLst/>
-          </a:prstGeom>
-          <a:noFill/>
-          <a:ln/>
-        </p:spPr>
-        <p:txBody>
-          <a:bodyPr wrap="square" lIns="0" tIns="0" rIns="0" bIns="0" rtlCol="0" anchor="t"/>
-          <a:lstStyle/>
-          <a:p>
-            <a:pPr marL="0" indent="0">
-              <a:buNone/>
-            </a:pPr>
-            <a:r>
-              <a:rPr lang="en-US" sz="900" b="1" kern="0" spc="100" dirty="0">
-                <a:solidFill>
-                  <a:schemeClr val="accent4"/>
-                </a:solidFill>
-              </a:rPr>
-              <a:t>WHAT WE DO</a:t>
-            </a:r>
-            <a:endParaRPr lang="en-US" sz="900" dirty="0"/>
-          </a:p>
-        </p:txBody>
-      </p:sp>
-      <p:sp>
-        <p:nvSpPr>
-          <p:cNvPr id="28" name="Text 25"/>
-          <p:cNvSpPr txBox="1"/>
-          <p:nvPr/>
-        </p:nvSpPr>
-        <p:spPr>
-          <a:xfrm>
-            <a:off x="8229600" y="3108960"/>
-            <a:ext cx="3227832" cy="2240280"/>
-          </a:xfrm>
-          <a:prstGeom prst="rect">
-            <a:avLst/>
-          </a:prstGeom>
-          <a:noFill/>
-          <a:ln/>
-        </p:spPr>
-        <p:txBody>
-          <a:bodyPr wrap="square" lIns="0" tIns="0" rIns="0" bIns="0" rtlCol="0" anchor="t"/>
-          <a:lstStyle/>
-          <a:p>
-            <a:pPr marL="342900" indent="-342900">
-              <a:buSzPct val="100000"/>
-              <a:buChar char="•"/>
-            </a:pPr>
-            <a:r>
-              <a:rPr lang="en-US" sz="1300" b="1" dirty="0">
-                <a:solidFill>
-                  <a:srgbClr val="1B1F2A"/>
-                </a:solidFill>
-              </a:rPr>
-              <a:t>Check: </a:t>
-            </a:r>
-            <a:r>
-              <a:rPr lang="en-US" sz="1300" dirty="0">
-                <a:solidFill>
-                  <a:schemeClr val="tx1"/>
-                </a:solidFill>
-              </a:rPr>
-              <a:t>every quote matched to its item character for character, by code; a quote stitched from two places fails.</a:t>
-            </a:r>
-            <a:endParaRPr lang="en-US" sz="1300" dirty="0"/>
-          </a:p>
-          <a:p>
-            <a:pPr marL="342900" indent="-342900">
-              <a:buSzPct val="100000"/>
-              <a:buChar char="•"/>
-            </a:pPr>
-            <a:r>
-              <a:rPr lang="en-US" sz="1300" b="1" dirty="0">
-                <a:solidFill>
-                  <a:srgbClr val="1B1F2A"/>
-                </a:solidFill>
-              </a:rPr>
-              <a:t>Bounds: </a:t>
-            </a:r>
-            <a:r>
-              <a:rPr lang="en-US" sz="1300" dirty="0">
-                <a:solidFill>
-                  <a:schemeClr val="tx1"/>
-                </a:solidFill>
-              </a:rPr>
-              <a:t>every watch-out answered by id; the opinion clipped to −10 to +10.</a:t>
-            </a:r>
-            <a:endParaRPr lang="en-US" sz="1300" dirty="0"/>
-          </a:p>
-          <a:p>
-            <a:pPr marL="342900" indent="-342900">
-              <a:buSzPct val="100000"/>
-              <a:buChar char="•"/>
-            </a:pPr>
-            <a:r>
-              <a:rPr lang="en-US" sz="1300" b="1" dirty="0">
-                <a:solidFill>
-                  <a:srgbClr val="1B1F2A"/>
-                </a:solidFill>
-              </a:rPr>
-              <a:t>One repair round: </a:t>
-            </a:r>
-            <a:r>
-              <a:rPr lang="en-US" sz="1300" dirty="0">
-                <a:solidFill>
-                  <a:schemeClr val="tx1"/>
-                </a:solidFill>
-              </a:rPr>
-              <a:t>the verifier's report goes back once; both answers are kept; what still fails stays unverified.</a:t>
-            </a:r>
-            <a:endParaRPr lang="en-US" sz="1300" dirty="0"/>
-          </a:p>
-        </p:txBody>
-      </p:sp>
-      <p:sp>
-        <p:nvSpPr>
-          <p:cNvPr id="3" name="Slide Number Placeholder 0"/>
+          <p:cNvPr id="25" name="Slide Number Placeholder 0"/>
           <p:cNvSpPr>
             <a:spLocks noGrp="1"/>
           </p:cNvSpPr>
@@ -5708,7 +5429,7 @@
           </a:prstGeom>
           <a:extLst>
             <a:ext uri="{C572A759-6A51-4108-AA02-DFA0A04FC94B}">
-              <ma14:wrappingTextBoxFlag xmlns="" xmlns:ma14="http://schemas.microsoft.com/office/mac/drawingml/2011/main" val="0"/>
+              <ma14:wrappingTextBoxFlag xmlns:ma14="http://schemas.microsoft.com/office/mac/drawingml/2011/main" xmlns="" val="0"/>
             </a:ext>
           </a:extLst>
         </p:spPr>
@@ -5736,7 +5457,7 @@
     </p:spTree>
     <p:extLst>
       <p:ext uri="{BB962C8B-B14F-4D97-AF65-F5344CB8AC3E}">
-        <p14:creationId xmlns:p14="http://schemas.microsoft.com/office/powerpoint/2010/main" val="603732033"/>
+        <p14:creationId xmlns:p14="http://schemas.microsoft.com/office/powerpoint/2010/main" val="3216961536"/>
       </p:ext>
     </p:extLst>
   </p:cSld>
@@ -8115,7 +7836,7 @@
           </a:prstGeom>
           <a:extLst>
             <a:ext uri="{C572A759-6A51-4108-AA02-DFA0A04FC94B}">
-              <ma14:wrappingTextBoxFlag xmlns="" xmlns:ma14="http://schemas.microsoft.com/office/mac/drawingml/2011/main" val="0"/>
+              <ma14:wrappingTextBoxFlag xmlns:ma14="http://schemas.microsoft.com/office/mac/drawingml/2011/main" xmlns="" val="0"/>
             </a:ext>
           </a:extLst>
         </p:spPr>
@@ -9104,7 +8825,7 @@
           </a:prstGeom>
           <a:extLst>
             <a:ext uri="{C572A759-6A51-4108-AA02-DFA0A04FC94B}">
-              <ma14:wrappingTextBoxFlag xmlns="" xmlns:ma14="http://schemas.microsoft.com/office/mac/drawingml/2011/main" val="0"/>
+              <ma14:wrappingTextBoxFlag xmlns:ma14="http://schemas.microsoft.com/office/mac/drawingml/2011/main" xmlns="" val="0"/>
             </a:ext>
           </a:extLst>
         </p:spPr>
@@ -10808,7 +10529,7 @@
           </a:prstGeom>
           <a:extLst>
             <a:ext uri="{C572A759-6A51-4108-AA02-DFA0A04FC94B}">
-              <ma14:wrappingTextBoxFlag xmlns="" xmlns:ma14="http://schemas.microsoft.com/office/mac/drawingml/2011/main" val="0"/>
+              <ma14:wrappingTextBoxFlag xmlns:ma14="http://schemas.microsoft.com/office/mac/drawingml/2011/main" xmlns="" val="0"/>
             </a:ext>
           </a:extLst>
         </p:spPr>
@@ -13774,7 +13495,7 @@
           </a:prstGeom>
           <a:extLst>
             <a:ext uri="{C572A759-6A51-4108-AA02-DFA0A04FC94B}">
-              <ma14:wrappingTextBoxFlag xmlns="" xmlns:ma14="http://schemas.microsoft.com/office/mac/drawingml/2011/main" val="0"/>
+              <ma14:wrappingTextBoxFlag xmlns:ma14="http://schemas.microsoft.com/office/mac/drawingml/2011/main" xmlns="" val="0"/>
             </a:ext>
           </a:extLst>
         </p:spPr>
@@ -14698,7 +14419,7 @@
           </a:prstGeom>
           <a:extLst>
             <a:ext uri="{C572A759-6A51-4108-AA02-DFA0A04FC94B}">
-              <ma14:wrappingTextBoxFlag xmlns="" xmlns:ma14="http://schemas.microsoft.com/office/mac/drawingml/2011/main" val="0"/>
+              <ma14:wrappingTextBoxFlag xmlns:ma14="http://schemas.microsoft.com/office/mac/drawingml/2011/main" xmlns="" val="0"/>
             </a:ext>
           </a:extLst>
         </p:spPr>
@@ -16678,7 +16399,7 @@
           </a:prstGeom>
           <a:extLst>
             <a:ext uri="{C572A759-6A51-4108-AA02-DFA0A04FC94B}">
-              <ma14:wrappingTextBoxFlag xmlns="" xmlns:ma14="http://schemas.microsoft.com/office/mac/drawingml/2011/main" val="0"/>
+              <ma14:wrappingTextBoxFlag xmlns:ma14="http://schemas.microsoft.com/office/mac/drawingml/2011/main" xmlns="" val="0"/>
             </a:ext>
           </a:extLst>
         </p:spPr>
@@ -19655,7 +19376,7 @@
           </a:prstGeom>
           <a:extLst>
             <a:ext uri="{C572A759-6A51-4108-AA02-DFA0A04FC94B}">
-              <ma14:wrappingTextBoxFlag xmlns:ma14="http://schemas.microsoft.com/office/mac/drawingml/2011/main" xmlns="" val="0"/>
+              <ma14:wrappingTextBoxFlag xmlns="" xmlns:ma14="http://schemas.microsoft.com/office/mac/drawingml/2011/main" val="0"/>
             </a:ext>
           </a:extLst>
         </p:spPr>
@@ -21648,7 +21369,7 @@
           </a:prstGeom>
           <a:extLst>
             <a:ext uri="{C572A759-6A51-4108-AA02-DFA0A04FC94B}">
-              <ma14:wrappingTextBoxFlag xmlns:ma14="http://schemas.microsoft.com/office/mac/drawingml/2011/main" xmlns="" val="0"/>
+              <ma14:wrappingTextBoxFlag xmlns="" xmlns:ma14="http://schemas.microsoft.com/office/mac/drawingml/2011/main" val="0"/>
             </a:ext>
           </a:extLst>
         </p:spPr>
@@ -21677,6 +21398,2010 @@
     <p:extLst>
       <p:ext uri="{BB962C8B-B14F-4D97-AF65-F5344CB8AC3E}">
         <p14:creationId xmlns:p14="http://schemas.microsoft.com/office/powerpoint/2010/main" val="742894264"/>
+      </p:ext>
+    </p:extLst>
+  </p:cSld>
+  <p:clrMapOvr>
+    <a:masterClrMapping/>
+  </p:clrMapOvr>
+</p:sld>
+</file>
+
+<file path=ppt/slides/slide24.xml><?xml version="1.0" encoding="utf-8"?>
+<p:sld xmlns:a="http://schemas.openxmlformats.org/drawingml/2006/main" xmlns:r="http://schemas.openxmlformats.org/officeDocument/2006/relationships" xmlns:p="http://schemas.openxmlformats.org/presentationml/2006/main">
+  <p:cSld>
+    <p:spTree>
+      <p:nvGrpSpPr>
+        <p:cNvPr id="1" name=""/>
+        <p:cNvGrpSpPr/>
+        <p:nvPr/>
+      </p:nvGrpSpPr>
+      <p:grpSpPr>
+        <a:xfrm>
+          <a:off x="0" y="0"/>
+          <a:ext cx="0" cy="0"/>
+          <a:chOff x="0" y="0"/>
+          <a:chExt cx="0" cy="0"/>
+        </a:xfrm>
+      </p:grpSpPr>
+      <p:sp>
+        <p:nvSpPr>
+          <p:cNvPr id="2" name="Text 0"/>
+          <p:cNvSpPr>
+            <a:spLocks noGrp="1"/>
+          </p:cNvSpPr>
+          <p:nvPr>
+            <p:ph type="title" idx="100" hasCustomPrompt="1"/>
+          </p:nvPr>
+        </p:nvSpPr>
+        <p:spPr>
+          <a:xfrm>
+            <a:off x="548640" y="411480"/>
+            <a:ext cx="11091672" cy="822960"/>
+          </a:xfrm>
+          <a:prstGeom prst="rect">
+            <a:avLst/>
+          </a:prstGeom>
+          <a:noFill/>
+          <a:ln/>
+        </p:spPr>
+        <p:txBody>
+          <a:bodyPr wrap="square" lIns="0" tIns="0" rIns="0" bIns="0" rtlCol="0" anchor="ctr"/>
+          <a:lstStyle/>
+          <a:p>
+            <a:pPr marL="0" indent="0" algn="l">
+              <a:buNone/>
+            </a:pPr>
+            <a:r>
+              <a:rPr lang="en-US" sz="3200" b="1" dirty="0">
+                <a:solidFill>
+                  <a:schemeClr val="tx2"/>
+                </a:solidFill>
+              </a:rPr>
+              <a:t>Appendix: historical base rates</a:t>
+            </a:r>
+            <a:endParaRPr lang="en-US" sz="3200" dirty="0"/>
+          </a:p>
+        </p:txBody>
+      </p:sp>
+      <p:sp>
+        <p:nvSpPr>
+          <p:cNvPr id="4" name="Shape 1"/>
+          <p:cNvSpPr/>
+          <p:nvPr/>
+        </p:nvSpPr>
+        <p:spPr>
+          <a:xfrm>
+            <a:off x="548640" y="1325880"/>
+            <a:ext cx="5394960" cy="4846320"/>
+          </a:xfrm>
+          <a:prstGeom prst="roundRect">
+            <a:avLst>
+              <a:gd name="adj" fmla="val 2264"/>
+            </a:avLst>
+          </a:prstGeom>
+          <a:solidFill>
+            <a:srgbClr val="EEF2F7"/>
+          </a:solidFill>
+          <a:ln w="12700">
+            <a:solidFill>
+              <a:srgbClr val="EEF2F7"/>
+            </a:solidFill>
+            <a:prstDash val="solid"/>
+          </a:ln>
+          <a:effectLst>
+            <a:outerShdw blurRad="50800" dist="12700" dir="5400000" algn="bl" rotWithShape="0">
+              <a:srgbClr val="000000">
+                <a:alpha val="8000"/>
+              </a:srgbClr>
+            </a:outerShdw>
+          </a:effectLst>
+        </p:spPr>
+      </p:sp>
+      <p:sp>
+        <p:nvSpPr>
+          <p:cNvPr id="5" name="Text 2"/>
+          <p:cNvSpPr txBox="1"/>
+          <p:nvPr/>
+        </p:nvSpPr>
+        <p:spPr>
+          <a:xfrm>
+            <a:off x="777240" y="1417320"/>
+            <a:ext cx="4937760" cy="320040"/>
+          </a:xfrm>
+          <a:prstGeom prst="rect">
+            <a:avLst/>
+          </a:prstGeom>
+          <a:noFill/>
+          <a:ln/>
+        </p:spPr>
+        <p:txBody>
+          <a:bodyPr wrap="square" lIns="0" tIns="0" rIns="0" bIns="0" rtlCol="0" anchor="t"/>
+          <a:lstStyle/>
+          <a:p>
+            <a:pPr marL="0" indent="0">
+              <a:buNone/>
+            </a:pPr>
+            <a:r>
+              <a:rPr lang="en-US" sz="1400" b="1" dirty="0">
+                <a:solidFill>
+                  <a:schemeClr val="tx2"/>
+                </a:solidFill>
+              </a:rPr>
+              <a:t>What it is</a:t>
+            </a:r>
+            <a:endParaRPr lang="en-US" sz="1400" dirty="0"/>
+          </a:p>
+        </p:txBody>
+      </p:sp>
+      <p:sp>
+        <p:nvSpPr>
+          <p:cNvPr id="6" name="Text 3"/>
+          <p:cNvSpPr txBox="1"/>
+          <p:nvPr/>
+        </p:nvSpPr>
+        <p:spPr>
+          <a:xfrm>
+            <a:off x="777240" y="1755648"/>
+            <a:ext cx="4937760" cy="4297680"/>
+          </a:xfrm>
+          <a:prstGeom prst="rect">
+            <a:avLst/>
+          </a:prstGeom>
+          <a:noFill/>
+          <a:ln/>
+        </p:spPr>
+        <p:txBody>
+          <a:bodyPr wrap="square" lIns="0" tIns="0" rIns="0" bIns="0" rtlCol="0" anchor="t"/>
+          <a:lstStyle/>
+          <a:p>
+            <a:pPr marL="342900" indent="-342900">
+              <a:spcAft>
+                <a:spcPts val="500"/>
+              </a:spcAft>
+              <a:buSzPct val="100000"/>
+              <a:buChar char="•"/>
+            </a:pPr>
+            <a:r>
+              <a:rPr lang="en-US" sz="1050" dirty="0">
+                <a:solidFill>
+                  <a:schemeClr val="tx1"/>
+                </a:solidFill>
+              </a:rPr>
+              <a:t>The simplest model in the pool, and the only one with no parameters: nothing is fitted, nothing can be tuned.</a:t>
+            </a:r>
+            <a:endParaRPr lang="en-US" sz="1050" dirty="0"/>
+          </a:p>
+          <a:p>
+            <a:pPr marL="342900" indent="-342900">
+              <a:spcAft>
+                <a:spcPts val="500"/>
+              </a:spcAft>
+              <a:buSzPct val="100000"/>
+              <a:buChar char="•"/>
+            </a:pPr>
+            <a:r>
+              <a:rPr lang="en-US" sz="1050" dirty="0">
+                <a:solidFill>
+                  <a:schemeClr val="tx1"/>
+                </a:solidFill>
+              </a:rPr>
+              <a:t>Take the 266 scheduled decisions since 1994. Group them by what the Fed had done at the previous meeting: a hike, a hold or a cut. Count what it did next. That count is the forecast.</a:t>
+            </a:r>
+            <a:endParaRPr lang="en-US" sz="1050" dirty="0"/>
+          </a:p>
+          <a:p>
+            <a:pPr marL="342900" indent="-342900">
+              <a:spcAft>
+                <a:spcPts val="500"/>
+              </a:spcAft>
+              <a:buSzPct val="100000"/>
+              <a:buChar char="•"/>
+            </a:pPr>
+            <a:r>
+              <a:rPr lang="en-US" sz="1050" dirty="0">
+                <a:solidFill>
+                  <a:schemeClr val="tx1"/>
+                </a:solidFill>
+              </a:rPr>
+              <a:t>Today the last decision was a hike, so the model reads the 49 meetings that followed a hike: hold 35%, hike 65%. The hike share is split 80/20 between +25 and +50, the historical share of large moves.</a:t>
+            </a:r>
+            <a:endParaRPr lang="en-US" sz="1050" dirty="0"/>
+          </a:p>
+          <a:p>
+            <a:pPr marL="342900" indent="-342900">
+              <a:spcAft>
+                <a:spcPts val="500"/>
+              </a:spcAft>
+              <a:buSzPct val="100000"/>
+              <a:buChar char="•"/>
+            </a:pPr>
+            <a:r>
+              <a:rPr lang="en-US" sz="1050" dirty="0">
+                <a:solidFill>
+                  <a:schemeClr val="tx1"/>
+                </a:solidFill>
+              </a:rPr>
+              <a:t>Why it is in the pool: on the expanding-window test it beat the fitted probit (log score −0.584 against −0.788), so it earned 0.1 (amendment #6). Why not more: it knows nothing about today; it is the prior the other models update.</a:t>
+            </a:r>
+            <a:endParaRPr lang="en-US" sz="1050" dirty="0"/>
+          </a:p>
+          <a:p>
+            <a:pPr marL="342900" indent="-342900">
+              <a:spcAft>
+                <a:spcPts val="500"/>
+              </a:spcAft>
+              <a:buSzPct val="100000"/>
+              <a:buChar char="•"/>
+            </a:pPr>
+            <a:r>
+              <a:rPr lang="en-US" sz="1050" dirty="0">
+                <a:solidFill>
+                  <a:schemeClr val="tx1"/>
+                </a:solidFill>
+              </a:rPr>
+              <a:t>Intermeeting moves (28 since 1994) are counted separately and never as a scheduled decision.</a:t>
+            </a:r>
+            <a:endParaRPr lang="en-US" sz="1050" dirty="0"/>
+          </a:p>
+        </p:txBody>
+      </p:sp>
+      <p:sp>
+        <p:nvSpPr>
+          <p:cNvPr id="7" name="Text 4"/>
+          <p:cNvSpPr txBox="1"/>
+          <p:nvPr/>
+        </p:nvSpPr>
+        <p:spPr>
+          <a:xfrm>
+            <a:off x="6172200" y="1371600"/>
+            <a:ext cx="5468112" cy="320040"/>
+          </a:xfrm>
+          <a:prstGeom prst="rect">
+            <a:avLst/>
+          </a:prstGeom>
+          <a:noFill/>
+          <a:ln/>
+        </p:spPr>
+        <p:txBody>
+          <a:bodyPr wrap="square" lIns="0" tIns="0" rIns="0" bIns="0" rtlCol="0" anchor="t"/>
+          <a:lstStyle/>
+          <a:p>
+            <a:pPr marL="0" indent="0">
+              <a:buNone/>
+            </a:pPr>
+            <a:r>
+              <a:rPr lang="en-US" sz="1400" b="1" dirty="0">
+                <a:solidFill>
+                  <a:schemeClr val="tx2"/>
+                </a:solidFill>
+              </a:rPr>
+              <a:t>What the Fed did next, 266 scheduled meetings since 1994</a:t>
+            </a:r>
+            <a:endParaRPr lang="en-US" sz="1400" dirty="0"/>
+          </a:p>
+        </p:txBody>
+      </p:sp>
+      <p:graphicFrame>
+        <p:nvGraphicFramePr>
+          <p:cNvPr id="27" name="Table 0"/>
+          <p:cNvGraphicFramePr>
+            <a:graphicFrameLocks noGrp="1"/>
+          </p:cNvGraphicFramePr>
+          <p:nvPr>
+            <p:extLst>
+              <p:ext uri="{D42A27DB-BD31-4B8C-83A1-F6EECF244321}">
+                <p14:modId xmlns:p14="http://schemas.microsoft.com/office/powerpoint/2010/main" val="1579011935"/>
+              </p:ext>
+            </p:extLst>
+          </p:nvPr>
+        </p:nvGraphicFramePr>
+        <p:xfrm>
+          <a:off x="6172200" y="1783080"/>
+          <a:ext cx="5468112" cy="914400"/>
+        </p:xfrm>
+        <a:graphic>
+          <a:graphicData uri="http://schemas.openxmlformats.org/drawingml/2006/table">
+            <a:tbl>
+              <a:tblPr/>
+              <a:tblGrid>
+                <a:gridCol w="1920240">
+                  <a:extLst>
+                    <a:ext uri="{9D8B030D-6E8A-4147-A177-3AD203B41FA5}">
+                      <a16:colId xmlns:a16="http://schemas.microsoft.com/office/drawing/2014/main" val="20000"/>
+                    </a:ext>
+                  </a:extLst>
+                </a:gridCol>
+                <a:gridCol w="914400">
+                  <a:extLst>
+                    <a:ext uri="{9D8B030D-6E8A-4147-A177-3AD203B41FA5}">
+                      <a16:colId xmlns:a16="http://schemas.microsoft.com/office/drawing/2014/main" val="20001"/>
+                    </a:ext>
+                  </a:extLst>
+                </a:gridCol>
+                <a:gridCol w="960120">
+                  <a:extLst>
+                    <a:ext uri="{9D8B030D-6E8A-4147-A177-3AD203B41FA5}">
+                      <a16:colId xmlns:a16="http://schemas.microsoft.com/office/drawing/2014/main" val="20002"/>
+                    </a:ext>
+                  </a:extLst>
+                </a:gridCol>
+                <a:gridCol w="960120">
+                  <a:extLst>
+                    <a:ext uri="{9D8B030D-6E8A-4147-A177-3AD203B41FA5}">
+                      <a16:colId xmlns:a16="http://schemas.microsoft.com/office/drawing/2014/main" val="20003"/>
+                    </a:ext>
+                  </a:extLst>
+                </a:gridCol>
+                <a:gridCol w="987552">
+                  <a:extLst>
+                    <a:ext uri="{9D8B030D-6E8A-4147-A177-3AD203B41FA5}">
+                      <a16:colId xmlns:a16="http://schemas.microsoft.com/office/drawing/2014/main" val="20004"/>
+                    </a:ext>
+                  </a:extLst>
+                </a:gridCol>
+              </a:tblGrid>
+              <a:tr h="420624">
+                <a:tc>
+                  <a:txBody>
+                    <a:bodyPr/>
+                    <a:lstStyle/>
+                    <a:p>
+                      <a:pPr marL="0" indent="0">
+                        <a:buNone/>
+                      </a:pPr>
+                      <a:r>
+                        <a:rPr lang="en-US" sz="1150" b="1" dirty="0">
+                          <a:solidFill>
+                            <a:srgbClr val="FFFFFF"/>
+                          </a:solidFill>
+                        </a:rPr>
+                        <a:t>Previous decision</a:t>
+                      </a:r>
+                      <a:endParaRPr lang="en-US" sz="1150" dirty="0"/>
+                    </a:p>
+                  </a:txBody>
+                  <a:tcPr marL="45720" marR="45720" anchor="ctr">
+                    <a:lnL w="6350" cap="flat" cmpd="sng" algn="ctr">
+                      <a:solidFill>
+                        <a:srgbClr val="D5DBE5"/>
+                      </a:solidFill>
+                      <a:prstDash val="solid"/>
+                      <a:round/>
+                      <a:headEnd type="none" w="med" len="med"/>
+                      <a:tailEnd type="none" w="med" len="med"/>
+                    </a:lnL>
+                    <a:lnR w="6350" cap="flat" cmpd="sng" algn="ctr">
+                      <a:solidFill>
+                        <a:srgbClr val="D5DBE5"/>
+                      </a:solidFill>
+                      <a:prstDash val="solid"/>
+                      <a:round/>
+                      <a:headEnd type="none" w="med" len="med"/>
+                      <a:tailEnd type="none" w="med" len="med"/>
+                    </a:lnR>
+                    <a:lnT w="6350" cap="flat" cmpd="sng" algn="ctr">
+                      <a:solidFill>
+                        <a:srgbClr val="D5DBE5"/>
+                      </a:solidFill>
+                      <a:prstDash val="solid"/>
+                      <a:round/>
+                      <a:headEnd type="none" w="med" len="med"/>
+                      <a:tailEnd type="none" w="med" len="med"/>
+                    </a:lnT>
+                    <a:lnB w="6350" cap="flat" cmpd="sng" algn="ctr">
+                      <a:solidFill>
+                        <a:srgbClr val="D5DBE5"/>
+                      </a:solidFill>
+                      <a:prstDash val="solid"/>
+                      <a:round/>
+                      <a:headEnd type="none" w="med" len="med"/>
+                      <a:tailEnd type="none" w="med" len="med"/>
+                    </a:lnB>
+                    <a:solidFill>
+                      <a:srgbClr val="1E2761"/>
+                    </a:solidFill>
+                  </a:tcPr>
+                </a:tc>
+                <a:tc>
+                  <a:txBody>
+                    <a:bodyPr/>
+                    <a:lstStyle/>
+                    <a:p>
+                      <a:pPr marL="0" indent="0" algn="ctr">
+                        <a:buNone/>
+                      </a:pPr>
+                      <a:r>
+                        <a:rPr lang="en-US" sz="1150" b="1" dirty="0">
+                          <a:solidFill>
+                            <a:srgbClr val="FFFFFF"/>
+                          </a:solidFill>
+                        </a:rPr>
+                        <a:t>Cases</a:t>
+                      </a:r>
+                      <a:endParaRPr lang="en-US" sz="1150" dirty="0"/>
+                    </a:p>
+                  </a:txBody>
+                  <a:tcPr marL="45720" marR="45720" anchor="ctr">
+                    <a:lnL w="6350" cap="flat" cmpd="sng" algn="ctr">
+                      <a:solidFill>
+                        <a:srgbClr val="D5DBE5"/>
+                      </a:solidFill>
+                      <a:prstDash val="solid"/>
+                      <a:round/>
+                      <a:headEnd type="none" w="med" len="med"/>
+                      <a:tailEnd type="none" w="med" len="med"/>
+                    </a:lnL>
+                    <a:lnR w="6350" cap="flat" cmpd="sng" algn="ctr">
+                      <a:solidFill>
+                        <a:srgbClr val="D5DBE5"/>
+                      </a:solidFill>
+                      <a:prstDash val="solid"/>
+                      <a:round/>
+                      <a:headEnd type="none" w="med" len="med"/>
+                      <a:tailEnd type="none" w="med" len="med"/>
+                    </a:lnR>
+                    <a:lnT w="6350" cap="flat" cmpd="sng" algn="ctr">
+                      <a:solidFill>
+                        <a:srgbClr val="D5DBE5"/>
+                      </a:solidFill>
+                      <a:prstDash val="solid"/>
+                      <a:round/>
+                      <a:headEnd type="none" w="med" len="med"/>
+                      <a:tailEnd type="none" w="med" len="med"/>
+                    </a:lnT>
+                    <a:lnB w="6350" cap="flat" cmpd="sng" algn="ctr">
+                      <a:solidFill>
+                        <a:srgbClr val="D5DBE5"/>
+                      </a:solidFill>
+                      <a:prstDash val="solid"/>
+                      <a:round/>
+                      <a:headEnd type="none" w="med" len="med"/>
+                      <a:tailEnd type="none" w="med" len="med"/>
+                    </a:lnB>
+                    <a:solidFill>
+                      <a:srgbClr val="1E2761"/>
+                    </a:solidFill>
+                  </a:tcPr>
+                </a:tc>
+                <a:tc>
+                  <a:txBody>
+                    <a:bodyPr/>
+                    <a:lstStyle/>
+                    <a:p>
+                      <a:pPr marL="0" indent="0" algn="ctr">
+                        <a:buNone/>
+                      </a:pPr>
+                      <a:r>
+                        <a:rPr lang="en-US" sz="1150" b="1" dirty="0">
+                          <a:solidFill>
+                            <a:srgbClr val="FFFFFF"/>
+                          </a:solidFill>
+                        </a:rPr>
+                        <a:t>Next: cut</a:t>
+                      </a:r>
+                      <a:endParaRPr lang="en-US" sz="1150" dirty="0"/>
+                    </a:p>
+                  </a:txBody>
+                  <a:tcPr marL="45720" marR="45720" anchor="ctr">
+                    <a:lnL w="6350" cap="flat" cmpd="sng" algn="ctr">
+                      <a:solidFill>
+                        <a:srgbClr val="D5DBE5"/>
+                      </a:solidFill>
+                      <a:prstDash val="solid"/>
+                      <a:round/>
+                      <a:headEnd type="none" w="med" len="med"/>
+                      <a:tailEnd type="none" w="med" len="med"/>
+                    </a:lnL>
+                    <a:lnR w="6350" cap="flat" cmpd="sng" algn="ctr">
+                      <a:solidFill>
+                        <a:srgbClr val="D5DBE5"/>
+                      </a:solidFill>
+                      <a:prstDash val="solid"/>
+                      <a:round/>
+                      <a:headEnd type="none" w="med" len="med"/>
+                      <a:tailEnd type="none" w="med" len="med"/>
+                    </a:lnR>
+                    <a:lnT w="6350" cap="flat" cmpd="sng" algn="ctr">
+                      <a:solidFill>
+                        <a:srgbClr val="D5DBE5"/>
+                      </a:solidFill>
+                      <a:prstDash val="solid"/>
+                      <a:round/>
+                      <a:headEnd type="none" w="med" len="med"/>
+                      <a:tailEnd type="none" w="med" len="med"/>
+                    </a:lnT>
+                    <a:lnB w="6350" cap="flat" cmpd="sng" algn="ctr">
+                      <a:solidFill>
+                        <a:srgbClr val="D5DBE5"/>
+                      </a:solidFill>
+                      <a:prstDash val="solid"/>
+                      <a:round/>
+                      <a:headEnd type="none" w="med" len="med"/>
+                      <a:tailEnd type="none" w="med" len="med"/>
+                    </a:lnB>
+                    <a:solidFill>
+                      <a:srgbClr val="1E2761"/>
+                    </a:solidFill>
+                  </a:tcPr>
+                </a:tc>
+                <a:tc>
+                  <a:txBody>
+                    <a:bodyPr/>
+                    <a:lstStyle/>
+                    <a:p>
+                      <a:pPr marL="0" indent="0" algn="ctr">
+                        <a:buNone/>
+                      </a:pPr>
+                      <a:r>
+                        <a:rPr lang="en-US" sz="1150" b="1" dirty="0">
+                          <a:solidFill>
+                            <a:srgbClr val="FFFFFF"/>
+                          </a:solidFill>
+                        </a:rPr>
+                        <a:t>Next: hold</a:t>
+                      </a:r>
+                      <a:endParaRPr lang="en-US" sz="1150" dirty="0"/>
+                    </a:p>
+                  </a:txBody>
+                  <a:tcPr marL="45720" marR="45720" anchor="ctr">
+                    <a:lnL w="6350" cap="flat" cmpd="sng" algn="ctr">
+                      <a:solidFill>
+                        <a:srgbClr val="D5DBE5"/>
+                      </a:solidFill>
+                      <a:prstDash val="solid"/>
+                      <a:round/>
+                      <a:headEnd type="none" w="med" len="med"/>
+                      <a:tailEnd type="none" w="med" len="med"/>
+                    </a:lnL>
+                    <a:lnR w="6350" cap="flat" cmpd="sng" algn="ctr">
+                      <a:solidFill>
+                        <a:srgbClr val="D5DBE5"/>
+                      </a:solidFill>
+                      <a:prstDash val="solid"/>
+                      <a:round/>
+                      <a:headEnd type="none" w="med" len="med"/>
+                      <a:tailEnd type="none" w="med" len="med"/>
+                    </a:lnR>
+                    <a:lnT w="6350" cap="flat" cmpd="sng" algn="ctr">
+                      <a:solidFill>
+                        <a:srgbClr val="D5DBE5"/>
+                      </a:solidFill>
+                      <a:prstDash val="solid"/>
+                      <a:round/>
+                      <a:headEnd type="none" w="med" len="med"/>
+                      <a:tailEnd type="none" w="med" len="med"/>
+                    </a:lnT>
+                    <a:lnB w="6350" cap="flat" cmpd="sng" algn="ctr">
+                      <a:solidFill>
+                        <a:srgbClr val="D5DBE5"/>
+                      </a:solidFill>
+                      <a:prstDash val="solid"/>
+                      <a:round/>
+                      <a:headEnd type="none" w="med" len="med"/>
+                      <a:tailEnd type="none" w="med" len="med"/>
+                    </a:lnB>
+                    <a:solidFill>
+                      <a:srgbClr val="1E2761"/>
+                    </a:solidFill>
+                  </a:tcPr>
+                </a:tc>
+                <a:tc>
+                  <a:txBody>
+                    <a:bodyPr/>
+                    <a:lstStyle/>
+                    <a:p>
+                      <a:pPr marL="0" indent="0" algn="ctr">
+                        <a:buNone/>
+                      </a:pPr>
+                      <a:r>
+                        <a:rPr lang="en-US" sz="1150" b="1" dirty="0">
+                          <a:solidFill>
+                            <a:srgbClr val="FFFFFF"/>
+                          </a:solidFill>
+                        </a:rPr>
+                        <a:t>Next: hike</a:t>
+                      </a:r>
+                      <a:endParaRPr lang="en-US" sz="1150" dirty="0"/>
+                    </a:p>
+                  </a:txBody>
+                  <a:tcPr marL="45720" marR="45720" anchor="ctr">
+                    <a:lnL w="6350" cap="flat" cmpd="sng" algn="ctr">
+                      <a:solidFill>
+                        <a:srgbClr val="D5DBE5"/>
+                      </a:solidFill>
+                      <a:prstDash val="solid"/>
+                      <a:round/>
+                      <a:headEnd type="none" w="med" len="med"/>
+                      <a:tailEnd type="none" w="med" len="med"/>
+                    </a:lnL>
+                    <a:lnR w="6350" cap="flat" cmpd="sng" algn="ctr">
+                      <a:solidFill>
+                        <a:srgbClr val="D5DBE5"/>
+                      </a:solidFill>
+                      <a:prstDash val="solid"/>
+                      <a:round/>
+                      <a:headEnd type="none" w="med" len="med"/>
+                      <a:tailEnd type="none" w="med" len="med"/>
+                    </a:lnR>
+                    <a:lnT w="6350" cap="flat" cmpd="sng" algn="ctr">
+                      <a:solidFill>
+                        <a:srgbClr val="D5DBE5"/>
+                      </a:solidFill>
+                      <a:prstDash val="solid"/>
+                      <a:round/>
+                      <a:headEnd type="none" w="med" len="med"/>
+                      <a:tailEnd type="none" w="med" len="med"/>
+                    </a:lnT>
+                    <a:lnB w="6350" cap="flat" cmpd="sng" algn="ctr">
+                      <a:solidFill>
+                        <a:srgbClr val="D5DBE5"/>
+                      </a:solidFill>
+                      <a:prstDash val="solid"/>
+                      <a:round/>
+                      <a:headEnd type="none" w="med" len="med"/>
+                      <a:tailEnd type="none" w="med" len="med"/>
+                    </a:lnB>
+                    <a:solidFill>
+                      <a:srgbClr val="1E2761"/>
+                    </a:solidFill>
+                  </a:tcPr>
+                </a:tc>
+                <a:extLst>
+                  <a:ext uri="{0D108BD9-81ED-4DB2-BD59-A6C34878D82A}">
+                    <a16:rowId xmlns:a16="http://schemas.microsoft.com/office/drawing/2014/main" val="10000"/>
+                  </a:ext>
+                </a:extLst>
+              </a:tr>
+              <a:tr h="420624">
+                <a:tc>
+                  <a:txBody>
+                    <a:bodyPr/>
+                    <a:lstStyle/>
+                    <a:p>
+                      <a:pPr marL="0" indent="0">
+                        <a:buNone/>
+                      </a:pPr>
+                      <a:r>
+                        <a:rPr lang="en-US" sz="1150" b="1" dirty="0">
+                          <a:solidFill>
+                            <a:srgbClr val="1B1F2A"/>
+                          </a:solidFill>
+                        </a:rPr>
+                        <a:t>A hike (today's case)</a:t>
+                      </a:r>
+                      <a:endParaRPr lang="en-US" sz="1150" dirty="0"/>
+                    </a:p>
+                  </a:txBody>
+                  <a:tcPr marL="45720" marR="45720" anchor="ctr">
+                    <a:lnL w="6350" cap="flat" cmpd="sng" algn="ctr">
+                      <a:solidFill>
+                        <a:srgbClr val="D5DBE5"/>
+                      </a:solidFill>
+                      <a:prstDash val="solid"/>
+                      <a:round/>
+                      <a:headEnd type="none" w="med" len="med"/>
+                      <a:tailEnd type="none" w="med" len="med"/>
+                    </a:lnL>
+                    <a:lnR w="6350" cap="flat" cmpd="sng" algn="ctr">
+                      <a:solidFill>
+                        <a:srgbClr val="D5DBE5"/>
+                      </a:solidFill>
+                      <a:prstDash val="solid"/>
+                      <a:round/>
+                      <a:headEnd type="none" w="med" len="med"/>
+                      <a:tailEnd type="none" w="med" len="med"/>
+                    </a:lnR>
+                    <a:lnT w="6350" cap="flat" cmpd="sng" algn="ctr">
+                      <a:solidFill>
+                        <a:srgbClr val="D5DBE5"/>
+                      </a:solidFill>
+                      <a:prstDash val="solid"/>
+                      <a:round/>
+                      <a:headEnd type="none" w="med" len="med"/>
+                      <a:tailEnd type="none" w="med" len="med"/>
+                    </a:lnT>
+                    <a:lnB w="6350" cap="flat" cmpd="sng" algn="ctr">
+                      <a:solidFill>
+                        <a:srgbClr val="D5DBE5"/>
+                      </a:solidFill>
+                      <a:prstDash val="solid"/>
+                      <a:round/>
+                      <a:headEnd type="none" w="med" len="med"/>
+                      <a:tailEnd type="none" w="med" len="med"/>
+                    </a:lnB>
+                  </a:tcPr>
+                </a:tc>
+                <a:tc>
+                  <a:txBody>
+                    <a:bodyPr/>
+                    <a:lstStyle/>
+                    <a:p>
+                      <a:pPr marL="0" indent="0" algn="ctr">
+                        <a:buNone/>
+                      </a:pPr>
+                      <a:r>
+                        <a:rPr lang="en-US" sz="1150" b="1" dirty="0">
+                          <a:solidFill>
+                            <a:srgbClr val="1B1F2A"/>
+                          </a:solidFill>
+                        </a:rPr>
+                        <a:t>50</a:t>
+                      </a:r>
+                      <a:endParaRPr lang="en-US" sz="1150" dirty="0"/>
+                    </a:p>
+                  </a:txBody>
+                  <a:tcPr marL="45720" marR="45720" anchor="ctr">
+                    <a:lnL w="6350" cap="flat" cmpd="sng" algn="ctr">
+                      <a:solidFill>
+                        <a:srgbClr val="D5DBE5"/>
+                      </a:solidFill>
+                      <a:prstDash val="solid"/>
+                      <a:round/>
+                      <a:headEnd type="none" w="med" len="med"/>
+                      <a:tailEnd type="none" w="med" len="med"/>
+                    </a:lnL>
+                    <a:lnR w="6350" cap="flat" cmpd="sng" algn="ctr">
+                      <a:solidFill>
+                        <a:srgbClr val="D5DBE5"/>
+                      </a:solidFill>
+                      <a:prstDash val="solid"/>
+                      <a:round/>
+                      <a:headEnd type="none" w="med" len="med"/>
+                      <a:tailEnd type="none" w="med" len="med"/>
+                    </a:lnR>
+                    <a:lnT w="6350" cap="flat" cmpd="sng" algn="ctr">
+                      <a:solidFill>
+                        <a:srgbClr val="D5DBE5"/>
+                      </a:solidFill>
+                      <a:prstDash val="solid"/>
+                      <a:round/>
+                      <a:headEnd type="none" w="med" len="med"/>
+                      <a:tailEnd type="none" w="med" len="med"/>
+                    </a:lnT>
+                    <a:lnB w="6350" cap="flat" cmpd="sng" algn="ctr">
+                      <a:solidFill>
+                        <a:srgbClr val="D5DBE5"/>
+                      </a:solidFill>
+                      <a:prstDash val="solid"/>
+                      <a:round/>
+                      <a:headEnd type="none" w="med" len="med"/>
+                      <a:tailEnd type="none" w="med" len="med"/>
+                    </a:lnB>
+                  </a:tcPr>
+                </a:tc>
+                <a:tc>
+                  <a:txBody>
+                    <a:bodyPr/>
+                    <a:lstStyle/>
+                    <a:p>
+                      <a:pPr marL="0" indent="0" algn="ctr">
+                        <a:buNone/>
+                      </a:pPr>
+                      <a:r>
+                        <a:rPr lang="en-US" sz="1150" b="1" dirty="0">
+                          <a:solidFill>
+                            <a:srgbClr val="1B1F2A"/>
+                          </a:solidFill>
+                        </a:rPr>
+                        <a:t>0%</a:t>
+                      </a:r>
+                      <a:endParaRPr lang="en-US" sz="1150" dirty="0"/>
+                    </a:p>
+                  </a:txBody>
+                  <a:tcPr marL="45720" marR="45720" anchor="ctr">
+                    <a:lnL w="6350" cap="flat" cmpd="sng" algn="ctr">
+                      <a:solidFill>
+                        <a:srgbClr val="D5DBE5"/>
+                      </a:solidFill>
+                      <a:prstDash val="solid"/>
+                      <a:round/>
+                      <a:headEnd type="none" w="med" len="med"/>
+                      <a:tailEnd type="none" w="med" len="med"/>
+                    </a:lnL>
+                    <a:lnR w="6350" cap="flat" cmpd="sng" algn="ctr">
+                      <a:solidFill>
+                        <a:srgbClr val="D5DBE5"/>
+                      </a:solidFill>
+                      <a:prstDash val="solid"/>
+                      <a:round/>
+                      <a:headEnd type="none" w="med" len="med"/>
+                      <a:tailEnd type="none" w="med" len="med"/>
+                    </a:lnR>
+                    <a:lnT w="6350" cap="flat" cmpd="sng" algn="ctr">
+                      <a:solidFill>
+                        <a:srgbClr val="D5DBE5"/>
+                      </a:solidFill>
+                      <a:prstDash val="solid"/>
+                      <a:round/>
+                      <a:headEnd type="none" w="med" len="med"/>
+                      <a:tailEnd type="none" w="med" len="med"/>
+                    </a:lnT>
+                    <a:lnB w="6350" cap="flat" cmpd="sng" algn="ctr">
+                      <a:solidFill>
+                        <a:srgbClr val="D5DBE5"/>
+                      </a:solidFill>
+                      <a:prstDash val="solid"/>
+                      <a:round/>
+                      <a:headEnd type="none" w="med" len="med"/>
+                      <a:tailEnd type="none" w="med" len="med"/>
+                    </a:lnB>
+                  </a:tcPr>
+                </a:tc>
+                <a:tc>
+                  <a:txBody>
+                    <a:bodyPr/>
+                    <a:lstStyle/>
+                    <a:p>
+                      <a:pPr marL="0" indent="0" algn="ctr">
+                        <a:buNone/>
+                      </a:pPr>
+                      <a:r>
+                        <a:rPr lang="en-US" sz="1150" b="1" dirty="0">
+                          <a:solidFill>
+                            <a:srgbClr val="1B1F2A"/>
+                          </a:solidFill>
+                        </a:rPr>
+                        <a:t>36%</a:t>
+                      </a:r>
+                      <a:endParaRPr lang="en-US" sz="1150" dirty="0"/>
+                    </a:p>
+                  </a:txBody>
+                  <a:tcPr marL="45720" marR="45720" anchor="ctr">
+                    <a:lnL w="6350" cap="flat" cmpd="sng" algn="ctr">
+                      <a:solidFill>
+                        <a:srgbClr val="D5DBE5"/>
+                      </a:solidFill>
+                      <a:prstDash val="solid"/>
+                      <a:round/>
+                      <a:headEnd type="none" w="med" len="med"/>
+                      <a:tailEnd type="none" w="med" len="med"/>
+                    </a:lnL>
+                    <a:lnR w="6350" cap="flat" cmpd="sng" algn="ctr">
+                      <a:solidFill>
+                        <a:srgbClr val="D5DBE5"/>
+                      </a:solidFill>
+                      <a:prstDash val="solid"/>
+                      <a:round/>
+                      <a:headEnd type="none" w="med" len="med"/>
+                      <a:tailEnd type="none" w="med" len="med"/>
+                    </a:lnR>
+                    <a:lnT w="6350" cap="flat" cmpd="sng" algn="ctr">
+                      <a:solidFill>
+                        <a:srgbClr val="D5DBE5"/>
+                      </a:solidFill>
+                      <a:prstDash val="solid"/>
+                      <a:round/>
+                      <a:headEnd type="none" w="med" len="med"/>
+                      <a:tailEnd type="none" w="med" len="med"/>
+                    </a:lnT>
+                    <a:lnB w="6350" cap="flat" cmpd="sng" algn="ctr">
+                      <a:solidFill>
+                        <a:srgbClr val="D5DBE5"/>
+                      </a:solidFill>
+                      <a:prstDash val="solid"/>
+                      <a:round/>
+                      <a:headEnd type="none" w="med" len="med"/>
+                      <a:tailEnd type="none" w="med" len="med"/>
+                    </a:lnB>
+                  </a:tcPr>
+                </a:tc>
+                <a:tc>
+                  <a:txBody>
+                    <a:bodyPr/>
+                    <a:lstStyle/>
+                    <a:p>
+                      <a:pPr marL="0" indent="0" algn="ctr">
+                        <a:buNone/>
+                      </a:pPr>
+                      <a:r>
+                        <a:rPr lang="en-US" sz="1150" b="1" dirty="0">
+                          <a:solidFill>
+                            <a:srgbClr val="C8553D"/>
+                          </a:solidFill>
+                        </a:rPr>
+                        <a:t>64%</a:t>
+                      </a:r>
+                      <a:endParaRPr lang="en-US" sz="1150" dirty="0"/>
+                    </a:p>
+                  </a:txBody>
+                  <a:tcPr marL="45720" marR="45720" anchor="ctr">
+                    <a:lnL w="6350" cap="flat" cmpd="sng" algn="ctr">
+                      <a:solidFill>
+                        <a:srgbClr val="D5DBE5"/>
+                      </a:solidFill>
+                      <a:prstDash val="solid"/>
+                      <a:round/>
+                      <a:headEnd type="none" w="med" len="med"/>
+                      <a:tailEnd type="none" w="med" len="med"/>
+                    </a:lnL>
+                    <a:lnR w="6350" cap="flat" cmpd="sng" algn="ctr">
+                      <a:solidFill>
+                        <a:srgbClr val="D5DBE5"/>
+                      </a:solidFill>
+                      <a:prstDash val="solid"/>
+                      <a:round/>
+                      <a:headEnd type="none" w="med" len="med"/>
+                      <a:tailEnd type="none" w="med" len="med"/>
+                    </a:lnR>
+                    <a:lnT w="6350" cap="flat" cmpd="sng" algn="ctr">
+                      <a:solidFill>
+                        <a:srgbClr val="D5DBE5"/>
+                      </a:solidFill>
+                      <a:prstDash val="solid"/>
+                      <a:round/>
+                      <a:headEnd type="none" w="med" len="med"/>
+                      <a:tailEnd type="none" w="med" len="med"/>
+                    </a:lnT>
+                    <a:lnB w="6350" cap="flat" cmpd="sng" algn="ctr">
+                      <a:solidFill>
+                        <a:srgbClr val="D5DBE5"/>
+                      </a:solidFill>
+                      <a:prstDash val="solid"/>
+                      <a:round/>
+                      <a:headEnd type="none" w="med" len="med"/>
+                      <a:tailEnd type="none" w="med" len="med"/>
+                    </a:lnB>
+                  </a:tcPr>
+                </a:tc>
+                <a:extLst>
+                  <a:ext uri="{0D108BD9-81ED-4DB2-BD59-A6C34878D82A}">
+                    <a16:rowId xmlns:a16="http://schemas.microsoft.com/office/drawing/2014/main" val="10001"/>
+                  </a:ext>
+                </a:extLst>
+              </a:tr>
+              <a:tr h="420624">
+                <a:tc>
+                  <a:txBody>
+                    <a:bodyPr/>
+                    <a:lstStyle/>
+                    <a:p>
+                      <a:pPr marL="0" indent="0">
+                        <a:buNone/>
+                      </a:pPr>
+                      <a:r>
+                        <a:rPr lang="en-US" sz="1150" dirty="0">
+                          <a:solidFill>
+                            <a:srgbClr val="1B1F2A"/>
+                          </a:solidFill>
+                        </a:rPr>
+                        <a:t>A hold</a:t>
+                      </a:r>
+                      <a:endParaRPr lang="en-US" sz="1150" dirty="0"/>
+                    </a:p>
+                  </a:txBody>
+                  <a:tcPr marL="45720" marR="45720" anchor="ctr">
+                    <a:lnL w="6350" cap="flat" cmpd="sng" algn="ctr">
+                      <a:solidFill>
+                        <a:srgbClr val="D5DBE5"/>
+                      </a:solidFill>
+                      <a:prstDash val="solid"/>
+                      <a:round/>
+                      <a:headEnd type="none" w="med" len="med"/>
+                      <a:tailEnd type="none" w="med" len="med"/>
+                    </a:lnL>
+                    <a:lnR w="6350" cap="flat" cmpd="sng" algn="ctr">
+                      <a:solidFill>
+                        <a:srgbClr val="D5DBE5"/>
+                      </a:solidFill>
+                      <a:prstDash val="solid"/>
+                      <a:round/>
+                      <a:headEnd type="none" w="med" len="med"/>
+                      <a:tailEnd type="none" w="med" len="med"/>
+                    </a:lnR>
+                    <a:lnT w="6350" cap="flat" cmpd="sng" algn="ctr">
+                      <a:solidFill>
+                        <a:srgbClr val="D5DBE5"/>
+                      </a:solidFill>
+                      <a:prstDash val="solid"/>
+                      <a:round/>
+                      <a:headEnd type="none" w="med" len="med"/>
+                      <a:tailEnd type="none" w="med" len="med"/>
+                    </a:lnT>
+                    <a:lnB w="6350" cap="flat" cmpd="sng" algn="ctr">
+                      <a:solidFill>
+                        <a:srgbClr val="D5DBE5"/>
+                      </a:solidFill>
+                      <a:prstDash val="solid"/>
+                      <a:round/>
+                      <a:headEnd type="none" w="med" len="med"/>
+                      <a:tailEnd type="none" w="med" len="med"/>
+                    </a:lnB>
+                  </a:tcPr>
+                </a:tc>
+                <a:tc>
+                  <a:txBody>
+                    <a:bodyPr/>
+                    <a:lstStyle/>
+                    <a:p>
+                      <a:pPr marL="0" indent="0" algn="ctr">
+                        <a:buNone/>
+                      </a:pPr>
+                      <a:r>
+                        <a:rPr lang="en-US" sz="1150" dirty="0">
+                          <a:solidFill>
+                            <a:srgbClr val="1B1F2A"/>
+                          </a:solidFill>
+                        </a:rPr>
+                        <a:t>183</a:t>
+                      </a:r>
+                      <a:endParaRPr lang="en-US" sz="1150" dirty="0"/>
+                    </a:p>
+                  </a:txBody>
+                  <a:tcPr marL="45720" marR="45720" anchor="ctr">
+                    <a:lnL w="6350" cap="flat" cmpd="sng" algn="ctr">
+                      <a:solidFill>
+                        <a:srgbClr val="D5DBE5"/>
+                      </a:solidFill>
+                      <a:prstDash val="solid"/>
+                      <a:round/>
+                      <a:headEnd type="none" w="med" len="med"/>
+                      <a:tailEnd type="none" w="med" len="med"/>
+                    </a:lnL>
+                    <a:lnR w="6350" cap="flat" cmpd="sng" algn="ctr">
+                      <a:solidFill>
+                        <a:srgbClr val="D5DBE5"/>
+                      </a:solidFill>
+                      <a:prstDash val="solid"/>
+                      <a:round/>
+                      <a:headEnd type="none" w="med" len="med"/>
+                      <a:tailEnd type="none" w="med" len="med"/>
+                    </a:lnR>
+                    <a:lnT w="6350" cap="flat" cmpd="sng" algn="ctr">
+                      <a:solidFill>
+                        <a:srgbClr val="D5DBE5"/>
+                      </a:solidFill>
+                      <a:prstDash val="solid"/>
+                      <a:round/>
+                      <a:headEnd type="none" w="med" len="med"/>
+                      <a:tailEnd type="none" w="med" len="med"/>
+                    </a:lnT>
+                    <a:lnB w="6350" cap="flat" cmpd="sng" algn="ctr">
+                      <a:solidFill>
+                        <a:srgbClr val="D5DBE5"/>
+                      </a:solidFill>
+                      <a:prstDash val="solid"/>
+                      <a:round/>
+                      <a:headEnd type="none" w="med" len="med"/>
+                      <a:tailEnd type="none" w="med" len="med"/>
+                    </a:lnB>
+                  </a:tcPr>
+                </a:tc>
+                <a:tc>
+                  <a:txBody>
+                    <a:bodyPr/>
+                    <a:lstStyle/>
+                    <a:p>
+                      <a:pPr marL="0" indent="0" algn="ctr">
+                        <a:buNone/>
+                      </a:pPr>
+                      <a:r>
+                        <a:rPr lang="en-US" sz="1150" dirty="0">
+                          <a:solidFill>
+                            <a:srgbClr val="1B1F2A"/>
+                          </a:solidFill>
+                        </a:rPr>
+                        <a:t>6%</a:t>
+                      </a:r>
+                      <a:endParaRPr lang="en-US" sz="1150" dirty="0"/>
+                    </a:p>
+                  </a:txBody>
+                  <a:tcPr marL="45720" marR="45720" anchor="ctr">
+                    <a:lnL w="6350" cap="flat" cmpd="sng" algn="ctr">
+                      <a:solidFill>
+                        <a:srgbClr val="D5DBE5"/>
+                      </a:solidFill>
+                      <a:prstDash val="solid"/>
+                      <a:round/>
+                      <a:headEnd type="none" w="med" len="med"/>
+                      <a:tailEnd type="none" w="med" len="med"/>
+                    </a:lnL>
+                    <a:lnR w="6350" cap="flat" cmpd="sng" algn="ctr">
+                      <a:solidFill>
+                        <a:srgbClr val="D5DBE5"/>
+                      </a:solidFill>
+                      <a:prstDash val="solid"/>
+                      <a:round/>
+                      <a:headEnd type="none" w="med" len="med"/>
+                      <a:tailEnd type="none" w="med" len="med"/>
+                    </a:lnR>
+                    <a:lnT w="6350" cap="flat" cmpd="sng" algn="ctr">
+                      <a:solidFill>
+                        <a:srgbClr val="D5DBE5"/>
+                      </a:solidFill>
+                      <a:prstDash val="solid"/>
+                      <a:round/>
+                      <a:headEnd type="none" w="med" len="med"/>
+                      <a:tailEnd type="none" w="med" len="med"/>
+                    </a:lnT>
+                    <a:lnB w="6350" cap="flat" cmpd="sng" algn="ctr">
+                      <a:solidFill>
+                        <a:srgbClr val="D5DBE5"/>
+                      </a:solidFill>
+                      <a:prstDash val="solid"/>
+                      <a:round/>
+                      <a:headEnd type="none" w="med" len="med"/>
+                      <a:tailEnd type="none" w="med" len="med"/>
+                    </a:lnB>
+                  </a:tcPr>
+                </a:tc>
+                <a:tc>
+                  <a:txBody>
+                    <a:bodyPr/>
+                    <a:lstStyle/>
+                    <a:p>
+                      <a:pPr marL="0" indent="0" algn="ctr">
+                        <a:buNone/>
+                      </a:pPr>
+                      <a:r>
+                        <a:rPr lang="en-US" sz="1150" dirty="0">
+                          <a:solidFill>
+                            <a:srgbClr val="2C6E49"/>
+                          </a:solidFill>
+                        </a:rPr>
+                        <a:t>85%</a:t>
+                      </a:r>
+                      <a:endParaRPr lang="en-US" sz="1150" dirty="0"/>
+                    </a:p>
+                  </a:txBody>
+                  <a:tcPr marL="45720" marR="45720" anchor="ctr">
+                    <a:lnL w="6350" cap="flat" cmpd="sng" algn="ctr">
+                      <a:solidFill>
+                        <a:srgbClr val="D5DBE5"/>
+                      </a:solidFill>
+                      <a:prstDash val="solid"/>
+                      <a:round/>
+                      <a:headEnd type="none" w="med" len="med"/>
+                      <a:tailEnd type="none" w="med" len="med"/>
+                    </a:lnL>
+                    <a:lnR w="6350" cap="flat" cmpd="sng" algn="ctr">
+                      <a:solidFill>
+                        <a:srgbClr val="D5DBE5"/>
+                      </a:solidFill>
+                      <a:prstDash val="solid"/>
+                      <a:round/>
+                      <a:headEnd type="none" w="med" len="med"/>
+                      <a:tailEnd type="none" w="med" len="med"/>
+                    </a:lnR>
+                    <a:lnT w="6350" cap="flat" cmpd="sng" algn="ctr">
+                      <a:solidFill>
+                        <a:srgbClr val="D5DBE5"/>
+                      </a:solidFill>
+                      <a:prstDash val="solid"/>
+                      <a:round/>
+                      <a:headEnd type="none" w="med" len="med"/>
+                      <a:tailEnd type="none" w="med" len="med"/>
+                    </a:lnT>
+                    <a:lnB w="6350" cap="flat" cmpd="sng" algn="ctr">
+                      <a:solidFill>
+                        <a:srgbClr val="D5DBE5"/>
+                      </a:solidFill>
+                      <a:prstDash val="solid"/>
+                      <a:round/>
+                      <a:headEnd type="none" w="med" len="med"/>
+                      <a:tailEnd type="none" w="med" len="med"/>
+                    </a:lnB>
+                  </a:tcPr>
+                </a:tc>
+                <a:tc>
+                  <a:txBody>
+                    <a:bodyPr/>
+                    <a:lstStyle/>
+                    <a:p>
+                      <a:pPr marL="0" indent="0" algn="ctr">
+                        <a:buNone/>
+                      </a:pPr>
+                      <a:r>
+                        <a:rPr lang="en-US" sz="1150" dirty="0">
+                          <a:solidFill>
+                            <a:srgbClr val="1B1F2A"/>
+                          </a:solidFill>
+                        </a:rPr>
+                        <a:t>9%</a:t>
+                      </a:r>
+                      <a:endParaRPr lang="en-US" sz="1150" dirty="0"/>
+                    </a:p>
+                  </a:txBody>
+                  <a:tcPr marL="45720" marR="45720" anchor="ctr">
+                    <a:lnL w="6350" cap="flat" cmpd="sng" algn="ctr">
+                      <a:solidFill>
+                        <a:srgbClr val="D5DBE5"/>
+                      </a:solidFill>
+                      <a:prstDash val="solid"/>
+                      <a:round/>
+                      <a:headEnd type="none" w="med" len="med"/>
+                      <a:tailEnd type="none" w="med" len="med"/>
+                    </a:lnL>
+                    <a:lnR w="6350" cap="flat" cmpd="sng" algn="ctr">
+                      <a:solidFill>
+                        <a:srgbClr val="D5DBE5"/>
+                      </a:solidFill>
+                      <a:prstDash val="solid"/>
+                      <a:round/>
+                      <a:headEnd type="none" w="med" len="med"/>
+                      <a:tailEnd type="none" w="med" len="med"/>
+                    </a:lnR>
+                    <a:lnT w="6350" cap="flat" cmpd="sng" algn="ctr">
+                      <a:solidFill>
+                        <a:srgbClr val="D5DBE5"/>
+                      </a:solidFill>
+                      <a:prstDash val="solid"/>
+                      <a:round/>
+                      <a:headEnd type="none" w="med" len="med"/>
+                      <a:tailEnd type="none" w="med" len="med"/>
+                    </a:lnT>
+                    <a:lnB w="6350" cap="flat" cmpd="sng" algn="ctr">
+                      <a:solidFill>
+                        <a:srgbClr val="D5DBE5"/>
+                      </a:solidFill>
+                      <a:prstDash val="solid"/>
+                      <a:round/>
+                      <a:headEnd type="none" w="med" len="med"/>
+                      <a:tailEnd type="none" w="med" len="med"/>
+                    </a:lnB>
+                  </a:tcPr>
+                </a:tc>
+                <a:extLst>
+                  <a:ext uri="{0D108BD9-81ED-4DB2-BD59-A6C34878D82A}">
+                    <a16:rowId xmlns:a16="http://schemas.microsoft.com/office/drawing/2014/main" val="10002"/>
+                  </a:ext>
+                </a:extLst>
+              </a:tr>
+              <a:tr h="420624">
+                <a:tc>
+                  <a:txBody>
+                    <a:bodyPr/>
+                    <a:lstStyle/>
+                    <a:p>
+                      <a:pPr marL="0" indent="0">
+                        <a:buNone/>
+                      </a:pPr>
+                      <a:r>
+                        <a:rPr lang="en-US" sz="1150" dirty="0">
+                          <a:solidFill>
+                            <a:srgbClr val="1B1F2A"/>
+                          </a:solidFill>
+                        </a:rPr>
+                        <a:t>A cut</a:t>
+                      </a:r>
+                      <a:endParaRPr lang="en-US" sz="1150" dirty="0"/>
+                    </a:p>
+                  </a:txBody>
+                  <a:tcPr marL="45720" marR="45720" anchor="ctr">
+                    <a:lnL w="6350" cap="flat" cmpd="sng" algn="ctr">
+                      <a:solidFill>
+                        <a:srgbClr val="D5DBE5"/>
+                      </a:solidFill>
+                      <a:prstDash val="solid"/>
+                      <a:round/>
+                      <a:headEnd type="none" w="med" len="med"/>
+                      <a:tailEnd type="none" w="med" len="med"/>
+                    </a:lnL>
+                    <a:lnR w="6350" cap="flat" cmpd="sng" algn="ctr">
+                      <a:solidFill>
+                        <a:srgbClr val="D5DBE5"/>
+                      </a:solidFill>
+                      <a:prstDash val="solid"/>
+                      <a:round/>
+                      <a:headEnd type="none" w="med" len="med"/>
+                      <a:tailEnd type="none" w="med" len="med"/>
+                    </a:lnR>
+                    <a:lnT w="6350" cap="flat" cmpd="sng" algn="ctr">
+                      <a:solidFill>
+                        <a:srgbClr val="D5DBE5"/>
+                      </a:solidFill>
+                      <a:prstDash val="solid"/>
+                      <a:round/>
+                      <a:headEnd type="none" w="med" len="med"/>
+                      <a:tailEnd type="none" w="med" len="med"/>
+                    </a:lnT>
+                    <a:lnB w="6350" cap="flat" cmpd="sng" algn="ctr">
+                      <a:solidFill>
+                        <a:srgbClr val="D5DBE5"/>
+                      </a:solidFill>
+                      <a:prstDash val="solid"/>
+                      <a:round/>
+                      <a:headEnd type="none" w="med" len="med"/>
+                      <a:tailEnd type="none" w="med" len="med"/>
+                    </a:lnB>
+                  </a:tcPr>
+                </a:tc>
+                <a:tc>
+                  <a:txBody>
+                    <a:bodyPr/>
+                    <a:lstStyle/>
+                    <a:p>
+                      <a:pPr marL="0" indent="0" algn="ctr">
+                        <a:buNone/>
+                      </a:pPr>
+                      <a:r>
+                        <a:rPr lang="en-US" sz="1150" dirty="0">
+                          <a:solidFill>
+                            <a:srgbClr val="1B1F2A"/>
+                          </a:solidFill>
+                        </a:rPr>
+                        <a:t>32</a:t>
+                      </a:r>
+                      <a:endParaRPr lang="en-US" sz="1150" dirty="0"/>
+                    </a:p>
+                  </a:txBody>
+                  <a:tcPr marL="45720" marR="45720" anchor="ctr">
+                    <a:lnL w="6350" cap="flat" cmpd="sng" algn="ctr">
+                      <a:solidFill>
+                        <a:srgbClr val="D5DBE5"/>
+                      </a:solidFill>
+                      <a:prstDash val="solid"/>
+                      <a:round/>
+                      <a:headEnd type="none" w="med" len="med"/>
+                      <a:tailEnd type="none" w="med" len="med"/>
+                    </a:lnL>
+                    <a:lnR w="6350" cap="flat" cmpd="sng" algn="ctr">
+                      <a:solidFill>
+                        <a:srgbClr val="D5DBE5"/>
+                      </a:solidFill>
+                      <a:prstDash val="solid"/>
+                      <a:round/>
+                      <a:headEnd type="none" w="med" len="med"/>
+                      <a:tailEnd type="none" w="med" len="med"/>
+                    </a:lnR>
+                    <a:lnT w="6350" cap="flat" cmpd="sng" algn="ctr">
+                      <a:solidFill>
+                        <a:srgbClr val="D5DBE5"/>
+                      </a:solidFill>
+                      <a:prstDash val="solid"/>
+                      <a:round/>
+                      <a:headEnd type="none" w="med" len="med"/>
+                      <a:tailEnd type="none" w="med" len="med"/>
+                    </a:lnT>
+                    <a:lnB w="6350" cap="flat" cmpd="sng" algn="ctr">
+                      <a:solidFill>
+                        <a:srgbClr val="D5DBE5"/>
+                      </a:solidFill>
+                      <a:prstDash val="solid"/>
+                      <a:round/>
+                      <a:headEnd type="none" w="med" len="med"/>
+                      <a:tailEnd type="none" w="med" len="med"/>
+                    </a:lnB>
+                  </a:tcPr>
+                </a:tc>
+                <a:tc>
+                  <a:txBody>
+                    <a:bodyPr/>
+                    <a:lstStyle/>
+                    <a:p>
+                      <a:pPr marL="0" indent="0" algn="ctr">
+                        <a:buNone/>
+                      </a:pPr>
+                      <a:r>
+                        <a:rPr lang="en-US" sz="1150" dirty="0">
+                          <a:solidFill>
+                            <a:srgbClr val="2C6E49"/>
+                          </a:solidFill>
+                        </a:rPr>
+                        <a:t>66%</a:t>
+                      </a:r>
+                      <a:endParaRPr lang="en-US" sz="1150" dirty="0"/>
+                    </a:p>
+                  </a:txBody>
+                  <a:tcPr marL="45720" marR="45720" anchor="ctr">
+                    <a:lnL w="6350" cap="flat" cmpd="sng" algn="ctr">
+                      <a:solidFill>
+                        <a:srgbClr val="D5DBE5"/>
+                      </a:solidFill>
+                      <a:prstDash val="solid"/>
+                      <a:round/>
+                      <a:headEnd type="none" w="med" len="med"/>
+                      <a:tailEnd type="none" w="med" len="med"/>
+                    </a:lnL>
+                    <a:lnR w="6350" cap="flat" cmpd="sng" algn="ctr">
+                      <a:solidFill>
+                        <a:srgbClr val="D5DBE5"/>
+                      </a:solidFill>
+                      <a:prstDash val="solid"/>
+                      <a:round/>
+                      <a:headEnd type="none" w="med" len="med"/>
+                      <a:tailEnd type="none" w="med" len="med"/>
+                    </a:lnR>
+                    <a:lnT w="6350" cap="flat" cmpd="sng" algn="ctr">
+                      <a:solidFill>
+                        <a:srgbClr val="D5DBE5"/>
+                      </a:solidFill>
+                      <a:prstDash val="solid"/>
+                      <a:round/>
+                      <a:headEnd type="none" w="med" len="med"/>
+                      <a:tailEnd type="none" w="med" len="med"/>
+                    </a:lnT>
+                    <a:lnB w="6350" cap="flat" cmpd="sng" algn="ctr">
+                      <a:solidFill>
+                        <a:srgbClr val="D5DBE5"/>
+                      </a:solidFill>
+                      <a:prstDash val="solid"/>
+                      <a:round/>
+                      <a:headEnd type="none" w="med" len="med"/>
+                      <a:tailEnd type="none" w="med" len="med"/>
+                    </a:lnB>
+                  </a:tcPr>
+                </a:tc>
+                <a:tc>
+                  <a:txBody>
+                    <a:bodyPr/>
+                    <a:lstStyle/>
+                    <a:p>
+                      <a:pPr marL="0" indent="0" algn="ctr">
+                        <a:buNone/>
+                      </a:pPr>
+                      <a:r>
+                        <a:rPr lang="en-US" sz="1150" dirty="0">
+                          <a:solidFill>
+                            <a:srgbClr val="1B1F2A"/>
+                          </a:solidFill>
+                        </a:rPr>
+                        <a:t>34%</a:t>
+                      </a:r>
+                      <a:endParaRPr lang="en-US" sz="1150" dirty="0"/>
+                    </a:p>
+                  </a:txBody>
+                  <a:tcPr marL="45720" marR="45720" anchor="ctr">
+                    <a:lnL w="6350" cap="flat" cmpd="sng" algn="ctr">
+                      <a:solidFill>
+                        <a:srgbClr val="D5DBE5"/>
+                      </a:solidFill>
+                      <a:prstDash val="solid"/>
+                      <a:round/>
+                      <a:headEnd type="none" w="med" len="med"/>
+                      <a:tailEnd type="none" w="med" len="med"/>
+                    </a:lnL>
+                    <a:lnR w="6350" cap="flat" cmpd="sng" algn="ctr">
+                      <a:solidFill>
+                        <a:srgbClr val="D5DBE5"/>
+                      </a:solidFill>
+                      <a:prstDash val="solid"/>
+                      <a:round/>
+                      <a:headEnd type="none" w="med" len="med"/>
+                      <a:tailEnd type="none" w="med" len="med"/>
+                    </a:lnR>
+                    <a:lnT w="6350" cap="flat" cmpd="sng" algn="ctr">
+                      <a:solidFill>
+                        <a:srgbClr val="D5DBE5"/>
+                      </a:solidFill>
+                      <a:prstDash val="solid"/>
+                      <a:round/>
+                      <a:headEnd type="none" w="med" len="med"/>
+                      <a:tailEnd type="none" w="med" len="med"/>
+                    </a:lnT>
+                    <a:lnB w="6350" cap="flat" cmpd="sng" algn="ctr">
+                      <a:solidFill>
+                        <a:srgbClr val="D5DBE5"/>
+                      </a:solidFill>
+                      <a:prstDash val="solid"/>
+                      <a:round/>
+                      <a:headEnd type="none" w="med" len="med"/>
+                      <a:tailEnd type="none" w="med" len="med"/>
+                    </a:lnB>
+                  </a:tcPr>
+                </a:tc>
+                <a:tc>
+                  <a:txBody>
+                    <a:bodyPr/>
+                    <a:lstStyle/>
+                    <a:p>
+                      <a:pPr marL="0" indent="0" algn="ctr">
+                        <a:buNone/>
+                      </a:pPr>
+                      <a:r>
+                        <a:rPr lang="en-US" sz="1150" dirty="0">
+                          <a:solidFill>
+                            <a:srgbClr val="1B1F2A"/>
+                          </a:solidFill>
+                        </a:rPr>
+                        <a:t>0%</a:t>
+                      </a:r>
+                      <a:endParaRPr lang="en-US" sz="1150" dirty="0"/>
+                    </a:p>
+                  </a:txBody>
+                  <a:tcPr marL="45720" marR="45720" anchor="ctr">
+                    <a:lnL w="6350" cap="flat" cmpd="sng" algn="ctr">
+                      <a:solidFill>
+                        <a:srgbClr val="D5DBE5"/>
+                      </a:solidFill>
+                      <a:prstDash val="solid"/>
+                      <a:round/>
+                      <a:headEnd type="none" w="med" len="med"/>
+                      <a:tailEnd type="none" w="med" len="med"/>
+                    </a:lnL>
+                    <a:lnR w="6350" cap="flat" cmpd="sng" algn="ctr">
+                      <a:solidFill>
+                        <a:srgbClr val="D5DBE5"/>
+                      </a:solidFill>
+                      <a:prstDash val="solid"/>
+                      <a:round/>
+                      <a:headEnd type="none" w="med" len="med"/>
+                      <a:tailEnd type="none" w="med" len="med"/>
+                    </a:lnR>
+                    <a:lnT w="6350" cap="flat" cmpd="sng" algn="ctr">
+                      <a:solidFill>
+                        <a:srgbClr val="D5DBE5"/>
+                      </a:solidFill>
+                      <a:prstDash val="solid"/>
+                      <a:round/>
+                      <a:headEnd type="none" w="med" len="med"/>
+                      <a:tailEnd type="none" w="med" len="med"/>
+                    </a:lnT>
+                    <a:lnB w="6350" cap="flat" cmpd="sng" algn="ctr">
+                      <a:solidFill>
+                        <a:srgbClr val="D5DBE5"/>
+                      </a:solidFill>
+                      <a:prstDash val="solid"/>
+                      <a:round/>
+                      <a:headEnd type="none" w="med" len="med"/>
+                      <a:tailEnd type="none" w="med" len="med"/>
+                    </a:lnB>
+                  </a:tcPr>
+                </a:tc>
+                <a:extLst>
+                  <a:ext uri="{0D108BD9-81ED-4DB2-BD59-A6C34878D82A}">
+                    <a16:rowId xmlns:a16="http://schemas.microsoft.com/office/drawing/2014/main" val="10003"/>
+                  </a:ext>
+                </a:extLst>
+              </a:tr>
+              <a:tr h="420624">
+                <a:tc>
+                  <a:txBody>
+                    <a:bodyPr/>
+                    <a:lstStyle/>
+                    <a:p>
+                      <a:pPr marL="0" indent="0">
+                        <a:buNone/>
+                      </a:pPr>
+                      <a:r>
+                        <a:rPr lang="en-US" sz="1150" dirty="0">
+                          <a:solidFill>
+                            <a:srgbClr val="6B7280"/>
+                          </a:solidFill>
+                        </a:rPr>
+                        <a:t>All decisions</a:t>
+                      </a:r>
+                      <a:endParaRPr lang="en-US" sz="1150" dirty="0"/>
+                    </a:p>
+                  </a:txBody>
+                  <a:tcPr marL="45720" marR="45720" anchor="ctr">
+                    <a:lnL w="6350" cap="flat" cmpd="sng" algn="ctr">
+                      <a:solidFill>
+                        <a:srgbClr val="D5DBE5"/>
+                      </a:solidFill>
+                      <a:prstDash val="solid"/>
+                      <a:round/>
+                      <a:headEnd type="none" w="med" len="med"/>
+                      <a:tailEnd type="none" w="med" len="med"/>
+                    </a:lnL>
+                    <a:lnR w="6350" cap="flat" cmpd="sng" algn="ctr">
+                      <a:solidFill>
+                        <a:srgbClr val="D5DBE5"/>
+                      </a:solidFill>
+                      <a:prstDash val="solid"/>
+                      <a:round/>
+                      <a:headEnd type="none" w="med" len="med"/>
+                      <a:tailEnd type="none" w="med" len="med"/>
+                    </a:lnR>
+                    <a:lnT w="6350" cap="flat" cmpd="sng" algn="ctr">
+                      <a:solidFill>
+                        <a:srgbClr val="D5DBE5"/>
+                      </a:solidFill>
+                      <a:prstDash val="solid"/>
+                      <a:round/>
+                      <a:headEnd type="none" w="med" len="med"/>
+                      <a:tailEnd type="none" w="med" len="med"/>
+                    </a:lnT>
+                    <a:lnB w="6350" cap="flat" cmpd="sng" algn="ctr">
+                      <a:solidFill>
+                        <a:srgbClr val="D5DBE5"/>
+                      </a:solidFill>
+                      <a:prstDash val="solid"/>
+                      <a:round/>
+                      <a:headEnd type="none" w="med" len="med"/>
+                      <a:tailEnd type="none" w="med" len="med"/>
+                    </a:lnB>
+                  </a:tcPr>
+                </a:tc>
+                <a:tc>
+                  <a:txBody>
+                    <a:bodyPr/>
+                    <a:lstStyle/>
+                    <a:p>
+                      <a:pPr marL="0" indent="0" algn="ctr">
+                        <a:buNone/>
+                      </a:pPr>
+                      <a:r>
+                        <a:rPr lang="en-US" sz="1150" dirty="0">
+                          <a:solidFill>
+                            <a:srgbClr val="6B7280"/>
+                          </a:solidFill>
+                        </a:rPr>
+                        <a:t>266</a:t>
+                      </a:r>
+                      <a:endParaRPr lang="en-US" sz="1150" dirty="0"/>
+                    </a:p>
+                  </a:txBody>
+                  <a:tcPr marL="45720" marR="45720" anchor="ctr">
+                    <a:lnL w="6350" cap="flat" cmpd="sng" algn="ctr">
+                      <a:solidFill>
+                        <a:srgbClr val="D5DBE5"/>
+                      </a:solidFill>
+                      <a:prstDash val="solid"/>
+                      <a:round/>
+                      <a:headEnd type="none" w="med" len="med"/>
+                      <a:tailEnd type="none" w="med" len="med"/>
+                    </a:lnL>
+                    <a:lnR w="6350" cap="flat" cmpd="sng" algn="ctr">
+                      <a:solidFill>
+                        <a:srgbClr val="D5DBE5"/>
+                      </a:solidFill>
+                      <a:prstDash val="solid"/>
+                      <a:round/>
+                      <a:headEnd type="none" w="med" len="med"/>
+                      <a:tailEnd type="none" w="med" len="med"/>
+                    </a:lnR>
+                    <a:lnT w="6350" cap="flat" cmpd="sng" algn="ctr">
+                      <a:solidFill>
+                        <a:srgbClr val="D5DBE5"/>
+                      </a:solidFill>
+                      <a:prstDash val="solid"/>
+                      <a:round/>
+                      <a:headEnd type="none" w="med" len="med"/>
+                      <a:tailEnd type="none" w="med" len="med"/>
+                    </a:lnT>
+                    <a:lnB w="6350" cap="flat" cmpd="sng" algn="ctr">
+                      <a:solidFill>
+                        <a:srgbClr val="D5DBE5"/>
+                      </a:solidFill>
+                      <a:prstDash val="solid"/>
+                      <a:round/>
+                      <a:headEnd type="none" w="med" len="med"/>
+                      <a:tailEnd type="none" w="med" len="med"/>
+                    </a:lnB>
+                  </a:tcPr>
+                </a:tc>
+                <a:tc>
+                  <a:txBody>
+                    <a:bodyPr/>
+                    <a:lstStyle/>
+                    <a:p>
+                      <a:pPr marL="0" indent="0" algn="ctr">
+                        <a:buNone/>
+                      </a:pPr>
+                      <a:r>
+                        <a:rPr lang="en-US" sz="1150" dirty="0">
+                          <a:solidFill>
+                            <a:srgbClr val="6B7280"/>
+                          </a:solidFill>
+                        </a:rPr>
+                        <a:t>12%</a:t>
+                      </a:r>
+                      <a:endParaRPr lang="en-US" sz="1150" dirty="0"/>
+                    </a:p>
+                  </a:txBody>
+                  <a:tcPr marL="45720" marR="45720" anchor="ctr">
+                    <a:lnL w="6350" cap="flat" cmpd="sng" algn="ctr">
+                      <a:solidFill>
+                        <a:srgbClr val="D5DBE5"/>
+                      </a:solidFill>
+                      <a:prstDash val="solid"/>
+                      <a:round/>
+                      <a:headEnd type="none" w="med" len="med"/>
+                      <a:tailEnd type="none" w="med" len="med"/>
+                    </a:lnL>
+                    <a:lnR w="6350" cap="flat" cmpd="sng" algn="ctr">
+                      <a:solidFill>
+                        <a:srgbClr val="D5DBE5"/>
+                      </a:solidFill>
+                      <a:prstDash val="solid"/>
+                      <a:round/>
+                      <a:headEnd type="none" w="med" len="med"/>
+                      <a:tailEnd type="none" w="med" len="med"/>
+                    </a:lnR>
+                    <a:lnT w="6350" cap="flat" cmpd="sng" algn="ctr">
+                      <a:solidFill>
+                        <a:srgbClr val="D5DBE5"/>
+                      </a:solidFill>
+                      <a:prstDash val="solid"/>
+                      <a:round/>
+                      <a:headEnd type="none" w="med" len="med"/>
+                      <a:tailEnd type="none" w="med" len="med"/>
+                    </a:lnT>
+                    <a:lnB w="6350" cap="flat" cmpd="sng" algn="ctr">
+                      <a:solidFill>
+                        <a:srgbClr val="D5DBE5"/>
+                      </a:solidFill>
+                      <a:prstDash val="solid"/>
+                      <a:round/>
+                      <a:headEnd type="none" w="med" len="med"/>
+                      <a:tailEnd type="none" w="med" len="med"/>
+                    </a:lnB>
+                  </a:tcPr>
+                </a:tc>
+                <a:tc>
+                  <a:txBody>
+                    <a:bodyPr/>
+                    <a:lstStyle/>
+                    <a:p>
+                      <a:pPr marL="0" indent="0" algn="ctr">
+                        <a:buNone/>
+                      </a:pPr>
+                      <a:r>
+                        <a:rPr lang="en-US" sz="1150" dirty="0">
+                          <a:solidFill>
+                            <a:srgbClr val="6B7280"/>
+                          </a:solidFill>
+                        </a:rPr>
+                        <a:t>69%</a:t>
+                      </a:r>
+                      <a:endParaRPr lang="en-US" sz="1150" dirty="0"/>
+                    </a:p>
+                  </a:txBody>
+                  <a:tcPr marL="45720" marR="45720" anchor="ctr">
+                    <a:lnL w="6350" cap="flat" cmpd="sng" algn="ctr">
+                      <a:solidFill>
+                        <a:srgbClr val="D5DBE5"/>
+                      </a:solidFill>
+                      <a:prstDash val="solid"/>
+                      <a:round/>
+                      <a:headEnd type="none" w="med" len="med"/>
+                      <a:tailEnd type="none" w="med" len="med"/>
+                    </a:lnL>
+                    <a:lnR w="6350" cap="flat" cmpd="sng" algn="ctr">
+                      <a:solidFill>
+                        <a:srgbClr val="D5DBE5"/>
+                      </a:solidFill>
+                      <a:prstDash val="solid"/>
+                      <a:round/>
+                      <a:headEnd type="none" w="med" len="med"/>
+                      <a:tailEnd type="none" w="med" len="med"/>
+                    </a:lnR>
+                    <a:lnT w="6350" cap="flat" cmpd="sng" algn="ctr">
+                      <a:solidFill>
+                        <a:srgbClr val="D5DBE5"/>
+                      </a:solidFill>
+                      <a:prstDash val="solid"/>
+                      <a:round/>
+                      <a:headEnd type="none" w="med" len="med"/>
+                      <a:tailEnd type="none" w="med" len="med"/>
+                    </a:lnT>
+                    <a:lnB w="6350" cap="flat" cmpd="sng" algn="ctr">
+                      <a:solidFill>
+                        <a:srgbClr val="D5DBE5"/>
+                      </a:solidFill>
+                      <a:prstDash val="solid"/>
+                      <a:round/>
+                      <a:headEnd type="none" w="med" len="med"/>
+                      <a:tailEnd type="none" w="med" len="med"/>
+                    </a:lnB>
+                  </a:tcPr>
+                </a:tc>
+                <a:tc>
+                  <a:txBody>
+                    <a:bodyPr/>
+                    <a:lstStyle/>
+                    <a:p>
+                      <a:pPr marL="0" indent="0" algn="ctr">
+                        <a:buNone/>
+                      </a:pPr>
+                      <a:r>
+                        <a:rPr lang="en-US" sz="1150" dirty="0">
+                          <a:solidFill>
+                            <a:srgbClr val="6B7280"/>
+                          </a:solidFill>
+                        </a:rPr>
+                        <a:t>19%</a:t>
+                      </a:r>
+                      <a:endParaRPr lang="en-US" sz="1150" dirty="0"/>
+                    </a:p>
+                  </a:txBody>
+                  <a:tcPr marL="45720" marR="45720" anchor="ctr">
+                    <a:lnL w="6350" cap="flat" cmpd="sng" algn="ctr">
+                      <a:solidFill>
+                        <a:srgbClr val="D5DBE5"/>
+                      </a:solidFill>
+                      <a:prstDash val="solid"/>
+                      <a:round/>
+                      <a:headEnd type="none" w="med" len="med"/>
+                      <a:tailEnd type="none" w="med" len="med"/>
+                    </a:lnL>
+                    <a:lnR w="6350" cap="flat" cmpd="sng" algn="ctr">
+                      <a:solidFill>
+                        <a:srgbClr val="D5DBE5"/>
+                      </a:solidFill>
+                      <a:prstDash val="solid"/>
+                      <a:round/>
+                      <a:headEnd type="none" w="med" len="med"/>
+                      <a:tailEnd type="none" w="med" len="med"/>
+                    </a:lnR>
+                    <a:lnT w="6350" cap="flat" cmpd="sng" algn="ctr">
+                      <a:solidFill>
+                        <a:srgbClr val="D5DBE5"/>
+                      </a:solidFill>
+                      <a:prstDash val="solid"/>
+                      <a:round/>
+                      <a:headEnd type="none" w="med" len="med"/>
+                      <a:tailEnd type="none" w="med" len="med"/>
+                    </a:lnT>
+                    <a:lnB w="6350" cap="flat" cmpd="sng" algn="ctr">
+                      <a:solidFill>
+                        <a:srgbClr val="D5DBE5"/>
+                      </a:solidFill>
+                      <a:prstDash val="solid"/>
+                      <a:round/>
+                      <a:headEnd type="none" w="med" len="med"/>
+                      <a:tailEnd type="none" w="med" len="med"/>
+                    </a:lnB>
+                  </a:tcPr>
+                </a:tc>
+                <a:extLst>
+                  <a:ext uri="{0D108BD9-81ED-4DB2-BD59-A6C34878D82A}">
+                    <a16:rowId xmlns:a16="http://schemas.microsoft.com/office/drawing/2014/main" val="10004"/>
+                  </a:ext>
+                </a:extLst>
+              </a:tr>
+            </a:tbl>
+          </a:graphicData>
+        </a:graphic>
+      </p:graphicFrame>
+      <p:sp>
+        <p:nvSpPr>
+          <p:cNvPr id="9" name="Text 5"/>
+          <p:cNvSpPr txBox="1"/>
+          <p:nvPr/>
+        </p:nvSpPr>
+        <p:spPr>
+          <a:xfrm>
+            <a:off x="6172200" y="4023360"/>
+            <a:ext cx="5468112" cy="822960"/>
+          </a:xfrm>
+          <a:prstGeom prst="rect">
+            <a:avLst/>
+          </a:prstGeom>
+          <a:noFill/>
+          <a:ln/>
+        </p:spPr>
+        <p:txBody>
+          <a:bodyPr wrap="square" lIns="0" tIns="0" rIns="0" bIns="0" rtlCol="0" anchor="t"/>
+          <a:lstStyle/>
+          <a:p>
+            <a:pPr marL="0" indent="0">
+              <a:buNone/>
+            </a:pPr>
+            <a:r>
+              <a:rPr lang="en-US" sz="1050" dirty="0">
+                <a:solidFill>
+                  <a:schemeClr val="accent4"/>
+                </a:solidFill>
+              </a:rPr>
+              <a:t>Read the first row: of the 50 meetings that came right after a hike, the Fed hiked again at 32 and held at 18; it never cut straight after a hike. The pool uses the 49 cases known at the time of the 28 October snapshot.</a:t>
+            </a:r>
+            <a:endParaRPr lang="en-US" sz="1050" dirty="0"/>
+          </a:p>
+        </p:txBody>
+      </p:sp>
+      <p:sp>
+        <p:nvSpPr>
+          <p:cNvPr id="10" name="Text 6"/>
+          <p:cNvSpPr txBox="1"/>
+          <p:nvPr/>
+        </p:nvSpPr>
+        <p:spPr>
+          <a:xfrm>
+            <a:off x="6172200" y="4892040"/>
+            <a:ext cx="5468112" cy="320040"/>
+          </a:xfrm>
+          <a:prstGeom prst="rect">
+            <a:avLst/>
+          </a:prstGeom>
+          <a:noFill/>
+          <a:ln/>
+        </p:spPr>
+        <p:txBody>
+          <a:bodyPr wrap="square" lIns="0" tIns="0" rIns="0" bIns="0" rtlCol="0" anchor="t"/>
+          <a:lstStyle/>
+          <a:p>
+            <a:pPr marL="0" indent="0">
+              <a:buNone/>
+            </a:pPr>
+            <a:r>
+              <a:rPr lang="en-US" sz="1400" b="1" dirty="0">
+                <a:solidFill>
+                  <a:schemeClr val="tx2"/>
+                </a:solidFill>
+              </a:rPr>
+              <a:t>Why a prior matters</a:t>
+            </a:r>
+            <a:endParaRPr lang="en-US" sz="1400" dirty="0"/>
+          </a:p>
+        </p:txBody>
+      </p:sp>
+      <p:sp>
+        <p:nvSpPr>
+          <p:cNvPr id="11" name="Text 7"/>
+          <p:cNvSpPr txBox="1"/>
+          <p:nvPr/>
+        </p:nvSpPr>
+        <p:spPr>
+          <a:xfrm>
+            <a:off x="6172200" y="5212080"/>
+            <a:ext cx="5468112" cy="914400"/>
+          </a:xfrm>
+          <a:prstGeom prst="rect">
+            <a:avLst/>
+          </a:prstGeom>
+          <a:noFill/>
+          <a:ln/>
+        </p:spPr>
+        <p:txBody>
+          <a:bodyPr wrap="square" lIns="0" tIns="0" rIns="0" bIns="0" rtlCol="0" anchor="t"/>
+          <a:lstStyle/>
+          <a:p>
+            <a:pPr marL="0" indent="0">
+              <a:buNone/>
+            </a:pPr>
+            <a:r>
+              <a:rPr lang="en-US" sz="1050" dirty="0">
+                <a:solidFill>
+                  <a:schemeClr val="tx1"/>
+                </a:solidFill>
+              </a:rPr>
+              <a:t>The Fed moves in runs. A hike is usually followed by another hike, a cut by another cut, and a hold by a hold. Any forecast that ignores this starts from the wrong place; the base rate is the place to start, and the market, the rules and the analysts move it from there.</a:t>
+            </a:r>
+            <a:endParaRPr lang="en-US" sz="1050" dirty="0"/>
+          </a:p>
+        </p:txBody>
+      </p:sp>
+      <p:sp>
+        <p:nvSpPr>
+          <p:cNvPr id="25" name="Slide Number Placeholder 0"/>
+          <p:cNvSpPr>
+            <a:spLocks noGrp="1"/>
+          </p:cNvSpPr>
+          <p:nvPr>
+            <p:ph type="sldNum" sz="quarter" idx="4294967295"/>
+          </p:nvPr>
+        </p:nvSpPr>
+        <p:spPr>
+          <a:xfrm>
+            <a:off x="11091672" y="6400800"/>
+            <a:ext cx="548640" cy="274320"/>
+          </a:xfrm>
+          <a:prstGeom prst="rect">
+            <a:avLst/>
+          </a:prstGeom>
+          <a:extLst>
+            <a:ext uri="{C572A759-6A51-4108-AA02-DFA0A04FC94B}">
+              <ma14:wrappingTextBoxFlag xmlns:ma14="http://schemas.microsoft.com/office/mac/drawingml/2011/main" xmlns="" val="0"/>
+            </a:ext>
+          </a:extLst>
+        </p:spPr>
+        <p:txBody>
+          <a:bodyPr/>
+          <a:lstStyle>
+            <a:lvl1pPr>
+              <a:defRPr sz="1000">
+                <a:solidFill>
+                  <a:srgbClr val="6B7280"/>
+                </a:solidFill>
+              </a:defRPr>
+            </a:lvl1pPr>
+          </a:lstStyle>
+          <a:p>
+            <a:pPr algn="r"/>
+            <a:fld id="{F7021451-1387-4CA6-816F-3879F97B5CBC}" type="slidenum">
+              <a:rPr lang="en-US" b="0"/>
+              <a:t>24</a:t>
+            </a:fld>
+            <a:endParaRPr lang="en-US"/>
+          </a:p>
+        </p:txBody>
+      </p:sp>
+    </p:spTree>
+    <p:extLst>
+      <p:ext uri="{BB962C8B-B14F-4D97-AF65-F5344CB8AC3E}">
+        <p14:creationId xmlns:p14="http://schemas.microsoft.com/office/powerpoint/2010/main" val="4031238931"/>
       </p:ext>
     </p:extLst>
   </p:cSld>
@@ -22710,7 +24435,7 @@
           </a:prstGeom>
           <a:extLst>
             <a:ext uri="{C572A759-6A51-4108-AA02-DFA0A04FC94B}">
-              <ma14:wrappingTextBoxFlag xmlns:ma14="http://schemas.microsoft.com/office/mac/drawingml/2011/main" xmlns="" val="0"/>
+              <ma14:wrappingTextBoxFlag xmlns="" xmlns:ma14="http://schemas.microsoft.com/office/mac/drawingml/2011/main" val="0"/>
             </a:ext>
           </a:extLst>
         </p:spPr>
@@ -24962,7 +26687,7 @@
           </a:prstGeom>
           <a:extLst>
             <a:ext uri="{C572A759-6A51-4108-AA02-DFA0A04FC94B}">
-              <ma14:wrappingTextBoxFlag xmlns:ma14="http://schemas.microsoft.com/office/mac/drawingml/2011/main" xmlns="" val="0"/>
+              <ma14:wrappingTextBoxFlag xmlns="" xmlns:ma14="http://schemas.microsoft.com/office/mac/drawingml/2011/main" val="0"/>
             </a:ext>
           </a:extLst>
         </p:spPr>
@@ -26934,7 +28659,7 @@
           </a:prstGeom>
           <a:extLst>
             <a:ext uri="{C572A759-6A51-4108-AA02-DFA0A04FC94B}">
-              <ma14:wrappingTextBoxFlag xmlns="" xmlns:ma14="http://schemas.microsoft.com/office/mac/drawingml/2011/main" val="0"/>
+              <ma14:wrappingTextBoxFlag xmlns:ma14="http://schemas.microsoft.com/office/mac/drawingml/2011/main" xmlns="" val="0"/>
             </a:ext>
           </a:extLst>
         </p:spPr>
@@ -28150,7 +29875,7 @@
           </a:prstGeom>
           <a:extLst>
             <a:ext uri="{C572A759-6A51-4108-AA02-DFA0A04FC94B}">
-              <ma14:wrappingTextBoxFlag xmlns="" xmlns:ma14="http://schemas.microsoft.com/office/mac/drawingml/2011/main" val="0"/>
+              <ma14:wrappingTextBoxFlag xmlns:ma14="http://schemas.microsoft.com/office/mac/drawingml/2011/main" xmlns="" val="0"/>
             </a:ext>
           </a:extLst>
         </p:spPr>
@@ -28472,12 +30197,12 @@
               <a:buNone/>
             </a:pPr>
             <a:r>
-              <a:rPr lang="en-US" sz="950" dirty="0">
+              <a:rPr lang="en-US" sz="950">
                 <a:solidFill>
                   <a:schemeClr val="bg1"/>
                 </a:solidFill>
               </a:rPr>
-              <a:t>What followed each kind of decision over 32 years of FOMC history, conditioned on the last move</a:t>
+              <a:t>What the Fed did next after each kind of decision, 266 scheduled meetings since 1994. After a hike: hiked again 64%, held 36%, never cut</a:t>
             </a:r>
             <a:endParaRPr lang="en-US" sz="950" dirty="0"/>
           </a:p>
@@ -29761,7 +31486,7 @@
           </a:prstGeom>
           <a:extLst>
             <a:ext uri="{C572A759-6A51-4108-AA02-DFA0A04FC94B}">
-              <ma14:wrappingTextBoxFlag xmlns:ma14="http://schemas.microsoft.com/office/mac/drawingml/2011/main" xmlns="" val="0"/>
+              <ma14:wrappingTextBoxFlag xmlns="" xmlns:ma14="http://schemas.microsoft.com/office/mac/drawingml/2011/main" val="0"/>
             </a:ext>
           </a:extLst>
         </p:spPr>
@@ -29865,7 +31590,7 @@
           <p:nvPr>
             <p:extLst>
               <p:ext uri="{D42A27DB-BD31-4B8C-83A1-F6EECF244321}">
-                <p14:modId xmlns:p14="http://schemas.microsoft.com/office/powerpoint/2010/main" val="1563022806"/>
+                <p14:modId xmlns:p14="http://schemas.microsoft.com/office/powerpoint/2010/main" val="3817199728"/>
               </p:ext>
             </p:extLst>
           </p:nvPr>
@@ -30431,12 +32156,12 @@
                         <a:buNone/>
                       </a:pPr>
                       <a:r>
-                        <a:rPr lang="en-US" sz="1050" dirty="0">
+                        <a:rPr lang="en-US" sz="1050">
                           <a:solidFill>
                             <a:srgbClr val="1B1F2A"/>
                           </a:solidFill>
                         </a:rPr>
-                        <a:t>November fed-funds future against the overnight rate: +2.5 bp expected, split between the two nearest outcomes</a:t>
+                        <a:t>The November fed-funds futures price</a:t>
                       </a:r>
                       <a:endParaRPr lang="en-US" sz="1050" dirty="0"/>
                     </a:p>
@@ -30844,12 +32569,12 @@
                         <a:buNone/>
                       </a:pPr>
                       <a:r>
-                        <a:rPr lang="en-US" sz="1050" dirty="0">
+                        <a:rPr lang="en-US" sz="1050">
                           <a:solidFill>
                             <a:srgbClr val="1B1F2A"/>
                           </a:solidFill>
                         </a:rPr>
-                        <a:t>12-month core PCE 3.0%, unemployment 4.2%, r* from the NY Fed DSGE model (0.65 / 1.86 / 3.06%); three level rules × nine r*/u* pairs plus the first-difference rule × three u*: 30 prescriptions, mean +22.5 bp</a:t>
+                        <a:t>Core PCE inflation, unemployment, the NY Fed natural rate, through the Fed's own four policy rules</a:t>
                       </a:r>
                       <a:endParaRPr lang="en-US" sz="1050" dirty="0"/>
                     </a:p>
@@ -31257,12 +32982,12 @@
                         <a:buNone/>
                       </a:pPr>
                       <a:r>
-                        <a:rPr lang="en-US" sz="1050" dirty="0">
+                        <a:rPr lang="en-US" sz="1050">
                           <a:solidFill>
                             <a:srgbClr val="1B1F2A"/>
                           </a:solidFill>
                         </a:rPr>
-                        <a:t>Polymarket, 26 Oct, $67m traded: 94.5% no change at the mid price, 94.9% once the five prices are renormalised</a:t>
+                        <a:t>Polymarket odds on each outcome, 26 October</a:t>
                       </a:r>
                       <a:endParaRPr lang="en-US" sz="1050" dirty="0"/>
                     </a:p>
@@ -31670,12 +33395,12 @@
                         <a:buNone/>
                       </a:pPr>
                       <a:r>
-                        <a:rPr lang="en-US" sz="1050" dirty="0">
+                        <a:rPr lang="en-US" sz="1050">
                           <a:solidFill>
                             <a:srgbClr val="1B1F2A"/>
                           </a:solidFill>
                         </a:rPr>
-                        <a:t>What followed a hike at the 49 scheduled meetings since 1994 that came after one</a:t>
+                        <a:t>What the Fed did at the 49 meetings since 1994 that followed a hike</a:t>
                       </a:r>
                       <a:endParaRPr lang="en-US" sz="1050" dirty="0"/>
                     </a:p>
@@ -32083,12 +33808,12 @@
                         <a:buNone/>
                       </a:pPr>
                       <a:r>
-                        <a:rPr lang="en-US" sz="1050" dirty="0">
+                        <a:rPr lang="en-US" sz="1050">
                           <a:solidFill>
                             <a:srgbClr val="1B1F2A"/>
                           </a:solidFill>
                         </a:rPr>
-                        <a:t>Nine features on first-published data; failed v1, caveated v2</a:t>
+                        <a:t>Nine macro features, as first published; fitted on decisions since 2000</a:t>
                       </a:r>
                       <a:endParaRPr lang="en-US" sz="1050" dirty="0"/>
                     </a:p>
@@ -33841,7 +35566,7 @@
           </a:prstGeom>
           <a:extLst>
             <a:ext uri="{C572A759-6A51-4108-AA02-DFA0A04FC94B}">
-              <ma14:wrappingTextBoxFlag xmlns="" xmlns:ma14="http://schemas.microsoft.com/office/mac/drawingml/2011/main" val="0"/>
+              <ma14:wrappingTextBoxFlag xmlns:ma14="http://schemas.microsoft.com/office/mac/drawingml/2011/main" xmlns="" val="0"/>
             </a:ext>
           </a:extLst>
         </p:spPr>

</xml_diff>

<commit_message>
Slide 12: the specialists are asked for an opinion from -10 (dovish) to +10 (hawkish), not how likely each outcome is; the conversion to probability points is the code's step
Co-Authored-By: Claude Fable 5.1 <noreply@anthropic.com>
</commit_message>
<xml_diff>
--- a/docs/FedCast_Fullerton.pptx
+++ b/docs/FedCast_Fullerton.pptx
@@ -3493,7 +3493,7 @@
           </a:prstGeom>
           <a:extLst>
             <a:ext uri="{C572A759-6A51-4108-AA02-DFA0A04FC94B}">
-              <ma14:wrappingTextBoxFlag xmlns:ma14="http://schemas.microsoft.com/office/mac/drawingml/2011/main" xmlns="" val="0"/>
+              <ma14:wrappingTextBoxFlag xmlns="" xmlns:ma14="http://schemas.microsoft.com/office/mac/drawingml/2011/main" val="0"/>
             </a:ext>
           </a:extLst>
         </p:spPr>
@@ -3678,7 +3678,7 @@
           </a:prstGeom>
           <a:extLst>
             <a:ext uri="{C572A759-6A51-4108-AA02-DFA0A04FC94B}">
-              <ma14:wrappingTextBoxFlag xmlns:ma14="http://schemas.microsoft.com/office/mac/drawingml/2011/main" xmlns="" val="0"/>
+              <ma14:wrappingTextBoxFlag xmlns="" xmlns:ma14="http://schemas.microsoft.com/office/mac/drawingml/2011/main" val="0"/>
             </a:ext>
           </a:extLst>
         </p:spPr>
@@ -4811,6 +4811,13 @@
             <a:prstDash val="solid"/>
           </a:ln>
         </p:spPr>
+        <p:txBody>
+          <a:bodyPr/>
+          <a:lstStyle/>
+          <a:p>
+            <a:endParaRPr lang="en-US"/>
+          </a:p>
+        </p:txBody>
       </p:sp>
       <p:sp>
         <p:nvSpPr>
@@ -4836,6 +4843,13 @@
             <a:prstDash val="solid"/>
           </a:ln>
         </p:spPr>
+        <p:txBody>
+          <a:bodyPr/>
+          <a:lstStyle/>
+          <a:p>
+            <a:endParaRPr lang="en-US"/>
+          </a:p>
+        </p:txBody>
       </p:sp>
       <p:sp>
         <p:nvSpPr>
@@ -4969,6 +4983,13 @@
             <a:prstDash val="solid"/>
           </a:ln>
         </p:spPr>
+        <p:txBody>
+          <a:bodyPr/>
+          <a:lstStyle/>
+          <a:p>
+            <a:endParaRPr lang="en-US"/>
+          </a:p>
+        </p:txBody>
       </p:sp>
       <p:sp>
         <p:nvSpPr>
@@ -5123,6 +5144,13 @@
             <a:prstDash val="solid"/>
           </a:ln>
         </p:spPr>
+        <p:txBody>
+          <a:bodyPr/>
+          <a:lstStyle/>
+          <a:p>
+            <a:endParaRPr lang="en-US"/>
+          </a:p>
+        </p:txBody>
       </p:sp>
       <p:sp>
         <p:nvSpPr>
@@ -5148,6 +5176,13 @@
             <a:prstDash val="solid"/>
           </a:ln>
         </p:spPr>
+        <p:txBody>
+          <a:bodyPr/>
+          <a:lstStyle/>
+          <a:p>
+            <a:endParaRPr lang="en-US"/>
+          </a:p>
+        </p:txBody>
       </p:sp>
       <p:sp>
         <p:nvSpPr>
@@ -5281,6 +5316,13 @@
             <a:prstDash val="solid"/>
           </a:ln>
         </p:spPr>
+        <p:txBody>
+          <a:bodyPr/>
+          <a:lstStyle/>
+          <a:p>
+            <a:endParaRPr lang="en-US"/>
+          </a:p>
+        </p:txBody>
       </p:sp>
       <p:sp>
         <p:nvSpPr>
@@ -5429,7 +5471,7 @@
           </a:prstGeom>
           <a:extLst>
             <a:ext uri="{C572A759-6A51-4108-AA02-DFA0A04FC94B}">
-              <ma14:wrappingTextBoxFlag xmlns:ma14="http://schemas.microsoft.com/office/mac/drawingml/2011/main" xmlns="" val="0"/>
+              <ma14:wrappingTextBoxFlag xmlns="" xmlns:ma14="http://schemas.microsoft.com/office/mac/drawingml/2011/main" val="0"/>
             </a:ext>
           </a:extLst>
         </p:spPr>
@@ -7572,12 +7614,36 @@
               <a:buNone/>
             </a:pPr>
             <a:r>
+              <a:rPr lang="en-US" sz="1150" dirty="0">
+                <a:solidFill>
+                  <a:srgbClr val="CADCFC"/>
+                </a:solidFill>
+              </a:rPr>
+              <a:t>Each specialist is asked one question about its own slice (above</a:t>
+            </a:r>
+            <a:r>
               <a:rPr lang="en-US" sz="1150">
                 <a:solidFill>
                   <a:srgbClr val="CADCFC"/>
                 </a:solidFill>
               </a:rPr>
-              <a:t>Each specialist is asked one question about its own slice (above), never for a probability. It returns claims, each with a verbatim quote and item id, and an opinion from -10 to +10: points of probability toward a hike (positive) or a cut (negative). Code averages the five opinions and moves that many points from the hold side to the hike side (or the reverse), capped at 10.</a:t>
+              <a:t>), not how likely each outcome is. </a:t>
+            </a:r>
+            <a:r>
+              <a:rPr lang="en-US" sz="1150" dirty="0">
+                <a:solidFill>
+                  <a:srgbClr val="CADCFC"/>
+                </a:solidFill>
+              </a:rPr>
+              <a:t>It returns claims, each with a verbatim quote and item id, and an opinion from -</a:t>
+            </a:r>
+            <a:r>
+              <a:rPr lang="en-US" sz="1150">
+                <a:solidFill>
+                  <a:srgbClr val="CADCFC"/>
+                </a:solidFill>
+              </a:rPr>
+              <a:t>10 (strongly dovish) to +10 (strongly hawkish). Code averages the five opinions and moves that many points of probability from hold toward a hike (positive) or a cut (negative), capped at 10.</a:t>
             </a:r>
             <a:endParaRPr lang="en-US" sz="1150" dirty="0"/>
           </a:p>
@@ -7836,7 +7902,7 @@
           </a:prstGeom>
           <a:extLst>
             <a:ext uri="{C572A759-6A51-4108-AA02-DFA0A04FC94B}">
-              <ma14:wrappingTextBoxFlag xmlns:ma14="http://schemas.microsoft.com/office/mac/drawingml/2011/main" xmlns="" val="0"/>
+              <ma14:wrappingTextBoxFlag xmlns="" xmlns:ma14="http://schemas.microsoft.com/office/mac/drawingml/2011/main" val="0"/>
             </a:ext>
           </a:extLst>
         </p:spPr>
@@ -8607,7 +8673,7 @@
                   <a:schemeClr val="tx2"/>
                 </a:solidFill>
               </a:rPr>
-              <a:t>Numbers from memory (count)</a:t>
+              <a:t>Cited numbers from memory (count)</a:t>
             </a:r>
             <a:endParaRPr lang="en-US" sz="1300" dirty="0"/>
           </a:p>
@@ -8825,7 +8891,7 @@
           </a:prstGeom>
           <a:extLst>
             <a:ext uri="{C572A759-6A51-4108-AA02-DFA0A04FC94B}">
-              <ma14:wrappingTextBoxFlag xmlns:ma14="http://schemas.microsoft.com/office/mac/drawingml/2011/main" xmlns="" val="0"/>
+              <ma14:wrappingTextBoxFlag xmlns="" xmlns:ma14="http://schemas.microsoft.com/office/mac/drawingml/2011/main" val="0"/>
             </a:ext>
           </a:extLst>
         </p:spPr>
@@ -10529,7 +10595,7 @@
           </a:prstGeom>
           <a:extLst>
             <a:ext uri="{C572A759-6A51-4108-AA02-DFA0A04FC94B}">
-              <ma14:wrappingTextBoxFlag xmlns:ma14="http://schemas.microsoft.com/office/mac/drawingml/2011/main" xmlns="" val="0"/>
+              <ma14:wrappingTextBoxFlag xmlns="" xmlns:ma14="http://schemas.microsoft.com/office/mac/drawingml/2011/main" val="0"/>
             </a:ext>
           </a:extLst>
         </p:spPr>
@@ -13495,7 +13561,7 @@
           </a:prstGeom>
           <a:extLst>
             <a:ext uri="{C572A759-6A51-4108-AA02-DFA0A04FC94B}">
-              <ma14:wrappingTextBoxFlag xmlns:ma14="http://schemas.microsoft.com/office/mac/drawingml/2011/main" xmlns="" val="0"/>
+              <ma14:wrappingTextBoxFlag xmlns="" xmlns:ma14="http://schemas.microsoft.com/office/mac/drawingml/2011/main" val="0"/>
             </a:ext>
           </a:extLst>
         </p:spPr>
@@ -14419,7 +14485,7 @@
           </a:prstGeom>
           <a:extLst>
             <a:ext uri="{C572A759-6A51-4108-AA02-DFA0A04FC94B}">
-              <ma14:wrappingTextBoxFlag xmlns:ma14="http://schemas.microsoft.com/office/mac/drawingml/2011/main" xmlns="" val="0"/>
+              <ma14:wrappingTextBoxFlag xmlns="" xmlns:ma14="http://schemas.microsoft.com/office/mac/drawingml/2011/main" val="0"/>
             </a:ext>
           </a:extLst>
         </p:spPr>
@@ -16399,7 +16465,7 @@
           </a:prstGeom>
           <a:extLst>
             <a:ext uri="{C572A759-6A51-4108-AA02-DFA0A04FC94B}">
-              <ma14:wrappingTextBoxFlag xmlns:ma14="http://schemas.microsoft.com/office/mac/drawingml/2011/main" xmlns="" val="0"/>
+              <ma14:wrappingTextBoxFlag xmlns="" xmlns:ma14="http://schemas.microsoft.com/office/mac/drawingml/2011/main" val="0"/>
             </a:ext>
           </a:extLst>
         </p:spPr>
@@ -19376,7 +19442,7 @@
           </a:prstGeom>
           <a:extLst>
             <a:ext uri="{C572A759-6A51-4108-AA02-DFA0A04FC94B}">
-              <ma14:wrappingTextBoxFlag xmlns="" xmlns:ma14="http://schemas.microsoft.com/office/mac/drawingml/2011/main" val="0"/>
+              <ma14:wrappingTextBoxFlag xmlns:ma14="http://schemas.microsoft.com/office/mac/drawingml/2011/main" xmlns="" val="0"/>
             </a:ext>
           </a:extLst>
         </p:spPr>
@@ -21369,7 +21435,7 @@
           </a:prstGeom>
           <a:extLst>
             <a:ext uri="{C572A759-6A51-4108-AA02-DFA0A04FC94B}">
-              <ma14:wrappingTextBoxFlag xmlns="" xmlns:ma14="http://schemas.microsoft.com/office/mac/drawingml/2011/main" val="0"/>
+              <ma14:wrappingTextBoxFlag xmlns:ma14="http://schemas.microsoft.com/office/mac/drawingml/2011/main" xmlns="" val="0"/>
             </a:ext>
           </a:extLst>
         </p:spPr>
@@ -21497,6 +21563,13 @@
             </a:outerShdw>
           </a:effectLst>
         </p:spPr>
+        <p:txBody>
+          <a:bodyPr/>
+          <a:lstStyle/>
+          <a:p>
+            <a:endParaRPr lang="en-US"/>
+          </a:p>
+        </p:txBody>
       </p:sp>
       <p:sp>
         <p:nvSpPr>
@@ -21698,7 +21771,7 @@
         </p:nvGraphicFramePr>
         <p:xfrm>
           <a:off x="6172200" y="1783080"/>
-          <a:ext cx="5468112" cy="914400"/>
+          <a:ext cx="5742432" cy="2103120"/>
         </p:xfrm>
         <a:graphic>
           <a:graphicData uri="http://schemas.openxmlformats.org/drawingml/2006/table">
@@ -23373,7 +23446,7 @@
           </a:prstGeom>
           <a:extLst>
             <a:ext uri="{C572A759-6A51-4108-AA02-DFA0A04FC94B}">
-              <ma14:wrappingTextBoxFlag xmlns:ma14="http://schemas.microsoft.com/office/mac/drawingml/2011/main" xmlns="" val="0"/>
+              <ma14:wrappingTextBoxFlag xmlns="" xmlns:ma14="http://schemas.microsoft.com/office/mac/drawingml/2011/main" val="0"/>
             </a:ext>
           </a:extLst>
         </p:spPr>
@@ -24435,7 +24508,7 @@
           </a:prstGeom>
           <a:extLst>
             <a:ext uri="{C572A759-6A51-4108-AA02-DFA0A04FC94B}">
-              <ma14:wrappingTextBoxFlag xmlns="" xmlns:ma14="http://schemas.microsoft.com/office/mac/drawingml/2011/main" val="0"/>
+              <ma14:wrappingTextBoxFlag xmlns:ma14="http://schemas.microsoft.com/office/mac/drawingml/2011/main" xmlns="" val="0"/>
             </a:ext>
           </a:extLst>
         </p:spPr>
@@ -26687,7 +26760,7 @@
           </a:prstGeom>
           <a:extLst>
             <a:ext uri="{C572A759-6A51-4108-AA02-DFA0A04FC94B}">
-              <ma14:wrappingTextBoxFlag xmlns="" xmlns:ma14="http://schemas.microsoft.com/office/mac/drawingml/2011/main" val="0"/>
+              <ma14:wrappingTextBoxFlag xmlns:ma14="http://schemas.microsoft.com/office/mac/drawingml/2011/main" xmlns="" val="0"/>
             </a:ext>
           </a:extLst>
         </p:spPr>
@@ -28659,7 +28732,7 @@
           </a:prstGeom>
           <a:extLst>
             <a:ext uri="{C572A759-6A51-4108-AA02-DFA0A04FC94B}">
-              <ma14:wrappingTextBoxFlag xmlns:ma14="http://schemas.microsoft.com/office/mac/drawingml/2011/main" xmlns="" val="0"/>
+              <ma14:wrappingTextBoxFlag xmlns="" xmlns:ma14="http://schemas.microsoft.com/office/mac/drawingml/2011/main" val="0"/>
             </a:ext>
           </a:extLst>
         </p:spPr>
@@ -29875,7 +29948,7 @@
           </a:prstGeom>
           <a:extLst>
             <a:ext uri="{C572A759-6A51-4108-AA02-DFA0A04FC94B}">
-              <ma14:wrappingTextBoxFlag xmlns:ma14="http://schemas.microsoft.com/office/mac/drawingml/2011/main" xmlns="" val="0"/>
+              <ma14:wrappingTextBoxFlag xmlns="" xmlns:ma14="http://schemas.microsoft.com/office/mac/drawingml/2011/main" val="0"/>
             </a:ext>
           </a:extLst>
         </p:spPr>
@@ -31486,7 +31559,7 @@
           </a:prstGeom>
           <a:extLst>
             <a:ext uri="{C572A759-6A51-4108-AA02-DFA0A04FC94B}">
-              <ma14:wrappingTextBoxFlag xmlns="" xmlns:ma14="http://schemas.microsoft.com/office/mac/drawingml/2011/main" val="0"/>
+              <ma14:wrappingTextBoxFlag xmlns:ma14="http://schemas.microsoft.com/office/mac/drawingml/2011/main" xmlns="" val="0"/>
             </a:ext>
           </a:extLst>
         </p:spPr>
@@ -31597,7 +31670,7 @@
         </p:nvGraphicFramePr>
         <p:xfrm>
           <a:off x="548640" y="1325880"/>
-          <a:ext cx="11091672" cy="3899916"/>
+          <a:ext cx="11091672" cy="3749040"/>
         </p:xfrm>
         <a:graphic>
           <a:graphicData uri="http://schemas.openxmlformats.org/drawingml/2006/table">
@@ -35566,7 +35639,7 @@
           </a:prstGeom>
           <a:extLst>
             <a:ext uri="{C572A759-6A51-4108-AA02-DFA0A04FC94B}">
-              <ma14:wrappingTextBoxFlag xmlns:ma14="http://schemas.microsoft.com/office/mac/drawingml/2011/main" xmlns="" val="0"/>
+              <ma14:wrappingTextBoxFlag xmlns="" xmlns:ma14="http://schemas.microsoft.com/office/mac/drawingml/2011/main" val="0"/>
             </a:ext>
           </a:extLst>
         </p:spPr>

</xml_diff>

<commit_message>
Slide 15: say how the +4.0 opinion is spread across the five outcomes, with a before/after table from ledger entry 18
Co-Authored-By: Claude Fable 5.1 <noreply@anthropic.com>
</commit_message>
<xml_diff>
--- a/docs/FedCast_Fullerton.pptx
+++ b/docs/FedCast_Fullerton.pptx
@@ -9492,7 +9492,21 @@
                   <a:schemeClr val="tx1"/>
                 </a:solidFill>
               </a:rPr>
-              <a:t>100%; 0 numbers from memory</a:t>
+              <a:t>100% from evidence </a:t>
+            </a:r>
+            <a:endParaRPr lang="en-US" sz="1050" dirty="0"/>
+          </a:p>
+          <a:p>
+            <a:pPr marL="0" indent="0" algn="ctr">
+              <a:buNone/>
+            </a:pPr>
+            <a:r>
+              <a:rPr lang="en-US" sz="1050" dirty="0">
+                <a:solidFill>
+                  <a:schemeClr val="tx1"/>
+                </a:solidFill>
+              </a:rPr>
+              <a:t>0 numbers from memory</a:t>
             </a:r>
             <a:endParaRPr lang="en-US" sz="1050" dirty="0"/>
           </a:p>
@@ -9555,12 +9569,12 @@
               <a:buNone/>
             </a:pPr>
             <a:r>
-              <a:rPr lang="en-US" sz="2000" b="1">
+              <a:rPr lang="en-US" sz="2000" b="1" dirty="0">
                 <a:solidFill>
                   <a:schemeClr val="bg1"/>
                 </a:solidFill>
               </a:rPr>
-              <a:t>5 opinions, ±10</a:t>
+              <a:t>5 opinions</a:t>
             </a:r>
             <a:endParaRPr lang="en-US" sz="2000" dirty="0"/>
           </a:p>
@@ -9590,22 +9604,6 @@
             <a:pPr marL="0" indent="0" algn="ctr">
               <a:buNone/>
             </a:pPr>
-            <a:r>
-              <a:rPr lang="en-US" sz="1050" dirty="0">
-                <a:solidFill>
-                  <a:srgbClr val="CADCFC"/>
-                </a:solidFill>
-              </a:rPr>
-              <a:t>+6.0 · +6.2 · +5.8 · −1.4 </a:t>
-            </a:r>
-            <a:r>
-              <a:rPr lang="en-US" sz="1050">
-                <a:solidFill>
-                  <a:srgbClr val="CADCFC"/>
-                </a:solidFill>
-              </a:rPr>
-              <a:t>· +3.4</a:t>
-            </a:r>
             <a:endParaRPr lang="en-US" sz="1050" dirty="0"/>
           </a:p>
         </p:txBody>
@@ -9619,7 +9617,7 @@
         <p:spPr>
           <a:xfrm>
             <a:off x="548640" y="3931920"/>
-            <a:ext cx="4434840" cy="2377440"/>
+            <a:ext cx="4434840" cy="2468880"/>
           </a:xfrm>
           <a:prstGeom prst="roundRect">
             <a:avLst>
@@ -10188,7 +10186,7 @@
         <p:spPr>
           <a:xfrm>
             <a:off x="2880360" y="4315968"/>
-            <a:ext cx="1965960" cy="1188720"/>
+            <a:ext cx="2011680" cy="1005840"/>
           </a:xfrm>
           <a:prstGeom prst="rect">
             <a:avLst/>
@@ -10204,146 +10202,43 @@
               <a:buNone/>
             </a:pPr>
             <a:r>
-              <a:rPr lang="en-US" sz="1050" b="1" dirty="0">
+              <a:rPr lang="en-US" sz="1000" b="1">
                 <a:solidFill>
                   <a:schemeClr val="tx1"/>
                 </a:solidFill>
               </a:rPr>
-              <a:t>Four say hike, one says hold back. </a:t>
-            </a:r>
-            <a:r>
-              <a:rPr lang="en-US" sz="1050" dirty="0">
+              <a:t>Four say hike, one says hold: </a:t>
+            </a:r>
+            <a:r>
+              <a:rPr lang="en-US" sz="1000">
                 <a:solidFill>
                   <a:schemeClr val="tx1"/>
                 </a:solidFill>
               </a:rPr>
-              <a:t>Plain average, one vote each: +4.0.</a:t>
-            </a:r>
-            <a:endParaRPr lang="en-US" sz="1050" dirty="0"/>
+              <a:t>+4.0.</a:t>
+            </a:r>
           </a:p>
           <a:p>
             <a:pPr marL="0" indent="0">
               <a:buNone/>
             </a:pPr>
             <a:r>
-              <a:rPr lang="en-US" sz="1050" b="1">
+              <a:rPr lang="en-US" sz="1000" b="1">
                 <a:solidFill>
                   <a:schemeClr val="tx1"/>
                 </a:solidFill>
               </a:rPr>
-              <a:t>Each point of opinion </a:t>
-            </a:r>
-            <a:r>
-              <a:rPr lang="en-US" sz="1050" b="1" dirty="0">
+              <a:t>+4.0 moves 4 points of probability to the hike side. </a:t>
+            </a:r>
+            <a:r>
+              <a:rPr lang="en-US" sz="1000">
                 <a:solidFill>
                   <a:schemeClr val="tx1"/>
                 </a:solidFill>
               </a:rPr>
-              <a:t>moves one point of probability </a:t>
-            </a:r>
-            <a:r>
-              <a:rPr lang="en-US" sz="1050" dirty="0">
-                <a:solidFill>
-                  <a:schemeClr val="tx1"/>
-                </a:solidFill>
-              </a:rPr>
-              <a:t>from the hold side to the hike side, by rule, capped at 10. So +4.0 moves 4.0 points, after the pool:</a:t>
-            </a:r>
-            <a:endParaRPr lang="en-US" sz="1050" dirty="0"/>
-          </a:p>
-        </p:txBody>
-      </p:sp>
-      <p:sp>
-        <p:nvSpPr>
-          <p:cNvPr id="25" name="Text 21"/>
-          <p:cNvSpPr txBox="1"/>
-          <p:nvPr/>
-        </p:nvSpPr>
-        <p:spPr>
-          <a:xfrm>
-            <a:off x="2880360" y="5559552"/>
-            <a:ext cx="2011680" cy="329184"/>
-          </a:xfrm>
-          <a:prstGeom prst="rect">
-            <a:avLst/>
-          </a:prstGeom>
-          <a:noFill/>
-          <a:ln/>
-        </p:spPr>
-        <p:txBody>
-          <a:bodyPr wrap="square" lIns="0" tIns="0" rIns="0" bIns="0" rtlCol="0" anchor="t"/>
-          <a:lstStyle/>
-          <a:p>
-            <a:pPr marL="0" indent="0">
-              <a:buNone/>
-            </a:pPr>
-            <a:r>
-              <a:rPr lang="en-US" sz="1200" b="1">
-                <a:solidFill>
-                  <a:schemeClr val="tx2"/>
-                </a:solidFill>
-                <a:latin typeface="Cambria" pitchFamily="34" charset="0"/>
-                <a:ea typeface="Cambria" pitchFamily="34" charset="-122"/>
-                <a:cs typeface="Cambria" pitchFamily="34" charset="-120"/>
-              </a:rPr>
-              <a:t>+25 bps: 20.2% </a:t>
-            </a:r>
-            <a:r>
-              <a:rPr lang="en-US" sz="1200" b="1" dirty="0">
-                <a:solidFill>
-                  <a:schemeClr val="tx2"/>
-                </a:solidFill>
-                <a:latin typeface="Cambria" pitchFamily="34" charset="0"/>
-                <a:ea typeface="Cambria" pitchFamily="34" charset="-122"/>
-                <a:cs typeface="Cambria" pitchFamily="34" charset="-120"/>
-              </a:rPr>
-              <a:t>→ 22.4%</a:t>
-            </a:r>
-            <a:endParaRPr lang="en-US" sz="1200" dirty="0"/>
-          </a:p>
-        </p:txBody>
-      </p:sp>
-      <p:sp>
-        <p:nvSpPr>
-          <p:cNvPr id="26" name="Text 22"/>
-          <p:cNvSpPr txBox="1"/>
-          <p:nvPr/>
-        </p:nvSpPr>
-        <p:spPr>
-          <a:xfrm>
-            <a:off x="2880360" y="5897880"/>
-            <a:ext cx="2011680" cy="365760"/>
-          </a:xfrm>
-          <a:prstGeom prst="rect">
-            <a:avLst/>
-          </a:prstGeom>
-          <a:noFill/>
-          <a:ln/>
-        </p:spPr>
-        <p:txBody>
-          <a:bodyPr wrap="square" lIns="0" tIns="0" rIns="0" bIns="0" rtlCol="0" anchor="t"/>
-          <a:lstStyle/>
-          <a:p>
-            <a:pPr marL="0" indent="0">
-              <a:buNone/>
-            </a:pPr>
-            <a:r>
-              <a:rPr lang="en-US" sz="950">
-                <a:solidFill>
-                  <a:schemeClr val="accent4"/>
-                </a:solidFill>
-              </a:rPr>
-              <a:t>+50 bps 6.0 </a:t>
-            </a:r>
-            <a:r>
-              <a:rPr lang="en-US" sz="950" dirty="0">
-                <a:solidFill>
-                  <a:schemeClr val="accent4"/>
-                </a:solidFill>
-              </a:rPr>
-              <a:t>→ 7.7; no change 70.9 → 67.6; cuts 3.0 → 2.3</a:t>
-            </a:r>
-            <a:endParaRPr lang="en-US" sz="950" dirty="0"/>
+              <a:t>Each bucket is scaled by a factor rising from the cut end to the hike end, so the hikes gain 4.0 and hold plus the cuts lose 4.0:</a:t>
+            </a:r>
+            <a:endParaRPr lang="en-US" sz="1000" dirty="0"/>
           </a:p>
         </p:txBody>
       </p:sp>
@@ -10620,6 +10515,1114 @@
           </a:p>
         </p:txBody>
       </p:sp>
+      <p:graphicFrame>
+        <p:nvGraphicFramePr>
+          <p:cNvPr id="32" name="SpreadTable">
+            <a:extLst>
+              <a:ext uri="{FF2B5EF4-FFF2-40B4-BE49-F238E27FC236}">
+                <a16:creationId xmlns:a16="http://schemas.microsoft.com/office/drawing/2014/main" id="{BCDD3364-9B79-B82C-6C52-1F95802C7B60}"/>
+              </a:ext>
+            </a:extLst>
+          </p:cNvPr>
+          <p:cNvGraphicFramePr>
+            <a:graphicFrameLocks noGrp="1"/>
+          </p:cNvGraphicFramePr>
+          <p:nvPr>
+            <p:extLst>
+              <p:ext uri="{D42A27DB-BD31-4B8C-83A1-F6EECF244321}">
+                <p14:modId xmlns:p14="http://schemas.microsoft.com/office/powerpoint/2010/main" val="2430876610"/>
+              </p:ext>
+            </p:extLst>
+          </p:nvPr>
+        </p:nvGraphicFramePr>
+        <p:xfrm>
+          <a:off x="2880360" y="5394960"/>
+          <a:ext cx="2011680" cy="932688"/>
+        </p:xfrm>
+        <a:graphic>
+          <a:graphicData uri="http://schemas.openxmlformats.org/drawingml/2006/table">
+            <a:tbl>
+              <a:tblPr>
+                <a:tableStyleId>{5C22544A-7EE6-4342-B048-85BDC9FD1C3A}</a:tableStyleId>
+              </a:tblPr>
+              <a:tblGrid>
+                <a:gridCol w="685800">
+                  <a:extLst>
+                    <a:ext uri="{9D8B030D-6E8A-4147-A177-3AD203B41FA5}">
+                      <a16:colId xmlns:a16="http://schemas.microsoft.com/office/drawing/2014/main" val="504904212"/>
+                    </a:ext>
+                  </a:extLst>
+                </a:gridCol>
+                <a:gridCol w="411480">
+                  <a:extLst>
+                    <a:ext uri="{9D8B030D-6E8A-4147-A177-3AD203B41FA5}">
+                      <a16:colId xmlns:a16="http://schemas.microsoft.com/office/drawing/2014/main" val="1883679819"/>
+                    </a:ext>
+                  </a:extLst>
+                </a:gridCol>
+                <a:gridCol w="411480">
+                  <a:extLst>
+                    <a:ext uri="{9D8B030D-6E8A-4147-A177-3AD203B41FA5}">
+                      <a16:colId xmlns:a16="http://schemas.microsoft.com/office/drawing/2014/main" val="3792611000"/>
+                    </a:ext>
+                  </a:extLst>
+                </a:gridCol>
+                <a:gridCol w="502920">
+                  <a:extLst>
+                    <a:ext uri="{9D8B030D-6E8A-4147-A177-3AD203B41FA5}">
+                      <a16:colId xmlns:a16="http://schemas.microsoft.com/office/drawing/2014/main" val="4160339742"/>
+                    </a:ext>
+                  </a:extLst>
+                </a:gridCol>
+              </a:tblGrid>
+              <a:tr h="155448">
+                <a:tc>
+                  <a:txBody>
+                    <a:bodyPr/>
+                    <a:lstStyle/>
+                    <a:p>
+                      <a:r>
+                        <a:rPr lang="en-US" sz="850" b="1">
+                          <a:solidFill>
+                            <a:srgbClr val="FFFFFF"/>
+                          </a:solidFill>
+                        </a:rPr>
+                        <a:t>Outcome</a:t>
+                      </a:r>
+                    </a:p>
+                  </a:txBody>
+                  <a:tcPr marL="25400" marR="25400" marT="12700" marB="12700" anchor="ctr">
+                    <a:lnL w="6350" cmpd="sng">
+                      <a:solidFill>
+                        <a:srgbClr val="E7CFC5"/>
+                      </a:solidFill>
+                    </a:lnL>
+                    <a:lnR w="6350" cmpd="sng">
+                      <a:solidFill>
+                        <a:srgbClr val="E7CFC5"/>
+                      </a:solidFill>
+                    </a:lnR>
+                    <a:lnT w="6350" cmpd="sng">
+                      <a:solidFill>
+                        <a:srgbClr val="E7CFC5"/>
+                      </a:solidFill>
+                    </a:lnT>
+                    <a:lnB w="6350" cmpd="sng">
+                      <a:solidFill>
+                        <a:srgbClr val="E7CFC5"/>
+                      </a:solidFill>
+                    </a:lnB>
+                    <a:solidFill>
+                      <a:srgbClr val="1E2E5E"/>
+                    </a:solidFill>
+                  </a:tcPr>
+                </a:tc>
+                <a:tc>
+                  <a:txBody>
+                    <a:bodyPr/>
+                    <a:lstStyle/>
+                    <a:p>
+                      <a:pPr algn="ctr"/>
+                      <a:r>
+                        <a:rPr lang="en-US" sz="850" b="1">
+                          <a:solidFill>
+                            <a:srgbClr val="FFFFFF"/>
+                          </a:solidFill>
+                        </a:rPr>
+                        <a:t>Before</a:t>
+                      </a:r>
+                    </a:p>
+                  </a:txBody>
+                  <a:tcPr marL="25400" marR="25400" marT="12700" marB="12700" anchor="ctr">
+                    <a:lnL w="6350" cmpd="sng">
+                      <a:solidFill>
+                        <a:srgbClr val="E7CFC5"/>
+                      </a:solidFill>
+                    </a:lnL>
+                    <a:lnR w="6350" cmpd="sng">
+                      <a:solidFill>
+                        <a:srgbClr val="E7CFC5"/>
+                      </a:solidFill>
+                    </a:lnR>
+                    <a:lnT w="6350" cmpd="sng">
+                      <a:solidFill>
+                        <a:srgbClr val="E7CFC5"/>
+                      </a:solidFill>
+                    </a:lnT>
+                    <a:lnB w="6350" cmpd="sng">
+                      <a:solidFill>
+                        <a:srgbClr val="E7CFC5"/>
+                      </a:solidFill>
+                    </a:lnB>
+                    <a:solidFill>
+                      <a:srgbClr val="1E2E5E"/>
+                    </a:solidFill>
+                  </a:tcPr>
+                </a:tc>
+                <a:tc>
+                  <a:txBody>
+                    <a:bodyPr/>
+                    <a:lstStyle/>
+                    <a:p>
+                      <a:pPr algn="ctr"/>
+                      <a:r>
+                        <a:rPr lang="en-US" sz="850" b="1">
+                          <a:solidFill>
+                            <a:srgbClr val="FFFFFF"/>
+                          </a:solidFill>
+                        </a:rPr>
+                        <a:t>After</a:t>
+                      </a:r>
+                    </a:p>
+                  </a:txBody>
+                  <a:tcPr marL="25400" marR="25400" marT="12700" marB="12700" anchor="ctr">
+                    <a:lnL w="6350" cmpd="sng">
+                      <a:solidFill>
+                        <a:srgbClr val="E7CFC5"/>
+                      </a:solidFill>
+                    </a:lnL>
+                    <a:lnR w="6350" cmpd="sng">
+                      <a:solidFill>
+                        <a:srgbClr val="E7CFC5"/>
+                      </a:solidFill>
+                    </a:lnR>
+                    <a:lnT w="6350" cmpd="sng">
+                      <a:solidFill>
+                        <a:srgbClr val="E7CFC5"/>
+                      </a:solidFill>
+                    </a:lnT>
+                    <a:lnB w="6350" cmpd="sng">
+                      <a:solidFill>
+                        <a:srgbClr val="E7CFC5"/>
+                      </a:solidFill>
+                    </a:lnB>
+                    <a:solidFill>
+                      <a:srgbClr val="1E2E5E"/>
+                    </a:solidFill>
+                  </a:tcPr>
+                </a:tc>
+                <a:tc>
+                  <a:txBody>
+                    <a:bodyPr/>
+                    <a:lstStyle/>
+                    <a:p>
+                      <a:pPr algn="ctr"/>
+                      <a:r>
+                        <a:rPr lang="en-US" sz="850" b="1">
+                          <a:solidFill>
+                            <a:srgbClr val="FFFFFF"/>
+                          </a:solidFill>
+                        </a:rPr>
+                        <a:t>Change</a:t>
+                      </a:r>
+                    </a:p>
+                  </a:txBody>
+                  <a:tcPr marL="25400" marR="25400" marT="12700" marB="12700" anchor="ctr">
+                    <a:lnL w="6350" cmpd="sng">
+                      <a:solidFill>
+                        <a:srgbClr val="E7CFC5"/>
+                      </a:solidFill>
+                    </a:lnL>
+                    <a:lnR w="6350" cmpd="sng">
+                      <a:solidFill>
+                        <a:srgbClr val="E7CFC5"/>
+                      </a:solidFill>
+                    </a:lnR>
+                    <a:lnT w="6350" cmpd="sng">
+                      <a:solidFill>
+                        <a:srgbClr val="E7CFC5"/>
+                      </a:solidFill>
+                    </a:lnT>
+                    <a:lnB w="6350" cmpd="sng">
+                      <a:solidFill>
+                        <a:srgbClr val="E7CFC5"/>
+                      </a:solidFill>
+                    </a:lnB>
+                    <a:solidFill>
+                      <a:srgbClr val="1E2E5E"/>
+                    </a:solidFill>
+                  </a:tcPr>
+                </a:tc>
+                <a:extLst>
+                  <a:ext uri="{0D108BD9-81ED-4DB2-BD59-A6C34878D82A}">
+                    <a16:rowId xmlns:a16="http://schemas.microsoft.com/office/drawing/2014/main" val="3738462938"/>
+                  </a:ext>
+                </a:extLst>
+              </a:tr>
+              <a:tr h="155448">
+                <a:tc>
+                  <a:txBody>
+                    <a:bodyPr/>
+                    <a:lstStyle/>
+                    <a:p>
+                      <a:r>
+                        <a:rPr lang="en-US" sz="850" b="0">
+                          <a:solidFill>
+                            <a:srgbClr val="1C1F2B"/>
+                          </a:solidFill>
+                        </a:rPr>
+                        <a:t>−50 bps</a:t>
+                      </a:r>
+                    </a:p>
+                  </a:txBody>
+                  <a:tcPr marL="25400" marR="25400" marT="12700" marB="12700" anchor="ctr">
+                    <a:lnL w="6350" cmpd="sng">
+                      <a:solidFill>
+                        <a:srgbClr val="E7CFC5"/>
+                      </a:solidFill>
+                    </a:lnL>
+                    <a:lnR w="6350" cmpd="sng">
+                      <a:solidFill>
+                        <a:srgbClr val="E7CFC5"/>
+                      </a:solidFill>
+                    </a:lnR>
+                    <a:lnT w="6350" cmpd="sng">
+                      <a:solidFill>
+                        <a:srgbClr val="E7CFC5"/>
+                      </a:solidFill>
+                    </a:lnT>
+                    <a:lnB w="6350" cmpd="sng">
+                      <a:solidFill>
+                        <a:srgbClr val="E7CFC5"/>
+                      </a:solidFill>
+                    </a:lnB>
+                    <a:solidFill>
+                      <a:srgbClr val="FBEFEA"/>
+                    </a:solidFill>
+                  </a:tcPr>
+                </a:tc>
+                <a:tc>
+                  <a:txBody>
+                    <a:bodyPr/>
+                    <a:lstStyle/>
+                    <a:p>
+                      <a:pPr algn="r"/>
+                      <a:r>
+                        <a:rPr lang="en-US" sz="850" b="0">
+                          <a:solidFill>
+                            <a:srgbClr val="1C1F2B"/>
+                          </a:solidFill>
+                        </a:rPr>
+                        <a:t>1.5</a:t>
+                      </a:r>
+                    </a:p>
+                  </a:txBody>
+                  <a:tcPr marL="25400" marR="25400" marT="12700" marB="12700" anchor="ctr">
+                    <a:lnL w="6350" cmpd="sng">
+                      <a:solidFill>
+                        <a:srgbClr val="E7CFC5"/>
+                      </a:solidFill>
+                    </a:lnL>
+                    <a:lnR w="6350" cmpd="sng">
+                      <a:solidFill>
+                        <a:srgbClr val="E7CFC5"/>
+                      </a:solidFill>
+                    </a:lnR>
+                    <a:lnT w="6350" cmpd="sng">
+                      <a:solidFill>
+                        <a:srgbClr val="E7CFC5"/>
+                      </a:solidFill>
+                    </a:lnT>
+                    <a:lnB w="6350" cmpd="sng">
+                      <a:solidFill>
+                        <a:srgbClr val="E7CFC5"/>
+                      </a:solidFill>
+                    </a:lnB>
+                    <a:solidFill>
+                      <a:srgbClr val="FBEFEA"/>
+                    </a:solidFill>
+                  </a:tcPr>
+                </a:tc>
+                <a:tc>
+                  <a:txBody>
+                    <a:bodyPr/>
+                    <a:lstStyle/>
+                    <a:p>
+                      <a:pPr algn="r"/>
+                      <a:r>
+                        <a:rPr lang="en-US" sz="850" b="0">
+                          <a:solidFill>
+                            <a:srgbClr val="1C1F2B"/>
+                          </a:solidFill>
+                        </a:rPr>
+                        <a:t>1.1</a:t>
+                      </a:r>
+                    </a:p>
+                  </a:txBody>
+                  <a:tcPr marL="25400" marR="25400" marT="12700" marB="12700" anchor="ctr">
+                    <a:lnL w="6350" cmpd="sng">
+                      <a:solidFill>
+                        <a:srgbClr val="E7CFC5"/>
+                      </a:solidFill>
+                    </a:lnL>
+                    <a:lnR w="6350" cmpd="sng">
+                      <a:solidFill>
+                        <a:srgbClr val="E7CFC5"/>
+                      </a:solidFill>
+                    </a:lnR>
+                    <a:lnT w="6350" cmpd="sng">
+                      <a:solidFill>
+                        <a:srgbClr val="E7CFC5"/>
+                      </a:solidFill>
+                    </a:lnT>
+                    <a:lnB w="6350" cmpd="sng">
+                      <a:solidFill>
+                        <a:srgbClr val="E7CFC5"/>
+                      </a:solidFill>
+                    </a:lnB>
+                    <a:solidFill>
+                      <a:srgbClr val="FBEFEA"/>
+                    </a:solidFill>
+                  </a:tcPr>
+                </a:tc>
+                <a:tc>
+                  <a:txBody>
+                    <a:bodyPr/>
+                    <a:lstStyle/>
+                    <a:p>
+                      <a:pPr algn="r"/>
+                      <a:r>
+                        <a:rPr lang="en-US" sz="850" b="0">
+                          <a:solidFill>
+                            <a:srgbClr val="1C1F2B"/>
+                          </a:solidFill>
+                        </a:rPr>
+                        <a:t>−0.45</a:t>
+                      </a:r>
+                    </a:p>
+                  </a:txBody>
+                  <a:tcPr marL="25400" marR="25400" marT="12700" marB="12700" anchor="ctr">
+                    <a:lnL w="6350" cmpd="sng">
+                      <a:solidFill>
+                        <a:srgbClr val="E7CFC5"/>
+                      </a:solidFill>
+                    </a:lnL>
+                    <a:lnR w="6350" cmpd="sng">
+                      <a:solidFill>
+                        <a:srgbClr val="E7CFC5"/>
+                      </a:solidFill>
+                    </a:lnR>
+                    <a:lnT w="6350" cmpd="sng">
+                      <a:solidFill>
+                        <a:srgbClr val="E7CFC5"/>
+                      </a:solidFill>
+                    </a:lnT>
+                    <a:lnB w="6350" cmpd="sng">
+                      <a:solidFill>
+                        <a:srgbClr val="E7CFC5"/>
+                      </a:solidFill>
+                    </a:lnB>
+                    <a:solidFill>
+                      <a:srgbClr val="FBEFEA"/>
+                    </a:solidFill>
+                  </a:tcPr>
+                </a:tc>
+                <a:extLst>
+                  <a:ext uri="{0D108BD9-81ED-4DB2-BD59-A6C34878D82A}">
+                    <a16:rowId xmlns:a16="http://schemas.microsoft.com/office/drawing/2014/main" val="3143711139"/>
+                  </a:ext>
+                </a:extLst>
+              </a:tr>
+              <a:tr h="155448">
+                <a:tc>
+                  <a:txBody>
+                    <a:bodyPr/>
+                    <a:lstStyle/>
+                    <a:p>
+                      <a:r>
+                        <a:rPr lang="en-US" sz="850" b="0">
+                          <a:solidFill>
+                            <a:srgbClr val="1C1F2B"/>
+                          </a:solidFill>
+                        </a:rPr>
+                        <a:t>−25 bps</a:t>
+                      </a:r>
+                    </a:p>
+                  </a:txBody>
+                  <a:tcPr marL="25400" marR="25400" marT="12700" marB="12700" anchor="ctr">
+                    <a:lnL w="6350" cmpd="sng">
+                      <a:solidFill>
+                        <a:srgbClr val="E7CFC5"/>
+                      </a:solidFill>
+                    </a:lnL>
+                    <a:lnR w="6350" cmpd="sng">
+                      <a:solidFill>
+                        <a:srgbClr val="E7CFC5"/>
+                      </a:solidFill>
+                    </a:lnR>
+                    <a:lnT w="6350" cmpd="sng">
+                      <a:solidFill>
+                        <a:srgbClr val="E7CFC5"/>
+                      </a:solidFill>
+                    </a:lnT>
+                    <a:lnB w="6350" cmpd="sng">
+                      <a:solidFill>
+                        <a:srgbClr val="E7CFC5"/>
+                      </a:solidFill>
+                    </a:lnB>
+                    <a:solidFill>
+                      <a:srgbClr val="FBEFEA"/>
+                    </a:solidFill>
+                  </a:tcPr>
+                </a:tc>
+                <a:tc>
+                  <a:txBody>
+                    <a:bodyPr/>
+                    <a:lstStyle/>
+                    <a:p>
+                      <a:pPr algn="r"/>
+                      <a:r>
+                        <a:rPr lang="en-US" sz="850" b="0">
+                          <a:solidFill>
+                            <a:srgbClr val="1C1F2B"/>
+                          </a:solidFill>
+                        </a:rPr>
+                        <a:t>1.5</a:t>
+                      </a:r>
+                    </a:p>
+                  </a:txBody>
+                  <a:tcPr marL="25400" marR="25400" marT="12700" marB="12700" anchor="ctr">
+                    <a:lnL w="6350" cmpd="sng">
+                      <a:solidFill>
+                        <a:srgbClr val="E7CFC5"/>
+                      </a:solidFill>
+                    </a:lnL>
+                    <a:lnR w="6350" cmpd="sng">
+                      <a:solidFill>
+                        <a:srgbClr val="E7CFC5"/>
+                      </a:solidFill>
+                    </a:lnR>
+                    <a:lnT w="6350" cmpd="sng">
+                      <a:solidFill>
+                        <a:srgbClr val="E7CFC5"/>
+                      </a:solidFill>
+                    </a:lnT>
+                    <a:lnB w="6350" cmpd="sng">
+                      <a:solidFill>
+                        <a:srgbClr val="E7CFC5"/>
+                      </a:solidFill>
+                    </a:lnB>
+                    <a:solidFill>
+                      <a:srgbClr val="FBEFEA"/>
+                    </a:solidFill>
+                  </a:tcPr>
+                </a:tc>
+                <a:tc>
+                  <a:txBody>
+                    <a:bodyPr/>
+                    <a:lstStyle/>
+                    <a:p>
+                      <a:pPr algn="r"/>
+                      <a:r>
+                        <a:rPr lang="en-US" sz="850" b="0">
+                          <a:solidFill>
+                            <a:srgbClr val="1C1F2B"/>
+                          </a:solidFill>
+                        </a:rPr>
+                        <a:t>1.2</a:t>
+                      </a:r>
+                    </a:p>
+                  </a:txBody>
+                  <a:tcPr marL="25400" marR="25400" marT="12700" marB="12700" anchor="ctr">
+                    <a:lnL w="6350" cmpd="sng">
+                      <a:solidFill>
+                        <a:srgbClr val="E7CFC5"/>
+                      </a:solidFill>
+                    </a:lnL>
+                    <a:lnR w="6350" cmpd="sng">
+                      <a:solidFill>
+                        <a:srgbClr val="E7CFC5"/>
+                      </a:solidFill>
+                    </a:lnR>
+                    <a:lnT w="6350" cmpd="sng">
+                      <a:solidFill>
+                        <a:srgbClr val="E7CFC5"/>
+                      </a:solidFill>
+                    </a:lnT>
+                    <a:lnB w="6350" cmpd="sng">
+                      <a:solidFill>
+                        <a:srgbClr val="E7CFC5"/>
+                      </a:solidFill>
+                    </a:lnB>
+                    <a:solidFill>
+                      <a:srgbClr val="FBEFEA"/>
+                    </a:solidFill>
+                  </a:tcPr>
+                </a:tc>
+                <a:tc>
+                  <a:txBody>
+                    <a:bodyPr/>
+                    <a:lstStyle/>
+                    <a:p>
+                      <a:pPr algn="r"/>
+                      <a:r>
+                        <a:rPr lang="en-US" sz="850" b="0">
+                          <a:solidFill>
+                            <a:srgbClr val="1C1F2B"/>
+                          </a:solidFill>
+                        </a:rPr>
+                        <a:t>−0.27</a:t>
+                      </a:r>
+                    </a:p>
+                  </a:txBody>
+                  <a:tcPr marL="25400" marR="25400" marT="12700" marB="12700" anchor="ctr">
+                    <a:lnL w="6350" cmpd="sng">
+                      <a:solidFill>
+                        <a:srgbClr val="E7CFC5"/>
+                      </a:solidFill>
+                    </a:lnL>
+                    <a:lnR w="6350" cmpd="sng">
+                      <a:solidFill>
+                        <a:srgbClr val="E7CFC5"/>
+                      </a:solidFill>
+                    </a:lnR>
+                    <a:lnT w="6350" cmpd="sng">
+                      <a:solidFill>
+                        <a:srgbClr val="E7CFC5"/>
+                      </a:solidFill>
+                    </a:lnT>
+                    <a:lnB w="6350" cmpd="sng">
+                      <a:solidFill>
+                        <a:srgbClr val="E7CFC5"/>
+                      </a:solidFill>
+                    </a:lnB>
+                    <a:solidFill>
+                      <a:srgbClr val="FBEFEA"/>
+                    </a:solidFill>
+                  </a:tcPr>
+                </a:tc>
+                <a:extLst>
+                  <a:ext uri="{0D108BD9-81ED-4DB2-BD59-A6C34878D82A}">
+                    <a16:rowId xmlns:a16="http://schemas.microsoft.com/office/drawing/2014/main" val="429369120"/>
+                  </a:ext>
+                </a:extLst>
+              </a:tr>
+              <a:tr h="155448">
+                <a:tc>
+                  <a:txBody>
+                    <a:bodyPr/>
+                    <a:lstStyle/>
+                    <a:p>
+                      <a:r>
+                        <a:rPr lang="en-US" sz="850" b="0">
+                          <a:solidFill>
+                            <a:srgbClr val="1C1F2B"/>
+                          </a:solidFill>
+                        </a:rPr>
+                        <a:t>no change</a:t>
+                      </a:r>
+                    </a:p>
+                  </a:txBody>
+                  <a:tcPr marL="25400" marR="25400" marT="12700" marB="12700" anchor="ctr">
+                    <a:lnL w="6350" cmpd="sng">
+                      <a:solidFill>
+                        <a:srgbClr val="E7CFC5"/>
+                      </a:solidFill>
+                    </a:lnL>
+                    <a:lnR w="6350" cmpd="sng">
+                      <a:solidFill>
+                        <a:srgbClr val="E7CFC5"/>
+                      </a:solidFill>
+                    </a:lnR>
+                    <a:lnT w="6350" cmpd="sng">
+                      <a:solidFill>
+                        <a:srgbClr val="E7CFC5"/>
+                      </a:solidFill>
+                    </a:lnT>
+                    <a:lnB w="6350" cmpd="sng">
+                      <a:solidFill>
+                        <a:srgbClr val="E7CFC5"/>
+                      </a:solidFill>
+                    </a:lnB>
+                    <a:solidFill>
+                      <a:srgbClr val="FBEFEA"/>
+                    </a:solidFill>
+                  </a:tcPr>
+                </a:tc>
+                <a:tc>
+                  <a:txBody>
+                    <a:bodyPr/>
+                    <a:lstStyle/>
+                    <a:p>
+                      <a:pPr algn="r"/>
+                      <a:r>
+                        <a:rPr lang="en-US" sz="850" b="0">
+                          <a:solidFill>
+                            <a:srgbClr val="1C1F2B"/>
+                          </a:solidFill>
+                        </a:rPr>
+                        <a:t>70.9</a:t>
+                      </a:r>
+                    </a:p>
+                  </a:txBody>
+                  <a:tcPr marL="25400" marR="25400" marT="12700" marB="12700" anchor="ctr">
+                    <a:lnL w="6350" cmpd="sng">
+                      <a:solidFill>
+                        <a:srgbClr val="E7CFC5"/>
+                      </a:solidFill>
+                    </a:lnL>
+                    <a:lnR w="6350" cmpd="sng">
+                      <a:solidFill>
+                        <a:srgbClr val="E7CFC5"/>
+                      </a:solidFill>
+                    </a:lnR>
+                    <a:lnT w="6350" cmpd="sng">
+                      <a:solidFill>
+                        <a:srgbClr val="E7CFC5"/>
+                      </a:solidFill>
+                    </a:lnT>
+                    <a:lnB w="6350" cmpd="sng">
+                      <a:solidFill>
+                        <a:srgbClr val="E7CFC5"/>
+                      </a:solidFill>
+                    </a:lnB>
+                    <a:solidFill>
+                      <a:srgbClr val="FBEFEA"/>
+                    </a:solidFill>
+                  </a:tcPr>
+                </a:tc>
+                <a:tc>
+                  <a:txBody>
+                    <a:bodyPr/>
+                    <a:lstStyle/>
+                    <a:p>
+                      <a:pPr algn="r"/>
+                      <a:r>
+                        <a:rPr lang="en-US" sz="850" b="0">
+                          <a:solidFill>
+                            <a:srgbClr val="1C1F2B"/>
+                          </a:solidFill>
+                        </a:rPr>
+                        <a:t>67.6</a:t>
+                      </a:r>
+                    </a:p>
+                  </a:txBody>
+                  <a:tcPr marL="25400" marR="25400" marT="12700" marB="12700" anchor="ctr">
+                    <a:lnL w="6350" cmpd="sng">
+                      <a:solidFill>
+                        <a:srgbClr val="E7CFC5"/>
+                      </a:solidFill>
+                    </a:lnL>
+                    <a:lnR w="6350" cmpd="sng">
+                      <a:solidFill>
+                        <a:srgbClr val="E7CFC5"/>
+                      </a:solidFill>
+                    </a:lnR>
+                    <a:lnT w="6350" cmpd="sng">
+                      <a:solidFill>
+                        <a:srgbClr val="E7CFC5"/>
+                      </a:solidFill>
+                    </a:lnT>
+                    <a:lnB w="6350" cmpd="sng">
+                      <a:solidFill>
+                        <a:srgbClr val="E7CFC5"/>
+                      </a:solidFill>
+                    </a:lnB>
+                    <a:solidFill>
+                      <a:srgbClr val="FBEFEA"/>
+                    </a:solidFill>
+                  </a:tcPr>
+                </a:tc>
+                <a:tc>
+                  <a:txBody>
+                    <a:bodyPr/>
+                    <a:lstStyle/>
+                    <a:p>
+                      <a:pPr algn="r"/>
+                      <a:r>
+                        <a:rPr lang="en-US" sz="850" b="0">
+                          <a:solidFill>
+                            <a:srgbClr val="1C1F2B"/>
+                          </a:solidFill>
+                        </a:rPr>
+                        <a:t>−3.28</a:t>
+                      </a:r>
+                    </a:p>
+                  </a:txBody>
+                  <a:tcPr marL="25400" marR="25400" marT="12700" marB="12700" anchor="ctr">
+                    <a:lnL w="6350" cmpd="sng">
+                      <a:solidFill>
+                        <a:srgbClr val="E7CFC5"/>
+                      </a:solidFill>
+                    </a:lnL>
+                    <a:lnR w="6350" cmpd="sng">
+                      <a:solidFill>
+                        <a:srgbClr val="E7CFC5"/>
+                      </a:solidFill>
+                    </a:lnR>
+                    <a:lnT w="6350" cmpd="sng">
+                      <a:solidFill>
+                        <a:srgbClr val="E7CFC5"/>
+                      </a:solidFill>
+                    </a:lnT>
+                    <a:lnB w="6350" cmpd="sng">
+                      <a:solidFill>
+                        <a:srgbClr val="E7CFC5"/>
+                      </a:solidFill>
+                    </a:lnB>
+                    <a:solidFill>
+                      <a:srgbClr val="FBEFEA"/>
+                    </a:solidFill>
+                  </a:tcPr>
+                </a:tc>
+                <a:extLst>
+                  <a:ext uri="{0D108BD9-81ED-4DB2-BD59-A6C34878D82A}">
+                    <a16:rowId xmlns:a16="http://schemas.microsoft.com/office/drawing/2014/main" val="890441951"/>
+                  </a:ext>
+                </a:extLst>
+              </a:tr>
+              <a:tr h="155448">
+                <a:tc>
+                  <a:txBody>
+                    <a:bodyPr/>
+                    <a:lstStyle/>
+                    <a:p>
+                      <a:r>
+                        <a:rPr lang="en-US" sz="850" b="0">
+                          <a:solidFill>
+                            <a:srgbClr val="1C1F2B"/>
+                          </a:solidFill>
+                        </a:rPr>
+                        <a:t>+25 bps</a:t>
+                      </a:r>
+                    </a:p>
+                  </a:txBody>
+                  <a:tcPr marL="25400" marR="25400" marT="12700" marB="12700" anchor="ctr">
+                    <a:lnL w="6350" cmpd="sng">
+                      <a:solidFill>
+                        <a:srgbClr val="E7CFC5"/>
+                      </a:solidFill>
+                    </a:lnL>
+                    <a:lnR w="6350" cmpd="sng">
+                      <a:solidFill>
+                        <a:srgbClr val="E7CFC5"/>
+                      </a:solidFill>
+                    </a:lnR>
+                    <a:lnT w="6350" cmpd="sng">
+                      <a:solidFill>
+                        <a:srgbClr val="E7CFC5"/>
+                      </a:solidFill>
+                    </a:lnT>
+                    <a:lnB w="6350" cmpd="sng">
+                      <a:solidFill>
+                        <a:srgbClr val="E7CFC5"/>
+                      </a:solidFill>
+                    </a:lnB>
+                    <a:solidFill>
+                      <a:srgbClr val="FBEFEA"/>
+                    </a:solidFill>
+                  </a:tcPr>
+                </a:tc>
+                <a:tc>
+                  <a:txBody>
+                    <a:bodyPr/>
+                    <a:lstStyle/>
+                    <a:p>
+                      <a:pPr algn="r"/>
+                      <a:r>
+                        <a:rPr lang="en-US" sz="850" b="0">
+                          <a:solidFill>
+                            <a:srgbClr val="1C1F2B"/>
+                          </a:solidFill>
+                        </a:rPr>
+                        <a:t>20.2</a:t>
+                      </a:r>
+                    </a:p>
+                  </a:txBody>
+                  <a:tcPr marL="25400" marR="25400" marT="12700" marB="12700" anchor="ctr">
+                    <a:lnL w="6350" cmpd="sng">
+                      <a:solidFill>
+                        <a:srgbClr val="E7CFC5"/>
+                      </a:solidFill>
+                    </a:lnL>
+                    <a:lnR w="6350" cmpd="sng">
+                      <a:solidFill>
+                        <a:srgbClr val="E7CFC5"/>
+                      </a:solidFill>
+                    </a:lnR>
+                    <a:lnT w="6350" cmpd="sng">
+                      <a:solidFill>
+                        <a:srgbClr val="E7CFC5"/>
+                      </a:solidFill>
+                    </a:lnT>
+                    <a:lnB w="6350" cmpd="sng">
+                      <a:solidFill>
+                        <a:srgbClr val="E7CFC5"/>
+                      </a:solidFill>
+                    </a:lnB>
+                    <a:solidFill>
+                      <a:srgbClr val="FBEFEA"/>
+                    </a:solidFill>
+                  </a:tcPr>
+                </a:tc>
+                <a:tc>
+                  <a:txBody>
+                    <a:bodyPr/>
+                    <a:lstStyle/>
+                    <a:p>
+                      <a:pPr algn="r"/>
+                      <a:r>
+                        <a:rPr lang="en-US" sz="850" b="0">
+                          <a:solidFill>
+                            <a:srgbClr val="1C1F2B"/>
+                          </a:solidFill>
+                        </a:rPr>
+                        <a:t>22.4</a:t>
+                      </a:r>
+                    </a:p>
+                  </a:txBody>
+                  <a:tcPr marL="25400" marR="25400" marT="12700" marB="12700" anchor="ctr">
+                    <a:lnL w="6350" cmpd="sng">
+                      <a:solidFill>
+                        <a:srgbClr val="E7CFC5"/>
+                      </a:solidFill>
+                    </a:lnL>
+                    <a:lnR w="6350" cmpd="sng">
+                      <a:solidFill>
+                        <a:srgbClr val="E7CFC5"/>
+                      </a:solidFill>
+                    </a:lnR>
+                    <a:lnT w="6350" cmpd="sng">
+                      <a:solidFill>
+                        <a:srgbClr val="E7CFC5"/>
+                      </a:solidFill>
+                    </a:lnT>
+                    <a:lnB w="6350" cmpd="sng">
+                      <a:solidFill>
+                        <a:srgbClr val="E7CFC5"/>
+                      </a:solidFill>
+                    </a:lnB>
+                    <a:solidFill>
+                      <a:srgbClr val="FBEFEA"/>
+                    </a:solidFill>
+                  </a:tcPr>
+                </a:tc>
+                <a:tc>
+                  <a:txBody>
+                    <a:bodyPr/>
+                    <a:lstStyle/>
+                    <a:p>
+                      <a:pPr algn="r"/>
+                      <a:r>
+                        <a:rPr lang="en-US" sz="850" b="0">
+                          <a:solidFill>
+                            <a:srgbClr val="1C1F2B"/>
+                          </a:solidFill>
+                        </a:rPr>
+                        <a:t>+2.24</a:t>
+                      </a:r>
+                    </a:p>
+                  </a:txBody>
+                  <a:tcPr marL="25400" marR="25400" marT="12700" marB="12700" anchor="ctr">
+                    <a:lnL w="6350" cmpd="sng">
+                      <a:solidFill>
+                        <a:srgbClr val="E7CFC5"/>
+                      </a:solidFill>
+                    </a:lnL>
+                    <a:lnR w="6350" cmpd="sng">
+                      <a:solidFill>
+                        <a:srgbClr val="E7CFC5"/>
+                      </a:solidFill>
+                    </a:lnR>
+                    <a:lnT w="6350" cmpd="sng">
+                      <a:solidFill>
+                        <a:srgbClr val="E7CFC5"/>
+                      </a:solidFill>
+                    </a:lnT>
+                    <a:lnB w="6350" cmpd="sng">
+                      <a:solidFill>
+                        <a:srgbClr val="E7CFC5"/>
+                      </a:solidFill>
+                    </a:lnB>
+                    <a:solidFill>
+                      <a:srgbClr val="FBEFEA"/>
+                    </a:solidFill>
+                  </a:tcPr>
+                </a:tc>
+                <a:extLst>
+                  <a:ext uri="{0D108BD9-81ED-4DB2-BD59-A6C34878D82A}">
+                    <a16:rowId xmlns:a16="http://schemas.microsoft.com/office/drawing/2014/main" val="1000320103"/>
+                  </a:ext>
+                </a:extLst>
+              </a:tr>
+              <a:tr h="155448">
+                <a:tc>
+                  <a:txBody>
+                    <a:bodyPr/>
+                    <a:lstStyle/>
+                    <a:p>
+                      <a:r>
+                        <a:rPr lang="en-US" sz="850" b="0">
+                          <a:solidFill>
+                            <a:srgbClr val="1C1F2B"/>
+                          </a:solidFill>
+                        </a:rPr>
+                        <a:t>+50 bps</a:t>
+                      </a:r>
+                    </a:p>
+                  </a:txBody>
+                  <a:tcPr marL="25400" marR="25400" marT="12700" marB="12700" anchor="ctr">
+                    <a:lnL w="6350" cmpd="sng">
+                      <a:solidFill>
+                        <a:srgbClr val="E7CFC5"/>
+                      </a:solidFill>
+                    </a:lnL>
+                    <a:lnR w="6350" cmpd="sng">
+                      <a:solidFill>
+                        <a:srgbClr val="E7CFC5"/>
+                      </a:solidFill>
+                    </a:lnR>
+                    <a:lnT w="6350" cmpd="sng">
+                      <a:solidFill>
+                        <a:srgbClr val="E7CFC5"/>
+                      </a:solidFill>
+                    </a:lnT>
+                    <a:lnB w="6350" cmpd="sng">
+                      <a:solidFill>
+                        <a:srgbClr val="E7CFC5"/>
+                      </a:solidFill>
+                    </a:lnB>
+                    <a:solidFill>
+                      <a:srgbClr val="FBEFEA"/>
+                    </a:solidFill>
+                  </a:tcPr>
+                </a:tc>
+                <a:tc>
+                  <a:txBody>
+                    <a:bodyPr/>
+                    <a:lstStyle/>
+                    <a:p>
+                      <a:pPr algn="r"/>
+                      <a:r>
+                        <a:rPr lang="en-US" sz="850" b="0">
+                          <a:solidFill>
+                            <a:srgbClr val="1C1F2B"/>
+                          </a:solidFill>
+                        </a:rPr>
+                        <a:t>6.0</a:t>
+                      </a:r>
+                    </a:p>
+                  </a:txBody>
+                  <a:tcPr marL="25400" marR="25400" marT="12700" marB="12700" anchor="ctr">
+                    <a:lnL w="6350" cmpd="sng">
+                      <a:solidFill>
+                        <a:srgbClr val="E7CFC5"/>
+                      </a:solidFill>
+                    </a:lnL>
+                    <a:lnR w="6350" cmpd="sng">
+                      <a:solidFill>
+                        <a:srgbClr val="E7CFC5"/>
+                      </a:solidFill>
+                    </a:lnR>
+                    <a:lnT w="6350" cmpd="sng">
+                      <a:solidFill>
+                        <a:srgbClr val="E7CFC5"/>
+                      </a:solidFill>
+                    </a:lnT>
+                    <a:lnB w="6350" cmpd="sng">
+                      <a:solidFill>
+                        <a:srgbClr val="E7CFC5"/>
+                      </a:solidFill>
+                    </a:lnB>
+                    <a:solidFill>
+                      <a:srgbClr val="FBEFEA"/>
+                    </a:solidFill>
+                  </a:tcPr>
+                </a:tc>
+                <a:tc>
+                  <a:txBody>
+                    <a:bodyPr/>
+                    <a:lstStyle/>
+                    <a:p>
+                      <a:pPr algn="r"/>
+                      <a:r>
+                        <a:rPr lang="en-US" sz="850" b="0">
+                          <a:solidFill>
+                            <a:srgbClr val="1C1F2B"/>
+                          </a:solidFill>
+                        </a:rPr>
+                        <a:t>7.7</a:t>
+                      </a:r>
+                    </a:p>
+                  </a:txBody>
+                  <a:tcPr marL="25400" marR="25400" marT="12700" marB="12700" anchor="ctr">
+                    <a:lnL w="6350" cmpd="sng">
+                      <a:solidFill>
+                        <a:srgbClr val="E7CFC5"/>
+                      </a:solidFill>
+                    </a:lnL>
+                    <a:lnR w="6350" cmpd="sng">
+                      <a:solidFill>
+                        <a:srgbClr val="E7CFC5"/>
+                      </a:solidFill>
+                    </a:lnR>
+                    <a:lnT w="6350" cmpd="sng">
+                      <a:solidFill>
+                        <a:srgbClr val="E7CFC5"/>
+                      </a:solidFill>
+                    </a:lnT>
+                    <a:lnB w="6350" cmpd="sng">
+                      <a:solidFill>
+                        <a:srgbClr val="E7CFC5"/>
+                      </a:solidFill>
+                    </a:lnB>
+                    <a:solidFill>
+                      <a:srgbClr val="FBEFEA"/>
+                    </a:solidFill>
+                  </a:tcPr>
+                </a:tc>
+                <a:tc>
+                  <a:txBody>
+                    <a:bodyPr/>
+                    <a:lstStyle/>
+                    <a:p>
+                      <a:pPr algn="r"/>
+                      <a:r>
+                        <a:rPr lang="en-US" sz="850" b="0">
+                          <a:solidFill>
+                            <a:srgbClr val="1C1F2B"/>
+                          </a:solidFill>
+                        </a:rPr>
+                        <a:t>+1.76</a:t>
+                      </a:r>
+                    </a:p>
+                  </a:txBody>
+                  <a:tcPr marL="25400" marR="25400" marT="12700" marB="12700" anchor="ctr">
+                    <a:lnL w="6350" cmpd="sng">
+                      <a:solidFill>
+                        <a:srgbClr val="E7CFC5"/>
+                      </a:solidFill>
+                    </a:lnL>
+                    <a:lnR w="6350" cmpd="sng">
+                      <a:solidFill>
+                        <a:srgbClr val="E7CFC5"/>
+                      </a:solidFill>
+                    </a:lnR>
+                    <a:lnT w="6350" cmpd="sng">
+                      <a:solidFill>
+                        <a:srgbClr val="E7CFC5"/>
+                      </a:solidFill>
+                    </a:lnT>
+                    <a:lnB w="6350" cmpd="sng">
+                      <a:solidFill>
+                        <a:srgbClr val="E7CFC5"/>
+                      </a:solidFill>
+                    </a:lnB>
+                    <a:solidFill>
+                      <a:srgbClr val="FBEFEA"/>
+                    </a:solidFill>
+                  </a:tcPr>
+                </a:tc>
+                <a:extLst>
+                  <a:ext uri="{0D108BD9-81ED-4DB2-BD59-A6C34878D82A}">
+                    <a16:rowId xmlns:a16="http://schemas.microsoft.com/office/drawing/2014/main" val="1554394274"/>
+                  </a:ext>
+                </a:extLst>
+              </a:tr>
+            </a:tbl>
+          </a:graphicData>
+        </a:graphic>
+      </p:graphicFrame>
     </p:spTree>
     <p:extLst>
       <p:ext uri="{BB962C8B-B14F-4D97-AF65-F5344CB8AC3E}">

</xml_diff>

<commit_message>
Slide 19: 'alternative weightings' instead of 'candidate weight sets'; the backtest can guide the Taylor/base-rate split but not the market share
Co-Authored-By: Claude Fable 5.1 <noreply@anthropic.com>
</commit_message>
<xml_diff>
--- a/docs/FedCast_Fullerton.pptx
+++ b/docs/FedCast_Fullerton.pptx
@@ -1986,7 +1986,7 @@
           <a:p>
             <a:r>
               <a:rPr lang="en-US"/>
-              <a:t>2 MIN. December is on file (entry #23, +25 at 73.6%). Six follow-ups in order of value: 1 pre-registered weight sets scored on every live decision; 2 reasoning quality graded by people in the app, the grader trusted only once it agrees with the hand grades; 3 an events agent for regime shifts; 4 a second model family; 5 other central banks, same chain; 6 a classical model built for class imbalance. Ask the room which they would do first.</a:t>
+              <a:t>2 MIN. December is on file (entry #23, +25 at 73.6%). Six follow-ups in order of value: 1 alternative weightings written down now, scored on every live decision; the backtest can guide the Taylor/base-rate split, not the market share; 2 reasoning quality graded by people in the app, the grader trusted only once it agrees with the hand grades; 3 an events agent for regime shifts; 4 a second model family; 5 other central banks, same chain; 6 a classical model built for class imbalance. Ask the room which they would do first.</a:t>
             </a:r>
             <a:endParaRPr lang="en-US" dirty="0"/>
           </a:p>
@@ -13560,12 +13560,12 @@
               <a:buNone/>
             </a:pPr>
             <a:r>
-              <a:rPr lang="en-US" sz="1300" b="1" dirty="0">
+              <a:rPr lang="en-US" sz="1300" b="1">
                 <a:solidFill>
                   <a:schemeClr val="tx2"/>
                 </a:solidFill>
               </a:rPr>
-              <a:t>Pre-registered weight sets, scored live</a:t>
+              <a:t>Alternative weightings, written down now, scored live</a:t>
             </a:r>
             <a:endParaRPr lang="en-US" sz="1300" dirty="0"/>
           </a:p>
@@ -13596,12 +13596,12 @@
               <a:buNone/>
             </a:pPr>
             <a:r>
-              <a:rPr lang="en-US" sz="1000" dirty="0">
+              <a:rPr lang="en-US" sz="1000">
                 <a:solidFill>
                   <a:schemeClr val="tx1"/>
                 </a:solidFill>
               </a:rPr>
-              <a:t>Write down three or four candidate weight sets now (for example market 0.6 / 0.5 / 0.7 with the rest redistributed). Score every set on every live decision with the same log score and Brier. The live set changes only by amendment, on that record. Weights stop being judgement without ever being fitted to the past.</a:t>
+              <a:t>Write down three or four alternative weightings now, for example market 0.6, 0.5 or 0.7 with the rest redistributed. The backtest can guide the split between Taylor and base rates; it cannot set the market share, since we hold no history of futures or prediction-market odds. Score every weighting on every live decision with the same log score and Brier. The live weighting changes only by amendment, on that record. Weights are never fitted to the past.</a:t>
             </a:r>
             <a:endParaRPr lang="en-US" sz="1000" dirty="0"/>
           </a:p>

</xml_diff>

<commit_message>
Deck: slide 20 rebuilt around three points (design around the limits, the engineering is in the harness, judge the process) with an ask; demos 3 and 4 use the 29 October snapshot: analyst 4's tone pre-read and its eight verified claims
Co-Authored-By: Claude Fable 5.1 <noreply@anthropic.com>
</commit_message>
<xml_diff>
--- a/docs/FedCast_Fullerton.pptx
+++ b/docs/FedCast_Fullerton.pptx
@@ -20,14 +20,14 @@
     <p:sldId id="264" r:id="rId11"/>
     <p:sldId id="285" r:id="rId12"/>
     <p:sldId id="266" r:id="rId13"/>
-    <p:sldId id="268" r:id="rId14"/>
+    <p:sldId id="287" r:id="rId14"/>
     <p:sldId id="269" r:id="rId15"/>
     <p:sldId id="267" r:id="rId16"/>
-    <p:sldId id="271" r:id="rId17"/>
+    <p:sldId id="272" r:id="rId17"/>
     <p:sldId id="273" r:id="rId18"/>
     <p:sldId id="274" r:id="rId19"/>
     <p:sldId id="275" r:id="rId20"/>
-    <p:sldId id="276" r:id="rId21"/>
+    <p:sldId id="288" r:id="rId21"/>
     <p:sldId id="277" r:id="rId22"/>
     <p:sldId id="278" r:id="rId23"/>
     <p:sldId id="279" r:id="rId24"/>
@@ -156,23 +156,22 @@
         <p14:section name="The harness" id="{92928B70-AC41-17EA-8015-68E5296D82D9}">
           <p14:sldIdLst>
             <p14:sldId id="266"/>
-            <p14:sldId id="268"/>
+            <p14:sldId id="287"/>
           </p14:sldIdLst>
         </p14:section>
         <p14:section name="Evidence" id="{5A3B821E-E9C2-E8B2-83B3-FA9E97777045}">
           <p14:sldIdLst>
             <p14:sldId id="269"/>
             <p14:sldId id="267"/>
-            <p14:sldId id="271"/>
+            <p14:sldId id="272"/>
             <p14:sldId id="273"/>
             <p14:sldId id="274"/>
             <p14:sldId id="275"/>
+            <p14:sldId id="288"/>
           </p14:sldIdLst>
         </p14:section>
         <p14:section name="Limits and next" id="{A86175A9-6A09-739A-6218-CDC852B09B1B}">
-          <p14:sldIdLst>
-            <p14:sldId id="276"/>
-          </p14:sldIdLst>
+          <p14:sldIdLst/>
         </p14:section>
         <p14:section name="Backup" id="{C779AD3C-958E-9E55-6CE0-CB67D10A91C1}">
           <p14:sldIdLst>
@@ -1451,10 +1450,9 @@
           <a:lstStyle/>
           <a:p>
             <a:r>
-              <a:rPr lang="en-US"/>
-              <a:t>DEMO 3, 2 MIN. Analyst prompts view. Open analyst 1: 195 characters, no evidence. Open analyst 6: the system prompt, the schema (claims with quote and item id; the opinion bounded -10 to +10), the inflation pre-read, the item ids. Say: 'if it is not on this page, the analyst does not get it; the only difference between analyst 1 and analyst 6 is this page.'</a:t>
-            </a:r>
-            <a:endParaRPr lang="en-US" dirty="0"/>
+              <a:rPr lang="en-US" dirty="0"/>
+              <a:t>DEMO 3, 2 MIN. Analyst prompts view on the 29 October snapshot. Open analyst 1: 195 characters, the question and the date, asked for probabilities. Open analyst 4: 45,000 characters; scroll past the schema to the tone pre-read and stop there. Say: the vote (10 to 2, Cook and Hammack), the diff (the September 'raise by 1/4 percentage point' is gone, 'maintain' and the dissent sentence are new), the lexicon (seven hawkish terms, no dovish). That block was computed by code; the model is handed it and must quote. Then: 'if it is not on this page, the analyst does not get it; the only difference between analyst 1 and analyst 4 is this page.' Its answer comes in the next demo.</a:t>
+            </a:r>
           </a:p>
         </p:txBody>
       </p:sp>
@@ -1484,7 +1482,7 @@
     </p:spTree>
     <p:extLst>
       <p:ext uri="{BB962C8B-B14F-4D97-AF65-F5344CB8AC3E}">
-        <p14:creationId xmlns:p14="http://schemas.microsoft.com/office/powerpoint/2010/main" val="1024086991"/>
+        <p14:creationId xmlns:p14="http://schemas.microsoft.com/office/powerpoint/2010/main" val="3342714903"/>
       </p:ext>
     </p:extLst>
   </p:cSld>
@@ -1721,10 +1719,9 @@
           <a:lstStyle/>
           <a:p>
             <a:r>
-              <a:rPr lang="en-US"/>
-              <a:t>DEMO 4, 2 MIN. Analyst results. Analyst 1 card: a cut, numbers from memory flagged. Analyst 4 card: opinion, grounded, leaked, watch-out badges; one claim with its quote and the verified mark. If asked where a quote comes from, open the statement claim on analyst 4: the statement's own line, found by code.</a:t>
-            </a:r>
-            <a:endParaRPr lang="en-US" dirty="0"/>
+              <a:rPr lang="en-US" dirty="0"/>
+              <a:t>DEMO 4, 2 MIN. Analyst results view, 29 October snapshot. Analyst 1 first: cut 25 at 52%, 64 numbers from memory, nothing quoted; its memory of the Fed is stale. Then analyst 4, run 1: 8 claims, 8 verified, opinion +4; the mean of five runs +5.0 with a spread of 0.6. Open the first claim: the dissent sentence, found by code in the 28 October statement. Open the sixth: 'the committee actually chose to hold', its own dovish offset. Say: the analyst was handed the diff and quoted it, and it argued both sides; the number it gives is an opinion, bounded, and the code decides what it is worth.</a:t>
+            </a:r>
           </a:p>
         </p:txBody>
       </p:sp>
@@ -1754,7 +1751,7 @@
     </p:spTree>
     <p:extLst>
       <p:ext uri="{BB962C8B-B14F-4D97-AF65-F5344CB8AC3E}">
-        <p14:creationId xmlns:p14="http://schemas.microsoft.com/office/powerpoint/2010/main" val="1024086991"/>
+        <p14:creationId xmlns:p14="http://schemas.microsoft.com/office/powerpoint/2010/main" val="374287121"/>
       </p:ext>
     </p:extLst>
   </p:cSld>
@@ -2167,10 +2164,9 @@
           <a:lstStyle/>
           <a:p>
             <a:r>
-              <a:rPr lang="en-US"/>
-              <a:t>1 MIN. Close on the three lines, then the ask: scrutinise the scorecard, challenge a quote, name the next decision that deserves the same chain. Questions.</a:t>
-            </a:r>
-            <a:endParaRPr lang="en-US" dirty="0"/>
+              <a:rPr lang="en-US" dirty="0"/>
+              <a:t>1 MIN. Three lines, then the ask. One: the model's limits are designed around, not removed. Two: the engineering is in the chain around the model, not in the model. Three: the model lifts, the architecture decides whether the result can be trusted; judge the process. The ask: open the December entry, challenge a quote, grade an answer, pick the first follow-up. Questions.</a:t>
+            </a:r>
           </a:p>
         </p:txBody>
       </p:sp>
@@ -2200,7 +2196,7 @@
     </p:spTree>
     <p:extLst>
       <p:ext uri="{BB962C8B-B14F-4D97-AF65-F5344CB8AC3E}">
-        <p14:creationId xmlns:p14="http://schemas.microsoft.com/office/powerpoint/2010/main" val="1024086991"/>
+        <p14:creationId xmlns:p14="http://schemas.microsoft.com/office/powerpoint/2010/main" val="974913004"/>
       </p:ext>
     </p:extLst>
   </p:cSld>
@@ -3493,7 +3489,7 @@
           </a:prstGeom>
           <a:extLst>
             <a:ext uri="{C572A759-6A51-4108-AA02-DFA0A04FC94B}">
-              <ma14:wrappingTextBoxFlag xmlns="" xmlns:ma14="http://schemas.microsoft.com/office/mac/drawingml/2011/main" val="0"/>
+              <ma14:wrappingTextBoxFlag xmlns:ma14="http://schemas.microsoft.com/office/mac/drawingml/2011/main" xmlns="" val="0"/>
             </a:ext>
           </a:extLst>
         </p:spPr>
@@ -3678,7 +3674,7 @@
           </a:prstGeom>
           <a:extLst>
             <a:ext uri="{C572A759-6A51-4108-AA02-DFA0A04FC94B}">
-              <ma14:wrappingTextBoxFlag xmlns="" xmlns:ma14="http://schemas.microsoft.com/office/mac/drawingml/2011/main" val="0"/>
+              <ma14:wrappingTextBoxFlag xmlns:ma14="http://schemas.microsoft.com/office/mac/drawingml/2011/main" xmlns="" val="0"/>
             </a:ext>
           </a:extLst>
         </p:spPr>
@@ -5471,7 +5467,7 @@
           </a:prstGeom>
           <a:extLst>
             <a:ext uri="{C572A759-6A51-4108-AA02-DFA0A04FC94B}">
-              <ma14:wrappingTextBoxFlag xmlns="" xmlns:ma14="http://schemas.microsoft.com/office/mac/drawingml/2011/main" val="0"/>
+              <ma14:wrappingTextBoxFlag xmlns:ma14="http://schemas.microsoft.com/office/mac/drawingml/2011/main" xmlns="" val="0"/>
             </a:ext>
           </a:extLst>
         </p:spPr>
@@ -7902,7 +7898,7 @@
           </a:prstGeom>
           <a:extLst>
             <a:ext uri="{C572A759-6A51-4108-AA02-DFA0A04FC94B}">
-              <ma14:wrappingTextBoxFlag xmlns="" xmlns:ma14="http://schemas.microsoft.com/office/mac/drawingml/2011/main" val="0"/>
+              <ma14:wrappingTextBoxFlag xmlns:ma14="http://schemas.microsoft.com/office/mac/drawingml/2011/main" xmlns="" val="0"/>
             </a:ext>
           </a:extLst>
         </p:spPr>
@@ -7937,7 +7933,7 @@
 
 <file path=ppt/slides/slide13.xml><?xml version="1.0" encoding="utf-8"?>
 <p:sld xmlns:a="http://schemas.openxmlformats.org/drawingml/2006/main" xmlns:r="http://schemas.openxmlformats.org/officeDocument/2006/relationships" xmlns:p="http://schemas.openxmlformats.org/presentationml/2006/main">
-  <p:cSld name="Slide 13">
+  <p:cSld>
     <p:spTree>
       <p:nvGrpSpPr>
         <p:cNvPr id="1" name=""/>
@@ -8018,13 +8014,6 @@
             <a:prstDash val="solid"/>
           </a:ln>
         </p:spPr>
-        <p:txBody>
-          <a:bodyPr/>
-          <a:lstStyle/>
-          <a:p>
-            <a:endParaRPr lang="en-US"/>
-          </a:p>
-        </p:txBody>
       </p:sp>
       <p:sp>
         <p:nvSpPr>
@@ -8088,13 +8077,6 @@
             <a:prstDash val="solid"/>
           </a:ln>
         </p:spPr>
-        <p:txBody>
-          <a:bodyPr/>
-          <a:lstStyle/>
-          <a:p>
-            <a:endParaRPr lang="en-US"/>
-          </a:p>
-        </p:txBody>
       </p:sp>
       <p:sp>
         <p:nvSpPr>
@@ -8166,7 +8148,7 @@
                   <a:srgbClr val="FFFFFF"/>
                 </a:solidFill>
               </a:rPr>
-              <a:t>Analyst prompts view</a:t>
+              <a:t>Analyst prompts view, snapshot of 29 October: the December call</a:t>
             </a:r>
             <a:endParaRPr lang="en-US" sz="1300" dirty="0"/>
           </a:p>
@@ -8202,7 +8184,7 @@
                   <a:srgbClr val="FFFFFF"/>
                 </a:solidFill>
               </a:rPr>
-              <a:t>Analyst 6: open the full prompt</a:t>
+              <a:t>Analyst 4, Communications: open the full prompt</a:t>
             </a:r>
             <a:endParaRPr lang="en-US" sz="1300" dirty="0"/>
           </a:p>
@@ -8234,13 +8216,6 @@
             <a:prstDash val="solid"/>
           </a:ln>
         </p:spPr>
-        <p:txBody>
-          <a:bodyPr/>
-          <a:lstStyle/>
-          <a:p>
-            <a:endParaRPr lang="en-US"/>
-          </a:p>
-        </p:txBody>
       </p:sp>
       <p:sp>
         <p:nvSpPr>
@@ -8312,7 +8287,7 @@
                   <a:srgbClr val="FFFFFF"/>
                 </a:solidFill>
               </a:rPr>
-              <a:t>Analyst 1: 195 characters, no evidence</a:t>
+              <a:t>Analyst 1: 195 characters, no evidence, asked for probabilities</a:t>
             </a:r>
             <a:endParaRPr lang="en-US" sz="1300" dirty="0"/>
           </a:p>
@@ -8330,7 +8305,7 @@
                   <a:srgbClr val="FFFFFF"/>
                 </a:solidFill>
               </a:rPr>
-              <a:t>Analyst 6: the system prompt, the enforced answer schema, the inflation pre-read, the item ids</a:t>
+              <a:t>Analyst 4: 45,000 characters. The answer schema. The tone pre-read: vote 10 to 2, Cook and Hammack; the diff: 'raise by 1/4 percentage point' removed, 'maintain' added; seven hawkish terms counted, no dovish ones</a:t>
             </a:r>
             <a:endParaRPr lang="en-US" sz="1300" dirty="0"/>
           </a:p>
@@ -8380,13 +8355,6 @@
             <a:prstDash val="solid"/>
           </a:ln>
         </p:spPr>
-        <p:txBody>
-          <a:bodyPr/>
-          <a:lstStyle/>
-          <a:p>
-            <a:endParaRPr lang="en-US"/>
-          </a:p>
-        </p:txBody>
       </p:sp>
       <p:sp>
         <p:nvSpPr>
@@ -8458,7 +8426,7 @@
                   <a:srgbClr val="FFFFFF"/>
                 </a:solidFill>
               </a:rPr>
-              <a:t>If it is not on this page, the analyst does not get it.</a:t>
+              <a:t>The pre-read is code, not the model: it parsed the vote, diffed the two statements, counted the words. The model is handed the result and must quote.</a:t>
             </a:r>
             <a:endParaRPr lang="en-US" sz="1300" dirty="0"/>
           </a:p>
@@ -8476,13 +8444,36 @@
                   <a:srgbClr val="FFFFFF"/>
                 </a:solidFill>
               </a:rPr>
-              <a:t>Same model. The only difference between analyst 1 and analyst 6 is this page.</a:t>
+              <a:t>Its answer, next demo: 8 claims, 8 quotes found; the first quotes the dissent sentence; opinion +4.</a:t>
             </a:r>
             <a:endParaRPr lang="en-US" sz="1300" dirty="0"/>
           </a:p>
+          <a:p>
+            <a:pPr marL="342900" indent="-342900">
+              <a:spcAft>
+                <a:spcPts val="800"/>
+              </a:spcAft>
+              <a:buSzPct val="100000"/>
+              <a:buChar char="•"/>
+            </a:pPr>
+            <a:r>
+              <a:rPr lang="en-US" sz="1300" dirty="0">
+                <a:solidFill>
+                  <a:srgbClr val="FFFFFF"/>
+                </a:solidFill>
+              </a:rPr>
+              <a:t>Same model. The only difference between analyst 1 and analyst 4 is this page.</a:t>
+            </a:r>
+            <a:endParaRPr lang="en-US" sz="1300" dirty="0"/>
+          </a:p>
         </p:txBody>
       </p:sp>
     </p:spTree>
+    <p:extLst>
+      <p:ext uri="{BB962C8B-B14F-4D97-AF65-F5344CB8AC3E}">
+        <p14:creationId xmlns:p14="http://schemas.microsoft.com/office/powerpoint/2010/main" val="882734555"/>
+      </p:ext>
+    </p:extLst>
   </p:cSld>
   <p:clrMapOvr>
     <a:masterClrMapping/>
@@ -8891,7 +8882,7 @@
           </a:prstGeom>
           <a:extLst>
             <a:ext uri="{C572A759-6A51-4108-AA02-DFA0A04FC94B}">
-              <ma14:wrappingTextBoxFlag xmlns="" xmlns:ma14="http://schemas.microsoft.com/office/mac/drawingml/2011/main" val="0"/>
+              <ma14:wrappingTextBoxFlag xmlns:ma14="http://schemas.microsoft.com/office/mac/drawingml/2011/main" xmlns="" val="0"/>
             </a:ext>
           </a:extLst>
         </p:spPr>
@@ -10202,7 +10193,7 @@
               <a:buNone/>
             </a:pPr>
             <a:r>
-              <a:rPr lang="en-US" sz="1000" b="1">
+              <a:rPr lang="en-US" sz="1000" b="1" dirty="0">
                 <a:solidFill>
                   <a:schemeClr val="tx1"/>
                 </a:solidFill>
@@ -10210,7 +10201,7 @@
               <a:t>Four say hike, one says hold: </a:t>
             </a:r>
             <a:r>
-              <a:rPr lang="en-US" sz="1000">
+              <a:rPr lang="en-US" sz="1000" dirty="0">
                 <a:solidFill>
                   <a:schemeClr val="tx1"/>
                 </a:solidFill>
@@ -10223,7 +10214,7 @@
               <a:buNone/>
             </a:pPr>
             <a:r>
-              <a:rPr lang="en-US" sz="1000" b="1">
+              <a:rPr lang="en-US" sz="1000" b="1" dirty="0">
                 <a:solidFill>
                   <a:schemeClr val="tx1"/>
                 </a:solidFill>
@@ -10231,7 +10222,7 @@
               <a:t>+4.0 moves 4 points of probability to the hike side. </a:t>
             </a:r>
             <a:r>
-              <a:rPr lang="en-US" sz="1000">
+              <a:rPr lang="en-US" sz="1000" dirty="0">
                 <a:solidFill>
                   <a:schemeClr val="tx1"/>
                 </a:solidFill>
@@ -10490,7 +10481,7 @@
           </a:prstGeom>
           <a:extLst>
             <a:ext uri="{C572A759-6A51-4108-AA02-DFA0A04FC94B}">
-              <ma14:wrappingTextBoxFlag xmlns="" xmlns:ma14="http://schemas.microsoft.com/office/mac/drawingml/2011/main" val="0"/>
+              <ma14:wrappingTextBoxFlag xmlns:ma14="http://schemas.microsoft.com/office/mac/drawingml/2011/main" xmlns="" val="0"/>
             </a:ext>
           </a:extLst>
         </p:spPr>
@@ -10840,7 +10831,7 @@
                     <a:p>
                       <a:pPr algn="r"/>
                       <a:r>
-                        <a:rPr lang="en-US" sz="850" b="0">
+                        <a:rPr lang="en-US" sz="850" b="0" dirty="0">
                           <a:solidFill>
                             <a:srgbClr val="1C1F2B"/>
                           </a:solidFill>
@@ -11578,7 +11569,7 @@
                     <a:p>
                       <a:pPr algn="r"/>
                       <a:r>
-                        <a:rPr lang="en-US" sz="850" b="0">
+                        <a:rPr lang="en-US" sz="850" b="0" dirty="0">
                           <a:solidFill>
                             <a:srgbClr val="1C1F2B"/>
                           </a:solidFill>
@@ -11638,7 +11629,7 @@
 
 <file path=ppt/slides/slide16.xml><?xml version="1.0" encoding="utf-8"?>
 <p:sld xmlns:a="http://schemas.openxmlformats.org/drawingml/2006/main" xmlns:r="http://schemas.openxmlformats.org/officeDocument/2006/relationships" xmlns:p="http://schemas.openxmlformats.org/presentationml/2006/main">
-  <p:cSld name="Slide 16">
+  <p:cSld>
     <p:spTree>
       <p:nvGrpSpPr>
         <p:cNvPr id="1" name=""/>
@@ -11719,13 +11710,6 @@
             <a:prstDash val="solid"/>
           </a:ln>
         </p:spPr>
-        <p:txBody>
-          <a:bodyPr/>
-          <a:lstStyle/>
-          <a:p>
-            <a:endParaRPr lang="en-US"/>
-          </a:p>
-        </p:txBody>
       </p:sp>
       <p:sp>
         <p:nvSpPr>
@@ -11789,13 +11773,6 @@
             <a:prstDash val="solid"/>
           </a:ln>
         </p:spPr>
-        <p:txBody>
-          <a:bodyPr/>
-          <a:lstStyle/>
-          <a:p>
-            <a:endParaRPr lang="en-US"/>
-          </a:p>
-        </p:txBody>
       </p:sp>
       <p:sp>
         <p:nvSpPr>
@@ -11867,7 +11844,7 @@
                   <a:srgbClr val="FFFFFF"/>
                 </a:solidFill>
               </a:rPr>
-              <a:t>Analyst results view</a:t>
+              <a:t>Analyst results view, same snapshot of 29 October</a:t>
             </a:r>
             <a:endParaRPr lang="en-US" sz="1300" dirty="0"/>
           </a:p>
@@ -11903,7 +11880,7 @@
                   <a:srgbClr val="FFFFFF"/>
                 </a:solidFill>
               </a:rPr>
-              <a:t>Analyst 4 (communications) card</a:t>
+              <a:t>Analyst 4 (communications) card, run 1</a:t>
             </a:r>
             <a:endParaRPr lang="en-US" sz="1300" dirty="0"/>
           </a:p>
@@ -11935,13 +11912,6 @@
             <a:prstDash val="solid"/>
           </a:ln>
         </p:spPr>
-        <p:txBody>
-          <a:bodyPr/>
-          <a:lstStyle/>
-          <a:p>
-            <a:endParaRPr lang="en-US"/>
-          </a:p>
-        </p:txBody>
       </p:sp>
       <p:sp>
         <p:nvSpPr>
@@ -12013,7 +11983,7 @@
                   <a:srgbClr val="FFFFFF"/>
                 </a:solidFill>
               </a:rPr>
-              <a:t>Analyst 1: cut 25 at 57%, numbers from memory flagged</a:t>
+              <a:t>Analyst 1: cut 25 at 52%, 64 numbers from memory across five runs, nothing quoted</a:t>
             </a:r>
             <a:endParaRPr lang="en-US" sz="1300" dirty="0"/>
           </a:p>
@@ -12031,23 +12001,7 @@
                   <a:srgbClr val="FFFFFF"/>
                 </a:solidFill>
               </a:rPr>
-              <a:t>Analyst 4</a:t>
-            </a:r>
-            <a:r>
-              <a:rPr lang="en-US" sz="1300">
-                <a:solidFill>
-                  <a:srgbClr val="FFFFFF"/>
-                </a:solidFill>
-              </a:rPr>
-              <a:t>: the opinion, grounded, </a:t>
-            </a:r>
-            <a:r>
-              <a:rPr lang="en-US" sz="1300" dirty="0">
-                <a:solidFill>
-                  <a:srgbClr val="FFFFFF"/>
-                </a:solidFill>
-              </a:rPr>
-              <a:t>leaked, watch-outs badges; one claim with its quote and the 'quote verified' mark</a:t>
+              <a:t>Analyst 4: 8 claims, 8 quotes found, 0 numbers from memory; five runs mean +5.0, spread 0.6</a:t>
             </a:r>
             <a:endParaRPr lang="en-US" sz="1300" dirty="0"/>
           </a:p>
@@ -12065,7 +12019,7 @@
                   <a:srgbClr val="FFFFFF"/>
                 </a:solidFill>
               </a:rPr>
-              <a:t>Hover a badge for its definition</a:t>
+              <a:t>Claim 1: the dissenters wanted to tighten, quoting the dissent sentence in the 28 October statement. Claim 6, dovish: the committee chose to hold</a:t>
             </a:r>
             <a:endParaRPr lang="en-US" sz="1300" dirty="0"/>
           </a:p>
@@ -12097,13 +12051,6 @@
             <a:prstDash val="solid"/>
           </a:ln>
         </p:spPr>
-        <p:txBody>
-          <a:bodyPr/>
-          <a:lstStyle/>
-          <a:p>
-            <a:endParaRPr lang="en-US"/>
-          </a:p>
-        </p:txBody>
       </p:sp>
       <p:sp>
         <p:nvSpPr>
@@ -12193,6 +12140,24 @@
                   <a:srgbClr val="FFFFFF"/>
                 </a:solidFill>
               </a:rPr>
+              <a:t>The analyst read the diff the pre-read flagged and quoted it. It also argued the other side: the hold itself, and the wait-for-data line.</a:t>
+            </a:r>
+            <a:endParaRPr lang="en-US" sz="1300" dirty="0"/>
+          </a:p>
+          <a:p>
+            <a:pPr marL="342900" indent="-342900">
+              <a:spcAft>
+                <a:spcPts val="800"/>
+              </a:spcAft>
+              <a:buSzPct val="100000"/>
+              <a:buChar char="•"/>
+            </a:pPr>
+            <a:r>
+              <a:rPr lang="en-US" sz="1300" dirty="0">
+                <a:solidFill>
+                  <a:srgbClr val="FFFFFF"/>
+                </a:solidFill>
+              </a:rPr>
               <a:t>The naive analyst still thinks the Fed is cutting. Same model, no evidence.</a:t>
             </a:r>
             <a:endParaRPr lang="en-US" sz="1300" dirty="0"/>
@@ -12200,6 +12165,11 @@
         </p:txBody>
       </p:sp>
     </p:spTree>
+    <p:extLst>
+      <p:ext uri="{BB962C8B-B14F-4D97-AF65-F5344CB8AC3E}">
+        <p14:creationId xmlns:p14="http://schemas.microsoft.com/office/powerpoint/2010/main" val="534180374"/>
+      </p:ext>
+    </p:extLst>
   </p:cSld>
   <p:clrMapOvr>
     <a:masterClrMapping/>
@@ -14564,7 +14534,7 @@
           </a:prstGeom>
           <a:extLst>
             <a:ext uri="{C572A759-6A51-4108-AA02-DFA0A04FC94B}">
-              <ma14:wrappingTextBoxFlag xmlns="" xmlns:ma14="http://schemas.microsoft.com/office/mac/drawingml/2011/main" val="0"/>
+              <ma14:wrappingTextBoxFlag xmlns:ma14="http://schemas.microsoft.com/office/mac/drawingml/2011/main" xmlns="" val="0"/>
             </a:ext>
           </a:extLst>
         </p:spPr>
@@ -15488,7 +15458,7 @@
           </a:prstGeom>
           <a:extLst>
             <a:ext uri="{C572A759-6A51-4108-AA02-DFA0A04FC94B}">
-              <ma14:wrappingTextBoxFlag xmlns="" xmlns:ma14="http://schemas.microsoft.com/office/mac/drawingml/2011/main" val="0"/>
+              <ma14:wrappingTextBoxFlag xmlns:ma14="http://schemas.microsoft.com/office/mac/drawingml/2011/main" xmlns="" val="0"/>
             </a:ext>
           </a:extLst>
         </p:spPr>
@@ -15562,7 +15532,7 @@
 
 <file path=ppt/slides/slide20.xml><?xml version="1.0" encoding="utf-8"?>
 <p:sld xmlns:a="http://schemas.openxmlformats.org/drawingml/2006/main" xmlns:r="http://schemas.openxmlformats.org/officeDocument/2006/relationships" xmlns:p="http://schemas.openxmlformats.org/presentationml/2006/main">
-  <p:cSld name="Slide 21">
+  <p:cSld>
     <p:spTree>
       <p:nvGrpSpPr>
         <p:cNvPr id="1" name=""/>
@@ -15589,8 +15559,8 @@
         </p:nvSpPr>
         <p:spPr>
           <a:xfrm>
-            <a:off x="548640" y="2103120"/>
-            <a:ext cx="11091672" cy="1280160"/>
+            <a:off x="548640" y="411480"/>
+            <a:ext cx="11091672" cy="822960"/>
           </a:xfrm>
           <a:prstGeom prst="rect">
             <a:avLst/>
@@ -15599,102 +15569,647 @@
           <a:ln/>
         </p:spPr>
         <p:txBody>
-          <a:bodyPr wrap="square" lIns="0" tIns="0" rIns="0" bIns="0" rtlCol="0" anchor="b"/>
+          <a:bodyPr wrap="square" lIns="0" tIns="0" rIns="0" bIns="0" rtlCol="0" anchor="ctr"/>
           <a:lstStyle/>
           <a:p>
             <a:pPr marL="0" indent="0" algn="l">
               <a:buNone/>
             </a:pPr>
             <a:r>
-              <a:rPr lang="en-US" sz="4000" b="1" dirty="0">
+              <a:rPr lang="en-US" sz="3200" b="1" dirty="0">
+                <a:solidFill>
+                  <a:schemeClr val="tx2"/>
+                </a:solidFill>
+              </a:rPr>
+              <a:t>Three things to take away</a:t>
+            </a:r>
+            <a:endParaRPr lang="en-US" sz="3200" dirty="0"/>
+          </a:p>
+        </p:txBody>
+      </p:sp>
+      <p:sp>
+        <p:nvSpPr>
+          <p:cNvPr id="4" name="Shape 1"/>
+          <p:cNvSpPr/>
+          <p:nvPr/>
+        </p:nvSpPr>
+        <p:spPr>
+          <a:xfrm>
+            <a:off x="548640" y="1371600"/>
+            <a:ext cx="3575304" cy="3566160"/>
+          </a:xfrm>
+          <a:prstGeom prst="roundRect">
+            <a:avLst>
+              <a:gd name="adj" fmla="val 3077"/>
+            </a:avLst>
+          </a:prstGeom>
+          <a:solidFill>
+            <a:srgbClr val="EEF2F7"/>
+          </a:solidFill>
+          <a:ln w="12700">
+            <a:solidFill>
+              <a:srgbClr val="EEF2F7"/>
+            </a:solidFill>
+            <a:prstDash val="solid"/>
+          </a:ln>
+          <a:effectLst>
+            <a:outerShdw blurRad="50800" dist="12700" dir="5400000" algn="bl" rotWithShape="0">
+              <a:srgbClr val="000000">
+                <a:alpha val="8000"/>
+              </a:srgbClr>
+            </a:outerShdw>
+          </a:effectLst>
+        </p:spPr>
+      </p:sp>
+      <p:sp>
+        <p:nvSpPr>
+          <p:cNvPr id="5" name="Shape 2"/>
+          <p:cNvSpPr/>
+          <p:nvPr/>
+        </p:nvSpPr>
+        <p:spPr>
+          <a:xfrm>
+            <a:off x="777240" y="1600200"/>
+            <a:ext cx="384048" cy="384048"/>
+          </a:xfrm>
+          <a:prstGeom prst="ellipse">
+            <a:avLst/>
+          </a:prstGeom>
+          <a:solidFill>
+            <a:srgbClr val="1E2761"/>
+          </a:solidFill>
+          <a:ln w="12700">
+            <a:solidFill>
+              <a:srgbClr val="1E2761"/>
+            </a:solidFill>
+            <a:prstDash val="solid"/>
+          </a:ln>
+        </p:spPr>
+      </p:sp>
+      <p:sp>
+        <p:nvSpPr>
+          <p:cNvPr id="6" name="Text 3"/>
+          <p:cNvSpPr txBox="1"/>
+          <p:nvPr/>
+        </p:nvSpPr>
+        <p:spPr>
+          <a:xfrm>
+            <a:off x="777240" y="1600200"/>
+            <a:ext cx="384048" cy="384048"/>
+          </a:xfrm>
+          <a:prstGeom prst="rect">
+            <a:avLst/>
+          </a:prstGeom>
+          <a:noFill/>
+          <a:ln/>
+        </p:spPr>
+        <p:txBody>
+          <a:bodyPr wrap="square" lIns="0" tIns="0" rIns="0" bIns="0" rtlCol="0" anchor="ctr"/>
+          <a:lstStyle/>
+          <a:p>
+            <a:pPr marL="0" indent="0" algn="ctr">
+              <a:buNone/>
+            </a:pPr>
+            <a:r>
+              <a:rPr lang="en-US" sz="1400" b="1" dirty="0">
                 <a:solidFill>
                   <a:schemeClr val="bg1"/>
                 </a:solidFill>
               </a:rPr>
-              <a:t>Three things to take away</a:t>
-            </a:r>
-            <a:endParaRPr lang="en-US" sz="4000" dirty="0"/>
-          </a:p>
-        </p:txBody>
-      </p:sp>
-      <p:sp>
-        <p:nvSpPr>
-          <p:cNvPr id="3" name="Text 0"/>
+              <a:t>1</a:t>
+            </a:r>
+            <a:endParaRPr lang="en-US" sz="1400" dirty="0"/>
+          </a:p>
+        </p:txBody>
+      </p:sp>
+      <p:sp>
+        <p:nvSpPr>
+          <p:cNvPr id="7" name="Text 4"/>
+          <p:cNvSpPr txBox="1"/>
+          <p:nvPr/>
+        </p:nvSpPr>
+        <p:spPr>
+          <a:xfrm>
+            <a:off x="1280160" y="1572768"/>
+            <a:ext cx="2660904" cy="457200"/>
+          </a:xfrm>
+          <a:prstGeom prst="rect">
+            <a:avLst/>
+          </a:prstGeom>
+          <a:noFill/>
+          <a:ln/>
+        </p:spPr>
+        <p:txBody>
+          <a:bodyPr wrap="square" lIns="0" tIns="0" rIns="0" bIns="0" rtlCol="0" anchor="ctr"/>
+          <a:lstStyle/>
+          <a:p>
+            <a:pPr marL="0" indent="0">
+              <a:buNone/>
+            </a:pPr>
+            <a:r>
+              <a:rPr lang="en-US" sz="1600" b="1" dirty="0">
+                <a:solidFill>
+                  <a:schemeClr val="tx2"/>
+                </a:solidFill>
+              </a:rPr>
+              <a:t>Design around the model's limits</a:t>
+            </a:r>
+            <a:endParaRPr lang="en-US" sz="1600" dirty="0"/>
+          </a:p>
+        </p:txBody>
+      </p:sp>
+      <p:sp>
+        <p:nvSpPr>
+          <p:cNvPr id="8" name="Text 5"/>
+          <p:cNvSpPr txBox="1"/>
+          <p:nvPr/>
+        </p:nvSpPr>
+        <p:spPr>
+          <a:xfrm>
+            <a:off x="777240" y="2240280"/>
+            <a:ext cx="3118104" cy="2606040"/>
+          </a:xfrm>
+          <a:prstGeom prst="rect">
+            <a:avLst/>
+          </a:prstGeom>
+          <a:noFill/>
+          <a:ln/>
+        </p:spPr>
+        <p:txBody>
+          <a:bodyPr wrap="square" lIns="0" tIns="0" rIns="0" bIns="0" rtlCol="0" anchor="t"/>
+          <a:lstStyle/>
+          <a:p>
+            <a:pPr marL="0" indent="0">
+              <a:buNone/>
+            </a:pPr>
+            <a:r>
+              <a:rPr lang="en-US" sz="1400" dirty="0">
+                <a:solidFill>
+                  <a:schemeClr val="tx1"/>
+                </a:solidFill>
+              </a:rPr>
+              <a:t>It remembers: so it reads only the frozen evidence, and every number in its answer is matched to the snapshot. It varies: so it answers in a fixed shape, five times, and the spread is measured against a pass mark. It invents: so every claim carries a verbatim quote that code finds character for character, with one repair round. Nothing is removed. Everything is checked.</a:t>
+            </a:r>
+            <a:endParaRPr lang="en-US" sz="1400" dirty="0"/>
+          </a:p>
+        </p:txBody>
+      </p:sp>
+      <p:sp>
+        <p:nvSpPr>
+          <p:cNvPr id="9" name="Shape 6"/>
+          <p:cNvSpPr/>
+          <p:nvPr/>
+        </p:nvSpPr>
+        <p:spPr>
+          <a:xfrm>
+            <a:off x="4306824" y="1371600"/>
+            <a:ext cx="3575304" cy="3566160"/>
+          </a:xfrm>
+          <a:prstGeom prst="roundRect">
+            <a:avLst>
+              <a:gd name="adj" fmla="val 3077"/>
+            </a:avLst>
+          </a:prstGeom>
+          <a:solidFill>
+            <a:srgbClr val="EEF2F7"/>
+          </a:solidFill>
+          <a:ln w="12700">
+            <a:solidFill>
+              <a:srgbClr val="EEF2F7"/>
+            </a:solidFill>
+            <a:prstDash val="solid"/>
+          </a:ln>
+          <a:effectLst>
+            <a:outerShdw blurRad="50800" dist="12700" dir="5400000" algn="bl" rotWithShape="0">
+              <a:srgbClr val="000000">
+                <a:alpha val="8000"/>
+              </a:srgbClr>
+            </a:outerShdw>
+          </a:effectLst>
+        </p:spPr>
+      </p:sp>
+      <p:sp>
+        <p:nvSpPr>
+          <p:cNvPr id="10" name="Shape 7"/>
+          <p:cNvSpPr/>
+          <p:nvPr/>
+        </p:nvSpPr>
+        <p:spPr>
+          <a:xfrm>
+            <a:off x="4535424" y="1600200"/>
+            <a:ext cx="384048" cy="384048"/>
+          </a:xfrm>
+          <a:prstGeom prst="ellipse">
+            <a:avLst/>
+          </a:prstGeom>
+          <a:solidFill>
+            <a:srgbClr val="1E2761"/>
+          </a:solidFill>
+          <a:ln w="12700">
+            <a:solidFill>
+              <a:srgbClr val="1E2761"/>
+            </a:solidFill>
+            <a:prstDash val="solid"/>
+          </a:ln>
+        </p:spPr>
+      </p:sp>
+      <p:sp>
+        <p:nvSpPr>
+          <p:cNvPr id="11" name="Text 8"/>
+          <p:cNvSpPr txBox="1"/>
+          <p:nvPr/>
+        </p:nvSpPr>
+        <p:spPr>
+          <a:xfrm>
+            <a:off x="4535424" y="1600200"/>
+            <a:ext cx="384048" cy="384048"/>
+          </a:xfrm>
+          <a:prstGeom prst="rect">
+            <a:avLst/>
+          </a:prstGeom>
+          <a:noFill/>
+          <a:ln/>
+        </p:spPr>
+        <p:txBody>
+          <a:bodyPr wrap="square" lIns="0" tIns="0" rIns="0" bIns="0" rtlCol="0" anchor="ctr"/>
+          <a:lstStyle/>
+          <a:p>
+            <a:pPr marL="0" indent="0" algn="ctr">
+              <a:buNone/>
+            </a:pPr>
+            <a:r>
+              <a:rPr lang="en-US" sz="1400" b="1" dirty="0">
+                <a:solidFill>
+                  <a:schemeClr val="bg1"/>
+                </a:solidFill>
+              </a:rPr>
+              <a:t>2</a:t>
+            </a:r>
+            <a:endParaRPr lang="en-US" sz="1400" dirty="0"/>
+          </a:p>
+        </p:txBody>
+      </p:sp>
+      <p:sp>
+        <p:nvSpPr>
+          <p:cNvPr id="12" name="Text 9"/>
+          <p:cNvSpPr txBox="1"/>
+          <p:nvPr/>
+        </p:nvSpPr>
+        <p:spPr>
+          <a:xfrm>
+            <a:off x="5038344" y="1572768"/>
+            <a:ext cx="2660904" cy="457200"/>
+          </a:xfrm>
+          <a:prstGeom prst="rect">
+            <a:avLst/>
+          </a:prstGeom>
+          <a:noFill/>
+          <a:ln/>
+        </p:spPr>
+        <p:txBody>
+          <a:bodyPr wrap="square" lIns="0" tIns="0" rIns="0" bIns="0" rtlCol="0" anchor="ctr"/>
+          <a:lstStyle/>
+          <a:p>
+            <a:pPr marL="0" indent="0">
+              <a:buNone/>
+            </a:pPr>
+            <a:r>
+              <a:rPr lang="en-US" sz="1600" b="1" dirty="0">
+                <a:solidFill>
+                  <a:schemeClr val="tx2"/>
+                </a:solidFill>
+              </a:rPr>
+              <a:t>The engineering is in the harness</a:t>
+            </a:r>
+            <a:endParaRPr lang="en-US" sz="1600" dirty="0"/>
+          </a:p>
+        </p:txBody>
+      </p:sp>
+      <p:sp>
+        <p:nvSpPr>
+          <p:cNvPr id="13" name="Text 10"/>
+          <p:cNvSpPr txBox="1"/>
+          <p:nvPr/>
+        </p:nvSpPr>
+        <p:spPr>
+          <a:xfrm>
+            <a:off x="4535424" y="2240280"/>
+            <a:ext cx="3118104" cy="2606040"/>
+          </a:xfrm>
+          <a:prstGeom prst="rect">
+            <a:avLst/>
+          </a:prstGeom>
+          <a:noFill/>
+          <a:ln/>
+        </p:spPr>
+        <p:txBody>
+          <a:bodyPr wrap="square" lIns="0" tIns="0" rIns="0" bIns="0" rtlCol="0" anchor="t"/>
+          <a:lstStyle/>
+          <a:p>
+            <a:pPr marL="0" indent="0">
+              <a:buNone/>
+            </a:pPr>
+            <a:r>
+              <a:rPr lang="en-US" sz="1400" dirty="0">
+                <a:solidFill>
+                  <a:schemeClr val="tx1"/>
+                </a:solidFill>
+              </a:rPr>
+              <a:t>The model is one component in a chain: frozen evidence, pre-reads computed by code, a fixed answer shape, a verifier, a bounded opinion, a pool at fixed weights, an append-only ledger. The chain decides what the model may read, what shape it must answer in, and what happens when it is wrong. Swap the model and the chain stands. Remove the chain and the same model wobbles and leaks.</a:t>
+            </a:r>
+            <a:endParaRPr lang="en-US" sz="1400" dirty="0"/>
+          </a:p>
+        </p:txBody>
+      </p:sp>
+      <p:sp>
+        <p:nvSpPr>
+          <p:cNvPr id="14" name="Shape 11"/>
+          <p:cNvSpPr/>
+          <p:nvPr/>
+        </p:nvSpPr>
+        <p:spPr>
+          <a:xfrm>
+            <a:off x="8065008" y="1371600"/>
+            <a:ext cx="3575304" cy="3566160"/>
+          </a:xfrm>
+          <a:prstGeom prst="roundRect">
+            <a:avLst>
+              <a:gd name="adj" fmla="val 3077"/>
+            </a:avLst>
+          </a:prstGeom>
+          <a:solidFill>
+            <a:srgbClr val="EEF2F7"/>
+          </a:solidFill>
+          <a:ln w="12700">
+            <a:solidFill>
+              <a:srgbClr val="EEF2F7"/>
+            </a:solidFill>
+            <a:prstDash val="solid"/>
+          </a:ln>
+          <a:effectLst>
+            <a:outerShdw blurRad="50800" dist="12700" dir="5400000" algn="bl" rotWithShape="0">
+              <a:srgbClr val="000000">
+                <a:alpha val="8000"/>
+              </a:srgbClr>
+            </a:outerShdw>
+          </a:effectLst>
+        </p:spPr>
+      </p:sp>
+      <p:sp>
+        <p:nvSpPr>
+          <p:cNvPr id="15" name="Shape 12"/>
+          <p:cNvSpPr/>
+          <p:nvPr/>
+        </p:nvSpPr>
+        <p:spPr>
+          <a:xfrm>
+            <a:off x="8293608" y="1600200"/>
+            <a:ext cx="384048" cy="384048"/>
+          </a:xfrm>
+          <a:prstGeom prst="ellipse">
+            <a:avLst/>
+          </a:prstGeom>
+          <a:solidFill>
+            <a:srgbClr val="1E2761"/>
+          </a:solidFill>
+          <a:ln w="12700">
+            <a:solidFill>
+              <a:srgbClr val="1E2761"/>
+            </a:solidFill>
+            <a:prstDash val="solid"/>
+          </a:ln>
+        </p:spPr>
+      </p:sp>
+      <p:sp>
+        <p:nvSpPr>
+          <p:cNvPr id="16" name="Text 13"/>
+          <p:cNvSpPr txBox="1"/>
+          <p:nvPr/>
+        </p:nvSpPr>
+        <p:spPr>
+          <a:xfrm>
+            <a:off x="8293608" y="1600200"/>
+            <a:ext cx="384048" cy="384048"/>
+          </a:xfrm>
+          <a:prstGeom prst="rect">
+            <a:avLst/>
+          </a:prstGeom>
+          <a:noFill/>
+          <a:ln/>
+        </p:spPr>
+        <p:txBody>
+          <a:bodyPr wrap="square" lIns="0" tIns="0" rIns="0" bIns="0" rtlCol="0" anchor="ctr"/>
+          <a:lstStyle/>
+          <a:p>
+            <a:pPr marL="0" indent="0" algn="ctr">
+              <a:buNone/>
+            </a:pPr>
+            <a:r>
+              <a:rPr lang="en-US" sz="1400" b="1" dirty="0">
+                <a:solidFill>
+                  <a:schemeClr val="bg1"/>
+                </a:solidFill>
+              </a:rPr>
+              <a:t>3</a:t>
+            </a:r>
+            <a:endParaRPr lang="en-US" sz="1400" dirty="0"/>
+          </a:p>
+        </p:txBody>
+      </p:sp>
+      <p:sp>
+        <p:nvSpPr>
+          <p:cNvPr id="17" name="Text 14"/>
+          <p:cNvSpPr txBox="1"/>
+          <p:nvPr/>
+        </p:nvSpPr>
+        <p:spPr>
+          <a:xfrm>
+            <a:off x="8796528" y="1572768"/>
+            <a:ext cx="2660904" cy="457200"/>
+          </a:xfrm>
+          <a:prstGeom prst="rect">
+            <a:avLst/>
+          </a:prstGeom>
+          <a:noFill/>
+          <a:ln/>
+        </p:spPr>
+        <p:txBody>
+          <a:bodyPr wrap="square" lIns="0" tIns="0" rIns="0" bIns="0" rtlCol="0" anchor="ctr"/>
+          <a:lstStyle/>
+          <a:p>
+            <a:pPr marL="0" indent="0">
+              <a:buNone/>
+            </a:pPr>
+            <a:r>
+              <a:rPr lang="en-US" sz="1600" b="1" dirty="0">
+                <a:solidFill>
+                  <a:schemeClr val="tx2"/>
+                </a:solidFill>
+              </a:rPr>
+              <a:t>Process is what you can judge</a:t>
+            </a:r>
+            <a:endParaRPr lang="en-US" sz="1600" dirty="0"/>
+          </a:p>
+        </p:txBody>
+      </p:sp>
+      <p:sp>
+        <p:nvSpPr>
+          <p:cNvPr id="18" name="Text 15"/>
+          <p:cNvSpPr txBox="1"/>
+          <p:nvPr/>
+        </p:nvSpPr>
+        <p:spPr>
+          <a:xfrm>
+            <a:off x="8293608" y="2240280"/>
+            <a:ext cx="3118104" cy="2606040"/>
+          </a:xfrm>
+          <a:prstGeom prst="rect">
+            <a:avLst/>
+          </a:prstGeom>
+          <a:noFill/>
+          <a:ln/>
+        </p:spPr>
+        <p:txBody>
+          <a:bodyPr wrap="square" lIns="0" tIns="0" rIns="0" bIns="0" rtlCol="0" anchor="t"/>
+          <a:lstStyle/>
+          <a:p>
+            <a:pPr marL="0" indent="0">
+              <a:buNone/>
+            </a:pPr>
+            <a:r>
+              <a:rPr lang="en-US" sz="1400" dirty="0">
+                <a:solidFill>
+                  <a:schemeClr val="tx1"/>
+                </a:solidFill>
+              </a:rPr>
+              <a:t>The model does the heavy lifting: it reads the statements, the minutes and the transcript in a minute and comes back with quoted claims. The architecture decides whether that work can be trusted, repeated and replayed. Eight decisions a year cannot prove skill. A scorecard written before the first run and measured on every snapshot shows discipline and catches drift.</a:t>
+            </a:r>
+            <a:endParaRPr lang="en-US" sz="1400" dirty="0"/>
+          </a:p>
+        </p:txBody>
+      </p:sp>
+      <p:sp>
+        <p:nvSpPr>
+          <p:cNvPr id="19" name="Shape 16"/>
+          <p:cNvSpPr/>
+          <p:nvPr/>
+        </p:nvSpPr>
+        <p:spPr>
+          <a:xfrm>
+            <a:off x="548640" y="5212080"/>
+            <a:ext cx="11091672" cy="685800"/>
+          </a:xfrm>
+          <a:prstGeom prst="roundRect">
+            <a:avLst>
+              <a:gd name="adj" fmla="val 13333"/>
+            </a:avLst>
+          </a:prstGeom>
+          <a:solidFill>
+            <a:srgbClr val="1E2761"/>
+          </a:solidFill>
+          <a:ln w="12700">
+            <a:solidFill>
+              <a:srgbClr val="1E2761"/>
+            </a:solidFill>
+            <a:prstDash val="solid"/>
+          </a:ln>
+        </p:spPr>
+      </p:sp>
+      <p:sp>
+        <p:nvSpPr>
+          <p:cNvPr id="20" name="Text 17"/>
+          <p:cNvSpPr txBox="1"/>
+          <p:nvPr/>
+        </p:nvSpPr>
+        <p:spPr>
+          <a:xfrm>
+            <a:off x="822960" y="5212080"/>
+            <a:ext cx="10543032" cy="685800"/>
+          </a:xfrm>
+          <a:prstGeom prst="rect">
+            <a:avLst/>
+          </a:prstGeom>
+          <a:noFill/>
+          <a:ln/>
+        </p:spPr>
+        <p:txBody>
+          <a:bodyPr wrap="square" lIns="0" tIns="0" rIns="0" bIns="0" rtlCol="0" anchor="ctr"/>
+          <a:lstStyle/>
+          <a:p>
+            <a:pPr marL="0" indent="0">
+              <a:buNone/>
+            </a:pPr>
+            <a:r>
+              <a:rPr lang="en-US" sz="1400" b="1" dirty="0">
+                <a:solidFill>
+                  <a:srgbClr val="E9B44C"/>
+                </a:solidFill>
+              </a:rPr>
+              <a:t>The ask. </a:t>
+            </a:r>
+            <a:r>
+              <a:rPr lang="en-US" sz="1400" dirty="0">
+                <a:solidFill>
+                  <a:srgbClr val="FFFFFF"/>
+                </a:solidFill>
+              </a:rPr>
+              <a:t>Open the app on the 9 December entry. Challenge a quote. Grade one analyst's answer. Tell us which of the six follow-ups to do first.</a:t>
+            </a:r>
+            <a:endParaRPr lang="en-US" sz="1400" dirty="0"/>
+          </a:p>
+        </p:txBody>
+      </p:sp>
+      <p:sp>
+        <p:nvSpPr>
+          <p:cNvPr id="25" name="Slide Number Placeholder 0"/>
           <p:cNvSpPr>
             <a:spLocks noGrp="1"/>
           </p:cNvSpPr>
           <p:nvPr>
-            <p:ph type="body" idx="101" hasCustomPrompt="1"/>
+            <p:ph type="sldNum" sz="quarter" idx="4294967295"/>
           </p:nvPr>
         </p:nvSpPr>
         <p:spPr>
           <a:xfrm>
-            <a:off x="548640" y="3520440"/>
-            <a:ext cx="11091672" cy="1463040"/>
+            <a:off x="11091672" y="6400800"/>
+            <a:ext cx="548640" cy="274320"/>
           </a:xfrm>
           <a:prstGeom prst="rect">
             <a:avLst/>
           </a:prstGeom>
-          <a:noFill/>
-          <a:ln/>
-        </p:spPr>
-        <p:txBody>
-          <a:bodyPr wrap="square" lIns="0" tIns="0" rIns="0" bIns="0" rtlCol="0" anchor="t"/>
-          <a:lstStyle/>
-          <a:p>
-            <a:pPr marL="342900" indent="-342900" algn="l">
-              <a:spcAft>
-                <a:spcPts val="800"/>
-              </a:spcAft>
-              <a:buSzPct val="100000"/>
-              <a:buChar char="•"/>
-            </a:pPr>
-            <a:r>
-              <a:rPr lang="en-US" sz="2000" dirty="0">
-                <a:solidFill>
-                  <a:srgbClr val="CADCFC"/>
-                </a:solidFill>
-              </a:rPr>
-              <a:t>The harness is the product. Same model, same evidence, same day: naive it wobbles and leaks; harnessed it is stable, quoted and checked.</a:t>
-            </a:r>
-            <a:endParaRPr lang="en-US" sz="2000" dirty="0"/>
-          </a:p>
-          <a:p>
-            <a:pPr marL="342900" indent="-342900" algn="l">
-              <a:spcAft>
-                <a:spcPts val="800"/>
-              </a:spcAft>
-              <a:buSzPct val="100000"/>
-              <a:buChar char="•"/>
-            </a:pPr>
-            <a:r>
-              <a:rPr lang="en-US" sz="2000" dirty="0">
-                <a:solidFill>
-                  <a:srgbClr val="CADCFC"/>
-                </a:solidFill>
-              </a:rPr>
-              <a:t>Judge the process. Eight decisions a year cannot prove skill; a pre-registered scorecard measured on every snapshot can show discipline and catch drift.</a:t>
-            </a:r>
-            <a:endParaRPr lang="en-US" sz="2000" dirty="0"/>
-          </a:p>
-          <a:p>
-            <a:pPr marL="342900" indent="-342900" algn="l">
-              <a:buSzPct val="100000"/>
-              <a:buChar char="•"/>
-            </a:pPr>
-            <a:r>
-              <a:rPr lang="en-US" sz="2000" dirty="0">
-                <a:solidFill>
-                  <a:srgbClr val="CADCFC"/>
-                </a:solidFill>
-              </a:rPr>
-              <a:t>The ask: scrutinise the scorecard, challenge a quote, and tell us which other decisions deserve the same chain. The 28 October call is on file; the 9 December forecast is too.</a:t>
-            </a:r>
-            <a:endParaRPr lang="en-US" sz="2000" dirty="0"/>
+          <a:extLst>
+            <a:ext uri="{C572A759-6A51-4108-AA02-DFA0A04FC94B}">
+              <ma14:wrappingTextBoxFlag xmlns:ma14="http://schemas.microsoft.com/office/mac/drawingml/2011/main" xmlns="" val="0"/>
+            </a:ext>
+          </a:extLst>
+        </p:spPr>
+        <p:txBody>
+          <a:bodyPr/>
+          <a:lstStyle>
+            <a:lvl1pPr>
+              <a:defRPr sz="1000">
+                <a:solidFill>
+                  <a:srgbClr val="6B7280"/>
+                </a:solidFill>
+              </a:defRPr>
+            </a:lvl1pPr>
+          </a:lstStyle>
+          <a:p>
+            <a:pPr algn="r"/>
+            <a:fld id="{F7021451-1387-4CA6-816F-3879F97B5CBC}" type="slidenum">
+              <a:rPr lang="en-US" b="0"/>
+              <a:t>20</a:t>
+            </a:fld>
+            <a:endParaRPr lang="en-US"/>
           </a:p>
         </p:txBody>
       </p:sp>
     </p:spTree>
+    <p:extLst>
+      <p:ext uri="{BB962C8B-B14F-4D97-AF65-F5344CB8AC3E}">
+        <p14:creationId xmlns:p14="http://schemas.microsoft.com/office/powerpoint/2010/main" val="1529671003"/>
+      </p:ext>
+    </p:extLst>
   </p:cSld>
   <p:clrMapOvr>
     <a:masterClrMapping/>
@@ -17468,7 +17983,7 @@
           </a:prstGeom>
           <a:extLst>
             <a:ext uri="{C572A759-6A51-4108-AA02-DFA0A04FC94B}">
-              <ma14:wrappingTextBoxFlag xmlns="" xmlns:ma14="http://schemas.microsoft.com/office/mac/drawingml/2011/main" val="0"/>
+              <ma14:wrappingTextBoxFlag xmlns:ma14="http://schemas.microsoft.com/office/mac/drawingml/2011/main" xmlns="" val="0"/>
             </a:ext>
           </a:extLst>
         </p:spPr>
@@ -20445,7 +20960,7 @@
           </a:prstGeom>
           <a:extLst>
             <a:ext uri="{C572A759-6A51-4108-AA02-DFA0A04FC94B}">
-              <ma14:wrappingTextBoxFlag xmlns:ma14="http://schemas.microsoft.com/office/mac/drawingml/2011/main" xmlns="" val="0"/>
+              <ma14:wrappingTextBoxFlag xmlns="" xmlns:ma14="http://schemas.microsoft.com/office/mac/drawingml/2011/main" val="0"/>
             </a:ext>
           </a:extLst>
         </p:spPr>
@@ -22438,7 +22953,7 @@
           </a:prstGeom>
           <a:extLst>
             <a:ext uri="{C572A759-6A51-4108-AA02-DFA0A04FC94B}">
-              <ma14:wrappingTextBoxFlag xmlns:ma14="http://schemas.microsoft.com/office/mac/drawingml/2011/main" xmlns="" val="0"/>
+              <ma14:wrappingTextBoxFlag xmlns="" xmlns:ma14="http://schemas.microsoft.com/office/mac/drawingml/2011/main" val="0"/>
             </a:ext>
           </a:extLst>
         </p:spPr>
@@ -24449,7 +24964,7 @@
           </a:prstGeom>
           <a:extLst>
             <a:ext uri="{C572A759-6A51-4108-AA02-DFA0A04FC94B}">
-              <ma14:wrappingTextBoxFlag xmlns="" xmlns:ma14="http://schemas.microsoft.com/office/mac/drawingml/2011/main" val="0"/>
+              <ma14:wrappingTextBoxFlag xmlns:ma14="http://schemas.microsoft.com/office/mac/drawingml/2011/main" xmlns="" val="0"/>
             </a:ext>
           </a:extLst>
         </p:spPr>
@@ -25511,7 +26026,7 @@
           </a:prstGeom>
           <a:extLst>
             <a:ext uri="{C572A759-6A51-4108-AA02-DFA0A04FC94B}">
-              <ma14:wrappingTextBoxFlag xmlns:ma14="http://schemas.microsoft.com/office/mac/drawingml/2011/main" xmlns="" val="0"/>
+              <ma14:wrappingTextBoxFlag xmlns="" xmlns:ma14="http://schemas.microsoft.com/office/mac/drawingml/2011/main" val="0"/>
             </a:ext>
           </a:extLst>
         </p:spPr>
@@ -27763,7 +28278,7 @@
           </a:prstGeom>
           <a:extLst>
             <a:ext uri="{C572A759-6A51-4108-AA02-DFA0A04FC94B}">
-              <ma14:wrappingTextBoxFlag xmlns:ma14="http://schemas.microsoft.com/office/mac/drawingml/2011/main" xmlns="" val="0"/>
+              <ma14:wrappingTextBoxFlag xmlns="" xmlns:ma14="http://schemas.microsoft.com/office/mac/drawingml/2011/main" val="0"/>
             </a:ext>
           </a:extLst>
         </p:spPr>
@@ -29735,7 +30250,7 @@
           </a:prstGeom>
           <a:extLst>
             <a:ext uri="{C572A759-6A51-4108-AA02-DFA0A04FC94B}">
-              <ma14:wrappingTextBoxFlag xmlns="" xmlns:ma14="http://schemas.microsoft.com/office/mac/drawingml/2011/main" val="0"/>
+              <ma14:wrappingTextBoxFlag xmlns:ma14="http://schemas.microsoft.com/office/mac/drawingml/2011/main" xmlns="" val="0"/>
             </a:ext>
           </a:extLst>
         </p:spPr>
@@ -30951,7 +31466,7 @@
           </a:prstGeom>
           <a:extLst>
             <a:ext uri="{C572A759-6A51-4108-AA02-DFA0A04FC94B}">
-              <ma14:wrappingTextBoxFlag xmlns="" xmlns:ma14="http://schemas.microsoft.com/office/mac/drawingml/2011/main" val="0"/>
+              <ma14:wrappingTextBoxFlag xmlns:ma14="http://schemas.microsoft.com/office/mac/drawingml/2011/main" xmlns="" val="0"/>
             </a:ext>
           </a:extLst>
         </p:spPr>
@@ -32562,7 +33077,7 @@
           </a:prstGeom>
           <a:extLst>
             <a:ext uri="{C572A759-6A51-4108-AA02-DFA0A04FC94B}">
-              <ma14:wrappingTextBoxFlag xmlns:ma14="http://schemas.microsoft.com/office/mac/drawingml/2011/main" xmlns="" val="0"/>
+              <ma14:wrappingTextBoxFlag xmlns="" xmlns:ma14="http://schemas.microsoft.com/office/mac/drawingml/2011/main" val="0"/>
             </a:ext>
           </a:extLst>
         </p:spPr>
@@ -36642,7 +37157,7 @@
           </a:prstGeom>
           <a:extLst>
             <a:ext uri="{C572A759-6A51-4108-AA02-DFA0A04FC94B}">
-              <ma14:wrappingTextBoxFlag xmlns="" xmlns:ma14="http://schemas.microsoft.com/office/mac/drawingml/2011/main" val="0"/>
+              <ma14:wrappingTextBoxFlag xmlns:ma14="http://schemas.microsoft.com/office/mac/drawingml/2011/main" xmlns="" val="0"/>
             </a:ext>
           </a:extLst>
         </p:spPr>

</xml_diff>

<commit_message>
Slide 7 redone as three whys: why an ensemble (each signal fails in a known way, fixed weights, floor, nothing fitted), why a harnessed language model on top, why the process is judged
Co-Authored-By: Claude Fable 5.1 <noreply@anthropic.com>
</commit_message>
<xml_diff>
--- a/docs/FedCast_Fullerton.pptx
+++ b/docs/FedCast_Fullerton.pptx
@@ -14,7 +14,7 @@
     <p:sldId id="284" r:id="rId5"/>
     <p:sldId id="259" r:id="rId6"/>
     <p:sldId id="261" r:id="rId7"/>
-    <p:sldId id="260" r:id="rId8"/>
+    <p:sldId id="289" r:id="rId8"/>
     <p:sldId id="281" r:id="rId9"/>
     <p:sldId id="263" r:id="rId10"/>
     <p:sldId id="264" r:id="rId11"/>
@@ -142,7 +142,7 @@
           <p14:sldIdLst>
             <p14:sldId id="259"/>
             <p14:sldId id="261"/>
-            <p14:sldId id="260"/>
+            <p14:sldId id="289"/>
             <p14:sldId id="281"/>
           </p14:sldIdLst>
         </p14:section>
@@ -2979,16 +2979,9 @@
           <a:lstStyle/>
           <a:p>
             <a:r>
-              <a:rPr lang="en-US"/>
-              <a:t>2 MIN. The one to land is point 1: eight decisions a year cannot tell skill from luck, so we judge the process, with questions fixed before any code: same evidence same answer, every claim quoted, no number from memory, shocks move the number the right way. Outcomes logged, never used to tune.</a:t>
-            </a:r>
-          </a:p>
-          <a:p>
-            <a:r>
-              <a:rPr lang="en-US"/>
-              <a:t>Point 2, concrete: an analyst that says inflation is elevated must quote the line, and code checks it. Point 3: because everything is quotable and repeatable, a wrong call is traceable and a fix stays fixed: audit, fix, re-measure.</a:t>
-            </a:r>
-            <a:endParaRPr lang="en-US" dirty="0"/>
+              <a:rPr lang="en-US" dirty="0"/>
+              <a:t>2 MIN. Three whys. One, why an ensemble: each signal is good at one thing and fails in a known way, futures the best single predictor but a price, rules transparent but built on an unobservable r*, base rates blind to today, odds fast but thin; pooled at fixed published weights no single failure owns the number, the floor keeps every outcome alive, and nothing is fitted because eight decisions a year would fit noise; the backtest only decides who enters, and the probit failed it. Two, why a language model on top: the pool cannot read, and the dissent sentence or a changed word lives only in the text; the model reads it in a minute but remembers, varies and invents, so it never writes the number, it returns quoted claims code verifies and an opinion capped at 10 points. Three, why judge the process: a good year proves nothing; the scorecard was fixed before any code; outcomes are logged, never used to tune; a wrong call is traceable and a fix stays fixed.</a:t>
+            </a:r>
           </a:p>
         </p:txBody>
       </p:sp>
@@ -3018,7 +3011,7 @@
     </p:spTree>
     <p:extLst>
       <p:ext uri="{BB962C8B-B14F-4D97-AF65-F5344CB8AC3E}">
-        <p14:creationId xmlns:p14="http://schemas.microsoft.com/office/powerpoint/2010/main" val="1024086991"/>
+        <p14:creationId xmlns:p14="http://schemas.microsoft.com/office/powerpoint/2010/main" val="2216349963"/>
       </p:ext>
     </p:extLst>
   </p:cSld>
@@ -3489,7 +3482,7 @@
           </a:prstGeom>
           <a:extLst>
             <a:ext uri="{C572A759-6A51-4108-AA02-DFA0A04FC94B}">
-              <ma14:wrappingTextBoxFlag xmlns:ma14="http://schemas.microsoft.com/office/mac/drawingml/2011/main" xmlns="" val="0"/>
+              <ma14:wrappingTextBoxFlag xmlns="" xmlns:ma14="http://schemas.microsoft.com/office/mac/drawingml/2011/main" val="0"/>
             </a:ext>
           </a:extLst>
         </p:spPr>
@@ -3674,7 +3667,7 @@
           </a:prstGeom>
           <a:extLst>
             <a:ext uri="{C572A759-6A51-4108-AA02-DFA0A04FC94B}">
-              <ma14:wrappingTextBoxFlag xmlns:ma14="http://schemas.microsoft.com/office/mac/drawingml/2011/main" xmlns="" val="0"/>
+              <ma14:wrappingTextBoxFlag xmlns="" xmlns:ma14="http://schemas.microsoft.com/office/mac/drawingml/2011/main" val="0"/>
             </a:ext>
           </a:extLst>
         </p:spPr>
@@ -5467,7 +5460,7 @@
           </a:prstGeom>
           <a:extLst>
             <a:ext uri="{C572A759-6A51-4108-AA02-DFA0A04FC94B}">
-              <ma14:wrappingTextBoxFlag xmlns:ma14="http://schemas.microsoft.com/office/mac/drawingml/2011/main" xmlns="" val="0"/>
+              <ma14:wrappingTextBoxFlag xmlns="" xmlns:ma14="http://schemas.microsoft.com/office/mac/drawingml/2011/main" val="0"/>
             </a:ext>
           </a:extLst>
         </p:spPr>
@@ -7898,7 +7891,7 @@
           </a:prstGeom>
           <a:extLst>
             <a:ext uri="{C572A759-6A51-4108-AA02-DFA0A04FC94B}">
-              <ma14:wrappingTextBoxFlag xmlns:ma14="http://schemas.microsoft.com/office/mac/drawingml/2011/main" xmlns="" val="0"/>
+              <ma14:wrappingTextBoxFlag xmlns="" xmlns:ma14="http://schemas.microsoft.com/office/mac/drawingml/2011/main" val="0"/>
             </a:ext>
           </a:extLst>
         </p:spPr>
@@ -8882,7 +8875,7 @@
           </a:prstGeom>
           <a:extLst>
             <a:ext uri="{C572A759-6A51-4108-AA02-DFA0A04FC94B}">
-              <ma14:wrappingTextBoxFlag xmlns:ma14="http://schemas.microsoft.com/office/mac/drawingml/2011/main" xmlns="" val="0"/>
+              <ma14:wrappingTextBoxFlag xmlns="" xmlns:ma14="http://schemas.microsoft.com/office/mac/drawingml/2011/main" val="0"/>
             </a:ext>
           </a:extLst>
         </p:spPr>
@@ -10481,7 +10474,7 @@
           </a:prstGeom>
           <a:extLst>
             <a:ext uri="{C572A759-6A51-4108-AA02-DFA0A04FC94B}">
-              <ma14:wrappingTextBoxFlag xmlns:ma14="http://schemas.microsoft.com/office/mac/drawingml/2011/main" xmlns="" val="0"/>
+              <ma14:wrappingTextBoxFlag xmlns="" xmlns:ma14="http://schemas.microsoft.com/office/mac/drawingml/2011/main" val="0"/>
             </a:ext>
           </a:extLst>
         </p:spPr>
@@ -14534,7 +14527,7 @@
           </a:prstGeom>
           <a:extLst>
             <a:ext uri="{C572A759-6A51-4108-AA02-DFA0A04FC94B}">
-              <ma14:wrappingTextBoxFlag xmlns:ma14="http://schemas.microsoft.com/office/mac/drawingml/2011/main" xmlns="" val="0"/>
+              <ma14:wrappingTextBoxFlag xmlns="" xmlns:ma14="http://schemas.microsoft.com/office/mac/drawingml/2011/main" val="0"/>
             </a:ext>
           </a:extLst>
         </p:spPr>
@@ -15458,7 +15451,7 @@
           </a:prstGeom>
           <a:extLst>
             <a:ext uri="{C572A759-6A51-4108-AA02-DFA0A04FC94B}">
-              <ma14:wrappingTextBoxFlag xmlns:ma14="http://schemas.microsoft.com/office/mac/drawingml/2011/main" xmlns="" val="0"/>
+              <ma14:wrappingTextBoxFlag xmlns="" xmlns:ma14="http://schemas.microsoft.com/office/mac/drawingml/2011/main" val="0"/>
             </a:ext>
           </a:extLst>
         </p:spPr>
@@ -16179,7 +16172,7 @@
           </a:prstGeom>
           <a:extLst>
             <a:ext uri="{C572A759-6A51-4108-AA02-DFA0A04FC94B}">
-              <ma14:wrappingTextBoxFlag xmlns:ma14="http://schemas.microsoft.com/office/mac/drawingml/2011/main" xmlns="" val="0"/>
+              <ma14:wrappingTextBoxFlag xmlns="" xmlns:ma14="http://schemas.microsoft.com/office/mac/drawingml/2011/main" val="0"/>
             </a:ext>
           </a:extLst>
         </p:spPr>
@@ -17983,7 +17976,7 @@
           </a:prstGeom>
           <a:extLst>
             <a:ext uri="{C572A759-6A51-4108-AA02-DFA0A04FC94B}">
-              <ma14:wrappingTextBoxFlag xmlns:ma14="http://schemas.microsoft.com/office/mac/drawingml/2011/main" xmlns="" val="0"/>
+              <ma14:wrappingTextBoxFlag xmlns="" xmlns:ma14="http://schemas.microsoft.com/office/mac/drawingml/2011/main" val="0"/>
             </a:ext>
           </a:extLst>
         </p:spPr>
@@ -20960,7 +20953,7 @@
           </a:prstGeom>
           <a:extLst>
             <a:ext uri="{C572A759-6A51-4108-AA02-DFA0A04FC94B}">
-              <ma14:wrappingTextBoxFlag xmlns="" xmlns:ma14="http://schemas.microsoft.com/office/mac/drawingml/2011/main" val="0"/>
+              <ma14:wrappingTextBoxFlag xmlns:ma14="http://schemas.microsoft.com/office/mac/drawingml/2011/main" xmlns="" val="0"/>
             </a:ext>
           </a:extLst>
         </p:spPr>
@@ -22953,7 +22946,7 @@
           </a:prstGeom>
           <a:extLst>
             <a:ext uri="{C572A759-6A51-4108-AA02-DFA0A04FC94B}">
-              <ma14:wrappingTextBoxFlag xmlns="" xmlns:ma14="http://schemas.microsoft.com/office/mac/drawingml/2011/main" val="0"/>
+              <ma14:wrappingTextBoxFlag xmlns:ma14="http://schemas.microsoft.com/office/mac/drawingml/2011/main" xmlns="" val="0"/>
             </a:ext>
           </a:extLst>
         </p:spPr>
@@ -24964,7 +24957,7 @@
           </a:prstGeom>
           <a:extLst>
             <a:ext uri="{C572A759-6A51-4108-AA02-DFA0A04FC94B}">
-              <ma14:wrappingTextBoxFlag xmlns:ma14="http://schemas.microsoft.com/office/mac/drawingml/2011/main" xmlns="" val="0"/>
+              <ma14:wrappingTextBoxFlag xmlns="" xmlns:ma14="http://schemas.microsoft.com/office/mac/drawingml/2011/main" val="0"/>
             </a:ext>
           </a:extLst>
         </p:spPr>
@@ -26026,7 +26019,7 @@
           </a:prstGeom>
           <a:extLst>
             <a:ext uri="{C572A759-6A51-4108-AA02-DFA0A04FC94B}">
-              <ma14:wrappingTextBoxFlag xmlns="" xmlns:ma14="http://schemas.microsoft.com/office/mac/drawingml/2011/main" val="0"/>
+              <ma14:wrappingTextBoxFlag xmlns:ma14="http://schemas.microsoft.com/office/mac/drawingml/2011/main" xmlns="" val="0"/>
             </a:ext>
           </a:extLst>
         </p:spPr>
@@ -28278,7 +28271,7 @@
           </a:prstGeom>
           <a:extLst>
             <a:ext uri="{C572A759-6A51-4108-AA02-DFA0A04FC94B}">
-              <ma14:wrappingTextBoxFlag xmlns="" xmlns:ma14="http://schemas.microsoft.com/office/mac/drawingml/2011/main" val="0"/>
+              <ma14:wrappingTextBoxFlag xmlns:ma14="http://schemas.microsoft.com/office/mac/drawingml/2011/main" xmlns="" val="0"/>
             </a:ext>
           </a:extLst>
         </p:spPr>
@@ -30250,7 +30243,7 @@
           </a:prstGeom>
           <a:extLst>
             <a:ext uri="{C572A759-6A51-4108-AA02-DFA0A04FC94B}">
-              <ma14:wrappingTextBoxFlag xmlns:ma14="http://schemas.microsoft.com/office/mac/drawingml/2011/main" xmlns="" val="0"/>
+              <ma14:wrappingTextBoxFlag xmlns="" xmlns:ma14="http://schemas.microsoft.com/office/mac/drawingml/2011/main" val="0"/>
             </a:ext>
           </a:extLst>
         </p:spPr>
@@ -30575,7 +30568,7 @@
 
 <file path=ppt/slides/slide7.xml><?xml version="1.0" encoding="utf-8"?>
 <p:sld xmlns:a="http://schemas.openxmlformats.org/drawingml/2006/main" xmlns:r="http://schemas.openxmlformats.org/officeDocument/2006/relationships" xmlns:p="http://schemas.openxmlformats.org/presentationml/2006/main">
-  <p:cSld name="Slide 5">
+  <p:cSld>
     <p:spTree>
       <p:nvGrpSpPr>
         <p:cNvPr id="1" name=""/>
@@ -30638,8 +30631,8 @@
         </p:nvSpPr>
         <p:spPr>
           <a:xfrm>
-            <a:off x="548640" y="1417320"/>
-            <a:ext cx="3520440" cy="3977640"/>
+            <a:off x="548640" y="1371600"/>
+            <a:ext cx="3520440" cy="4663440"/>
           </a:xfrm>
           <a:prstGeom prst="roundRect">
             <a:avLst>
@@ -30663,13 +30656,6 @@
             </a:outerShdw>
           </a:effectLst>
         </p:spPr>
-        <p:txBody>
-          <a:bodyPr/>
-          <a:lstStyle/>
-          <a:p>
-            <a:endParaRPr lang="en-US"/>
-          </a:p>
-        </p:txBody>
       </p:sp>
       <p:sp>
         <p:nvSpPr>
@@ -30679,7 +30665,7 @@
         </p:nvSpPr>
         <p:spPr>
           <a:xfrm>
-            <a:off x="822960" y="1600200"/>
+            <a:off x="822960" y="1554480"/>
             <a:ext cx="384048" cy="384048"/>
           </a:xfrm>
           <a:prstGeom prst="ellipse">
@@ -30695,13 +30681,6 @@
             <a:prstDash val="solid"/>
           </a:ln>
         </p:spPr>
-        <p:txBody>
-          <a:bodyPr/>
-          <a:lstStyle/>
-          <a:p>
-            <a:endParaRPr lang="en-US"/>
-          </a:p>
-        </p:txBody>
       </p:sp>
       <p:sp>
         <p:nvSpPr>
@@ -30711,7 +30690,7 @@
         </p:nvSpPr>
         <p:spPr>
           <a:xfrm>
-            <a:off x="822960" y="1600200"/>
+            <a:off x="822960" y="1554480"/>
             <a:ext cx="384048" cy="384048"/>
           </a:xfrm>
           <a:prstGeom prst="rect">
@@ -30747,7 +30726,7 @@
         </p:nvSpPr>
         <p:spPr>
           <a:xfrm>
-            <a:off x="1325880" y="1554480"/>
+            <a:off x="1325880" y="1508760"/>
             <a:ext cx="2560320" cy="502920"/>
           </a:xfrm>
           <a:prstGeom prst="rect">
@@ -30769,7 +30748,7 @@
                   <a:schemeClr val="tx2"/>
                 </a:solidFill>
               </a:rPr>
-              <a:t>We judge the process, not the luck</a:t>
+              <a:t>Why an ensemble, not one model</a:t>
             </a:r>
             <a:endParaRPr lang="en-US" sz="1500" dirty="0"/>
           </a:p>
@@ -30783,8 +30762,8 @@
         </p:nvSpPr>
         <p:spPr>
           <a:xfrm>
-            <a:off x="822960" y="2240280"/>
-            <a:ext cx="3017520" cy="3063240"/>
+            <a:off x="822960" y="2194560"/>
+            <a:ext cx="3017520" cy="3703320"/>
           </a:xfrm>
           <a:prstGeom prst="rect">
             <a:avLst/>
@@ -30804,30 +30783,14 @@
               <a:buChar char="•"/>
             </a:pPr>
             <a:r>
-              <a:rPr lang="en-US" sz="1300" dirty="0">
+              <a:rPr lang="en-US" sz="1200" dirty="0">
                 <a:solidFill>
                   <a:schemeClr val="tx1"/>
                 </a:solidFill>
               </a:rPr>
-              <a:t>We are at early stages of model building hence </a:t>
-            </a:r>
-            <a:r>
-              <a:rPr lang="en-US" sz="1300" b="1" dirty="0">
-                <a:solidFill>
-                  <a:schemeClr val="tx1"/>
-                </a:solidFill>
-              </a:rPr>
-              <a:t>process takes precedence over results</a:t>
-            </a:r>
-            <a:r>
-              <a:rPr lang="en-US" sz="1300" dirty="0">
-                <a:solidFill>
-                  <a:schemeClr val="tx1"/>
-                </a:solidFill>
-              </a:rPr>
-              <a:t>.</a:t>
-            </a:r>
-            <a:endParaRPr lang="en-US" sz="1300" dirty="0"/>
+              <a:t>Each signal is good at one thing and fails in a known way. Futures: the best single predictor at 30 days, about 88% right, but a price that moves with the market on the day. The Fed's rules: transparent, but built on an r* nobody observes. Base rates: what the Fed usually does next, nothing about today. Prediction markets: fast, but thin.</a:t>
+            </a:r>
+            <a:endParaRPr lang="en-US" sz="1200" dirty="0"/>
           </a:p>
           <a:p>
             <a:pPr marL="342900" indent="-342900">
@@ -30838,107 +30801,14 @@
               <a:buChar char="•"/>
             </a:pPr>
             <a:r>
-              <a:rPr lang="en-US" sz="1300">
+              <a:rPr lang="en-US" sz="1200" dirty="0">
                 <a:solidFill>
                   <a:schemeClr val="tx1"/>
                 </a:solidFill>
               </a:rPr>
-              <a:t>A good process is a repeatable one: </a:t>
-            </a:r>
-            <a:endParaRPr lang="en-US" sz="1300" dirty="0">
-              <a:solidFill>
-                <a:schemeClr val="tx1"/>
-              </a:solidFill>
-            </a:endParaRPr>
-          </a:p>
-          <a:p>
-            <a:pPr marL="800100" lvl="1" indent="-342900">
-              <a:spcAft>
-                <a:spcPts val="800"/>
-              </a:spcAft>
-              <a:buSzPct val="100000"/>
-              <a:buChar char="•"/>
-            </a:pPr>
-            <a:r>
-              <a:rPr lang="en-US" sz="1300" dirty="0"/>
-              <a:t>S</a:t>
-            </a:r>
-            <a:r>
-              <a:rPr lang="en-US" sz="1300" dirty="0">
-                <a:solidFill>
-                  <a:schemeClr val="tx1"/>
-                </a:solidFill>
-              </a:rPr>
-              <a:t>ame evidence, same answer?</a:t>
-            </a:r>
-          </a:p>
-          <a:p>
-            <a:pPr marL="800100" lvl="1" indent="-342900">
-              <a:spcAft>
-                <a:spcPts val="800"/>
-              </a:spcAft>
-              <a:buSzPct val="100000"/>
-              <a:buChar char="•"/>
-            </a:pPr>
-            <a:r>
-              <a:rPr lang="en-US" sz="1300" dirty="0"/>
-              <a:t>Is </a:t>
-            </a:r>
-            <a:r>
-              <a:rPr lang="en-US" sz="1300" dirty="0">
-                <a:solidFill>
-                  <a:schemeClr val="tx1"/>
-                </a:solidFill>
-              </a:rPr>
-              <a:t>every claim quoted? </a:t>
-            </a:r>
-          </a:p>
-          <a:p>
-            <a:pPr marL="800100" lvl="1" indent="-342900">
-              <a:spcAft>
-                <a:spcPts val="800"/>
-              </a:spcAft>
-              <a:buSzPct val="100000"/>
-              <a:buChar char="•"/>
-            </a:pPr>
-            <a:r>
-              <a:rPr lang="en-US" sz="1300" dirty="0">
-                <a:solidFill>
-                  <a:schemeClr val="tx1"/>
-                </a:solidFill>
-              </a:rPr>
-              <a:t>any number from memory? </a:t>
-            </a:r>
-          </a:p>
-          <a:p>
-            <a:pPr marL="800100" lvl="1" indent="-342900">
-              <a:spcAft>
-                <a:spcPts val="800"/>
-              </a:spcAft>
-              <a:buSzPct val="100000"/>
-              <a:buChar char="•"/>
-            </a:pPr>
-            <a:r>
-              <a:rPr lang="en-US" sz="1300"/>
-              <a:t>Does a shock move the number</a:t>
-            </a:r>
-            <a:r>
-              <a:rPr lang="en-US" sz="1300">
-                <a:solidFill>
-                  <a:schemeClr val="tx1"/>
-                </a:solidFill>
-              </a:rPr>
-              <a:t> </a:t>
-            </a:r>
-            <a:r>
-              <a:rPr lang="en-US" sz="1300" dirty="0">
-                <a:solidFill>
-                  <a:schemeClr val="tx1"/>
-                </a:solidFill>
-              </a:rPr>
-              <a:t>the right way?</a:t>
-            </a:r>
-            <a:endParaRPr lang="en-US" sz="1300" dirty="0"/>
+              <a:t>Pooled at fixed, published weights (0.6 / 0.2 / 0.1 / 0.1), no single input's failure owns the number. A 1.5% floor keeps every outcome alive, so a surprise is never scored at zero.</a:t>
+            </a:r>
+            <a:endParaRPr lang="en-US" sz="1200" dirty="0"/>
           </a:p>
           <a:p>
             <a:pPr marL="342900" indent="-342900">
@@ -30949,14 +30819,14 @@
               <a:buChar char="•"/>
             </a:pPr>
             <a:r>
-              <a:rPr lang="en-US" sz="1300" dirty="0">
+              <a:rPr lang="en-US" sz="1200" dirty="0">
                 <a:solidFill>
                   <a:schemeClr val="tx1"/>
                 </a:solidFill>
               </a:rPr>
-              <a:t>Outcomes are logged after each decision and never used to tune</a:t>
-            </a:r>
-            <a:endParaRPr lang="en-US" sz="1300" dirty="0"/>
+              <a:t>Nothing is fitted: eight decisions a year would fit noise. The backtest decides only which models enter; the probit failed it and sits at weight 0.</a:t>
+            </a:r>
+            <a:endParaRPr lang="en-US" sz="1200" dirty="0"/>
           </a:p>
         </p:txBody>
       </p:sp>
@@ -30968,8 +30838,8 @@
         </p:nvSpPr>
         <p:spPr>
           <a:xfrm>
-            <a:off x="4297680" y="1417320"/>
-            <a:ext cx="3520440" cy="3977640"/>
+            <a:off x="4297680" y="1371600"/>
+            <a:ext cx="3520440" cy="4663440"/>
           </a:xfrm>
           <a:prstGeom prst="roundRect">
             <a:avLst>
@@ -30993,13 +30863,6 @@
             </a:outerShdw>
           </a:effectLst>
         </p:spPr>
-        <p:txBody>
-          <a:bodyPr/>
-          <a:lstStyle/>
-          <a:p>
-            <a:endParaRPr lang="en-US"/>
-          </a:p>
-        </p:txBody>
       </p:sp>
       <p:sp>
         <p:nvSpPr>
@@ -31009,7 +30872,7 @@
         </p:nvSpPr>
         <p:spPr>
           <a:xfrm>
-            <a:off x="4572000" y="1600200"/>
+            <a:off x="4572000" y="1554480"/>
             <a:ext cx="384048" cy="384048"/>
           </a:xfrm>
           <a:prstGeom prst="ellipse">
@@ -31025,13 +30888,6 @@
             <a:prstDash val="solid"/>
           </a:ln>
         </p:spPr>
-        <p:txBody>
-          <a:bodyPr/>
-          <a:lstStyle/>
-          <a:p>
-            <a:endParaRPr lang="en-US"/>
-          </a:p>
-        </p:txBody>
       </p:sp>
       <p:sp>
         <p:nvSpPr>
@@ -31041,7 +30897,7 @@
         </p:nvSpPr>
         <p:spPr>
           <a:xfrm>
-            <a:off x="4572000" y="1600200"/>
+            <a:off x="4572000" y="1554480"/>
             <a:ext cx="384048" cy="384048"/>
           </a:xfrm>
           <a:prstGeom prst="rect">
@@ -31077,7 +30933,7 @@
         </p:nvSpPr>
         <p:spPr>
           <a:xfrm>
-            <a:off x="5074920" y="1554480"/>
+            <a:off x="5074920" y="1508760"/>
             <a:ext cx="2560320" cy="502920"/>
           </a:xfrm>
           <a:prstGeom prst="rect">
@@ -31099,7 +30955,7 @@
                   <a:schemeClr val="tx2"/>
                 </a:solidFill>
               </a:rPr>
-              <a:t>We build every step to be auditable</a:t>
+              <a:t>Why a language model on top, harnessed</a:t>
             </a:r>
             <a:endParaRPr lang="en-US" sz="1500" dirty="0"/>
           </a:p>
@@ -31113,8 +30969,8 @@
         </p:nvSpPr>
         <p:spPr>
           <a:xfrm>
-            <a:off x="4572000" y="2240280"/>
-            <a:ext cx="3017520" cy="3063240"/>
+            <a:off x="4572000" y="2194560"/>
+            <a:ext cx="3017520" cy="3703320"/>
           </a:xfrm>
           <a:prstGeom prst="rect">
             <a:avLst/>
@@ -31134,14 +30990,14 @@
               <a:buChar char="•"/>
             </a:pPr>
             <a:r>
-              <a:rPr lang="en-US" sz="1300" dirty="0">
+              <a:rPr lang="en-US" sz="1200" dirty="0">
                 <a:solidFill>
                   <a:schemeClr val="tx1"/>
                 </a:solidFill>
               </a:rPr>
-              <a:t>An analyst that says 'inflation remains elevated' must quote the statement line it read, and code checks the quote is there, character for character</a:t>
-            </a:r>
-            <a:endParaRPr lang="en-US" sz="1300" dirty="0"/>
+              <a:t>The pool cannot read. The dissent sentence, a changed word, 'the accumulation of more information': that is in the Fed's text and in no price or rule.</a:t>
+            </a:r>
+            <a:endParaRPr lang="en-US" sz="1200" dirty="0"/>
           </a:p>
           <a:p>
             <a:pPr marL="342900" indent="-342900">
@@ -31152,22 +31008,14 @@
               <a:buChar char="•"/>
             </a:pPr>
             <a:r>
-              <a:rPr lang="en-US" sz="1300" dirty="0">
+              <a:rPr lang="en-US" sz="1200" dirty="0">
                 <a:solidFill>
                   <a:schemeClr val="tx1"/>
                 </a:solidFill>
               </a:rPr>
-              <a:t>Every number it uses must exist in the frozen evidence, or </a:t>
-            </a:r>
-            <a:r>
-              <a:rPr lang="en-US" sz="1300" b="1" dirty="0">
-                <a:solidFill>
-                  <a:schemeClr val="tx1"/>
-                </a:solidFill>
-              </a:rPr>
-              <a:t>it is flagged as from memory</a:t>
-            </a:r>
-            <a:endParaRPr lang="en-US" sz="1300" b="1" dirty="0"/>
+              <a:t>A model reads it in a minute. But it remembers, varies and invents, so it never writes the number. It returns claims that each quote a line code finds, and an opinion that moves the pool by at most 10 points.</a:t>
+            </a:r>
+            <a:endParaRPr lang="en-US" sz="1200" dirty="0"/>
           </a:p>
           <a:p>
             <a:pPr marL="342900" indent="-342900">
@@ -31178,34 +31026,14 @@
               <a:buChar char="•"/>
             </a:pPr>
             <a:r>
-              <a:rPr lang="en-US" sz="1300" dirty="0">
+              <a:rPr lang="en-US" sz="1200" dirty="0">
                 <a:solidFill>
                   <a:schemeClr val="tx1"/>
                 </a:solidFill>
               </a:rPr>
-              <a:t>Every model lists the items it read; every ledger entry recomputes from its snapshot. If it is not quoted, it does not count</a:t>
-            </a:r>
-          </a:p>
-          <a:p>
-            <a:pPr marL="342900" indent="-342900">
-              <a:spcAft>
-                <a:spcPts val="800"/>
-              </a:spcAft>
-              <a:buSzPct val="100000"/>
-              <a:buChar char="•"/>
-            </a:pPr>
-            <a:r>
-              <a:rPr lang="en-US" sz="1300" dirty="0"/>
-              <a:t>We believe that this method allows us to </a:t>
-            </a:r>
-            <a:r>
-              <a:rPr lang="en-US" sz="1300" b="1" dirty="0"/>
-              <a:t>use less expensive models </a:t>
-            </a:r>
-            <a:r>
-              <a:rPr lang="en-US" sz="1300" dirty="0"/>
-              <a:t>as well</a:t>
-            </a:r>
+              <a:t>Five identical runs, the spread measured. Boxed and checked this way, a cheaper model can do the job.</a:t>
+            </a:r>
+            <a:endParaRPr lang="en-US" sz="1200" dirty="0"/>
           </a:p>
         </p:txBody>
       </p:sp>
@@ -31217,8 +31045,8 @@
         </p:nvSpPr>
         <p:spPr>
           <a:xfrm>
-            <a:off x="8046720" y="1417320"/>
-            <a:ext cx="3520440" cy="3977640"/>
+            <a:off x="8046720" y="1371600"/>
+            <a:ext cx="3520440" cy="4663440"/>
           </a:xfrm>
           <a:prstGeom prst="roundRect">
             <a:avLst>
@@ -31242,13 +31070,6 @@
             </a:outerShdw>
           </a:effectLst>
         </p:spPr>
-        <p:txBody>
-          <a:bodyPr/>
-          <a:lstStyle/>
-          <a:p>
-            <a:endParaRPr lang="en-US"/>
-          </a:p>
-        </p:txBody>
       </p:sp>
       <p:sp>
         <p:nvSpPr>
@@ -31258,7 +31079,7 @@
         </p:nvSpPr>
         <p:spPr>
           <a:xfrm>
-            <a:off x="8321040" y="1600200"/>
+            <a:off x="8321040" y="1554480"/>
             <a:ext cx="384048" cy="384048"/>
           </a:xfrm>
           <a:prstGeom prst="ellipse">
@@ -31274,13 +31095,6 @@
             <a:prstDash val="solid"/>
           </a:ln>
         </p:spPr>
-        <p:txBody>
-          <a:bodyPr/>
-          <a:lstStyle/>
-          <a:p>
-            <a:endParaRPr lang="en-US"/>
-          </a:p>
-        </p:txBody>
       </p:sp>
       <p:sp>
         <p:nvSpPr>
@@ -31290,7 +31104,7 @@
         </p:nvSpPr>
         <p:spPr>
           <a:xfrm>
-            <a:off x="8321040" y="1600200"/>
+            <a:off x="8321040" y="1554480"/>
             <a:ext cx="384048" cy="384048"/>
           </a:xfrm>
           <a:prstGeom prst="rect">
@@ -31326,7 +31140,7 @@
         </p:nvSpPr>
         <p:spPr>
           <a:xfrm>
-            <a:off x="8823960" y="1554480"/>
+            <a:off x="8823960" y="1508760"/>
             <a:ext cx="2560320" cy="502920"/>
           </a:xfrm>
           <a:prstGeom prst="rect">
@@ -31348,7 +31162,7 @@
                   <a:schemeClr val="tx2"/>
                 </a:solidFill>
               </a:rPr>
-              <a:t>A harness that compounds</a:t>
+              <a:t>Why judge the process, not the luck</a:t>
             </a:r>
             <a:endParaRPr lang="en-US" sz="1500" dirty="0"/>
           </a:p>
@@ -31362,8 +31176,8 @@
         </p:nvSpPr>
         <p:spPr>
           <a:xfrm>
-            <a:off x="8321040" y="2240280"/>
-            <a:ext cx="3017520" cy="3063240"/>
+            <a:off x="8321040" y="2194560"/>
+            <a:ext cx="3017520" cy="3703320"/>
           </a:xfrm>
           <a:prstGeom prst="rect">
             <a:avLst/>
@@ -31383,30 +31197,14 @@
               <a:buChar char="•"/>
             </a:pPr>
             <a:r>
-              <a:rPr lang="en-US" sz="1300">
+              <a:rPr lang="en-US" sz="1200" dirty="0">
                 <a:solidFill>
                   <a:schemeClr val="tx1"/>
                 </a:solidFill>
               </a:rPr>
-              <a:t>Since everything is quotable and the LLM analysts can read only the evidence, </a:t>
-            </a:r>
-            <a:r>
-              <a:rPr lang="en-US" sz="1300" dirty="0">
-                <a:solidFill>
-                  <a:schemeClr val="tx1"/>
-                </a:solidFill>
-              </a:rPr>
-              <a:t>so a wrong call is a traceable wrong call: we </a:t>
-            </a:r>
-            <a:r>
-              <a:rPr lang="en-US" sz="1300">
-                <a:solidFill>
-                  <a:schemeClr val="tx1"/>
-                </a:solidFill>
-              </a:rPr>
-              <a:t>see which quote led where.</a:t>
-            </a:r>
-            <a:endParaRPr lang="en-US" sz="1300" dirty="0"/>
+              <a:t>We are early, and eight decisions a year: a good year proves nothing. The yardstick is a ten-point scorecard fixed before any code: same evidence, same answer? every claim quoted? any number from memory? does a shock move the number the right way?</a:t>
+            </a:r>
+            <a:endParaRPr lang="en-US" sz="1200" dirty="0"/>
           </a:p>
           <a:p>
             <a:pPr marL="342900" indent="-342900">
@@ -31417,14 +31215,14 @@
               <a:buChar char="•"/>
             </a:pPr>
             <a:r>
-              <a:rPr lang="en-US" sz="1300" dirty="0">
+              <a:rPr lang="en-US" sz="1200" dirty="0">
                 <a:solidFill>
                   <a:schemeClr val="tx1"/>
                 </a:solidFill>
               </a:rPr>
-              <a:t>The harness is repeatable, so it goes wrong the same way every time; a fix can be tested, and the drift table shows it stayed fixed</a:t>
-            </a:r>
-            <a:endParaRPr lang="en-US" sz="1300" dirty="0"/>
+              <a:t>Outcomes are logged after each decision and never used to tune.</a:t>
+            </a:r>
+            <a:endParaRPr lang="en-US" sz="1200" dirty="0"/>
           </a:p>
           <a:p>
             <a:pPr marL="342900" indent="-342900">
@@ -31435,14 +31233,14 @@
               <a:buChar char="•"/>
             </a:pPr>
             <a:r>
-              <a:rPr lang="en-US" sz="1300" dirty="0">
+              <a:rPr lang="en-US" sz="1200" dirty="0">
                 <a:solidFill>
                   <a:schemeClr val="tx1"/>
                 </a:solidFill>
               </a:rPr>
-              <a:t>That is the virtuous cycle: audit, fix, re-measure. The ladder, the scorecard and the drift table later in the deck are that cycle</a:t>
-            </a:r>
-            <a:endParaRPr lang="en-US" sz="1300" dirty="0"/>
+              <a:t>A wrong call is a traceable wrong call: we see which input or quote led where. Repeatable means it goes wrong the same way every time, so a fix can be tested and the drift table shows it stayed fixed. Audit, fix, re-measure.</a:t>
+            </a:r>
+            <a:endParaRPr lang="en-US" sz="1200" dirty="0"/>
           </a:p>
         </p:txBody>
       </p:sp>
@@ -31492,6 +31290,11 @@
         </p:txBody>
       </p:sp>
     </p:spTree>
+    <p:extLst>
+      <p:ext uri="{BB962C8B-B14F-4D97-AF65-F5344CB8AC3E}">
+        <p14:creationId xmlns:p14="http://schemas.microsoft.com/office/powerpoint/2010/main" val="911937503"/>
+      </p:ext>
+    </p:extLst>
   </p:cSld>
   <p:clrMapOvr>
     <a:masterClrMapping/>
@@ -33077,7 +32880,7 @@
           </a:prstGeom>
           <a:extLst>
             <a:ext uri="{C572A759-6A51-4108-AA02-DFA0A04FC94B}">
-              <ma14:wrappingTextBoxFlag xmlns="" xmlns:ma14="http://schemas.microsoft.com/office/mac/drawingml/2011/main" val="0"/>
+              <ma14:wrappingTextBoxFlag xmlns:ma14="http://schemas.microsoft.com/office/mac/drawingml/2011/main" xmlns="" val="0"/>
             </a:ext>
           </a:extLst>
         </p:spPr>
@@ -37157,7 +36960,7 @@
           </a:prstGeom>
           <a:extLst>
             <a:ext uri="{C572A759-6A51-4108-AA02-DFA0A04FC94B}">
-              <ma14:wrappingTextBoxFlag xmlns:ma14="http://schemas.microsoft.com/office/mac/drawingml/2011/main" xmlns="" val="0"/>
+              <ma14:wrappingTextBoxFlag xmlns="" xmlns:ma14="http://schemas.microsoft.com/office/mac/drawingml/2011/main" val="0"/>
             </a:ext>
           </a:extLst>
         </p:spPr>

</xml_diff>

<commit_message>
Demo 3 script in slide 13's notes (click by click on the 29 October snapshot); the app's prompts view and methodology label the opinion as -10 to +10, not basis points
Co-Authored-By: Claude Fable 5.1 <noreply@anthropic.com>
</commit_message>
<xml_diff>
--- a/docs/FedCast_Fullerton.pptx
+++ b/docs/FedCast_Fullerton.pptx
@@ -1450,9 +1450,14 @@
           <a:lstStyle/>
           <a:p>
             <a:r>
-              <a:rPr lang="en-US" dirty="0"/>
-              <a:t>DEMO 3, 2 MIN. Analyst prompts view on the 29 October snapshot. Open analyst 1: 195 characters, the question and the date, asked for probabilities. Open analyst 4: 45,000 characters; scroll past the schema to the tone pre-read and stop there. Say: the vote (10 to 2, Cook and Hammack), the diff (the September 'raise by 1/4 percentage point' is gone, 'maintain' and the dissent sentence are new), the lexicon (seven hawkish terms, no dovish). That block was computed by code; the model is handed it and must quote. Then: 'if it is not on this page, the analyst does not get it; the only difference between analyst 1 and analyst 4 is this page.' Its answer comes in the next demo.</a:t>
-            </a:r>
+              <a:rPr lang="en-US"/>
+              <a:t>DEMO 3, 2 MIN. Before the talk: the app is open on the Analyst prompts view (left nav), snapshot 5f6a8d193890, evidence of 29 October. Eight cards, one per analyst.
+STEP 1, 20 s. Card 'Analyst 1: Naive control, 195 characters'. Read the Question row aloud: 'Today is 2026-10-29. What will the FOMC decide at its 2026-12-09 meeting? Give a probability for each outcome.' Say: 'That is the whole input. No evidence. This is just asking the model. It answers from memory, and in the next demo you will see its memory is stale.' Click 'open the full prompt': one line of system prompt, the schema (five probabilities and a reasoning string), the question. Close.
+STEP 2, 70 s. Scroll to 'Analyst 4: Communications, 45,363 characters'. Point at the four rows: Question (which way does the next decision lean, and why: not a probability); Evidence items (both statements, the minutes, the transcript, the speeches); Pre-computed numbers (signal.tone); Answer shape (claims with quotes, watch-outs, an opinion). Click 'open the full prompt'. Top of the reader: the same one-line system prompt, then the schema. Say: 'every claim must carry text, a quote, the item it came from and a lean; the opinion is a number between minus 10 and plus 10; the runtime rejects anything else.' Scroll a little to USER PROMPT: 'Snapshot date 2026-10-29. Next FOMC decision 2026-12-09. Question: from the committee's own communications, which way does the next decision lean, and why?' Then DETERMINISTIC PRE-READ (signal.tone). Stop here, this is the slide. Read it: vote 10 for, 2 against, Cook and Hammack. Lexicon: seven hawkish terms (elevated twice, strong twice, raise, robust, resilient, price stability), none dovish, score 1.0. Diff: removed 'raise', 'by 1/4 percentage point', '12', '0'; added '10', '2', 'maintain', 'strong', and the dissent sentence. Say: 'Code computed this before any model ran. It parsed the vote and compared the 28 October statement with the September one word by word. The model is handed the result and must quote it, not paraphrase it.' Then WATCH-OUTS: none. Then scroll fast through the rest: 'ITEM fed.minutes': 36,000 characters, then the press conference, both statements, the speeches. Say: 'That is 95 percent of the prompt: the Fed's own text as published. Nothing else.'
+STEP 3, 20 s. Close the reader. Point at the hash on the card (e612e90198de60b3): 'five repeats share it; a different hash is a different analyst.' The line: 'If it is not on this page, the analyst does not get it. Same model. The only difference between analyst 1 and analyst 4 is this page.' Bridge: 'Next: what it answered.'
+FALLBACK. If the reader is slow, the four rows on the card carry the point; read the Pre-computed numbers row and say what signal.tone contains from the slide.</a:t>
+            </a:r>
+            <a:endParaRPr lang="en-US" dirty="0"/>
           </a:p>
         </p:txBody>
       </p:sp>
@@ -3482,7 +3487,7 @@
           </a:prstGeom>
           <a:extLst>
             <a:ext uri="{C572A759-6A51-4108-AA02-DFA0A04FC94B}">
-              <ma14:wrappingTextBoxFlag xmlns="" xmlns:ma14="http://schemas.microsoft.com/office/mac/drawingml/2011/main" val="0"/>
+              <ma14:wrappingTextBoxFlag xmlns:ma14="http://schemas.microsoft.com/office/mac/drawingml/2011/main" xmlns="" val="0"/>
             </a:ext>
           </a:extLst>
         </p:spPr>
@@ -3667,7 +3672,7 @@
           </a:prstGeom>
           <a:extLst>
             <a:ext uri="{C572A759-6A51-4108-AA02-DFA0A04FC94B}">
-              <ma14:wrappingTextBoxFlag xmlns="" xmlns:ma14="http://schemas.microsoft.com/office/mac/drawingml/2011/main" val="0"/>
+              <ma14:wrappingTextBoxFlag xmlns:ma14="http://schemas.microsoft.com/office/mac/drawingml/2011/main" xmlns="" val="0"/>
             </a:ext>
           </a:extLst>
         </p:spPr>
@@ -5460,7 +5465,7 @@
           </a:prstGeom>
           <a:extLst>
             <a:ext uri="{C572A759-6A51-4108-AA02-DFA0A04FC94B}">
-              <ma14:wrappingTextBoxFlag xmlns="" xmlns:ma14="http://schemas.microsoft.com/office/mac/drawingml/2011/main" val="0"/>
+              <ma14:wrappingTextBoxFlag xmlns:ma14="http://schemas.microsoft.com/office/mac/drawingml/2011/main" xmlns="" val="0"/>
             </a:ext>
           </a:extLst>
         </p:spPr>
@@ -7891,7 +7896,7 @@
           </a:prstGeom>
           <a:extLst>
             <a:ext uri="{C572A759-6A51-4108-AA02-DFA0A04FC94B}">
-              <ma14:wrappingTextBoxFlag xmlns="" xmlns:ma14="http://schemas.microsoft.com/office/mac/drawingml/2011/main" val="0"/>
+              <ma14:wrappingTextBoxFlag xmlns:ma14="http://schemas.microsoft.com/office/mac/drawingml/2011/main" xmlns="" val="0"/>
             </a:ext>
           </a:extLst>
         </p:spPr>
@@ -8875,7 +8880,7 @@
           </a:prstGeom>
           <a:extLst>
             <a:ext uri="{C572A759-6A51-4108-AA02-DFA0A04FC94B}">
-              <ma14:wrappingTextBoxFlag xmlns="" xmlns:ma14="http://schemas.microsoft.com/office/mac/drawingml/2011/main" val="0"/>
+              <ma14:wrappingTextBoxFlag xmlns:ma14="http://schemas.microsoft.com/office/mac/drawingml/2011/main" xmlns="" val="0"/>
             </a:ext>
           </a:extLst>
         </p:spPr>
@@ -10474,7 +10479,7 @@
           </a:prstGeom>
           <a:extLst>
             <a:ext uri="{C572A759-6A51-4108-AA02-DFA0A04FC94B}">
-              <ma14:wrappingTextBoxFlag xmlns="" xmlns:ma14="http://schemas.microsoft.com/office/mac/drawingml/2011/main" val="0"/>
+              <ma14:wrappingTextBoxFlag xmlns:ma14="http://schemas.microsoft.com/office/mac/drawingml/2011/main" xmlns="" val="0"/>
             </a:ext>
           </a:extLst>
         </p:spPr>
@@ -14527,7 +14532,7 @@
           </a:prstGeom>
           <a:extLst>
             <a:ext uri="{C572A759-6A51-4108-AA02-DFA0A04FC94B}">
-              <ma14:wrappingTextBoxFlag xmlns="" xmlns:ma14="http://schemas.microsoft.com/office/mac/drawingml/2011/main" val="0"/>
+              <ma14:wrappingTextBoxFlag xmlns:ma14="http://schemas.microsoft.com/office/mac/drawingml/2011/main" xmlns="" val="0"/>
             </a:ext>
           </a:extLst>
         </p:spPr>
@@ -15451,7 +15456,7 @@
           </a:prstGeom>
           <a:extLst>
             <a:ext uri="{C572A759-6A51-4108-AA02-DFA0A04FC94B}">
-              <ma14:wrappingTextBoxFlag xmlns="" xmlns:ma14="http://schemas.microsoft.com/office/mac/drawingml/2011/main" val="0"/>
+              <ma14:wrappingTextBoxFlag xmlns:ma14="http://schemas.microsoft.com/office/mac/drawingml/2011/main" xmlns="" val="0"/>
             </a:ext>
           </a:extLst>
         </p:spPr>
@@ -16172,7 +16177,7 @@
           </a:prstGeom>
           <a:extLst>
             <a:ext uri="{C572A759-6A51-4108-AA02-DFA0A04FC94B}">
-              <ma14:wrappingTextBoxFlag xmlns="" xmlns:ma14="http://schemas.microsoft.com/office/mac/drawingml/2011/main" val="0"/>
+              <ma14:wrappingTextBoxFlag xmlns:ma14="http://schemas.microsoft.com/office/mac/drawingml/2011/main" xmlns="" val="0"/>
             </a:ext>
           </a:extLst>
         </p:spPr>
@@ -17976,7 +17981,7 @@
           </a:prstGeom>
           <a:extLst>
             <a:ext uri="{C572A759-6A51-4108-AA02-DFA0A04FC94B}">
-              <ma14:wrappingTextBoxFlag xmlns="" xmlns:ma14="http://schemas.microsoft.com/office/mac/drawingml/2011/main" val="0"/>
+              <ma14:wrappingTextBoxFlag xmlns:ma14="http://schemas.microsoft.com/office/mac/drawingml/2011/main" xmlns="" val="0"/>
             </a:ext>
           </a:extLst>
         </p:spPr>
@@ -20953,7 +20958,7 @@
           </a:prstGeom>
           <a:extLst>
             <a:ext uri="{C572A759-6A51-4108-AA02-DFA0A04FC94B}">
-              <ma14:wrappingTextBoxFlag xmlns:ma14="http://schemas.microsoft.com/office/mac/drawingml/2011/main" xmlns="" val="0"/>
+              <ma14:wrappingTextBoxFlag xmlns="" xmlns:ma14="http://schemas.microsoft.com/office/mac/drawingml/2011/main" val="0"/>
             </a:ext>
           </a:extLst>
         </p:spPr>
@@ -22946,7 +22951,7 @@
           </a:prstGeom>
           <a:extLst>
             <a:ext uri="{C572A759-6A51-4108-AA02-DFA0A04FC94B}">
-              <ma14:wrappingTextBoxFlag xmlns:ma14="http://schemas.microsoft.com/office/mac/drawingml/2011/main" xmlns="" val="0"/>
+              <ma14:wrappingTextBoxFlag xmlns="" xmlns:ma14="http://schemas.microsoft.com/office/mac/drawingml/2011/main" val="0"/>
             </a:ext>
           </a:extLst>
         </p:spPr>
@@ -24957,7 +24962,7 @@
           </a:prstGeom>
           <a:extLst>
             <a:ext uri="{C572A759-6A51-4108-AA02-DFA0A04FC94B}">
-              <ma14:wrappingTextBoxFlag xmlns="" xmlns:ma14="http://schemas.microsoft.com/office/mac/drawingml/2011/main" val="0"/>
+              <ma14:wrappingTextBoxFlag xmlns:ma14="http://schemas.microsoft.com/office/mac/drawingml/2011/main" xmlns="" val="0"/>
             </a:ext>
           </a:extLst>
         </p:spPr>
@@ -26019,7 +26024,7 @@
           </a:prstGeom>
           <a:extLst>
             <a:ext uri="{C572A759-6A51-4108-AA02-DFA0A04FC94B}">
-              <ma14:wrappingTextBoxFlag xmlns:ma14="http://schemas.microsoft.com/office/mac/drawingml/2011/main" xmlns="" val="0"/>
+              <ma14:wrappingTextBoxFlag xmlns="" xmlns:ma14="http://schemas.microsoft.com/office/mac/drawingml/2011/main" val="0"/>
             </a:ext>
           </a:extLst>
         </p:spPr>
@@ -28271,7 +28276,7 @@
           </a:prstGeom>
           <a:extLst>
             <a:ext uri="{C572A759-6A51-4108-AA02-DFA0A04FC94B}">
-              <ma14:wrappingTextBoxFlag xmlns:ma14="http://schemas.microsoft.com/office/mac/drawingml/2011/main" xmlns="" val="0"/>
+              <ma14:wrappingTextBoxFlag xmlns="" xmlns:ma14="http://schemas.microsoft.com/office/mac/drawingml/2011/main" val="0"/>
             </a:ext>
           </a:extLst>
         </p:spPr>
@@ -30243,7 +30248,7 @@
           </a:prstGeom>
           <a:extLst>
             <a:ext uri="{C572A759-6A51-4108-AA02-DFA0A04FC94B}">
-              <ma14:wrappingTextBoxFlag xmlns="" xmlns:ma14="http://schemas.microsoft.com/office/mac/drawingml/2011/main" val="0"/>
+              <ma14:wrappingTextBoxFlag xmlns:ma14="http://schemas.microsoft.com/office/mac/drawingml/2011/main" xmlns="" val="0"/>
             </a:ext>
           </a:extLst>
         </p:spPr>
@@ -31264,7 +31269,7 @@
           </a:prstGeom>
           <a:extLst>
             <a:ext uri="{C572A759-6A51-4108-AA02-DFA0A04FC94B}">
-              <ma14:wrappingTextBoxFlag xmlns:ma14="http://schemas.microsoft.com/office/mac/drawingml/2011/main" xmlns="" val="0"/>
+              <ma14:wrappingTextBoxFlag xmlns="" xmlns:ma14="http://schemas.microsoft.com/office/mac/drawingml/2011/main" val="0"/>
             </a:ext>
           </a:extLst>
         </p:spPr>
@@ -32880,7 +32885,7 @@
           </a:prstGeom>
           <a:extLst>
             <a:ext uri="{C572A759-6A51-4108-AA02-DFA0A04FC94B}">
-              <ma14:wrappingTextBoxFlag xmlns:ma14="http://schemas.microsoft.com/office/mac/drawingml/2011/main" xmlns="" val="0"/>
+              <ma14:wrappingTextBoxFlag xmlns="" xmlns:ma14="http://schemas.microsoft.com/office/mac/drawingml/2011/main" val="0"/>
             </a:ext>
           </a:extLst>
         </p:spPr>
@@ -36960,7 +36965,7 @@
           </a:prstGeom>
           <a:extLst>
             <a:ext uri="{C572A759-6A51-4108-AA02-DFA0A04FC94B}">
-              <ma14:wrappingTextBoxFlag xmlns="" xmlns:ma14="http://schemas.microsoft.com/office/mac/drawingml/2011/main" val="0"/>
+              <ma14:wrappingTextBoxFlag xmlns:ma14="http://schemas.microsoft.com/office/mac/drawingml/2011/main" xmlns="" val="0"/>
             </a:ext>
           </a:extLst>
         </p:spPr>

</xml_diff>